<commit_message>
docs: record internal TestFlight build 2 and refresh demo evidence
</commit_message>
<xml_diff>
--- a/presentation/output/spottr-judges.pptx
+++ b/presentation/output/spottr-judges.pptx
@@ -2,22 +2,22 @@
 <file path=ppt/presentation.xml><?xml version="1.0" encoding="utf-8"?>
 <p:presentation xmlns:p="http://schemas.openxmlformats.org/presentationml/2006/main">
   <p:sldMasterIdLst>
-    <p:sldMasterId xmlns:r="http://schemas.openxmlformats.org/officeDocument/2006/relationships" id="2147483648" r:id="R7dc755a3fef74011"/>
+    <p:sldMasterId xmlns:r="http://schemas.openxmlformats.org/officeDocument/2006/relationships" id="2147483648" r:id="R73856d90906b41d9"/>
   </p:sldMasterIdLst>
   <p:notesMasterIdLst>
-    <p:notesMasterId xmlns:r="http://schemas.openxmlformats.org/officeDocument/2006/relationships" r:id="Re85c5cb634a64d95"/>
+    <p:notesMasterId xmlns:r="http://schemas.openxmlformats.org/officeDocument/2006/relationships" r:id="R54b9702192d247cf"/>
   </p:notesMasterIdLst>
   <p:sldIdLst>
-    <p:sldId xmlns:r="http://schemas.openxmlformats.org/officeDocument/2006/relationships" id="256" r:id="Re731f8f50442405e"/>
-    <p:sldId xmlns:r="http://schemas.openxmlformats.org/officeDocument/2006/relationships" id="257" r:id="R63596128885541cb"/>
-    <p:sldId xmlns:r="http://schemas.openxmlformats.org/officeDocument/2006/relationships" id="258" r:id="R7915a60454ca4a95"/>
-    <p:sldId xmlns:r="http://schemas.openxmlformats.org/officeDocument/2006/relationships" id="259" r:id="Ra03133b502de4998"/>
-    <p:sldId xmlns:r="http://schemas.openxmlformats.org/officeDocument/2006/relationships" id="260" r:id="R8da42096efe444db"/>
-    <p:sldId xmlns:r="http://schemas.openxmlformats.org/officeDocument/2006/relationships" id="261" r:id="R50c41bc27a53443b"/>
-    <p:sldId xmlns:r="http://schemas.openxmlformats.org/officeDocument/2006/relationships" id="262" r:id="R82e6d9b5e9a6439e"/>
-    <p:sldId xmlns:r="http://schemas.openxmlformats.org/officeDocument/2006/relationships" id="263" r:id="Rea54b8ed652643b8"/>
-    <p:sldId xmlns:r="http://schemas.openxmlformats.org/officeDocument/2006/relationships" id="264" r:id="R06d5521a8bc3466d"/>
-    <p:sldId xmlns:r="http://schemas.openxmlformats.org/officeDocument/2006/relationships" id="265" r:id="Ra8c2e38477d744cb"/>
+    <p:sldId xmlns:r="http://schemas.openxmlformats.org/officeDocument/2006/relationships" id="256" r:id="Ra285e6301c924c84"/>
+    <p:sldId xmlns:r="http://schemas.openxmlformats.org/officeDocument/2006/relationships" id="257" r:id="R9941da905a534afe"/>
+    <p:sldId xmlns:r="http://schemas.openxmlformats.org/officeDocument/2006/relationships" id="258" r:id="R8f9a7a60b2b541d6"/>
+    <p:sldId xmlns:r="http://schemas.openxmlformats.org/officeDocument/2006/relationships" id="259" r:id="Rc4bce602d42c4efa"/>
+    <p:sldId xmlns:r="http://schemas.openxmlformats.org/officeDocument/2006/relationships" id="260" r:id="R899ec0b2b1f94e1b"/>
+    <p:sldId xmlns:r="http://schemas.openxmlformats.org/officeDocument/2006/relationships" id="261" r:id="Ra48130be618b44c1"/>
+    <p:sldId xmlns:r="http://schemas.openxmlformats.org/officeDocument/2006/relationships" id="262" r:id="R2592338b480645a3"/>
+    <p:sldId xmlns:r="http://schemas.openxmlformats.org/officeDocument/2006/relationships" id="263" r:id="R13552c05b65a45cb"/>
+    <p:sldId xmlns:r="http://schemas.openxmlformats.org/officeDocument/2006/relationships" id="264" r:id="R07f9504d3b60407e"/>
+    <p:sldId xmlns:r="http://schemas.openxmlformats.org/officeDocument/2006/relationships" id="265" r:id="R52e3cd138186474b"/>
   </p:sldIdLst>
   <p:sldSz cx="12192000" cy="6858000"/>
   <p:notesSz cx="6858000" cy="9144000"/>
@@ -451,7 +451,7 @@
           <a:lstStyle xmlns:a="http://schemas.openxmlformats.org/drawingml/2006/main"/>
           <a:p xmlns:a="http://schemas.openxmlformats.org/drawingml/2006/main">
             <a:r>
-              <a:t>Opening: Spottr is an implemented native bodyweight workout prototype. The motivation is short, timely feedback with an explicit evidence boundary, not a clinical or physical-capacity claim. The image is an actual iPhone simulator screenshot approved by the owner, with missing/unearned progress shown honestly. Evidence snapshot 24 October 2026, 20:55 UTC. Sources: /Users/scsoc/dev/AI PT/docs/app-guide.md; /Users/scsoc/dev/AI PT/docs/integration-readiness.md. Asset source and SHA256 are in presentation/source/assets.json.</a:t>
+              <a:t>Opening: Spottr is an implemented native bodyweight workout prototype. The motivation is short, timely feedback with an explicit evidence boundary, not a clinical or physical-capacity claim. The image is an actual iPhone simulator screenshot approved by the owner, with missing/unearned progress shown honestly. Evidence snapshot 24 October 2026, 23:11 UTC (25 October locally). Sources: /Users/scsoc/dev/AI PT/docs/app-guide.md; /Users/scsoc/dev/AI PT/docs/integration-readiness.md. Asset source and SHA256 are in presentation/source/assets.json.</a:t>
             </a:r>
           </a:p>
         </p:txBody>
@@ -521,7 +521,7 @@
           <a:lstStyle xmlns:a="http://schemas.openxmlformats.org/drawingml/2006/main"/>
           <a:p xmlns:a="http://schemas.openxmlformats.org/drawingml/2006/main">
             <a:r>
-              <a:t>Evidence snapshot 24 October 2026, 20:55 UTC. This is a suggested rehearsal sequence, not an assertion that a rehearsal occurred. Use normal history safely. Open current Today/profile, then tracked workout, pause/end and source-aware record, Skills and explicit Coach controls. If fixtures or a simulator supply values, label them and do not call them live physiological data. Do not spend provider credits as part of rehearsal without the existing approved scope. Show the saved public-data benchmark as offline. App Store profiles/record exist but no archive/export/upload/TestFlight acceptance. MediaPipe vendor packaging needs validation. Sources: /Users/scsoc/dev/AI PT/docs/app-guide.md; /Users/scsoc/dev/AI PT/docs/integration-readiness.md; /Users/scsoc/dev/AI PT/docs/release-readiness.md; /Users/scsoc/dev/AI PT/docs/testflight-provisioning.md.</a:t>
+              <a:t>Evidence snapshot 24 October 2026, 23:11 UTC (25 October locally). This is a suggested rehearsal sequence, not an assertion that a rehearsal occurred. Use normal history safely. Open current Today/profile, then tracked workout, pause/end and source-aware record, Skills and explicit Coach controls. If fixtures or a simulator supply values, label them and do not call them live physiological data. Do not spend provider credits as part of rehearsal without the existing approved scope. Show the saved public-data benchmark as offline. Build 0.1 (1) passed Apple validation/upload, is VALID and internally IN_BETA_TESTING. External build 1 remains WAITING_FOR_BETA_REVIEW and its 25-person invitation is not yet a usable external download. Build 0.1 (2), source b7bf563, passed signed archive/export and Apple validation at 23:06:21 UTC; upload succeeded at 23:08:00 UTC. At 23:10:33 UTC App Store Connect reported VALID and internal IN_BETA_TESTING after assignment to the existing Spottr Internal group. Both builds are internal. Build 2 remains READY_FOR_BETA_SUBMISSION and is not submitted externally; only build 1 is assigned to the external OxHack group. The configured discomfort fix and manual-set wording are after build 1 and are included in build 2, not the already available build 1. The unresolved MediaPipe upstream privacy/origin-signature gap is separate from successful Apple processing; no physical installation or public App Store approval is claimed. Sources: /Users/scsoc/dev/AI PT/docs/evidence/testflight-build-2-2026-10-24.md; /Users/scsoc/dev/AI PT/docs/testflight.md; /Users/scsoc/dev/AI PT/docs/app-guide.md; /Users/scsoc/dev/AI PT/docs/integration-readiness.md; /Users/scsoc/dev/AI PT/docs/release-readiness.md; /Users/scsoc/dev/AI PT/docs/testflight-provisioning.md.</a:t>
             </a:r>
           </a:p>
         </p:txBody>
@@ -591,7 +591,7 @@
           <a:lstStyle xmlns:a="http://schemas.openxmlformats.org/drawingml/2006/main"/>
           <a:p xmlns:a="http://schemas.openxmlformats.org/drawingml/2006/main">
             <a:r>
-              <a:t>Evidence snapshot 24 October 2026, 20:55 UTC. Implemented native flow, not a measured rep-accuracy claim. Manual/timed workouts work without cloud credentials. A real camera path exists for push-ups and squats; physical accuracy/error/abstention evaluation remains pending. Local speech is opt-in, fake-playback tested, with audible phone acceptance pending. Sources: /Users/scsoc/dev/AI PT/docs/app-guide.md; /Users/scsoc/dev/AI PT/docs/voice-feedback.md; /Users/scsoc/dev/AI PT/docs/integration-readiness.md.</a:t>
+              <a:t>Evidence snapshot 24 October 2026, 23:11 UTC (25 October locally). Implemented native flow, not a measured rep-accuracy claim. Manual/timed workouts work without cloud credentials. A real camera path exists for push-ups and squats; physical accuracy/error/abstention evaluation remains pending. Local speech is opt-in, fake-playback tested, with audible phone acceptance pending. Sources: /Users/scsoc/dev/AI PT/docs/app-guide.md; /Users/scsoc/dev/AI PT/docs/voice-feedback.md; /Users/scsoc/dev/AI PT/docs/integration-readiness.md.</a:t>
             </a:r>
           </a:p>
         </p:txBody>
@@ -661,7 +661,7 @@
           <a:lstStyle xmlns:a="http://schemas.openxmlformats.org/drawingml/2006/main"/>
           <a:p xmlns:a="http://schemas.openxmlformats.org/drawingml/2006/main">
             <a:r>
-              <a:t>Evidence snapshot 24 October 2026, 20:55 UTC. Editable architecture. Phone owns MediaPipe inference, session state and deterministic policy. Watch adapter forwards latest-value timestamped heart/motion signals, not raw lossless vectors. Simulator transport/visual evidence and unsigned device compilation are separate from physical Watch recording. Pi real HTTPS pairing/start/frame/stop tests succeeded, then USB disconnected after around two seconds. No Pi inference or sustained capture is claimed. Sources: /Users/scsoc/dev/AI PT/docs/watch-telemetry.md; /Users/scsoc/dev/AI PT/docs/watch-simulator-acceptance.md; /Users/scsoc/dev/AI PT/hardware/pi/EVIDENCE-2026-10-24.md; /Users/scsoc/dev/AI PT/hardware/pi/NATIVE-HANDOFF.md.</a:t>
+              <a:t>Evidence snapshot 24 October 2026, 23:11 UTC (25 October locally). Editable architecture. Phone owns MediaPipe inference, session state and deterministic policy. Watch adapter forwards latest-value timestamped heart/motion signals, not raw lossless vectors. Simulator transport/visual evidence and unsigned device compilation are separate from physical Watch recording. Pi real HTTPS pairing/start/frame/stop tests succeeded, then USB disconnected after around two seconds. No Pi inference or sustained capture is claimed. Sources: /Users/scsoc/dev/AI PT/docs/watch-telemetry.md; /Users/scsoc/dev/AI PT/docs/watch-simulator-acceptance.md; /Users/scsoc/dev/AI PT/hardware/pi/EVIDENCE-2026-10-24.md; /Users/scsoc/dev/AI PT/hardware/pi/NATIVE-HANDOFF.md.</a:t>
             </a:r>
           </a:p>
         </p:txBody>
@@ -731,7 +731,7 @@
           <a:lstStyle xmlns:a="http://schemas.openxmlformats.org/drawingml/2006/main"/>
           <a:p xmlns:a="http://schemas.openxmlformats.org/drawingml/2006/main">
             <a:r>
-              <a:t>Evidence snapshot 24 October 2026, 20:55 UTC. These are deterministic implementation rules, not calibrated physiological thresholds or a measurement of rep-count accuracy. RepCounter requires confidence&gt;=0.6 and a complete top-bottom-top cycle, resets on gaps&gt;0.75s or nonmonotonic time, uses0.15s zone stability and accepts0.6–15s cycle duration. CoachingPolicy compares a new valid rep with at least five prior valid durations using mean+max(sampleSD,0.25s). Discomfort stops coaching; lifecycle invalidation prevents old cues/sensor callbacks entering a new state. Sources: /Users/scsoc/dev/AI PT/Shared/Core/RepCounter.swift; /Users/scsoc/dev/AI PT/Shared/Core/CoachingPolicy.swift; /Users/scsoc/dev/AI PT/docs/watch-telemetry.md; /Users/scsoc/dev/AI PT/docs/voice-feedback.md. Phase images are existing illustrations, not captured workout evidence.</a:t>
+              <a:t>Evidence snapshot 24 October 2026, 23:11 UTC (25 October locally). These are deterministic implementation rules, not calibrated physiological thresholds or a measurement of rep-count accuracy. RepCounter requires confidence&gt;=0.6 and a complete top-bottom-top cycle, resets on gaps&gt;0.75s or nonmonotonic time, uses0.15s zone stability and accepts0.6–15s cycle duration. CoachingPolicy compares a new valid rep with at least five prior valid durations using mean+max(sampleSD,0.25s). Reported discomfort has an exercise-independent stop decision, including manual reps and holds. PR #64 passed 23 native checks, 26 core checks and a Watch simulator build; fake playback does not establish audible acceptance. Stop identity persists across ticks; repeated stop does not cut itself off or replay after background return. Lifecycle invalidation prevents old cues/sensor callbacks entering a new state. Sources: /Users/scsoc/dev/AI PT/Shared/Core/RepCounter.swift; /Users/scsoc/dev/AI PT/Shared/Core/CoachingPolicy.swift; /Users/scsoc/dev/AI PT/docs/watch-telemetry.md; /Users/scsoc/dev/AI PT/docs/voice-feedback.md. Phase images are existing illustrations, not captured workout evidence.</a:t>
             </a:r>
           </a:p>
         </p:txBody>
@@ -801,7 +801,7 @@
           <a:lstStyle xmlns:a="http://schemas.openxmlformats.org/drawingml/2006/main"/>
           <a:p xmlns:a="http://schemas.openxmlformats.org/drawingml/2006/main">
             <a:r>
-              <a:t>Evidence snapshot 24 October 2026, 20:55 UTC. The current app has19 catalogue entries and connected tree/linear options. This diagram shows the exact immediate prerequisite example for pushup: kneePushup and plank. Earlier prerequisites of those nodes are omitted. Node completion needs three qualifying sets across two days after all immediate prerequisites complete. Manual/camera evidence can qualify; video replay and discomfort stops do not. Game points are not physical capacity. Sources: /Users/scsoc/dev/AI PT/Shared/Core/SkillProgress.swift; /Users/scsoc/dev/AI PT/Shared/Core/ExerciseCatalog.swift; /Users/scsoc/dev/AI PT/Native/iOS/SkillsViews.swift; /Users/scsoc/dev/AI PT/docs/app-guide.md. Exercise artwork is existing PNG content, with source hashes in assets.json.</a:t>
+              <a:t>Evidence snapshot 24 October 2026, 23:11 UTC (25 October locally). The current app has19 catalogue entries and connected tree/linear options. This diagram shows the exact immediate prerequisite example for pushup: kneePushup and plank. Earlier prerequisites of those nodes are omitted. Node completion needs three qualifying sets across two days after all immediate prerequisites complete. Manual/camera evidence can qualify; video replay and discomfort stops do not. Game points are not physical capacity. Sources: /Users/scsoc/dev/AI PT/Shared/Core/SkillProgress.swift; /Users/scsoc/dev/AI PT/Shared/Core/ExerciseCatalog.swift; /Users/scsoc/dev/AI PT/Native/iOS/SkillsViews.swift; /Users/scsoc/dev/AI PT/docs/app-guide.md. Exercise artwork is existing PNG content, with source hashes in assets.json.</a:t>
             </a:r>
           </a:p>
         </p:txBody>
@@ -871,7 +871,7 @@
           <a:lstStyle xmlns:a="http://schemas.openxmlformats.org/drawingml/2006/main"/>
           <a:p xmlns:a="http://schemas.openxmlformats.org/drawingml/2006/main">
             <a:r>
-              <a:t>Evidence snapshot 24 October 2026, 20:55 UTC. Local gateway returned actual200 responses for chat/session/weekly/proposal using synthetic inputs. Native UI/contract tests use doubles and do not establish native network-to-provider acceptance. Automatic facts include selected goals and weekly target, omit optional name, and retain sources. Schema/evidence validation rejects missing/unknown fact IDs; generation identity rejects late context. Plans require explicit user selection/approval and proposed targets never count as completed work. No raw camera video or sensor stream is automatically supplied here. Sources: /Users/scsoc/dev/AI PT/docs/coach-goals.md; /Users/scsoc/dev/AI PT/Shared/Core/CoachContracts.swift; /Users/scsoc/dev/AI PT/Shared/Core/CoachGrounding.swift; /Users/scsoc/dev/AI PT/docs/integration-readiness.md.</a:t>
+              <a:t>Evidence snapshot 24 October 2026, 23:11 UTC (25 October locally). Local gateway returned actual200 responses for chat/session/weekly/proposal using synthetic inputs. Two signed-simulator native chats reached Google. The second accepted the server-owned capability context: base push-ups and squats support camera tracking; other rep exercises use manual logging and seconds exercises use an active hold timer. Native live proposals/reports, physical phone networking and personal factual review remain pending. Separate native fixture checks exercise structured-response display without a provider call. Automatic facts include selected goals and weekly target, omit optional name, and retain sources. Schema/evidence validation rejects missing/unknown fact IDs; generation identity rejects late context. Plans require explicit user selection/approval and proposed targets never count as completed work. No raw camera video or sensor stream is automatically supplied here. Sources: /Users/scsoc/dev/AI PT/docs/evidence/native-gemini-chat-2026-10-24.md; /Users/scsoc/dev/AI PT/docs/coach-goals.md; /Users/scsoc/dev/AI PT/Shared/Core/CoachContracts.swift; /Users/scsoc/dev/AI PT/Shared/Core/CoachGrounding.swift; /Users/scsoc/dev/AI PT/docs/integration-readiness.md.</a:t>
             </a:r>
           </a:p>
         </p:txBody>
@@ -941,7 +941,7 @@
           <a:lstStyle xmlns:a="http://schemas.openxmlformats.org/drawingml/2006/main"/>
           <a:p xmlns:a="http://schemas.openxmlformats.org/drawingml/2006/main">
             <a:r>
-              <a:t>Evidence snapshot 24 October 2026, 20:55 UTC. These are intended integration roles, not live database usage. Tiger service exists but strict TLS fails SELF_SIGNED_CERT_IN_CHAIN with current private CA endpoint, so no live query/migration/persistence is accepted. Snowflake SQL API check exists with doubles; no actual SQL statement/result accepted. Local history and explicit optional sync remain distinct. Sources: /Users/scsoc/dev/AI PT/docs/integration-readiness.md; /Users/scsoc/dev/AI PT/docs/tiger-live-readiness.md; /Users/scsoc/dev/AI PT/docs/ISSUES.md; /Users/scsoc/dev/AI PT/docs/personal-learning.md.</a:t>
+              <a:t>Evidence snapshot 24 October 2026, 23:11 UTC (25 October locally). These implemented adapters have offline acceptance, not live database usage. Operational Tiger storage and Snowflake retrospective public-data evaluation are separate. Tiger service exists but strict TLS fails SELF_SIGNED_CERT_IN_CHAIN with current private CA endpoint, so no live query/migration/persistence is accepted. Snowflake pinned public PAMAP2 import/reconciliation and bounded SQL transport are tested offline; dry-run is default and live public-data execution requires explicit opt-in. No actual warehouse statement/result is accepted. Local history and explicit optional sync remain distinct. Sources: /Users/scsoc/dev/AI PT/docs/integration-readiness.md; /Users/scsoc/dev/AI PT/docs/tiger-live-readiness.md; /Users/scsoc/dev/AI PT/docs/ISSUES.md; /Users/scsoc/dev/AI PT/docs/personal-learning.md.</a:t>
             </a:r>
           </a:p>
         </p:txBody>
@@ -1011,7 +1011,7 @@
           <a:lstStyle xmlns:a="http://schemas.openxmlformats.org/drawingml/2006/main"/>
           <a:p xmlns:a="http://schemas.openxmlformats.org/drawingml/2006/main">
             <a:r>
-              <a:t>Evidence snapshot 24 October 2026, 20:55 UTC. Actual offline PAMAP2 run2026-10-24T20:43:51–20:43:59UTC. Source: Reiss,A.(2012), PAMAP2 Physical Activity Monitoring, UCI DOI10.24432/C5NW2H, CC BY4.0. Changes: causal features/ridge/figures/evaluation. Official source https://archive.ics.uci.edu/dataset/231/pamap2+physical+activity+monitoring. Train101–105,validation106–107,test108–109. Future target: mean of five observed1s HR-bin means ending10/30s after origin; input history60s. No interpolation, future covariates or test normalization. Validation selected HR-only ridge alpha0.1, not wrist candidates. Test108:80310s and79930s forecasts. Test109:only410s and030s forecasts from84.76s recording. Macro10s gives both participants equal weight despite tiny109 count. At30s only108 contributes. Fixed prequential bias adapter worsened full-run error. No calibrated intervals, Watch transfer, recovery, failure/RIR prediction, or app integration.13 contract tests pass. Sources: /Users/scsoc/dev/AI PT/research/hr_forecast/protocol.json; /Users/scsoc/dev/AI PT/research/hr_forecast/results/report.json; /Users/scsoc/dev/AI PT/research/hr_forecast/results/inventory.json; /Users/scsoc/dev/AI PT/docs/public-data-benchmark.md. Original plots copied unchanged into presentation/assets/ for supplementary evidence. Native chart values round the recorded metrics to three decimal places for editable workbook compatibility.</a:t>
+              <a:t>Evidence snapshot 24 October 2026, 23:11 UTC (25 October locally). Actual offline PAMAP2 run2026-10-24T20:43:51–20:43:59UTC. Source: Reiss,A.(2012), PAMAP2 Physical Activity Monitoring, UCI DOI10.24432/C5NW2H, CC BY4.0. Changes: causal features/ridge/figures/evaluation. Official source https://archive.ics.uci.edu/dataset/231/pamap2+physical+activity+monitoring. Train101–105,validation106–107,test108–109. Future target: mean of five observed1s HR-bin means ending10/30s after origin; input history60s. No interpolation, future covariates or test normalization. Validation selected HR-only ridge alpha0.1, not wrist candidates. Test108:80310s and79930s forecasts. Test109:only410s and030s forecasts from84.76s recording. Macro10s gives both participants equal weight despite tiny109 count. At30s only108 contributes. Fixed prequential bias adapter worsened full-run error. No calibrated intervals, Watch transfer, recovery, failure/RIR prediction, or app integration.13 contract tests pass. Sources: /Users/scsoc/dev/AI PT/research/hr_forecast/protocol.json; /Users/scsoc/dev/AI PT/research/hr_forecast/results/report.json; /Users/scsoc/dev/AI PT/research/hr_forecast/results/inventory.json; /Users/scsoc/dev/AI PT/docs/public-data-benchmark.md. Original plots copied unchanged into presentation/assets/ for supplementary evidence. Native chart values round the recorded metrics to three decimal places for editable workbook compatibility.</a:t>
             </a:r>
           </a:p>
         </p:txBody>
@@ -1081,7 +1081,7 @@
           <a:lstStyle xmlns:a="http://schemas.openxmlformats.org/drawingml/2006/main"/>
           <a:p xmlns:a="http://schemas.openxmlformats.org/drawingml/2006/main">
             <a:r>
-              <a:t>Evidence snapshot 24 October 2026, 20:55 UTC. This table summarizes implementation/fixture/live distinctions. Never claim all sponsors/providers were used. Gemini actual synthetic provider responses are separate from native acceptance. Voice local Apple synthesis is implemented with fake playback tests; no audible/ElevenLabs run. Tiger current endpoint/private CA chain unresolved, no trust bypass. Snowflake keys/actual statement absent; Vultr no VM/credit/spend scope; Presage automatic derived-vitals egress unresolved; Delta zero judge requests and missing installation/legal operator gate. Sources: /Users/scsoc/dev/AI PT/docs/integration-readiness.md; /Users/scsoc/dev/AI PT/docs/ISSUES.md; /Users/scsoc/dev/AI PT/docs/voice-feedback.md; /Users/scsoc/dev/AI PT/docs/presage-integration.md; /Users/scsoc/dev/AI PT/docs/delta-workflow.md; /Users/scsoc/dev/AI PT/docs/tiger-live-readiness.md.</a:t>
+              <a:t>Evidence snapshot 24 October 2026, 23:11 UTC (25 October locally). This table summarizes implementation/fixture/live distinctions. Never claim all sponsors/providers were used. Gemini has four actual synthetic gateway response types and two signed-simulator native chat checks; physical networking and native structured-output acceptance remain pending. Voice local Apple synthesis is implemented with fake playback tests; no audible/ElevenLabs run. Tiger current endpoint/private CA chain unresolved, no trust bypass. Snowflake pinned batch workflow and local ARM64 gateway/Caddy runtime checks passed; no Snowflake live statement or Vultr VM/credit/spend scope; Presage automatic derived-vitals egress unresolved; Delta zero judge requests and missing installation/legal operator gate. Sources: /Users/scsoc/dev/AI PT/docs/evidence/pushup-prototype-integrity-2026-10-24.md; /Users/scsoc/dev/AI PT/docs/snowflake-analytics.md; /Users/scsoc/dev/AI PT/docs/vultr-deployment.md; /Users/scsoc/dev/AI PT/docs/integration-readiness.md; /Users/scsoc/dev/AI PT/docs/ISSUES.md; /Users/scsoc/dev/AI PT/docs/voice-feedback.md; /Users/scsoc/dev/AI PT/docs/presage-integration.md; /Users/scsoc/dev/AI PT/docs/delta-workflow.md; /Users/scsoc/dev/AI PT/docs/tiger-live-readiness.md.</a:t>
             </a:r>
           </a:p>
         </p:txBody>
@@ -1128,7 +1128,7 @@
           <p:cNvPr id="3" name="Title">
             <a:extLst xmlns:a="http://schemas.openxmlformats.org/drawingml/2006/main">
               <a:ext uri="{FF2B5EF4-FFF2-40B4-BE49-F238E27FC236}">
-                <a16:creationId xmlns:a16="http://schemas.microsoft.com/office/drawing/2014/main" id="{FE221120-F913-49A2-995C-EECDE01AC746}"/>
+                <a16:creationId xmlns:a16="http://schemas.microsoft.com/office/drawing/2014/main" id="{0FD2E04B-C8D2-4B43-8CC0-DAC897275919}"/>
               </a:ext>
             </a:extLst>
           </p:cNvPr>
@@ -1357,7 +1357,7 @@
           <p:cNvPr id="2" name="Subtitle">
             <a:extLst xmlns:a="http://schemas.openxmlformats.org/drawingml/2006/main">
               <a:ext uri="{FF2B5EF4-FFF2-40B4-BE49-F238E27FC236}">
-                <a16:creationId xmlns:a16="http://schemas.microsoft.com/office/drawing/2014/main" id="{5E753C4B-B156-404D-94B1-205E830CB615}"/>
+                <a16:creationId xmlns:a16="http://schemas.microsoft.com/office/drawing/2014/main" id="{BF8D96D4-D090-4E5A-831C-C6A7FFDE04E0}"/>
               </a:ext>
             </a:extLst>
           </p:cNvPr>
@@ -1603,7 +1603,7 @@
           <p:cNvPr id="2" name="Section title">
             <a:extLst xmlns:a="http://schemas.openxmlformats.org/drawingml/2006/main">
               <a:ext uri="{FF2B5EF4-FFF2-40B4-BE49-F238E27FC236}">
-                <a16:creationId xmlns:a16="http://schemas.microsoft.com/office/drawing/2014/main" id="{3EAA1C9B-F498-4AB4-A186-783B3F27CF6F}"/>
+                <a16:creationId xmlns:a16="http://schemas.microsoft.com/office/drawing/2014/main" id="{36B99A51-D159-4176-ADBC-6EC3999A1FAA}"/>
               </a:ext>
             </a:extLst>
           </p:cNvPr>
@@ -1849,7 +1849,7 @@
           <p:cNvPr id="3" name="Title">
             <a:extLst xmlns:a="http://schemas.openxmlformats.org/drawingml/2006/main">
               <a:ext uri="{FF2B5EF4-FFF2-40B4-BE49-F238E27FC236}">
-                <a16:creationId xmlns:a16="http://schemas.microsoft.com/office/drawing/2014/main" id="{AC6521A5-427F-4A50-951D-B70261E75419}"/>
+                <a16:creationId xmlns:a16="http://schemas.microsoft.com/office/drawing/2014/main" id="{AD21DAFF-302A-44F4-A9D0-0D529E2ADDFE}"/>
               </a:ext>
             </a:extLst>
           </p:cNvPr>
@@ -2078,7 +2078,7 @@
           <p:cNvPr id="2" name="Body">
             <a:extLst xmlns:a="http://schemas.openxmlformats.org/drawingml/2006/main">
               <a:ext uri="{FF2B5EF4-FFF2-40B4-BE49-F238E27FC236}">
-                <a16:creationId xmlns:a16="http://schemas.microsoft.com/office/drawing/2014/main" id="{125C9AD0-4110-48A7-A49D-96E8AAF1D9A2}"/>
+                <a16:creationId xmlns:a16="http://schemas.microsoft.com/office/drawing/2014/main" id="{01BDCFDC-E346-4EC8-B0CD-CF7E28458C97}"/>
               </a:ext>
             </a:extLst>
           </p:cNvPr>
@@ -2324,7 +2324,7 @@
           <p:cNvPr id="4" name="Title">
             <a:extLst xmlns:a="http://schemas.openxmlformats.org/drawingml/2006/main">
               <a:ext uri="{FF2B5EF4-FFF2-40B4-BE49-F238E27FC236}">
-                <a16:creationId xmlns:a16="http://schemas.microsoft.com/office/drawing/2014/main" id="{5BF38AAC-6BD8-41A1-A1C6-D9397EE705F9}"/>
+                <a16:creationId xmlns:a16="http://schemas.microsoft.com/office/drawing/2014/main" id="{E2E1B8FD-2D8D-4F0E-A508-331AA63CC5C5}"/>
               </a:ext>
             </a:extLst>
           </p:cNvPr>
@@ -2553,7 +2553,7 @@
           <p:cNvPr id="2" name="Left column">
             <a:extLst xmlns:a="http://schemas.openxmlformats.org/drawingml/2006/main">
               <a:ext uri="{FF2B5EF4-FFF2-40B4-BE49-F238E27FC236}">
-                <a16:creationId xmlns:a16="http://schemas.microsoft.com/office/drawing/2014/main" id="{DFE3395D-0245-48F1-8F4E-29019BC3C0DC}"/>
+                <a16:creationId xmlns:a16="http://schemas.microsoft.com/office/drawing/2014/main" id="{C3DFE2E4-7CFE-494C-B890-800B06F31738}"/>
               </a:ext>
             </a:extLst>
           </p:cNvPr>
@@ -2782,7 +2782,7 @@
           <p:cNvPr id="3" name="Right column">
             <a:extLst xmlns:a="http://schemas.openxmlformats.org/drawingml/2006/main">
               <a:ext uri="{FF2B5EF4-FFF2-40B4-BE49-F238E27FC236}">
-                <a16:creationId xmlns:a16="http://schemas.microsoft.com/office/drawing/2014/main" id="{D295E15B-A734-475A-86C1-D0E94AF5ED8F}"/>
+                <a16:creationId xmlns:a16="http://schemas.microsoft.com/office/drawing/2014/main" id="{1BF72B14-AEBC-4B92-B6A0-5A0F3304556D}"/>
               </a:ext>
             </a:extLst>
           </p:cNvPr>
@@ -3028,7 +3028,7 @@
           <p:cNvPr id="3" name="Title">
             <a:extLst xmlns:a="http://schemas.openxmlformats.org/drawingml/2006/main">
               <a:ext uri="{FF2B5EF4-FFF2-40B4-BE49-F238E27FC236}">
-                <a16:creationId xmlns:a16="http://schemas.microsoft.com/office/drawing/2014/main" id="{1953DB2C-E37D-43CE-9755-ABEF9892BF9C}"/>
+                <a16:creationId xmlns:a16="http://schemas.microsoft.com/office/drawing/2014/main" id="{8EC1E5D9-4C8B-49AB-848D-1455C626FC2B}"/>
               </a:ext>
             </a:extLst>
           </p:cNvPr>
@@ -3257,7 +3257,7 @@
           <p:cNvPr id="2" name="Left column">
             <a:extLst xmlns:a="http://schemas.openxmlformats.org/drawingml/2006/main">
               <a:ext uri="{FF2B5EF4-FFF2-40B4-BE49-F238E27FC236}">
-                <a16:creationId xmlns:a16="http://schemas.microsoft.com/office/drawing/2014/main" id="{A649C46E-B98E-4B33-904A-155AAC84E220}"/>
+                <a16:creationId xmlns:a16="http://schemas.microsoft.com/office/drawing/2014/main" id="{8E2B016D-FB1A-4606-B420-F3D865D67C28}"/>
               </a:ext>
             </a:extLst>
           </p:cNvPr>
@@ -3524,12 +3524,12 @@
   </p:cSld>
   <p:clrMap bg1="lt1" tx1="dk1" bg2="lt2" tx2="dk2" accent1="accent1" accent2="accent2" accent3="accent3" accent4="accent4" accent5="accent5" accent6="accent6" hlink="hlink" folHlink="folHlink"/>
   <p:sldLayoutIdLst>
-    <p:sldLayoutId xmlns:r="http://schemas.openxmlformats.org/officeDocument/2006/relationships" id="2147483649" r:id="Re6a7fd91120a4724"/>
-    <p:sldLayoutId xmlns:r="http://schemas.openxmlformats.org/officeDocument/2006/relationships" id="2147483650" r:id="R09becedaaa304494"/>
-    <p:sldLayoutId xmlns:r="http://schemas.openxmlformats.org/officeDocument/2006/relationships" id="2147483651" r:id="R2f8d1e4e337e4707"/>
-    <p:sldLayoutId xmlns:r="http://schemas.openxmlformats.org/officeDocument/2006/relationships" id="2147483652" r:id="R738d1c0d8c944cc7"/>
-    <p:sldLayoutId xmlns:r="http://schemas.openxmlformats.org/officeDocument/2006/relationships" id="2147483653" r:id="R667ca6bda69c4e42"/>
-    <p:sldLayoutId xmlns:r="http://schemas.openxmlformats.org/officeDocument/2006/relationships" id="2147483654" r:id="Rd87e0b6836d9431c"/>
+    <p:sldLayoutId xmlns:r="http://schemas.openxmlformats.org/officeDocument/2006/relationships" id="2147483649" r:id="R8bc79d273e39421f"/>
+    <p:sldLayoutId xmlns:r="http://schemas.openxmlformats.org/officeDocument/2006/relationships" id="2147483650" r:id="R98d65baf0f2d46bb"/>
+    <p:sldLayoutId xmlns:r="http://schemas.openxmlformats.org/officeDocument/2006/relationships" id="2147483651" r:id="R781484734593441c"/>
+    <p:sldLayoutId xmlns:r="http://schemas.openxmlformats.org/officeDocument/2006/relationships" id="2147483652" r:id="R74be7b5a1de243ec"/>
+    <p:sldLayoutId xmlns:r="http://schemas.openxmlformats.org/officeDocument/2006/relationships" id="2147483653" r:id="R2bef9b5e8bb64076"/>
+    <p:sldLayoutId xmlns:r="http://schemas.openxmlformats.org/officeDocument/2006/relationships" id="2147483654" r:id="R8deca65135ef4244"/>
   </p:sldLayoutIdLst>
   <p:txStyles>
     <p:titleStyle>
@@ -4403,7 +4403,7 @@
           <p:cNvPr id="7" name="text-1">
             <a:extLst xmlns:a="http://schemas.openxmlformats.org/drawingml/2006/main">
               <a:ext uri="{FF2B5EF4-FFF2-40B4-BE49-F238E27FC236}">
-                <a16:creationId xmlns:a16="http://schemas.microsoft.com/office/drawing/2014/main" id="{00941176-A178-4F6E-8F6E-68BD2AD09258}"/>
+                <a16:creationId xmlns:a16="http://schemas.microsoft.com/office/drawing/2014/main" id="{72700AA0-2983-4CBA-B5AF-0DA5C7286A34}"/>
               </a:ext>
             </a:extLst>
           </p:cNvPr>
@@ -4561,7 +4561,7 @@
           <p:cNvPr id="2" name="text-2">
             <a:extLst xmlns:a="http://schemas.openxmlformats.org/drawingml/2006/main">
               <a:ext uri="{FF2B5EF4-FFF2-40B4-BE49-F238E27FC236}">
-                <a16:creationId xmlns:a16="http://schemas.microsoft.com/office/drawing/2014/main" id="{AAEF2F00-35B4-4AD2-9DD3-895B945426BD}"/>
+                <a16:creationId xmlns:a16="http://schemas.microsoft.com/office/drawing/2014/main" id="{4B4B8753-4F2B-4EF3-B107-5696B9F4AE1F}"/>
               </a:ext>
             </a:extLst>
           </p:cNvPr>
@@ -4742,7 +4742,7 @@
           <p:cNvPr id="3" name="text-3">
             <a:extLst xmlns:a="http://schemas.openxmlformats.org/drawingml/2006/main">
               <a:ext uri="{FF2B5EF4-FFF2-40B4-BE49-F238E27FC236}">
-                <a16:creationId xmlns:a16="http://schemas.microsoft.com/office/drawing/2014/main" id="{0037456B-BB99-4FE4-A6B7-84A26EB05667}"/>
+                <a16:creationId xmlns:a16="http://schemas.microsoft.com/office/drawing/2014/main" id="{7CCDEC46-F61B-4911-97B4-858479A9EFCA}"/>
               </a:ext>
             </a:extLst>
           </p:cNvPr>
@@ -4923,7 +4923,7 @@
           <p:cNvPr id="4" name="text-4">
             <a:extLst xmlns:a="http://schemas.openxmlformats.org/drawingml/2006/main">
               <a:ext uri="{FF2B5EF4-FFF2-40B4-BE49-F238E27FC236}">
-                <a16:creationId xmlns:a16="http://schemas.microsoft.com/office/drawing/2014/main" id="{B0DADC92-C137-4159-B23B-2E49F6F7914A}"/>
+                <a16:creationId xmlns:a16="http://schemas.microsoft.com/office/drawing/2014/main" id="{1D57976C-6C9D-414C-B746-CA176A266525}"/>
               </a:ext>
             </a:extLst>
           </p:cNvPr>
@@ -5081,7 +5081,7 @@
           <p:cNvPr id="5" name="">
             <a:extLst xmlns:a="http://schemas.openxmlformats.org/drawingml/2006/main">
               <a:ext uri="{FF2B5EF4-FFF2-40B4-BE49-F238E27FC236}">
-                <a16:creationId xmlns:a16="http://schemas.microsoft.com/office/drawing/2014/main" id="{314F2718-0E75-4E9B-B53A-C6AD718EB195}"/>
+                <a16:creationId xmlns:a16="http://schemas.microsoft.com/office/drawing/2014/main" id="{E308BBC5-3233-405C-8701-8FAD13FF044F}"/>
               </a:ext>
             </a:extLst>
           </p:cNvPr>
@@ -5091,7 +5091,7 @@
           <p:nvPr/>
         </p:nvPicPr>
         <p:blipFill>
-          <a:blip xmlns:r="http://schemas.openxmlformats.org/officeDocument/2006/relationships" xmlns:a="http://schemas.openxmlformats.org/drawingml/2006/main" r:embed="R964cc32164ba419c"/>
+          <a:blip xmlns:r="http://schemas.openxmlformats.org/officeDocument/2006/relationships" xmlns:a="http://schemas.openxmlformats.org/drawingml/2006/main" r:embed="R94acd0e96e7f48db"/>
           <a:stretch xmlns:a="http://schemas.openxmlformats.org/drawingml/2006/main"/>
         </p:blipFill>
         <p:spPr>
@@ -5109,7 +5109,7 @@
           <p:cNvPr id="6" name="text-5">
             <a:extLst xmlns:a="http://schemas.openxmlformats.org/drawingml/2006/main">
               <a:ext uri="{FF2B5EF4-FFF2-40B4-BE49-F238E27FC236}">
-                <a16:creationId xmlns:a16="http://schemas.microsoft.com/office/drawing/2014/main" id="{62B99CD7-D10C-41A8-9B58-16C82755AFF1}"/>
+                <a16:creationId xmlns:a16="http://schemas.microsoft.com/office/drawing/2014/main" id="{843FCCE9-F014-4934-B818-64A921122D47}"/>
               </a:ext>
             </a:extLst>
           </p:cNvPr>
@@ -5265,7 +5265,7 @@
     </p:spTree>
     <p:extLst>
       <p:ext uri="{BB962C8B-B14F-4D97-AF65-F5344CB8AC3E}">
-        <p14:creationId xmlns:p14="http://schemas.microsoft.com/office/powerpoint/2010/main" val="1189363404"/>
+        <p14:creationId xmlns:p14="http://schemas.microsoft.com/office/powerpoint/2010/main" val="1049942259"/>
       </p:ext>
     </p:extLst>
   </p:cSld>
@@ -5296,7 +5296,7 @@
           <p:cNvPr id="19" name="text-87">
             <a:extLst xmlns:a="http://schemas.openxmlformats.org/drawingml/2006/main">
               <a:ext uri="{FF2B5EF4-FFF2-40B4-BE49-F238E27FC236}">
-                <a16:creationId xmlns:a16="http://schemas.microsoft.com/office/drawing/2014/main" id="{8B2D284D-19B8-4839-B984-5E819BB05906}"/>
+                <a16:creationId xmlns:a16="http://schemas.microsoft.com/office/drawing/2014/main" id="{BCFC194E-F60D-4064-9DA1-7E62B902C104}"/>
               </a:ext>
             </a:extLst>
           </p:cNvPr>
@@ -5454,7 +5454,7 @@
           <p:cNvPr id="2" name="text-88">
             <a:extLst xmlns:a="http://schemas.openxmlformats.org/drawingml/2006/main">
               <a:ext uri="{FF2B5EF4-FFF2-40B4-BE49-F238E27FC236}">
-                <a16:creationId xmlns:a16="http://schemas.microsoft.com/office/drawing/2014/main" id="{227D46C6-E43D-488B-88B6-333751E36818}"/>
+                <a16:creationId xmlns:a16="http://schemas.microsoft.com/office/drawing/2014/main" id="{722C12CC-4E5D-4923-923C-6A2990D54A38}"/>
               </a:ext>
             </a:extLst>
           </p:cNvPr>
@@ -5612,7 +5612,7 @@
           <p:cNvPr id="3" name="text-89">
             <a:extLst xmlns:a="http://schemas.openxmlformats.org/drawingml/2006/main">
               <a:ext uri="{FF2B5EF4-FFF2-40B4-BE49-F238E27FC236}">
-                <a16:creationId xmlns:a16="http://schemas.microsoft.com/office/drawing/2014/main" id="{B7CF5289-01DE-49BF-BE7B-CDF811EDA004}"/>
+                <a16:creationId xmlns:a16="http://schemas.microsoft.com/office/drawing/2014/main" id="{4CCEC1DA-375F-4BC2-91BA-790F53B14AAC}"/>
               </a:ext>
             </a:extLst>
           </p:cNvPr>
@@ -5770,7 +5770,7 @@
           <p:cNvPr id="4" name="text-90">
             <a:extLst xmlns:a="http://schemas.openxmlformats.org/drawingml/2006/main">
               <a:ext uri="{FF2B5EF4-FFF2-40B4-BE49-F238E27FC236}">
-                <a16:creationId xmlns:a16="http://schemas.microsoft.com/office/drawing/2014/main" id="{F1126E69-8675-4F8A-96D5-9AAC64CCB54E}"/>
+                <a16:creationId xmlns:a16="http://schemas.microsoft.com/office/drawing/2014/main" id="{48B39156-976B-4CD5-A815-1B7423F63091}"/>
               </a:ext>
             </a:extLst>
           </p:cNvPr>
@@ -5928,7 +5928,7 @@
           <p:cNvPr id="5" name="text-91">
             <a:extLst xmlns:a="http://schemas.openxmlformats.org/drawingml/2006/main">
               <a:ext uri="{FF2B5EF4-FFF2-40B4-BE49-F238E27FC236}">
-                <a16:creationId xmlns:a16="http://schemas.microsoft.com/office/drawing/2014/main" id="{CDFEEDE7-C799-4F68-83B5-E1A06CC3F156}"/>
+                <a16:creationId xmlns:a16="http://schemas.microsoft.com/office/drawing/2014/main" id="{658A0912-AA03-4EA2-BE02-32947C7D503A}"/>
               </a:ext>
             </a:extLst>
           </p:cNvPr>
@@ -6086,7 +6086,7 @@
           <p:cNvPr id="6" name="text-92">
             <a:extLst xmlns:a="http://schemas.openxmlformats.org/drawingml/2006/main">
               <a:ext uri="{FF2B5EF4-FFF2-40B4-BE49-F238E27FC236}">
-                <a16:creationId xmlns:a16="http://schemas.microsoft.com/office/drawing/2014/main" id="{CCA57B7C-DE45-42EE-8DBF-95EB769B245F}"/>
+                <a16:creationId xmlns:a16="http://schemas.microsoft.com/office/drawing/2014/main" id="{5E6C3121-F008-4835-BB85-2572A743AE53}"/>
               </a:ext>
             </a:extLst>
           </p:cNvPr>
@@ -6244,7 +6244,7 @@
           <p:cNvPr id="7" name="text-93">
             <a:extLst xmlns:a="http://schemas.openxmlformats.org/drawingml/2006/main">
               <a:ext uri="{FF2B5EF4-FFF2-40B4-BE49-F238E27FC236}">
-                <a16:creationId xmlns:a16="http://schemas.microsoft.com/office/drawing/2014/main" id="{B2CB3FCC-2D87-41AF-A011-758D997E63CC}"/>
+                <a16:creationId xmlns:a16="http://schemas.microsoft.com/office/drawing/2014/main" id="{BACBED4B-F1DA-40ED-88C8-1AEFB6D4922A}"/>
               </a:ext>
             </a:extLst>
           </p:cNvPr>
@@ -6402,7 +6402,7 @@
           <p:cNvPr id="8" name="text-94">
             <a:extLst xmlns:a="http://schemas.openxmlformats.org/drawingml/2006/main">
               <a:ext uri="{FF2B5EF4-FFF2-40B4-BE49-F238E27FC236}">
-                <a16:creationId xmlns:a16="http://schemas.microsoft.com/office/drawing/2014/main" id="{11CF8687-094F-4C62-A9A2-4CA8F31076D9}"/>
+                <a16:creationId xmlns:a16="http://schemas.microsoft.com/office/drawing/2014/main" id="{BAB247B1-08EE-4B06-A002-3A859C43C8BC}"/>
               </a:ext>
             </a:extLst>
           </p:cNvPr>
@@ -6560,7 +6560,7 @@
           <p:cNvPr id="9" name="text-95">
             <a:extLst xmlns:a="http://schemas.openxmlformats.org/drawingml/2006/main">
               <a:ext uri="{FF2B5EF4-FFF2-40B4-BE49-F238E27FC236}">
-                <a16:creationId xmlns:a16="http://schemas.microsoft.com/office/drawing/2014/main" id="{B57A081C-4795-4959-AB06-D8429B14309E}"/>
+                <a16:creationId xmlns:a16="http://schemas.microsoft.com/office/drawing/2014/main" id="{04A0BA92-DD24-4ECF-B0EE-14DC1CFF3A9D}"/>
               </a:ext>
             </a:extLst>
           </p:cNvPr>
@@ -6718,7 +6718,7 @@
           <p:cNvPr id="10" name="text-96">
             <a:extLst xmlns:a="http://schemas.openxmlformats.org/drawingml/2006/main">
               <a:ext uri="{FF2B5EF4-FFF2-40B4-BE49-F238E27FC236}">
-                <a16:creationId xmlns:a16="http://schemas.microsoft.com/office/drawing/2014/main" id="{2123AB7D-BBD6-4339-B648-46B13144D159}"/>
+                <a16:creationId xmlns:a16="http://schemas.microsoft.com/office/drawing/2014/main" id="{B04931F7-BE8A-4665-8142-371F10DE27E3}"/>
               </a:ext>
             </a:extLst>
           </p:cNvPr>
@@ -6876,7 +6876,7 @@
           <p:cNvPr id="11" name="text-97">
             <a:extLst xmlns:a="http://schemas.openxmlformats.org/drawingml/2006/main">
               <a:ext uri="{FF2B5EF4-FFF2-40B4-BE49-F238E27FC236}">
-                <a16:creationId xmlns:a16="http://schemas.microsoft.com/office/drawing/2014/main" id="{0C95BBCF-7E6C-4C8F-AA62-0BD8577259FC}"/>
+                <a16:creationId xmlns:a16="http://schemas.microsoft.com/office/drawing/2014/main" id="{FF4890F6-9CAB-45CD-B41C-276C5C088CE2}"/>
               </a:ext>
             </a:extLst>
           </p:cNvPr>
@@ -7034,7 +7034,7 @@
           <p:cNvPr id="12" name="text-98">
             <a:extLst xmlns:a="http://schemas.openxmlformats.org/drawingml/2006/main">
               <a:ext uri="{FF2B5EF4-FFF2-40B4-BE49-F238E27FC236}">
-                <a16:creationId xmlns:a16="http://schemas.microsoft.com/office/drawing/2014/main" id="{49CF3778-5F1B-46BF-BAC7-E900056339E3}"/>
+                <a16:creationId xmlns:a16="http://schemas.microsoft.com/office/drawing/2014/main" id="{8318A7C0-4A8D-45EB-B33D-AB92B347BCAF}"/>
               </a:ext>
             </a:extLst>
           </p:cNvPr>
@@ -7192,7 +7192,7 @@
           <p:cNvPr id="13" name="text-99">
             <a:extLst xmlns:a="http://schemas.openxmlformats.org/drawingml/2006/main">
               <a:ext uri="{FF2B5EF4-FFF2-40B4-BE49-F238E27FC236}">
-                <a16:creationId xmlns:a16="http://schemas.microsoft.com/office/drawing/2014/main" id="{F8543867-0853-4737-8005-9BA71B8B3550}"/>
+                <a16:creationId xmlns:a16="http://schemas.microsoft.com/office/drawing/2014/main" id="{3721A6E5-228E-4268-AA71-CF7A40A145C1}"/>
               </a:ext>
             </a:extLst>
           </p:cNvPr>
@@ -7350,7 +7350,7 @@
           <p:cNvPr id="14" name="text-100">
             <a:extLst xmlns:a="http://schemas.openxmlformats.org/drawingml/2006/main">
               <a:ext uri="{FF2B5EF4-FFF2-40B4-BE49-F238E27FC236}">
-                <a16:creationId xmlns:a16="http://schemas.microsoft.com/office/drawing/2014/main" id="{A22785BE-4D4B-43DF-A87A-A8E914733F47}"/>
+                <a16:creationId xmlns:a16="http://schemas.microsoft.com/office/drawing/2014/main" id="{DC134921-A5B4-4F5A-88C4-5E286DFDFFD1}"/>
               </a:ext>
             </a:extLst>
           </p:cNvPr>
@@ -7508,7 +7508,7 @@
           <p:cNvPr id="15" name="text-101">
             <a:extLst xmlns:a="http://schemas.openxmlformats.org/drawingml/2006/main">
               <a:ext uri="{FF2B5EF4-FFF2-40B4-BE49-F238E27FC236}">
-                <a16:creationId xmlns:a16="http://schemas.microsoft.com/office/drawing/2014/main" id="{A09C4487-CA68-4F54-B887-EEEBE40322FF}"/>
+                <a16:creationId xmlns:a16="http://schemas.microsoft.com/office/drawing/2014/main" id="{A2FA879B-9702-42F3-B4B6-CEF3FAB8FDB4}"/>
               </a:ext>
             </a:extLst>
           </p:cNvPr>
@@ -7666,7 +7666,7 @@
           <p:cNvPr id="16" name="text-102">
             <a:extLst xmlns:a="http://schemas.openxmlformats.org/drawingml/2006/main">
               <a:ext uri="{FF2B5EF4-FFF2-40B4-BE49-F238E27FC236}">
-                <a16:creationId xmlns:a16="http://schemas.microsoft.com/office/drawing/2014/main" id="{E73CB11E-E3EE-4445-9285-E228CF95DA99}"/>
+                <a16:creationId xmlns:a16="http://schemas.microsoft.com/office/drawing/2014/main" id="{29744C9C-1578-4E8B-931E-2238781A2C47}"/>
               </a:ext>
             </a:extLst>
           </p:cNvPr>
@@ -7824,7 +7824,7 @@
           <p:cNvPr id="17" name="text-103">
             <a:extLst xmlns:a="http://schemas.openxmlformats.org/drawingml/2006/main">
               <a:ext uri="{FF2B5EF4-FFF2-40B4-BE49-F238E27FC236}">
-                <a16:creationId xmlns:a16="http://schemas.microsoft.com/office/drawing/2014/main" id="{9457DDE5-554E-42E0-A0E2-4BAD9ED8C6AE}"/>
+                <a16:creationId xmlns:a16="http://schemas.microsoft.com/office/drawing/2014/main" id="{3D44BB5B-FF0F-415A-936D-09843E0BA670}"/>
               </a:ext>
             </a:extLst>
           </p:cNvPr>
@@ -7982,7 +7982,7 @@
           <p:cNvPr id="18" name="text-104">
             <a:extLst xmlns:a="http://schemas.openxmlformats.org/drawingml/2006/main">
               <a:ext uri="{FF2B5EF4-FFF2-40B4-BE49-F238E27FC236}">
-                <a16:creationId xmlns:a16="http://schemas.microsoft.com/office/drawing/2014/main" id="{B7BD4521-E7F6-43D4-81AA-7C75B9CBF668}"/>
+                <a16:creationId xmlns:a16="http://schemas.microsoft.com/office/drawing/2014/main" id="{1ADD71DD-410B-4AAB-A6BB-C8FA9702ADDB}"/>
               </a:ext>
             </a:extLst>
           </p:cNvPr>
@@ -7994,7 +7994,7 @@
         <p:spPr>
           <a:xfrm xmlns:a="http://schemas.openxmlformats.org/drawingml/2006/main">
             <a:off x="762000" y="6048375"/>
-            <a:ext cx="10477500" cy="628650"/>
+            <a:ext cx="10096500" cy="628650"/>
           </a:xfrm>
           <a:prstGeom xmlns:a="http://schemas.openxmlformats.org/drawingml/2006/main" prst="rect">
             <a:avLst/>
@@ -8130,7 +8130,30 @@
                 <a:ea typeface="Helvetica Neue"/>
                 <a:cs typeface="Helvetica Neue"/>
               </a:rPr>
-              <a:t>App Store profiles are ready. Archive, SDK validation, upload and TestFlight remain pending.</a:t>
+              <a:t>Builds 1 + 2: available internally in TestFlight.</a:t>
+            </a:r>
+          </a:p>
+          <a:p xmlns:a="http://schemas.openxmlformats.org/drawingml/2006/main">
+            <a:pPr>
+              <a:defRPr sz="1800" b="0">
+                <a:solidFill>
+                  <a:srgbClr val="5D6560"/>
+                </a:solidFill>
+                <a:latin typeface="Helvetica Neue"/>
+                <a:ea typeface="Helvetica Neue"/>
+                <a:cs typeface="Helvetica Neue"/>
+              </a:defRPr>
+            </a:pPr>
+            <a:r>
+              <a:rPr sz="1800" b="0">
+                <a:solidFill>
+                  <a:srgbClr val="5D6560"/>
+                </a:solidFill>
+                <a:latin typeface="Helvetica Neue"/>
+                <a:ea typeface="Helvetica Neue"/>
+                <a:cs typeface="Helvetica Neue"/>
+              </a:rPr>
+              <a:t>External build 1: beta review pending; physical installs unverified.</a:t>
             </a:r>
           </a:p>
         </p:txBody>
@@ -8138,7 +8161,7 @@
     </p:spTree>
     <p:extLst>
       <p:ext uri="{BB962C8B-B14F-4D97-AF65-F5344CB8AC3E}">
-        <p14:creationId xmlns:p14="http://schemas.microsoft.com/office/powerpoint/2010/main" val="1866588887"/>
+        <p14:creationId xmlns:p14="http://schemas.microsoft.com/office/powerpoint/2010/main" val="956444445"/>
       </p:ext>
     </p:extLst>
   </p:cSld>
@@ -8169,7 +8192,7 @@
           <p:cNvPr id="15" name="text-6">
             <a:extLst xmlns:a="http://schemas.openxmlformats.org/drawingml/2006/main">
               <a:ext uri="{FF2B5EF4-FFF2-40B4-BE49-F238E27FC236}">
-                <a16:creationId xmlns:a16="http://schemas.microsoft.com/office/drawing/2014/main" id="{752CE33D-F62B-4BC6-9F39-FA0DDA5C0280}"/>
+                <a16:creationId xmlns:a16="http://schemas.microsoft.com/office/drawing/2014/main" id="{DC80A6E8-86B1-46C0-9245-8C0EA2458982}"/>
               </a:ext>
             </a:extLst>
           </p:cNvPr>
@@ -8327,7 +8350,7 @@
           <p:cNvPr id="2" name="text-7">
             <a:extLst xmlns:a="http://schemas.openxmlformats.org/drawingml/2006/main">
               <a:ext uri="{FF2B5EF4-FFF2-40B4-BE49-F238E27FC236}">
-                <a16:creationId xmlns:a16="http://schemas.microsoft.com/office/drawing/2014/main" id="{04211B08-845B-4775-AA5B-FF8C82062421}"/>
+                <a16:creationId xmlns:a16="http://schemas.microsoft.com/office/drawing/2014/main" id="{C95168BE-C6A1-498C-BDA1-EB3C601F21EC}"/>
               </a:ext>
             </a:extLst>
           </p:cNvPr>
@@ -8485,7 +8508,7 @@
           <p:cNvPr id="3" name="text-8">
             <a:extLst xmlns:a="http://schemas.openxmlformats.org/drawingml/2006/main">
               <a:ext uri="{FF2B5EF4-FFF2-40B4-BE49-F238E27FC236}">
-                <a16:creationId xmlns:a16="http://schemas.microsoft.com/office/drawing/2014/main" id="{4F54BBCC-61B9-4623-B122-4B207004DA1E}"/>
+                <a16:creationId xmlns:a16="http://schemas.microsoft.com/office/drawing/2014/main" id="{453E64AD-9B72-4B2C-9866-6A238D1CC178}"/>
               </a:ext>
             </a:extLst>
           </p:cNvPr>
@@ -8643,7 +8666,7 @@
           <p:cNvPr id="4" name="text-9">
             <a:extLst xmlns:a="http://schemas.openxmlformats.org/drawingml/2006/main">
               <a:ext uri="{FF2B5EF4-FFF2-40B4-BE49-F238E27FC236}">
-                <a16:creationId xmlns:a16="http://schemas.microsoft.com/office/drawing/2014/main" id="{03794C94-1C20-4666-8997-B5ABA3F8741A}"/>
+                <a16:creationId xmlns:a16="http://schemas.microsoft.com/office/drawing/2014/main" id="{84CCF3AC-63B0-4A32-B663-4D458F8CBBEE}"/>
               </a:ext>
             </a:extLst>
           </p:cNvPr>
@@ -8801,7 +8824,7 @@
           <p:cNvPr id="5" name="text-10">
             <a:extLst xmlns:a="http://schemas.openxmlformats.org/drawingml/2006/main">
               <a:ext uri="{FF2B5EF4-FFF2-40B4-BE49-F238E27FC236}">
-                <a16:creationId xmlns:a16="http://schemas.microsoft.com/office/drawing/2014/main" id="{412D7AAE-259C-4E30-98F6-0F16403C1CB1}"/>
+                <a16:creationId xmlns:a16="http://schemas.microsoft.com/office/drawing/2014/main" id="{808A1460-D680-4C7C-9A2D-E9FFC51A560E}"/>
               </a:ext>
             </a:extLst>
           </p:cNvPr>
@@ -8959,7 +8982,7 @@
           <p:cNvPr id="6" name="text-11">
             <a:extLst xmlns:a="http://schemas.openxmlformats.org/drawingml/2006/main">
               <a:ext uri="{FF2B5EF4-FFF2-40B4-BE49-F238E27FC236}">
-                <a16:creationId xmlns:a16="http://schemas.microsoft.com/office/drawing/2014/main" id="{8013ED69-0B3F-4221-8A9D-10EC471D3A82}"/>
+                <a16:creationId xmlns:a16="http://schemas.microsoft.com/office/drawing/2014/main" id="{A56C7DF6-47B2-491F-B698-FB1EF7ACE533}"/>
               </a:ext>
             </a:extLst>
           </p:cNvPr>
@@ -9117,7 +9140,7 @@
           <p:cNvPr id="7" name="text-12">
             <a:extLst xmlns:a="http://schemas.openxmlformats.org/drawingml/2006/main">
               <a:ext uri="{FF2B5EF4-FFF2-40B4-BE49-F238E27FC236}">
-                <a16:creationId xmlns:a16="http://schemas.microsoft.com/office/drawing/2014/main" id="{CDDC7201-B690-4DC1-8617-2F205945B60D}"/>
+                <a16:creationId xmlns:a16="http://schemas.microsoft.com/office/drawing/2014/main" id="{45E668D9-4C38-417C-B17A-BCD959C786A7}"/>
               </a:ext>
             </a:extLst>
           </p:cNvPr>
@@ -9275,7 +9298,7 @@
           <p:cNvPr id="8" name="text-13">
             <a:extLst xmlns:a="http://schemas.openxmlformats.org/drawingml/2006/main">
               <a:ext uri="{FF2B5EF4-FFF2-40B4-BE49-F238E27FC236}">
-                <a16:creationId xmlns:a16="http://schemas.microsoft.com/office/drawing/2014/main" id="{B90E92BE-6F39-4349-9B40-51AD2D9E2519}"/>
+                <a16:creationId xmlns:a16="http://schemas.microsoft.com/office/drawing/2014/main" id="{6F358815-6D94-4462-9E75-8935DB12CDDB}"/>
               </a:ext>
             </a:extLst>
           </p:cNvPr>
@@ -9433,7 +9456,7 @@
           <p:cNvPr id="9" name="text-14">
             <a:extLst xmlns:a="http://schemas.openxmlformats.org/drawingml/2006/main">
               <a:ext uri="{FF2B5EF4-FFF2-40B4-BE49-F238E27FC236}">
-                <a16:creationId xmlns:a16="http://schemas.microsoft.com/office/drawing/2014/main" id="{844B3464-0AB5-4154-9E3B-249182D9250B}"/>
+                <a16:creationId xmlns:a16="http://schemas.microsoft.com/office/drawing/2014/main" id="{6E0CCA8D-BD53-4FF2-8A0B-070E08FA1DAA}"/>
               </a:ext>
             </a:extLst>
           </p:cNvPr>
@@ -9591,7 +9614,7 @@
           <p:cNvPr id="10" name="text-15">
             <a:extLst xmlns:a="http://schemas.openxmlformats.org/drawingml/2006/main">
               <a:ext uri="{FF2B5EF4-FFF2-40B4-BE49-F238E27FC236}">
-                <a16:creationId xmlns:a16="http://schemas.microsoft.com/office/drawing/2014/main" id="{222BEE43-C879-4F1B-A861-7A45719A2EF3}"/>
+                <a16:creationId xmlns:a16="http://schemas.microsoft.com/office/drawing/2014/main" id="{29F37374-156B-47FB-BB08-85BDF3B84C0C}"/>
               </a:ext>
             </a:extLst>
           </p:cNvPr>
@@ -9749,7 +9772,7 @@
           <p:cNvPr id="11" name="text-16">
             <a:extLst xmlns:a="http://schemas.openxmlformats.org/drawingml/2006/main">
               <a:ext uri="{FF2B5EF4-FFF2-40B4-BE49-F238E27FC236}">
-                <a16:creationId xmlns:a16="http://schemas.microsoft.com/office/drawing/2014/main" id="{B494640E-FACB-489D-A8FE-E33CDD839407}"/>
+                <a16:creationId xmlns:a16="http://schemas.microsoft.com/office/drawing/2014/main" id="{782D0954-988B-40D4-BA28-6215FC67C505}"/>
               </a:ext>
             </a:extLst>
           </p:cNvPr>
@@ -9907,7 +9930,7 @@
           <p:cNvPr id="12" name="text-17">
             <a:extLst xmlns:a="http://schemas.openxmlformats.org/drawingml/2006/main">
               <a:ext uri="{FF2B5EF4-FFF2-40B4-BE49-F238E27FC236}">
-                <a16:creationId xmlns:a16="http://schemas.microsoft.com/office/drawing/2014/main" id="{FC5A45D8-2EB1-4BA3-8357-73FAD68DF8AE}"/>
+                <a16:creationId xmlns:a16="http://schemas.microsoft.com/office/drawing/2014/main" id="{9EFA180B-BAD4-4022-9DC9-D5CFC6AB2B10}"/>
               </a:ext>
             </a:extLst>
           </p:cNvPr>
@@ -10065,7 +10088,7 @@
           <p:cNvPr id="13" name="text-18">
             <a:extLst xmlns:a="http://schemas.openxmlformats.org/drawingml/2006/main">
               <a:ext uri="{FF2B5EF4-FFF2-40B4-BE49-F238E27FC236}">
-                <a16:creationId xmlns:a16="http://schemas.microsoft.com/office/drawing/2014/main" id="{593ACF60-9E42-4005-A673-E270894C114E}"/>
+                <a16:creationId xmlns:a16="http://schemas.microsoft.com/office/drawing/2014/main" id="{D2960225-3C10-4C54-ACAB-FE7438F2CF50}"/>
               </a:ext>
             </a:extLst>
           </p:cNvPr>
@@ -10223,7 +10246,7 @@
           <p:cNvPr id="14" name="text-19">
             <a:extLst xmlns:a="http://schemas.openxmlformats.org/drawingml/2006/main">
               <a:ext uri="{FF2B5EF4-FFF2-40B4-BE49-F238E27FC236}">
-                <a16:creationId xmlns:a16="http://schemas.microsoft.com/office/drawing/2014/main" id="{D7BB4BB5-A6B6-4BDD-B422-E204F4B2899D}"/>
+                <a16:creationId xmlns:a16="http://schemas.microsoft.com/office/drawing/2014/main" id="{BC4BE32C-CF30-4053-A634-85664B7215C2}"/>
               </a:ext>
             </a:extLst>
           </p:cNvPr>
@@ -10379,7 +10402,7 @@
     </p:spTree>
     <p:extLst>
       <p:ext uri="{BB962C8B-B14F-4D97-AF65-F5344CB8AC3E}">
-        <p14:creationId xmlns:p14="http://schemas.microsoft.com/office/powerpoint/2010/main" val="37242659"/>
+        <p14:creationId xmlns:p14="http://schemas.microsoft.com/office/powerpoint/2010/main" val="1392655342"/>
       </p:ext>
     </p:extLst>
   </p:cSld>
@@ -10410,7 +10433,7 @@
           <p:cNvPr id="7" name="">
             <a:extLst xmlns:a="http://schemas.openxmlformats.org/drawingml/2006/main">
               <a:ext uri="{FF2B5EF4-FFF2-40B4-BE49-F238E27FC236}">
-                <a16:creationId xmlns:a16="http://schemas.microsoft.com/office/drawing/2014/main" id="{49787A93-CA0F-4F61-A90E-EF8F2B40BEBD}"/>
+                <a16:creationId xmlns:a16="http://schemas.microsoft.com/office/drawing/2014/main" id="{8960A4D9-44AE-45C0-8FA8-2284B04DD1BA}"/>
               </a:ext>
             </a:extLst>
           </p:cNvPr>
@@ -10441,7 +10464,7 @@
           <p:cNvPr id="6" name="">
             <a:extLst xmlns:a="http://schemas.openxmlformats.org/drawingml/2006/main">
               <a:ext uri="{FF2B5EF4-FFF2-40B4-BE49-F238E27FC236}">
-                <a16:creationId xmlns:a16="http://schemas.microsoft.com/office/drawing/2014/main" id="{CABC8147-46FF-4700-BFC6-ED6625225357}"/>
+                <a16:creationId xmlns:a16="http://schemas.microsoft.com/office/drawing/2014/main" id="{C1A15E6E-C573-425A-84E0-B640EE5E0EE9}"/>
               </a:ext>
             </a:extLst>
           </p:cNvPr>
@@ -10472,7 +10495,7 @@
           <p:cNvPr id="14" name="text-20">
             <a:extLst xmlns:a="http://schemas.openxmlformats.org/drawingml/2006/main">
               <a:ext uri="{FF2B5EF4-FFF2-40B4-BE49-F238E27FC236}">
-                <a16:creationId xmlns:a16="http://schemas.microsoft.com/office/drawing/2014/main" id="{1C1392C1-69F1-42E4-BD6B-634C430441C9}"/>
+                <a16:creationId xmlns:a16="http://schemas.microsoft.com/office/drawing/2014/main" id="{113E5C02-453F-4A85-BE0C-D6474E3D4463}"/>
               </a:ext>
             </a:extLst>
           </p:cNvPr>
@@ -10630,7 +10653,7 @@
           <p:cNvPr id="2" name="text-21">
             <a:extLst xmlns:a="http://schemas.openxmlformats.org/drawingml/2006/main">
               <a:ext uri="{FF2B5EF4-FFF2-40B4-BE49-F238E27FC236}">
-                <a16:creationId xmlns:a16="http://schemas.microsoft.com/office/drawing/2014/main" id="{AA2A689A-F43F-469E-8FAA-C11579869772}"/>
+                <a16:creationId xmlns:a16="http://schemas.microsoft.com/office/drawing/2014/main" id="{FD645D16-DEB5-41B4-B0A4-FF2756DA13FB}"/>
               </a:ext>
             </a:extLst>
           </p:cNvPr>
@@ -10788,7 +10811,7 @@
           <p:cNvPr id="3" name="diagram-22">
             <a:extLst xmlns:a="http://schemas.openxmlformats.org/drawingml/2006/main">
               <a:ext uri="{FF2B5EF4-FFF2-40B4-BE49-F238E27FC236}">
-                <a16:creationId xmlns:a16="http://schemas.microsoft.com/office/drawing/2014/main" id="{66C7B823-7BB2-4096-8BD2-12C7EA8D6537}"/>
+                <a16:creationId xmlns:a16="http://schemas.microsoft.com/office/drawing/2014/main" id="{28C05971-AFDD-47B1-9805-C3FC603CC91E}"/>
               </a:ext>
             </a:extLst>
           </p:cNvPr>
@@ -10948,7 +10971,7 @@
           <p:cNvPr id="4" name="diagram-23">
             <a:extLst xmlns:a="http://schemas.openxmlformats.org/drawingml/2006/main">
               <a:ext uri="{FF2B5EF4-FFF2-40B4-BE49-F238E27FC236}">
-                <a16:creationId xmlns:a16="http://schemas.microsoft.com/office/drawing/2014/main" id="{2D4D7547-ECDD-463A-9DBD-C5840A1E281E}"/>
+                <a16:creationId xmlns:a16="http://schemas.microsoft.com/office/drawing/2014/main" id="{A057E565-80BF-4431-AF3A-EDFC47861B35}"/>
               </a:ext>
             </a:extLst>
           </p:cNvPr>
@@ -11108,7 +11131,7 @@
           <p:cNvPr id="5" name="diagram-24">
             <a:extLst xmlns:a="http://schemas.openxmlformats.org/drawingml/2006/main">
               <a:ext uri="{FF2B5EF4-FFF2-40B4-BE49-F238E27FC236}">
-                <a16:creationId xmlns:a16="http://schemas.microsoft.com/office/drawing/2014/main" id="{A7DD120B-E209-47F1-8482-5024299B029E}"/>
+                <a16:creationId xmlns:a16="http://schemas.microsoft.com/office/drawing/2014/main" id="{DF60A79A-EA13-4D3A-B370-844DCD9B5BA0}"/>
               </a:ext>
             </a:extLst>
           </p:cNvPr>
@@ -11268,7 +11291,7 @@
           <p:cNvPr id="8" name="">
             <a:extLst xmlns:a="http://schemas.openxmlformats.org/drawingml/2006/main">
               <a:ext uri="{FF2B5EF4-FFF2-40B4-BE49-F238E27FC236}">
-                <a16:creationId xmlns:a16="http://schemas.microsoft.com/office/drawing/2014/main" id="{2A9D0DF7-8281-4779-8B7B-148A101E266A}"/>
+                <a16:creationId xmlns:a16="http://schemas.microsoft.com/office/drawing/2014/main" id="{DF5A763E-D275-4A77-B97B-231DABEF2E70}"/>
               </a:ext>
             </a:extLst>
           </p:cNvPr>
@@ -11278,7 +11301,7 @@
           <p:nvPr/>
         </p:nvPicPr>
         <p:blipFill>
-          <a:blip xmlns:r="http://schemas.openxmlformats.org/officeDocument/2006/relationships" xmlns:a="http://schemas.openxmlformats.org/drawingml/2006/main" r:embed="Rc967c9b05ed94a0b"/>
+          <a:blip xmlns:r="http://schemas.openxmlformats.org/officeDocument/2006/relationships" xmlns:a="http://schemas.openxmlformats.org/drawingml/2006/main" r:embed="R1041a7c3814b4414"/>
           <a:stretch xmlns:a="http://schemas.openxmlformats.org/drawingml/2006/main"/>
         </p:blipFill>
         <p:spPr>
@@ -11296,7 +11319,7 @@
           <p:cNvPr id="9" name="text-25">
             <a:extLst xmlns:a="http://schemas.openxmlformats.org/drawingml/2006/main">
               <a:ext uri="{FF2B5EF4-FFF2-40B4-BE49-F238E27FC236}">
-                <a16:creationId xmlns:a16="http://schemas.microsoft.com/office/drawing/2014/main" id="{6E1381E4-2554-4CF3-8BF2-8AE8A08C60A5}"/>
+                <a16:creationId xmlns:a16="http://schemas.microsoft.com/office/drawing/2014/main" id="{C29171CF-053F-469B-AE4F-3B81F93C1C11}"/>
               </a:ext>
             </a:extLst>
           </p:cNvPr>
@@ -11477,7 +11500,7 @@
           <p:cNvPr id="10" name="text-26">
             <a:extLst xmlns:a="http://schemas.openxmlformats.org/drawingml/2006/main">
               <a:ext uri="{FF2B5EF4-FFF2-40B4-BE49-F238E27FC236}">
-                <a16:creationId xmlns:a16="http://schemas.microsoft.com/office/drawing/2014/main" id="{4E6B8198-032B-41A3-B27E-D3EF0C543C04}"/>
+                <a16:creationId xmlns:a16="http://schemas.microsoft.com/office/drawing/2014/main" id="{AA3473D6-EB46-4847-9286-6DF557801F21}"/>
               </a:ext>
             </a:extLst>
           </p:cNvPr>
@@ -11635,7 +11658,7 @@
           <p:cNvPr id="11" name="text-27">
             <a:extLst xmlns:a="http://schemas.openxmlformats.org/drawingml/2006/main">
               <a:ext uri="{FF2B5EF4-FFF2-40B4-BE49-F238E27FC236}">
-                <a16:creationId xmlns:a16="http://schemas.microsoft.com/office/drawing/2014/main" id="{2F1435BA-50E0-4307-BC92-A67CBFCE8A21}"/>
+                <a16:creationId xmlns:a16="http://schemas.microsoft.com/office/drawing/2014/main" id="{1984E625-CDB2-475F-BEE7-FDAA88428F86}"/>
               </a:ext>
             </a:extLst>
           </p:cNvPr>
@@ -11862,7 +11885,7 @@
           <p:cNvPr id="12" name="text-28">
             <a:extLst xmlns:a="http://schemas.openxmlformats.org/drawingml/2006/main">
               <a:ext uri="{FF2B5EF4-FFF2-40B4-BE49-F238E27FC236}">
-                <a16:creationId xmlns:a16="http://schemas.microsoft.com/office/drawing/2014/main" id="{C2B73884-09FE-4DD0-962B-C860AE9F3F07}"/>
+                <a16:creationId xmlns:a16="http://schemas.microsoft.com/office/drawing/2014/main" id="{E8C600DE-D6AB-4DCF-8C1A-C3A6A33E8C97}"/>
               </a:ext>
             </a:extLst>
           </p:cNvPr>
@@ -12020,7 +12043,7 @@
           <p:cNvPr id="13" name="text-29">
             <a:extLst xmlns:a="http://schemas.openxmlformats.org/drawingml/2006/main">
               <a:ext uri="{FF2B5EF4-FFF2-40B4-BE49-F238E27FC236}">
-                <a16:creationId xmlns:a16="http://schemas.microsoft.com/office/drawing/2014/main" id="{D19D0835-E3D8-43A8-ADBD-A3E3F4A258C1}"/>
+                <a16:creationId xmlns:a16="http://schemas.microsoft.com/office/drawing/2014/main" id="{63026E24-5922-401D-A532-82BFA06984FC}"/>
               </a:ext>
             </a:extLst>
           </p:cNvPr>
@@ -12245,7 +12268,7 @@
     </p:spTree>
     <p:extLst>
       <p:ext uri="{BB962C8B-B14F-4D97-AF65-F5344CB8AC3E}">
-        <p14:creationId xmlns:p14="http://schemas.microsoft.com/office/powerpoint/2010/main" val="1647032909"/>
+        <p14:creationId xmlns:p14="http://schemas.microsoft.com/office/powerpoint/2010/main" val="413786090"/>
       </p:ext>
     </p:extLst>
   </p:cSld>
@@ -12276,7 +12299,7 @@
           <p:cNvPr id="15" name="text-30">
             <a:extLst xmlns:a="http://schemas.openxmlformats.org/drawingml/2006/main">
               <a:ext uri="{FF2B5EF4-FFF2-40B4-BE49-F238E27FC236}">
-                <a16:creationId xmlns:a16="http://schemas.microsoft.com/office/drawing/2014/main" id="{71F23F2F-5C14-4621-82CF-C3DE02215540}"/>
+                <a16:creationId xmlns:a16="http://schemas.microsoft.com/office/drawing/2014/main" id="{3923CEDB-D6F1-4DC9-9038-3D51B6ADD081}"/>
               </a:ext>
             </a:extLst>
           </p:cNvPr>
@@ -12434,7 +12457,7 @@
           <p:cNvPr id="2" name="text-31">
             <a:extLst xmlns:a="http://schemas.openxmlformats.org/drawingml/2006/main">
               <a:ext uri="{FF2B5EF4-FFF2-40B4-BE49-F238E27FC236}">
-                <a16:creationId xmlns:a16="http://schemas.microsoft.com/office/drawing/2014/main" id="{054E1DE3-3961-4B76-909F-DE4093E0A9CD}"/>
+                <a16:creationId xmlns:a16="http://schemas.microsoft.com/office/drawing/2014/main" id="{0A505EC4-272F-489B-90C4-C22819A0BD93}"/>
               </a:ext>
             </a:extLst>
           </p:cNvPr>
@@ -12592,7 +12615,7 @@
           <p:cNvPr id="3" name="text-32">
             <a:extLst xmlns:a="http://schemas.openxmlformats.org/drawingml/2006/main">
               <a:ext uri="{FF2B5EF4-FFF2-40B4-BE49-F238E27FC236}">
-                <a16:creationId xmlns:a16="http://schemas.microsoft.com/office/drawing/2014/main" id="{7D6EE968-E119-4B2D-AB46-99D6D600342A}"/>
+                <a16:creationId xmlns:a16="http://schemas.microsoft.com/office/drawing/2014/main" id="{932B375D-6E8A-4BFD-BB23-D38C169ABDC9}"/>
               </a:ext>
             </a:extLst>
           </p:cNvPr>
@@ -12750,7 +12773,7 @@
           <p:cNvPr id="4" name="text-33">
             <a:extLst xmlns:a="http://schemas.openxmlformats.org/drawingml/2006/main">
               <a:ext uri="{FF2B5EF4-FFF2-40B4-BE49-F238E27FC236}">
-                <a16:creationId xmlns:a16="http://schemas.microsoft.com/office/drawing/2014/main" id="{F569FCDB-4F73-4565-A84D-7A865E10098F}"/>
+                <a16:creationId xmlns:a16="http://schemas.microsoft.com/office/drawing/2014/main" id="{EAC4E178-633C-4004-BCEC-24C47E4A0705}"/>
               </a:ext>
             </a:extLst>
           </p:cNvPr>
@@ -12908,7 +12931,7 @@
           <p:cNvPr id="5" name="text-34">
             <a:extLst xmlns:a="http://schemas.openxmlformats.org/drawingml/2006/main">
               <a:ext uri="{FF2B5EF4-FFF2-40B4-BE49-F238E27FC236}">
-                <a16:creationId xmlns:a16="http://schemas.microsoft.com/office/drawing/2014/main" id="{0F8FAC6B-FCAC-47EF-8C8C-E1E2794929F7}"/>
+                <a16:creationId xmlns:a16="http://schemas.microsoft.com/office/drawing/2014/main" id="{4572090F-9D27-464E-B4F1-834931EB1496}"/>
               </a:ext>
             </a:extLst>
           </p:cNvPr>
@@ -13066,7 +13089,7 @@
           <p:cNvPr id="6" name="text-35">
             <a:extLst xmlns:a="http://schemas.openxmlformats.org/drawingml/2006/main">
               <a:ext uri="{FF2B5EF4-FFF2-40B4-BE49-F238E27FC236}">
-                <a16:creationId xmlns:a16="http://schemas.microsoft.com/office/drawing/2014/main" id="{DBE2A1B6-0222-418A-80E3-1F23FE2D7809}"/>
+                <a16:creationId xmlns:a16="http://schemas.microsoft.com/office/drawing/2014/main" id="{0F7DA814-AED6-4351-9EB5-D1C6FC3716F2}"/>
               </a:ext>
             </a:extLst>
           </p:cNvPr>
@@ -13247,7 +13270,7 @@
           <p:cNvPr id="7" name="text-36">
             <a:extLst xmlns:a="http://schemas.openxmlformats.org/drawingml/2006/main">
               <a:ext uri="{FF2B5EF4-FFF2-40B4-BE49-F238E27FC236}">
-                <a16:creationId xmlns:a16="http://schemas.microsoft.com/office/drawing/2014/main" id="{446169DE-3636-42B3-B119-F7DE1C53A6EC}"/>
+                <a16:creationId xmlns:a16="http://schemas.microsoft.com/office/drawing/2014/main" id="{BA8E233D-77ED-433F-8E3B-2FDC65CF58FA}"/>
               </a:ext>
             </a:extLst>
           </p:cNvPr>
@@ -13405,7 +13428,7 @@
           <p:cNvPr id="8" name="text-37">
             <a:extLst xmlns:a="http://schemas.openxmlformats.org/drawingml/2006/main">
               <a:ext uri="{FF2B5EF4-FFF2-40B4-BE49-F238E27FC236}">
-                <a16:creationId xmlns:a16="http://schemas.microsoft.com/office/drawing/2014/main" id="{E9070AEC-EBCB-4D39-A838-ED9B4C97DE83}"/>
+                <a16:creationId xmlns:a16="http://schemas.microsoft.com/office/drawing/2014/main" id="{3C21CA51-BBD3-4E92-A127-57671F397638}"/>
               </a:ext>
             </a:extLst>
           </p:cNvPr>
@@ -13553,7 +13576,30 @@
                 <a:ea typeface="Helvetica Neue"/>
                 <a:cs typeface="Helvetica Neue"/>
               </a:rPr>
-              <a:t>Discomfort ends encouragement. Pause and end cancel late cues.</a:t>
+              <a:t>Reported discomfort overrides ordinary cues.</a:t>
+            </a:r>
+          </a:p>
+          <a:p xmlns:a="http://schemas.openxmlformats.org/drawingml/2006/main">
+            <a:pPr>
+              <a:defRPr sz="2025" b="0">
+                <a:solidFill>
+                  <a:srgbClr val="5D6560"/>
+                </a:solidFill>
+                <a:latin typeface="Helvetica Neue"/>
+                <a:ea typeface="Helvetica Neue"/>
+                <a:cs typeface="Helvetica Neue"/>
+              </a:defRPr>
+            </a:pPr>
+            <a:r>
+              <a:rPr sz="2025" b="0">
+                <a:solidFill>
+                  <a:srgbClr val="5D6560"/>
+                </a:solidFill>
+                <a:latin typeface="Helvetica Neue"/>
+                <a:ea typeface="Helvetica Neue"/>
+                <a:cs typeface="Helvetica Neue"/>
+              </a:rPr>
+              <a:t>Pause and end cancel speech and old cues.</a:t>
             </a:r>
           </a:p>
         </p:txBody>
@@ -13563,7 +13609,7 @@
           <p:cNvPr id="9" name="text-38">
             <a:extLst xmlns:a="http://schemas.openxmlformats.org/drawingml/2006/main">
               <a:ext uri="{FF2B5EF4-FFF2-40B4-BE49-F238E27FC236}">
-                <a16:creationId xmlns:a16="http://schemas.microsoft.com/office/drawing/2014/main" id="{A3C1D648-9F4B-45F9-9FF6-A82964FDAAF9}"/>
+                <a16:creationId xmlns:a16="http://schemas.microsoft.com/office/drawing/2014/main" id="{04B4E6D5-9297-47E5-92CF-C75B9FEB80CE}"/>
               </a:ext>
             </a:extLst>
           </p:cNvPr>
@@ -13721,7 +13767,7 @@
           <p:cNvPr id="10" name="text-39">
             <a:extLst xmlns:a="http://schemas.openxmlformats.org/drawingml/2006/main">
               <a:ext uri="{FF2B5EF4-FFF2-40B4-BE49-F238E27FC236}">
-                <a16:creationId xmlns:a16="http://schemas.microsoft.com/office/drawing/2014/main" id="{A0DEDAE8-A397-460C-9D84-74516430B670}"/>
+                <a16:creationId xmlns:a16="http://schemas.microsoft.com/office/drawing/2014/main" id="{167E2A4F-1B11-436A-ADF6-1200FF8BDDA4}"/>
               </a:ext>
             </a:extLst>
           </p:cNvPr>
@@ -13879,7 +13925,7 @@
           <p:cNvPr id="11" name="">
             <a:extLst xmlns:a="http://schemas.openxmlformats.org/drawingml/2006/main">
               <a:ext uri="{FF2B5EF4-FFF2-40B4-BE49-F238E27FC236}">
-                <a16:creationId xmlns:a16="http://schemas.microsoft.com/office/drawing/2014/main" id="{673E509C-CE2A-4BDC-9624-132B1ABE3306}"/>
+                <a16:creationId xmlns:a16="http://schemas.microsoft.com/office/drawing/2014/main" id="{79D105F0-ED84-458E-8D3C-5271EFE9A72B}"/>
               </a:ext>
             </a:extLst>
           </p:cNvPr>
@@ -13889,7 +13935,7 @@
           <p:nvPr/>
         </p:nvPicPr>
         <p:blipFill>
-          <a:blip xmlns:r="http://schemas.openxmlformats.org/officeDocument/2006/relationships" xmlns:a="http://schemas.openxmlformats.org/drawingml/2006/main" r:embed="R7d8946052c1b4283"/>
+          <a:blip xmlns:r="http://schemas.openxmlformats.org/officeDocument/2006/relationships" xmlns:a="http://schemas.openxmlformats.org/drawingml/2006/main" r:embed="R1c2430076f014f01"/>
           <a:stretch xmlns:a="http://schemas.openxmlformats.org/drawingml/2006/main"/>
         </p:blipFill>
         <p:spPr>
@@ -13907,7 +13953,7 @@
           <p:cNvPr id="12" name="">
             <a:extLst xmlns:a="http://schemas.openxmlformats.org/drawingml/2006/main">
               <a:ext uri="{FF2B5EF4-FFF2-40B4-BE49-F238E27FC236}">
-                <a16:creationId xmlns:a16="http://schemas.microsoft.com/office/drawing/2014/main" id="{4D80A35D-58BD-4E29-85CF-B8BACD231628}"/>
+                <a16:creationId xmlns:a16="http://schemas.microsoft.com/office/drawing/2014/main" id="{A9224DF5-0D0A-4AA3-B531-5F239F8665D8}"/>
               </a:ext>
             </a:extLst>
           </p:cNvPr>
@@ -13917,7 +13963,7 @@
           <p:nvPr/>
         </p:nvPicPr>
         <p:blipFill>
-          <a:blip xmlns:r="http://schemas.openxmlformats.org/officeDocument/2006/relationships" xmlns:a="http://schemas.openxmlformats.org/drawingml/2006/main" r:embed="R6974e85bb74348b2"/>
+          <a:blip xmlns:r="http://schemas.openxmlformats.org/officeDocument/2006/relationships" xmlns:a="http://schemas.openxmlformats.org/drawingml/2006/main" r:embed="R6e53aed85fd94a84"/>
           <a:stretch xmlns:a="http://schemas.openxmlformats.org/drawingml/2006/main"/>
         </p:blipFill>
         <p:spPr>
@@ -13935,7 +13981,7 @@
           <p:cNvPr id="13" name="">
             <a:extLst xmlns:a="http://schemas.openxmlformats.org/drawingml/2006/main">
               <a:ext uri="{FF2B5EF4-FFF2-40B4-BE49-F238E27FC236}">
-                <a16:creationId xmlns:a16="http://schemas.microsoft.com/office/drawing/2014/main" id="{FB64E2F4-F732-4F9B-B288-62C50805979E}"/>
+                <a16:creationId xmlns:a16="http://schemas.microsoft.com/office/drawing/2014/main" id="{F27ECD71-0877-486E-B8C5-75192B85A15C}"/>
               </a:ext>
             </a:extLst>
           </p:cNvPr>
@@ -13945,7 +13991,7 @@
           <p:nvPr/>
         </p:nvPicPr>
         <p:blipFill>
-          <a:blip xmlns:r="http://schemas.openxmlformats.org/officeDocument/2006/relationships" xmlns:a="http://schemas.openxmlformats.org/drawingml/2006/main" r:embed="R758a0bf06d154f0c"/>
+          <a:blip xmlns:r="http://schemas.openxmlformats.org/officeDocument/2006/relationships" xmlns:a="http://schemas.openxmlformats.org/drawingml/2006/main" r:embed="Rae2d3b2b8cd74d23"/>
           <a:stretch xmlns:a="http://schemas.openxmlformats.org/drawingml/2006/main"/>
         </p:blipFill>
         <p:spPr>
@@ -13963,7 +14009,7 @@
           <p:cNvPr id="14" name="text-40">
             <a:extLst xmlns:a="http://schemas.openxmlformats.org/drawingml/2006/main">
               <a:ext uri="{FF2B5EF4-FFF2-40B4-BE49-F238E27FC236}">
-                <a16:creationId xmlns:a16="http://schemas.microsoft.com/office/drawing/2014/main" id="{A155A15A-D06B-4444-9030-62473D0666FC}"/>
+                <a16:creationId xmlns:a16="http://schemas.microsoft.com/office/drawing/2014/main" id="{DCF028F9-6D64-4F40-AF73-3D625A6D0E68}"/>
               </a:ext>
             </a:extLst>
           </p:cNvPr>
@@ -14119,7 +14165,7 @@
     </p:spTree>
     <p:extLst>
       <p:ext uri="{BB962C8B-B14F-4D97-AF65-F5344CB8AC3E}">
-        <p14:creationId xmlns:p14="http://schemas.microsoft.com/office/powerpoint/2010/main" val="2104837433"/>
+        <p14:creationId xmlns:p14="http://schemas.microsoft.com/office/powerpoint/2010/main" val="113665178"/>
       </p:ext>
     </p:extLst>
   </p:cSld>
@@ -14150,7 +14196,7 @@
           <p:cNvPr id="8" name="">
             <a:extLst xmlns:a="http://schemas.openxmlformats.org/drawingml/2006/main">
               <a:ext uri="{FF2B5EF4-FFF2-40B4-BE49-F238E27FC236}">
-                <a16:creationId xmlns:a16="http://schemas.microsoft.com/office/drawing/2014/main" id="{7EE277F5-266D-4589-9307-C2678CABAAAB}"/>
+                <a16:creationId xmlns:a16="http://schemas.microsoft.com/office/drawing/2014/main" id="{E368BA08-271F-49FF-80F5-6AB6F3EC3A31}"/>
               </a:ext>
             </a:extLst>
           </p:cNvPr>
@@ -14183,7 +14229,7 @@
           <p:cNvPr id="7" name="">
             <a:extLst xmlns:a="http://schemas.openxmlformats.org/drawingml/2006/main">
               <a:ext uri="{FF2B5EF4-FFF2-40B4-BE49-F238E27FC236}">
-                <a16:creationId xmlns:a16="http://schemas.microsoft.com/office/drawing/2014/main" id="{CF24F39F-CF01-426D-BCF7-7B931FF334C5}"/>
+                <a16:creationId xmlns:a16="http://schemas.microsoft.com/office/drawing/2014/main" id="{27D3D5FD-7EFF-4620-8D83-231EA0E90993}"/>
               </a:ext>
             </a:extLst>
           </p:cNvPr>
@@ -14216,7 +14262,7 @@
           <p:cNvPr id="13" name="text-41">
             <a:extLst xmlns:a="http://schemas.openxmlformats.org/drawingml/2006/main">
               <a:ext uri="{FF2B5EF4-FFF2-40B4-BE49-F238E27FC236}">
-                <a16:creationId xmlns:a16="http://schemas.microsoft.com/office/drawing/2014/main" id="{E15399F3-6C71-41D2-8C76-44980E32D0D9}"/>
+                <a16:creationId xmlns:a16="http://schemas.microsoft.com/office/drawing/2014/main" id="{68F2D281-D60F-4D03-AE40-CF35BDEE5AB2}"/>
               </a:ext>
             </a:extLst>
           </p:cNvPr>
@@ -14374,7 +14420,7 @@
           <p:cNvPr id="2" name="text-42">
             <a:extLst xmlns:a="http://schemas.openxmlformats.org/drawingml/2006/main">
               <a:ext uri="{FF2B5EF4-FFF2-40B4-BE49-F238E27FC236}">
-                <a16:creationId xmlns:a16="http://schemas.microsoft.com/office/drawing/2014/main" id="{AEBEADD4-7562-4902-85BE-8F02C87045BC}"/>
+                <a16:creationId xmlns:a16="http://schemas.microsoft.com/office/drawing/2014/main" id="{A880CCBD-21AA-4759-BFA8-05DD8822966E}"/>
               </a:ext>
             </a:extLst>
           </p:cNvPr>
@@ -14532,7 +14578,7 @@
           <p:cNvPr id="3" name="text-43">
             <a:extLst xmlns:a="http://schemas.openxmlformats.org/drawingml/2006/main">
               <a:ext uri="{FF2B5EF4-FFF2-40B4-BE49-F238E27FC236}">
-                <a16:creationId xmlns:a16="http://schemas.microsoft.com/office/drawing/2014/main" id="{CE2A088B-CA5A-418C-8694-6082983F183F}"/>
+                <a16:creationId xmlns:a16="http://schemas.microsoft.com/office/drawing/2014/main" id="{700CDD26-ACBE-4F5B-BD47-5CB3C6315600}"/>
               </a:ext>
             </a:extLst>
           </p:cNvPr>
@@ -14690,7 +14736,7 @@
           <p:cNvPr id="4" name="diagram-44">
             <a:extLst xmlns:a="http://schemas.openxmlformats.org/drawingml/2006/main">
               <a:ext uri="{FF2B5EF4-FFF2-40B4-BE49-F238E27FC236}">
-                <a16:creationId xmlns:a16="http://schemas.microsoft.com/office/drawing/2014/main" id="{5E04BC8E-3DD6-46C0-A49A-1911C7291B0C}"/>
+                <a16:creationId xmlns:a16="http://schemas.microsoft.com/office/drawing/2014/main" id="{D9DEC0CF-F9AD-4769-B7FF-E8273439A037}"/>
               </a:ext>
             </a:extLst>
           </p:cNvPr>
@@ -14850,7 +14896,7 @@
           <p:cNvPr id="5" name="diagram-45">
             <a:extLst xmlns:a="http://schemas.openxmlformats.org/drawingml/2006/main">
               <a:ext uri="{FF2B5EF4-FFF2-40B4-BE49-F238E27FC236}">
-                <a16:creationId xmlns:a16="http://schemas.microsoft.com/office/drawing/2014/main" id="{06D4B70E-1456-4801-B160-7C432E3BF033}"/>
+                <a16:creationId xmlns:a16="http://schemas.microsoft.com/office/drawing/2014/main" id="{16A4DB2E-9AA7-413D-8ECB-F10CF1C7E4CC}"/>
               </a:ext>
             </a:extLst>
           </p:cNvPr>
@@ -15010,7 +15056,7 @@
           <p:cNvPr id="6" name="diagram-46">
             <a:extLst xmlns:a="http://schemas.openxmlformats.org/drawingml/2006/main">
               <a:ext uri="{FF2B5EF4-FFF2-40B4-BE49-F238E27FC236}">
-                <a16:creationId xmlns:a16="http://schemas.microsoft.com/office/drawing/2014/main" id="{79723E61-2C5F-4C46-B357-DE2BF9CF1477}"/>
+                <a16:creationId xmlns:a16="http://schemas.microsoft.com/office/drawing/2014/main" id="{CC735890-DA8C-4298-9926-14C6E9D5779F}"/>
               </a:ext>
             </a:extLst>
           </p:cNvPr>
@@ -15170,7 +15216,7 @@
           <p:cNvPr id="9" name="text-47">
             <a:extLst xmlns:a="http://schemas.openxmlformats.org/drawingml/2006/main">
               <a:ext uri="{FF2B5EF4-FFF2-40B4-BE49-F238E27FC236}">
-                <a16:creationId xmlns:a16="http://schemas.microsoft.com/office/drawing/2014/main" id="{9C424FD3-DEDA-4E16-9061-804C13819DD2}"/>
+                <a16:creationId xmlns:a16="http://schemas.microsoft.com/office/drawing/2014/main" id="{BFFC4EDE-566C-4349-B9ED-858393E010D6}"/>
               </a:ext>
             </a:extLst>
           </p:cNvPr>
@@ -15328,7 +15374,7 @@
           <p:cNvPr id="10" name="text-48">
             <a:extLst xmlns:a="http://schemas.openxmlformats.org/drawingml/2006/main">
               <a:ext uri="{FF2B5EF4-FFF2-40B4-BE49-F238E27FC236}">
-                <a16:creationId xmlns:a16="http://schemas.microsoft.com/office/drawing/2014/main" id="{D3FAC1BC-1041-43B8-8F62-856CB0E7112A}"/>
+                <a16:creationId xmlns:a16="http://schemas.microsoft.com/office/drawing/2014/main" id="{A43C8221-84C7-4C32-A768-63E84D08411F}"/>
               </a:ext>
             </a:extLst>
           </p:cNvPr>
@@ -15509,7 +15555,7 @@
           <p:cNvPr id="11" name="text-49">
             <a:extLst xmlns:a="http://schemas.openxmlformats.org/drawingml/2006/main">
               <a:ext uri="{FF2B5EF4-FFF2-40B4-BE49-F238E27FC236}">
-                <a16:creationId xmlns:a16="http://schemas.microsoft.com/office/drawing/2014/main" id="{33AE6AC3-365B-44E1-8110-DE4F450EC970}"/>
+                <a16:creationId xmlns:a16="http://schemas.microsoft.com/office/drawing/2014/main" id="{9C0989D7-21D4-4B64-9504-FE1E1037FBC4}"/>
               </a:ext>
             </a:extLst>
           </p:cNvPr>
@@ -15713,7 +15759,7 @@
           <p:cNvPr id="12" name="text-50">
             <a:extLst xmlns:a="http://schemas.openxmlformats.org/drawingml/2006/main">
               <a:ext uri="{FF2B5EF4-FFF2-40B4-BE49-F238E27FC236}">
-                <a16:creationId xmlns:a16="http://schemas.microsoft.com/office/drawing/2014/main" id="{9CC7E67D-D4A5-46AE-9BFA-CC884D5A73D2}"/>
+                <a16:creationId xmlns:a16="http://schemas.microsoft.com/office/drawing/2014/main" id="{3092B195-321E-45D2-9755-4FDA896F35FB}"/>
               </a:ext>
             </a:extLst>
           </p:cNvPr>
@@ -15892,7 +15938,7 @@
     </p:spTree>
     <p:extLst>
       <p:ext uri="{BB962C8B-B14F-4D97-AF65-F5344CB8AC3E}">
-        <p14:creationId xmlns:p14="http://schemas.microsoft.com/office/powerpoint/2010/main" val="191995944"/>
+        <p14:creationId xmlns:p14="http://schemas.microsoft.com/office/powerpoint/2010/main" val="532678147"/>
       </p:ext>
     </p:extLst>
   </p:cSld>
@@ -15923,7 +15969,7 @@
           <p:cNvPr id="16" name="text-51">
             <a:extLst xmlns:a="http://schemas.openxmlformats.org/drawingml/2006/main">
               <a:ext uri="{FF2B5EF4-FFF2-40B4-BE49-F238E27FC236}">
-                <a16:creationId xmlns:a16="http://schemas.microsoft.com/office/drawing/2014/main" id="{C8F51ED0-18E7-42E8-BABC-424E2E211072}"/>
+                <a16:creationId xmlns:a16="http://schemas.microsoft.com/office/drawing/2014/main" id="{4153F1DD-AE01-4C48-960E-33EAAAE33D52}"/>
               </a:ext>
             </a:extLst>
           </p:cNvPr>
@@ -16081,7 +16127,7 @@
           <p:cNvPr id="2" name="text-52">
             <a:extLst xmlns:a="http://schemas.openxmlformats.org/drawingml/2006/main">
               <a:ext uri="{FF2B5EF4-FFF2-40B4-BE49-F238E27FC236}">
-                <a16:creationId xmlns:a16="http://schemas.microsoft.com/office/drawing/2014/main" id="{54474B8D-1CB7-48CD-BC70-6B3C2B6BF4BD}"/>
+                <a16:creationId xmlns:a16="http://schemas.microsoft.com/office/drawing/2014/main" id="{B7ECEFC8-E04E-4A18-939B-8334CD707A20}"/>
               </a:ext>
             </a:extLst>
           </p:cNvPr>
@@ -16239,7 +16285,7 @@
           <p:cNvPr id="3" name="text-53">
             <a:extLst xmlns:a="http://schemas.openxmlformats.org/drawingml/2006/main">
               <a:ext uri="{FF2B5EF4-FFF2-40B4-BE49-F238E27FC236}">
-                <a16:creationId xmlns:a16="http://schemas.microsoft.com/office/drawing/2014/main" id="{64199632-60C5-4BA8-B3FC-61BEE9460BAF}"/>
+                <a16:creationId xmlns:a16="http://schemas.microsoft.com/office/drawing/2014/main" id="{0F759620-ADE1-4828-A6CD-2A2D3445EB07}"/>
               </a:ext>
             </a:extLst>
           </p:cNvPr>
@@ -16397,7 +16443,7 @@
           <p:cNvPr id="4" name="text-54">
             <a:extLst xmlns:a="http://schemas.openxmlformats.org/drawingml/2006/main">
               <a:ext uri="{FF2B5EF4-FFF2-40B4-BE49-F238E27FC236}">
-                <a16:creationId xmlns:a16="http://schemas.microsoft.com/office/drawing/2014/main" id="{610BBD8C-F614-4A39-9BC1-9EA6B3C9A697}"/>
+                <a16:creationId xmlns:a16="http://schemas.microsoft.com/office/drawing/2014/main" id="{C7BA7092-B4C8-47B0-A302-0F31EDD75BE3}"/>
               </a:ext>
             </a:extLst>
           </p:cNvPr>
@@ -16555,7 +16601,7 @@
           <p:cNvPr id="5" name="text-55">
             <a:extLst xmlns:a="http://schemas.openxmlformats.org/drawingml/2006/main">
               <a:ext uri="{FF2B5EF4-FFF2-40B4-BE49-F238E27FC236}">
-                <a16:creationId xmlns:a16="http://schemas.microsoft.com/office/drawing/2014/main" id="{38E86EE0-3617-4ED0-BAB3-506AE6A6A234}"/>
+                <a16:creationId xmlns:a16="http://schemas.microsoft.com/office/drawing/2014/main" id="{F3C38850-33FB-4DC6-9668-1A4AE851516C}"/>
               </a:ext>
             </a:extLst>
           </p:cNvPr>
@@ -16713,7 +16759,7 @@
           <p:cNvPr id="6" name="text-56">
             <a:extLst xmlns:a="http://schemas.openxmlformats.org/drawingml/2006/main">
               <a:ext uri="{FF2B5EF4-FFF2-40B4-BE49-F238E27FC236}">
-                <a16:creationId xmlns:a16="http://schemas.microsoft.com/office/drawing/2014/main" id="{FCADD74C-C6E6-4EA7-B806-8164B38E4202}"/>
+                <a16:creationId xmlns:a16="http://schemas.microsoft.com/office/drawing/2014/main" id="{7B80210D-F1E7-40B4-9A61-A0180B2CCB43}"/>
               </a:ext>
             </a:extLst>
           </p:cNvPr>
@@ -16871,7 +16917,7 @@
           <p:cNvPr id="7" name="text-57">
             <a:extLst xmlns:a="http://schemas.openxmlformats.org/drawingml/2006/main">
               <a:ext uri="{FF2B5EF4-FFF2-40B4-BE49-F238E27FC236}">
-                <a16:creationId xmlns:a16="http://schemas.microsoft.com/office/drawing/2014/main" id="{5A248E09-7C70-4F07-8BF3-FE1B4F0AE670}"/>
+                <a16:creationId xmlns:a16="http://schemas.microsoft.com/office/drawing/2014/main" id="{2BA3692E-EC00-481D-8EFC-1DE28FB24DB6}"/>
               </a:ext>
             </a:extLst>
           </p:cNvPr>
@@ -17029,7 +17075,7 @@
           <p:cNvPr id="8" name="text-58">
             <a:extLst xmlns:a="http://schemas.openxmlformats.org/drawingml/2006/main">
               <a:ext uri="{FF2B5EF4-FFF2-40B4-BE49-F238E27FC236}">
-                <a16:creationId xmlns:a16="http://schemas.microsoft.com/office/drawing/2014/main" id="{67E97FF7-2C4B-4379-B7A8-8B5AF7A56526}"/>
+                <a16:creationId xmlns:a16="http://schemas.microsoft.com/office/drawing/2014/main" id="{8ACAA3CC-F795-428C-BDB0-F1043E751ED4}"/>
               </a:ext>
             </a:extLst>
           </p:cNvPr>
@@ -17187,7 +17233,7 @@
           <p:cNvPr id="9" name="text-59">
             <a:extLst xmlns:a="http://schemas.openxmlformats.org/drawingml/2006/main">
               <a:ext uri="{FF2B5EF4-FFF2-40B4-BE49-F238E27FC236}">
-                <a16:creationId xmlns:a16="http://schemas.microsoft.com/office/drawing/2014/main" id="{24A2F9F2-CCE1-4693-BB92-B30B99B18501}"/>
+                <a16:creationId xmlns:a16="http://schemas.microsoft.com/office/drawing/2014/main" id="{F95FE0EC-4547-481B-93E4-DEF05668795C}"/>
               </a:ext>
             </a:extLst>
           </p:cNvPr>
@@ -17345,7 +17391,7 @@
           <p:cNvPr id="10" name="text-60">
             <a:extLst xmlns:a="http://schemas.openxmlformats.org/drawingml/2006/main">
               <a:ext uri="{FF2B5EF4-FFF2-40B4-BE49-F238E27FC236}">
-                <a16:creationId xmlns:a16="http://schemas.microsoft.com/office/drawing/2014/main" id="{09BB44ED-6383-4614-A390-FFB51F40D5DE}"/>
+                <a16:creationId xmlns:a16="http://schemas.microsoft.com/office/drawing/2014/main" id="{989BB8B2-8AE7-42C6-96A2-47C7B05D5AE0}"/>
               </a:ext>
             </a:extLst>
           </p:cNvPr>
@@ -17503,7 +17549,7 @@
           <p:cNvPr id="11" name="text-61">
             <a:extLst xmlns:a="http://schemas.openxmlformats.org/drawingml/2006/main">
               <a:ext uri="{FF2B5EF4-FFF2-40B4-BE49-F238E27FC236}">
-                <a16:creationId xmlns:a16="http://schemas.microsoft.com/office/drawing/2014/main" id="{E8F21165-17CF-4B2F-A375-F0DA41AAC1DD}"/>
+                <a16:creationId xmlns:a16="http://schemas.microsoft.com/office/drawing/2014/main" id="{29CD5D5D-1C24-4D25-ACE8-4B04F7B4C895}"/>
               </a:ext>
             </a:extLst>
           </p:cNvPr>
@@ -17661,7 +17707,7 @@
           <p:cNvPr id="12" name="text-62">
             <a:extLst xmlns:a="http://schemas.openxmlformats.org/drawingml/2006/main">
               <a:ext uri="{FF2B5EF4-FFF2-40B4-BE49-F238E27FC236}">
-                <a16:creationId xmlns:a16="http://schemas.microsoft.com/office/drawing/2014/main" id="{3A91948A-AA08-4A24-9453-5B874008D029}"/>
+                <a16:creationId xmlns:a16="http://schemas.microsoft.com/office/drawing/2014/main" id="{112EDD55-33A9-4999-A824-6F509DC45705}"/>
               </a:ext>
             </a:extLst>
           </p:cNvPr>
@@ -17855,7 +17901,7 @@
                 <a:ea typeface="Helvetica Neue"/>
                 <a:cs typeface="Helvetica Neue"/>
               </a:rPr>
-              <a:t>Bounded exercise catalogue</a:t>
+              <a:t>Canonical catalogue capabilities</a:t>
             </a:r>
           </a:p>
         </p:txBody>
@@ -17865,7 +17911,7 @@
           <p:cNvPr id="13" name="text-63">
             <a:extLst xmlns:a="http://schemas.openxmlformats.org/drawingml/2006/main">
               <a:ext uri="{FF2B5EF4-FFF2-40B4-BE49-F238E27FC236}">
-                <a16:creationId xmlns:a16="http://schemas.microsoft.com/office/drawing/2014/main" id="{AA64128B-BD30-450F-9738-7F261CDA8AD4}"/>
+                <a16:creationId xmlns:a16="http://schemas.microsoft.com/office/drawing/2014/main" id="{E92B20AE-B3C2-4194-B531-2C69D43FCCE0}"/>
               </a:ext>
             </a:extLst>
           </p:cNvPr>
@@ -18023,7 +18069,7 @@
           <p:cNvPr id="14" name="text-64">
             <a:extLst xmlns:a="http://schemas.openxmlformats.org/drawingml/2006/main">
               <a:ext uri="{FF2B5EF4-FFF2-40B4-BE49-F238E27FC236}">
-                <a16:creationId xmlns:a16="http://schemas.microsoft.com/office/drawing/2014/main" id="{BE7313AB-284D-43FA-8DB5-DD041B20EC24}"/>
+                <a16:creationId xmlns:a16="http://schemas.microsoft.com/office/drawing/2014/main" id="{E266AEEC-5D74-4F05-B3B1-B3BF6DF6850F}"/>
               </a:ext>
             </a:extLst>
           </p:cNvPr>
@@ -18227,7 +18273,7 @@
           <p:cNvPr id="15" name="text-65">
             <a:extLst xmlns:a="http://schemas.openxmlformats.org/drawingml/2006/main">
               <a:ext uri="{FF2B5EF4-FFF2-40B4-BE49-F238E27FC236}">
-                <a16:creationId xmlns:a16="http://schemas.microsoft.com/office/drawing/2014/main" id="{5064FAC3-EC3D-488E-B4EF-920EE72DA175}"/>
+                <a16:creationId xmlns:a16="http://schemas.microsoft.com/office/drawing/2014/main" id="{35AF1440-D6BB-46B5-9065-04063F510963}"/>
               </a:ext>
             </a:extLst>
           </p:cNvPr>
@@ -18375,7 +18421,7 @@
                 <a:ea typeface="Helvetica Neue"/>
                 <a:cs typeface="Helvetica Neue"/>
               </a:rPr>
-              <a:t>All four gateway types returned 200 with synthetic facts. Native provider acceptance pending.</a:t>
+              <a:t>4 gateway types; 2 native chats. Live native plans/reports and physical phone checks pending.</a:t>
             </a:r>
           </a:p>
         </p:txBody>
@@ -18383,7 +18429,7 @@
     </p:spTree>
     <p:extLst>
       <p:ext uri="{BB962C8B-B14F-4D97-AF65-F5344CB8AC3E}">
-        <p14:creationId xmlns:p14="http://schemas.microsoft.com/office/powerpoint/2010/main" val="1821365812"/>
+        <p14:creationId xmlns:p14="http://schemas.microsoft.com/office/powerpoint/2010/main" val="1530314371"/>
       </p:ext>
     </p:extLst>
   </p:cSld>
@@ -18414,7 +18460,7 @@
           <p:cNvPr id="11" name="text-66">
             <a:extLst xmlns:a="http://schemas.openxmlformats.org/drawingml/2006/main">
               <a:ext uri="{FF2B5EF4-FFF2-40B4-BE49-F238E27FC236}">
-                <a16:creationId xmlns:a16="http://schemas.microsoft.com/office/drawing/2014/main" id="{B5171779-56B0-4964-B174-5130B400EA5F}"/>
+                <a16:creationId xmlns:a16="http://schemas.microsoft.com/office/drawing/2014/main" id="{36D6C4C2-CE75-4674-9880-04EE6795897A}"/>
               </a:ext>
             </a:extLst>
           </p:cNvPr>
@@ -18572,7 +18618,7 @@
           <p:cNvPr id="2" name="text-67">
             <a:extLst xmlns:a="http://schemas.openxmlformats.org/drawingml/2006/main">
               <a:ext uri="{FF2B5EF4-FFF2-40B4-BE49-F238E27FC236}">
-                <a16:creationId xmlns:a16="http://schemas.microsoft.com/office/drawing/2014/main" id="{E4723543-98DD-4881-9484-D98BDBB05AB9}"/>
+                <a16:creationId xmlns:a16="http://schemas.microsoft.com/office/drawing/2014/main" id="{F3A4DB76-CE33-4EF0-83E1-117D66FC9F7C}"/>
               </a:ext>
             </a:extLst>
           </p:cNvPr>
@@ -18730,7 +18776,7 @@
           <p:cNvPr id="3" name="text-68">
             <a:extLst xmlns:a="http://schemas.openxmlformats.org/drawingml/2006/main">
               <a:ext uri="{FF2B5EF4-FFF2-40B4-BE49-F238E27FC236}">
-                <a16:creationId xmlns:a16="http://schemas.microsoft.com/office/drawing/2014/main" id="{070723D4-AB45-407C-A254-3C9DFD36CDB6}"/>
+                <a16:creationId xmlns:a16="http://schemas.microsoft.com/office/drawing/2014/main" id="{E1C6494E-61D0-4F58-9C2B-132388465C40}"/>
               </a:ext>
             </a:extLst>
           </p:cNvPr>
@@ -18888,7 +18934,7 @@
           <p:cNvPr id="4" name="text-69">
             <a:extLst xmlns:a="http://schemas.openxmlformats.org/drawingml/2006/main">
               <a:ext uri="{FF2B5EF4-FFF2-40B4-BE49-F238E27FC236}">
-                <a16:creationId xmlns:a16="http://schemas.microsoft.com/office/drawing/2014/main" id="{271977D5-3FDF-4C7E-8AD4-7C0DC0B790D1}"/>
+                <a16:creationId xmlns:a16="http://schemas.microsoft.com/office/drawing/2014/main" id="{7E71E3C1-7D16-43E1-A2D8-9AAD7AEE175A}"/>
               </a:ext>
             </a:extLst>
           </p:cNvPr>
@@ -19046,7 +19092,7 @@
           <p:cNvPr id="5" name="text-70">
             <a:extLst xmlns:a="http://schemas.openxmlformats.org/drawingml/2006/main">
               <a:ext uri="{FF2B5EF4-FFF2-40B4-BE49-F238E27FC236}">
-                <a16:creationId xmlns:a16="http://schemas.microsoft.com/office/drawing/2014/main" id="{BD1210B9-CC17-46FC-BC41-17BD47793A05}"/>
+                <a16:creationId xmlns:a16="http://schemas.microsoft.com/office/drawing/2014/main" id="{6E09ADC8-A45D-488F-99E3-236240E33CF5}"/>
               </a:ext>
             </a:extLst>
           </p:cNvPr>
@@ -19194,7 +19240,7 @@
                 <a:ea typeface="Helvetica Neue"/>
                 <a:cs typeface="Helvetica Neue"/>
               </a:rPr>
-              <a:t>Proposed role</a:t>
+              <a:t>Implemented adapters</a:t>
             </a:r>
           </a:p>
           <a:p xmlns:a="http://schemas.openxmlformats.org/drawingml/2006/main">
@@ -19250,7 +19296,7 @@
           <p:cNvPr id="6" name="text-71">
             <a:extLst xmlns:a="http://schemas.openxmlformats.org/drawingml/2006/main">
               <a:ext uri="{FF2B5EF4-FFF2-40B4-BE49-F238E27FC236}">
-                <a16:creationId xmlns:a16="http://schemas.microsoft.com/office/drawing/2014/main" id="{973F6BA9-A38D-498D-B41D-94B7147D324F}"/>
+                <a16:creationId xmlns:a16="http://schemas.microsoft.com/office/drawing/2014/main" id="{200C39A6-A151-459F-9C25-4958BDF59279}"/>
               </a:ext>
             </a:extLst>
           </p:cNvPr>
@@ -19431,7 +19477,7 @@
           <p:cNvPr id="7" name="text-72">
             <a:extLst xmlns:a="http://schemas.openxmlformats.org/drawingml/2006/main">
               <a:ext uri="{FF2B5EF4-FFF2-40B4-BE49-F238E27FC236}">
-                <a16:creationId xmlns:a16="http://schemas.microsoft.com/office/drawing/2014/main" id="{254D775A-BCE4-431A-BC95-87614CB2A08F}"/>
+                <a16:creationId xmlns:a16="http://schemas.microsoft.com/office/drawing/2014/main" id="{8024F765-581B-4057-BAFA-40B5E1FF0347}"/>
               </a:ext>
             </a:extLst>
           </p:cNvPr>
@@ -19589,7 +19635,7 @@
           <p:cNvPr id="8" name="text-73">
             <a:extLst xmlns:a="http://schemas.openxmlformats.org/drawingml/2006/main">
               <a:ext uri="{FF2B5EF4-FFF2-40B4-BE49-F238E27FC236}">
-                <a16:creationId xmlns:a16="http://schemas.microsoft.com/office/drawing/2014/main" id="{7D68CBB3-DD37-4013-868F-309CDE74837C}"/>
+                <a16:creationId xmlns:a16="http://schemas.microsoft.com/office/drawing/2014/main" id="{8C4FC370-F69E-4737-BDE8-5C16BDA46F52}"/>
               </a:ext>
             </a:extLst>
           </p:cNvPr>
@@ -19747,7 +19793,7 @@
           <p:cNvPr id="9" name="text-74">
             <a:extLst xmlns:a="http://schemas.openxmlformats.org/drawingml/2006/main">
               <a:ext uri="{FF2B5EF4-FFF2-40B4-BE49-F238E27FC236}">
-                <a16:creationId xmlns:a16="http://schemas.microsoft.com/office/drawing/2014/main" id="{C11AAF6A-4D41-46FC-962E-C18BD12D0373}"/>
+                <a16:creationId xmlns:a16="http://schemas.microsoft.com/office/drawing/2014/main" id="{AF6402EF-AD3D-40A6-889B-E8975CFA8FA0}"/>
               </a:ext>
             </a:extLst>
           </p:cNvPr>
@@ -19895,7 +19941,7 @@
                 <a:ea typeface="Helvetica Neue"/>
                 <a:cs typeface="Helvetica Neue"/>
               </a:rPr>
-              <a:t>Proposed role</a:t>
+              <a:t>Implemented public-data batch</a:t>
             </a:r>
           </a:p>
           <a:p xmlns:a="http://schemas.openxmlformats.org/drawingml/2006/main">
@@ -19918,7 +19964,7 @@
                 <a:ea typeface="Helvetica Neue"/>
                 <a:cs typeface="Helvetica Neue"/>
               </a:rPr>
-              <a:t>Versioned evaluation tables</a:t>
+              <a:t>Pinned forecast lineage</a:t>
             </a:r>
           </a:p>
           <a:p xmlns:a="http://schemas.openxmlformats.org/drawingml/2006/main">
@@ -19941,7 +19987,7 @@
                 <a:ea typeface="Helvetica Neue"/>
                 <a:cs typeface="Helvetica Neue"/>
               </a:rPr>
-              <a:t>and offline error analysis</a:t>
+              <a:t>and error reconciliation</a:t>
             </a:r>
           </a:p>
         </p:txBody>
@@ -19951,7 +19997,7 @@
           <p:cNvPr id="10" name="text-75">
             <a:extLst xmlns:a="http://schemas.openxmlformats.org/drawingml/2006/main">
               <a:ext uri="{FF2B5EF4-FFF2-40B4-BE49-F238E27FC236}">
-                <a16:creationId xmlns:a16="http://schemas.microsoft.com/office/drawing/2014/main" id="{C32367D2-E3E6-42A1-91BD-712424166B53}"/>
+                <a16:creationId xmlns:a16="http://schemas.microsoft.com/office/drawing/2014/main" id="{44A9CD28-74E6-44FF-90E5-105FD1ACCC2D}"/>
               </a:ext>
             </a:extLst>
           </p:cNvPr>
@@ -20099,7 +20145,7 @@
                 <a:ea typeface="Helvetica Neue"/>
                 <a:cs typeface="Helvetica Neue"/>
               </a:rPr>
-              <a:t>SQL API adapter tested with doubles.</a:t>
+              <a:t>Dry-run import/evaluation tested.</a:t>
             </a:r>
           </a:p>
           <a:p xmlns:a="http://schemas.openxmlformats.org/drawingml/2006/main">
@@ -20122,7 +20168,7 @@
                 <a:ea typeface="Helvetica Neue"/>
                 <a:cs typeface="Helvetica Neue"/>
               </a:rPr>
-              <a:t>Live statement acceptance pending.</a:t>
+              <a:t>Live warehouse acceptance pending.</a:t>
             </a:r>
           </a:p>
         </p:txBody>
@@ -20130,7 +20176,7 @@
     </p:spTree>
     <p:extLst>
       <p:ext uri="{BB962C8B-B14F-4D97-AF65-F5344CB8AC3E}">
-        <p14:creationId xmlns:p14="http://schemas.microsoft.com/office/powerpoint/2010/main" val="889928101"/>
+        <p14:creationId xmlns:p14="http://schemas.microsoft.com/office/powerpoint/2010/main" val="1618343240"/>
       </p:ext>
     </p:extLst>
   </p:cSld>
@@ -20161,7 +20207,7 @@
           <p:cNvPr id="10" name="text-76">
             <a:extLst xmlns:a="http://schemas.openxmlformats.org/drawingml/2006/main">
               <a:ext uri="{FF2B5EF4-FFF2-40B4-BE49-F238E27FC236}">
-                <a16:creationId xmlns:a16="http://schemas.microsoft.com/office/drawing/2014/main" id="{3363C789-C4E0-44A2-9AD2-0DC48FC8F2CD}"/>
+                <a16:creationId xmlns:a16="http://schemas.microsoft.com/office/drawing/2014/main" id="{918CAB0C-67AE-44EE-9502-2CDA4139A2CD}"/>
               </a:ext>
             </a:extLst>
           </p:cNvPr>
@@ -20319,7 +20365,7 @@
           <p:cNvPr id="2" name="text-77">
             <a:extLst xmlns:a="http://schemas.openxmlformats.org/drawingml/2006/main">
               <a:ext uri="{FF2B5EF4-FFF2-40B4-BE49-F238E27FC236}">
-                <a16:creationId xmlns:a16="http://schemas.microsoft.com/office/drawing/2014/main" id="{3A0A34B0-FF46-45A6-9A15-F321638CE54B}"/>
+                <a16:creationId xmlns:a16="http://schemas.microsoft.com/office/drawing/2014/main" id="{487A4F16-9E3C-4340-857D-002376C2EDAC}"/>
               </a:ext>
             </a:extLst>
           </p:cNvPr>
@@ -20477,7 +20523,7 @@
           <p:cNvPr id="3" name="text-78">
             <a:extLst xmlns:a="http://schemas.openxmlformats.org/drawingml/2006/main">
               <a:ext uri="{FF2B5EF4-FFF2-40B4-BE49-F238E27FC236}">
-                <a16:creationId xmlns:a16="http://schemas.microsoft.com/office/drawing/2014/main" id="{04B215D8-127A-4A6B-B235-0EC39C701646}"/>
+                <a16:creationId xmlns:a16="http://schemas.microsoft.com/office/drawing/2014/main" id="{82F58ABE-4287-4200-B140-B199E2F74109}"/>
               </a:ext>
             </a:extLst>
           </p:cNvPr>
@@ -20635,7 +20681,7 @@
           <p:cNvPr id="4" name="Chart">
             <a:extLst xmlns:a="http://schemas.openxmlformats.org/drawingml/2006/main">
               <a:ext uri="{FF2B5EF4-FFF2-40B4-BE49-F238E27FC236}">
-                <a16:creationId xmlns:a16="http://schemas.microsoft.com/office/drawing/2014/main" id="{6A5B1F7F-7ACB-4DD7-89F6-97114651C106}"/>
+                <a16:creationId xmlns:a16="http://schemas.microsoft.com/office/drawing/2014/main" id="{C5DEB631-9D6A-4874-8896-C79650FA988A}"/>
               </a:ext>
             </a:extLst>
           </p:cNvPr>
@@ -20648,7 +20694,7 @@
         </p:xfrm>
         <a:graphic xmlns:a="http://schemas.openxmlformats.org/drawingml/2006/main">
           <a:graphicData uri="http://schemas.openxmlformats.org/drawingml/2006/chart">
-            <c:chart xmlns:r="http://schemas.openxmlformats.org/officeDocument/2006/relationships" xmlns:c="http://schemas.openxmlformats.org/drawingml/2006/chart" r:id="Rba8393a1ab014675"/>
+            <c:chart xmlns:r="http://schemas.openxmlformats.org/officeDocument/2006/relationships" xmlns:c="http://schemas.openxmlformats.org/drawingml/2006/chart" r:id="R1175eb1d9bd84a1e"/>
           </a:graphicData>
         </a:graphic>
       </p:graphicFrame>
@@ -20657,7 +20703,7 @@
           <p:cNvPr id="5" name="text-79">
             <a:extLst xmlns:a="http://schemas.openxmlformats.org/drawingml/2006/main">
               <a:ext uri="{FF2B5EF4-FFF2-40B4-BE49-F238E27FC236}">
-                <a16:creationId xmlns:a16="http://schemas.microsoft.com/office/drawing/2014/main" id="{D23CAC77-A85E-4286-954A-AA8AD40ED45C}"/>
+                <a16:creationId xmlns:a16="http://schemas.microsoft.com/office/drawing/2014/main" id="{59EE30D4-E356-4A73-88A5-9074C82C5DF6}"/>
               </a:ext>
             </a:extLst>
           </p:cNvPr>
@@ -20815,7 +20861,7 @@
           <p:cNvPr id="6" name="text-80">
             <a:extLst xmlns:a="http://schemas.openxmlformats.org/drawingml/2006/main">
               <a:ext uri="{FF2B5EF4-FFF2-40B4-BE49-F238E27FC236}">
-                <a16:creationId xmlns:a16="http://schemas.microsoft.com/office/drawing/2014/main" id="{A3DF92D3-0F45-4519-BC23-C242DFC09D63}"/>
+                <a16:creationId xmlns:a16="http://schemas.microsoft.com/office/drawing/2014/main" id="{CB8C1937-91CA-41BB-AB95-AED8D62509FC}"/>
               </a:ext>
             </a:extLst>
           </p:cNvPr>
@@ -20973,7 +21019,7 @@
           <p:cNvPr id="7" name="text-81">
             <a:extLst xmlns:a="http://schemas.openxmlformats.org/drawingml/2006/main">
               <a:ext uri="{FF2B5EF4-FFF2-40B4-BE49-F238E27FC236}">
-                <a16:creationId xmlns:a16="http://schemas.microsoft.com/office/drawing/2014/main" id="{1D741083-E9E6-403F-BA90-AC96DB0AFA3A}"/>
+                <a16:creationId xmlns:a16="http://schemas.microsoft.com/office/drawing/2014/main" id="{8D4F131B-3847-4778-871F-E24DFB49FDFF}"/>
               </a:ext>
             </a:extLst>
           </p:cNvPr>
@@ -21154,7 +21200,7 @@
           <p:cNvPr id="8" name="text-82">
             <a:extLst xmlns:a="http://schemas.openxmlformats.org/drawingml/2006/main">
               <a:ext uri="{FF2B5EF4-FFF2-40B4-BE49-F238E27FC236}">
-                <a16:creationId xmlns:a16="http://schemas.microsoft.com/office/drawing/2014/main" id="{A401E0BF-1274-4419-9E85-0983A494DFF4}"/>
+                <a16:creationId xmlns:a16="http://schemas.microsoft.com/office/drawing/2014/main" id="{287419B9-1F08-481F-931A-2EA639930623}"/>
               </a:ext>
             </a:extLst>
           </p:cNvPr>
@@ -21335,7 +21381,7 @@
           <p:cNvPr id="9" name="text-83">
             <a:extLst xmlns:a="http://schemas.openxmlformats.org/drawingml/2006/main">
               <a:ext uri="{FF2B5EF4-FFF2-40B4-BE49-F238E27FC236}">
-                <a16:creationId xmlns:a16="http://schemas.microsoft.com/office/drawing/2014/main" id="{BA6128B5-2758-47D0-A9F7-F60517AADC25}"/>
+                <a16:creationId xmlns:a16="http://schemas.microsoft.com/office/drawing/2014/main" id="{41A621C9-5D2D-415D-AFF4-C6064FF3C1B6}"/>
               </a:ext>
             </a:extLst>
           </p:cNvPr>
@@ -21491,7 +21537,7 @@
     </p:spTree>
     <p:extLst>
       <p:ext uri="{BB962C8B-B14F-4D97-AF65-F5344CB8AC3E}">
-        <p14:creationId xmlns:p14="http://schemas.microsoft.com/office/powerpoint/2010/main" val="705578982"/>
+        <p14:creationId xmlns:p14="http://schemas.microsoft.com/office/powerpoint/2010/main" val="1389472466"/>
       </p:ext>
     </p:extLst>
   </p:cSld>
@@ -21522,7 +21568,7 @@
           <p:cNvPr id="5" name="text-84">
             <a:extLst xmlns:a="http://schemas.openxmlformats.org/drawingml/2006/main">
               <a:ext uri="{FF2B5EF4-FFF2-40B4-BE49-F238E27FC236}">
-                <a16:creationId xmlns:a16="http://schemas.microsoft.com/office/drawing/2014/main" id="{EF320DBB-350D-4858-9F4C-9FA0717DAF39}"/>
+                <a16:creationId xmlns:a16="http://schemas.microsoft.com/office/drawing/2014/main" id="{6EEFD6F9-A67D-43A2-BAAA-50074EA31323}"/>
               </a:ext>
             </a:extLst>
           </p:cNvPr>
@@ -21680,7 +21726,7 @@
           <p:cNvPr id="2" name="text-85">
             <a:extLst xmlns:a="http://schemas.openxmlformats.org/drawingml/2006/main">
               <a:ext uri="{FF2B5EF4-FFF2-40B4-BE49-F238E27FC236}">
-                <a16:creationId xmlns:a16="http://schemas.microsoft.com/office/drawing/2014/main" id="{4CB2C467-0D12-4098-B29F-0692E5DD5994}"/>
+                <a16:creationId xmlns:a16="http://schemas.microsoft.com/office/drawing/2014/main" id="{8B54B533-43F2-4EF2-8F0B-B27E0F5A1FA0}"/>
               </a:ext>
             </a:extLst>
           </p:cNvPr>
@@ -21838,7 +21884,7 @@
           <p:cNvPr id="3" name="">
             <a:extLst xmlns:a="http://schemas.openxmlformats.org/drawingml/2006/main">
               <a:ext uri="{FF2B5EF4-FFF2-40B4-BE49-F238E27FC236}">
-                <a16:creationId xmlns:a16="http://schemas.microsoft.com/office/drawing/2014/main" id="{12A1ED36-D2B1-48FF-8347-64ACDDE0FBC4}"/>
+                <a16:creationId xmlns:a16="http://schemas.microsoft.com/office/drawing/2014/main" id="{3915D413-0934-4A1B-93D5-9648B3C6A4E8}"/>
               </a:ext>
             </a:extLst>
           </p:cNvPr>
@@ -22049,7 +22095,7 @@
                           <a:ea typeface="Helvetica Neue"/>
                           <a:cs typeface="Helvetica Neue"/>
                         </a:rPr>
-                        <a:t>4 gateway types: HTTP 200</a:t>
+                        <a:t>Gateway + 2 native chats</a:t>
                       </a:r>
                     </a:p>
                   </a:txBody>
@@ -22085,7 +22131,7 @@
                           <a:ea typeface="Helvetica Neue"/>
                           <a:cs typeface="Helvetica Neue"/>
                         </a:rPr>
-                        <a:t>Native acceptance and factual review</a:t>
+                        <a:t>Native plans/reports; physical networking</a:t>
                       </a:r>
                     </a:p>
                   </a:txBody>
@@ -22281,7 +22327,7 @@
                           <a:ea typeface="Helvetica Neue"/>
                           <a:cs typeface="Helvetica Neue"/>
                         </a:rPr>
-                        <a:t>SQL adapter tested</a:t>
+                        <a:t>Pinned batch workflow tested</a:t>
                       </a:r>
                     </a:p>
                   </a:txBody>
@@ -22317,7 +22363,7 @@
                           <a:ea typeface="Helvetica Neue"/>
                           <a:cs typeface="Helvetica Neue"/>
                         </a:rPr>
-                        <a:t>Credentials and a bounded live statement</a:t>
+                        <a:t>Existing warehouse and live SQL</a:t>
                       </a:r>
                     </a:p>
                   </a:txBody>
@@ -22397,7 +22443,7 @@
                           <a:ea typeface="Helvetica Neue"/>
                           <a:cs typeface="Helvetica Neue"/>
                         </a:rPr>
-                        <a:t>Packaging prepared</a:t>
+                        <a:t>Local ARM64 runtime checked</a:t>
                       </a:r>
                     </a:p>
                   </a:txBody>
@@ -22433,7 +22479,7 @@
                           <a:ea typeface="Helvetica Neue"/>
                           <a:cs typeface="Helvetica Neue"/>
                         </a:rPr>
-                        <a:t>Credit/spend scope and deployment</a:t>
+                        <a:t>Spend scope; hosted TLS/auth</a:t>
                       </a:r>
                     </a:p>
                   </a:txBody>
@@ -22813,7 +22859,7 @@
           <p:cNvPr id="4" name="text-86">
             <a:extLst xmlns:a="http://schemas.openxmlformats.org/drawingml/2006/main">
               <a:ext uri="{FF2B5EF4-FFF2-40B4-BE49-F238E27FC236}">
-                <a16:creationId xmlns:a16="http://schemas.microsoft.com/office/drawing/2014/main" id="{8E6B469D-F6E0-4D36-9402-153729213ACF}"/>
+                <a16:creationId xmlns:a16="http://schemas.microsoft.com/office/drawing/2014/main" id="{FF31FBA8-94D1-4748-86A8-67072320C59B}"/>
               </a:ext>
             </a:extLst>
           </p:cNvPr>
@@ -22824,8 +22870,8 @@
         </p:nvSpPr>
         <p:spPr>
           <a:xfrm xmlns:a="http://schemas.openxmlformats.org/drawingml/2006/main">
-            <a:off x="762000" y="6105525"/>
-            <a:ext cx="10477500" cy="381000"/>
+            <a:off x="762000" y="5972175"/>
+            <a:ext cx="9810750" cy="619125"/>
           </a:xfrm>
           <a:prstGeom xmlns:a="http://schemas.openxmlformats.org/drawingml/2006/main" prst="rect">
             <a:avLst/>
@@ -22841,7 +22887,7 @@
           </a:bodyPr>
           <a:lstStyle xmlns:a="http://schemas.openxmlformats.org/drawingml/2006/main">
             <a:defPPr>
-              <a:defRPr sz="1875" b="0">
+              <a:defRPr sz="1725" b="0">
                 <a:solidFill>
                   <a:srgbClr val="5D6560"/>
                 </a:solidFill>
@@ -22851,7 +22897,7 @@
               </a:defRPr>
             </a:defPPr>
             <a:lvl1pPr>
-              <a:defRPr sz="1875" b="0">
+              <a:defRPr sz="1725" b="0">
                 <a:solidFill>
                   <a:srgbClr val="5D6560"/>
                 </a:solidFill>
@@ -22861,7 +22907,7 @@
               </a:defRPr>
             </a:lvl1pPr>
             <a:lvl2pPr>
-              <a:defRPr sz="1875" b="0">
+              <a:defRPr sz="1725" b="0">
                 <a:solidFill>
                   <a:srgbClr val="5D6560"/>
                 </a:solidFill>
@@ -22871,7 +22917,7 @@
               </a:defRPr>
             </a:lvl2pPr>
             <a:lvl3pPr>
-              <a:defRPr sz="1875" b="0">
+              <a:defRPr sz="1725" b="0">
                 <a:solidFill>
                   <a:srgbClr val="5D6560"/>
                 </a:solidFill>
@@ -22881,7 +22927,7 @@
               </a:defRPr>
             </a:lvl3pPr>
             <a:lvl4pPr>
-              <a:defRPr sz="1875" b="0">
+              <a:defRPr sz="1725" b="0">
                 <a:solidFill>
                   <a:srgbClr val="5D6560"/>
                 </a:solidFill>
@@ -22891,7 +22937,7 @@
               </a:defRPr>
             </a:lvl4pPr>
             <a:lvl5pPr>
-              <a:defRPr sz="1875" b="0">
+              <a:defRPr sz="1725" b="0">
                 <a:solidFill>
                   <a:srgbClr val="5D6560"/>
                 </a:solidFill>
@@ -22901,7 +22947,7 @@
               </a:defRPr>
             </a:lvl5pPr>
             <a:lvl6pPr>
-              <a:defRPr sz="1875" b="0">
+              <a:defRPr sz="1725" b="0">
                 <a:solidFill>
                   <a:srgbClr val="5D6560"/>
                 </a:solidFill>
@@ -22911,7 +22957,7 @@
               </a:defRPr>
             </a:lvl6pPr>
             <a:lvl7pPr>
-              <a:defRPr sz="1875" b="0">
+              <a:defRPr sz="1725" b="0">
                 <a:solidFill>
                   <a:srgbClr val="5D6560"/>
                 </a:solidFill>
@@ -22921,7 +22967,7 @@
               </a:defRPr>
             </a:lvl7pPr>
             <a:lvl8pPr>
-              <a:defRPr sz="1875" b="0">
+              <a:defRPr sz="1725" b="0">
                 <a:solidFill>
                   <a:srgbClr val="5D6560"/>
                 </a:solidFill>
@@ -22931,7 +22977,7 @@
               </a:defRPr>
             </a:lvl8pPr>
             <a:lvl9pPr>
-              <a:defRPr sz="1875" b="0">
+              <a:defRPr sz="1725" b="0">
                 <a:solidFill>
                   <a:srgbClr val="5D6560"/>
                 </a:solidFill>
@@ -22943,7 +22989,7 @@
           </a:lstStyle>
           <a:p xmlns:a="http://schemas.openxmlformats.org/drawingml/2006/main">
             <a:pPr>
-              <a:defRPr sz="1875" b="0">
+              <a:defRPr sz="1725" b="0">
                 <a:solidFill>
                   <a:srgbClr val="5D6560"/>
                 </a:solidFill>
@@ -22953,7 +22999,7 @@
               </a:defRPr>
             </a:pPr>
             <a:r>
-              <a:rPr sz="1875" b="0">
+              <a:rPr sz="1725" b="0">
                 <a:solidFill>
                   <a:srgbClr val="5D6560"/>
                 </a:solidFill>
@@ -22961,7 +23007,7 @@
                 <a:ea typeface="Helvetica Neue"/>
                 <a:cs typeface="Helvetica Neue"/>
               </a:rPr>
-              <a:t>Local workouts remain usable while optional providers are pending.</a:t>
+              <a:t>Standalone web prototype: 92 offline checks and mock-profile browser acceptance. Real cloud upload pending.</a:t>
             </a:r>
           </a:p>
         </p:txBody>
@@ -22969,7 +23015,7 @@
     </p:spTree>
     <p:extLst>
       <p:ext uri="{BB962C8B-B14F-4D97-AF65-F5344CB8AC3E}">
-        <p14:creationId xmlns:p14="http://schemas.microsoft.com/office/powerpoint/2010/main" val="783430499"/>
+        <p14:creationId xmlns:p14="http://schemas.microsoft.com/office/powerpoint/2010/main" val="1701730222"/>
       </p:ext>
     </p:extLst>
   </p:cSld>

</xml_diff>

<commit_message>
docs: refresh judges deck with accepted Gemini and Tiger evidence
</commit_message>
<xml_diff>
--- a/presentation/output/spottr-judges.pptx
+++ b/presentation/output/spottr-judges.pptx
@@ -2,22 +2,22 @@
 <file path=ppt/presentation.xml><?xml version="1.0" encoding="utf-8"?>
 <p:presentation xmlns:p="http://schemas.openxmlformats.org/presentationml/2006/main">
   <p:sldMasterIdLst>
-    <p:sldMasterId xmlns:r="http://schemas.openxmlformats.org/officeDocument/2006/relationships" id="2147483648" r:id="R73856d90906b41d9"/>
+    <p:sldMasterId xmlns:r="http://schemas.openxmlformats.org/officeDocument/2006/relationships" id="2147483648" r:id="R401fdfa0c3a941ce"/>
   </p:sldMasterIdLst>
   <p:notesMasterIdLst>
-    <p:notesMasterId xmlns:r="http://schemas.openxmlformats.org/officeDocument/2006/relationships" r:id="R54b9702192d247cf"/>
+    <p:notesMasterId xmlns:r="http://schemas.openxmlformats.org/officeDocument/2006/relationships" r:id="R5990c4beba4b4a8b"/>
   </p:notesMasterIdLst>
   <p:sldIdLst>
-    <p:sldId xmlns:r="http://schemas.openxmlformats.org/officeDocument/2006/relationships" id="256" r:id="Ra285e6301c924c84"/>
-    <p:sldId xmlns:r="http://schemas.openxmlformats.org/officeDocument/2006/relationships" id="257" r:id="R9941da905a534afe"/>
-    <p:sldId xmlns:r="http://schemas.openxmlformats.org/officeDocument/2006/relationships" id="258" r:id="R8f9a7a60b2b541d6"/>
-    <p:sldId xmlns:r="http://schemas.openxmlformats.org/officeDocument/2006/relationships" id="259" r:id="Rc4bce602d42c4efa"/>
-    <p:sldId xmlns:r="http://schemas.openxmlformats.org/officeDocument/2006/relationships" id="260" r:id="R899ec0b2b1f94e1b"/>
-    <p:sldId xmlns:r="http://schemas.openxmlformats.org/officeDocument/2006/relationships" id="261" r:id="Ra48130be618b44c1"/>
-    <p:sldId xmlns:r="http://schemas.openxmlformats.org/officeDocument/2006/relationships" id="262" r:id="R2592338b480645a3"/>
-    <p:sldId xmlns:r="http://schemas.openxmlformats.org/officeDocument/2006/relationships" id="263" r:id="R13552c05b65a45cb"/>
-    <p:sldId xmlns:r="http://schemas.openxmlformats.org/officeDocument/2006/relationships" id="264" r:id="R07f9504d3b60407e"/>
-    <p:sldId xmlns:r="http://schemas.openxmlformats.org/officeDocument/2006/relationships" id="265" r:id="R52e3cd138186474b"/>
+    <p:sldId xmlns:r="http://schemas.openxmlformats.org/officeDocument/2006/relationships" id="256" r:id="R802c8f7c07c74c09"/>
+    <p:sldId xmlns:r="http://schemas.openxmlformats.org/officeDocument/2006/relationships" id="257" r:id="Rbdb04ac153c44c86"/>
+    <p:sldId xmlns:r="http://schemas.openxmlformats.org/officeDocument/2006/relationships" id="258" r:id="R10cab054fbd0443b"/>
+    <p:sldId xmlns:r="http://schemas.openxmlformats.org/officeDocument/2006/relationships" id="259" r:id="R8d00568116e84d03"/>
+    <p:sldId xmlns:r="http://schemas.openxmlformats.org/officeDocument/2006/relationships" id="260" r:id="R23e93013f5284f4a"/>
+    <p:sldId xmlns:r="http://schemas.openxmlformats.org/officeDocument/2006/relationships" id="261" r:id="Rd5b8bfab77d548e4"/>
+    <p:sldId xmlns:r="http://schemas.openxmlformats.org/officeDocument/2006/relationships" id="262" r:id="Re284a0b4f4264fe3"/>
+    <p:sldId xmlns:r="http://schemas.openxmlformats.org/officeDocument/2006/relationships" id="263" r:id="Rba689a70b59f4b6f"/>
+    <p:sldId xmlns:r="http://schemas.openxmlformats.org/officeDocument/2006/relationships" id="264" r:id="Ra6cd5b914ae54cd5"/>
+    <p:sldId xmlns:r="http://schemas.openxmlformats.org/officeDocument/2006/relationships" id="265" r:id="Re3defebe5d50421c"/>
   </p:sldIdLst>
   <p:sldSz cx="12192000" cy="6858000"/>
   <p:notesSz cx="6858000" cy="9144000"/>
@@ -451,7 +451,7 @@
           <a:lstStyle xmlns:a="http://schemas.openxmlformats.org/drawingml/2006/main"/>
           <a:p xmlns:a="http://schemas.openxmlformats.org/drawingml/2006/main">
             <a:r>
-              <a:t>Opening: Spottr is an implemented native bodyweight workout prototype. The motivation is short, timely feedback with an explicit evidence boundary, not a clinical or physical-capacity claim. The image is an actual iPhone simulator screenshot approved by the owner, with missing/unearned progress shown honestly. Evidence snapshot 24 October 2026, 23:11 UTC (25 October locally). Sources: /Users/scsoc/dev/AI PT/docs/app-guide.md; /Users/scsoc/dev/AI PT/docs/integration-readiness.md. Asset source and SHA256 are in presentation/source/assets.json.</a:t>
+              <a:t>Opening: Spottr is an implemented native bodyweight workout prototype. The motivation is short, timely feedback with an explicit evidence boundary, not a clinical or physical-capacity claim. The image is an actual iPhone simulator screenshot approved by the owner, with missing/unearned progress shown honestly. Evidence snapshot 25 October 2026, 00:09 UTC. Sources: /Users/scsoc/dev/AI PT/docs/app-guide.md; /Users/scsoc/dev/AI PT/docs/integration-readiness.md. Asset source and SHA256 are in presentation/source/assets.json.</a:t>
             </a:r>
           </a:p>
         </p:txBody>
@@ -521,7 +521,7 @@
           <a:lstStyle xmlns:a="http://schemas.openxmlformats.org/drawingml/2006/main"/>
           <a:p xmlns:a="http://schemas.openxmlformats.org/drawingml/2006/main">
             <a:r>
-              <a:t>Evidence snapshot 24 October 2026, 23:11 UTC (25 October locally). This is a suggested rehearsal sequence, not an assertion that a rehearsal occurred. Use normal history safely. Open current Today/profile, then tracked workout, pause/end and source-aware record, Skills and explicit Coach controls. If fixtures or a simulator supply values, label them and do not call them live physiological data. Do not spend provider credits as part of rehearsal without the existing approved scope. Show the saved public-data benchmark as offline. Build 0.1 (1) passed Apple validation/upload, is VALID and internally IN_BETA_TESTING. External build 1 remains WAITING_FOR_BETA_REVIEW and its 25-person invitation is not yet a usable external download. Build 0.1 (2), source b7bf563, passed signed archive/export and Apple validation at 23:06:21 UTC; upload succeeded at 23:08:00 UTC. At 23:10:33 UTC App Store Connect reported VALID and internal IN_BETA_TESTING after assignment to the existing Spottr Internal group. Both builds are internal. Build 2 remains READY_FOR_BETA_SUBMISSION and is not submitted externally; only build 1 is assigned to the external OxHack group. The configured discomfort fix and manual-set wording are after build 1 and are included in build 2, not the already available build 1. The unresolved MediaPipe upstream privacy/origin-signature gap is separate from successful Apple processing; no physical installation or public App Store approval is claimed. Sources: /Users/scsoc/dev/AI PT/docs/evidence/testflight-build-2-2026-10-24.md; /Users/scsoc/dev/AI PT/docs/testflight.md; /Users/scsoc/dev/AI PT/docs/app-guide.md; /Users/scsoc/dev/AI PT/docs/integration-readiness.md; /Users/scsoc/dev/AI PT/docs/release-readiness.md; /Users/scsoc/dev/AI PT/docs/testflight-provisioning.md.</a:t>
+              <a:t>Evidence snapshot 25 October 2026, 00:09 UTC. This is a suggested rehearsal sequence, not an assertion that a rehearsal occurred. Use normal history safely. Open current Today/profile, then tracked workout, pause/end and source-aware record, Skills and explicit Coach controls. If fixtures or a simulator supply values, label them and do not call them live physiological data. Do not spend provider credits as part of rehearsal without the existing approved scope. Show the saved public-data benchmark as offline. Build 0.1 (1) passed Apple validation/upload, is VALID and internally IN_BETA_TESTING. External build 1 remains WAITING_FOR_BETA_REVIEW and its 25-person invitation is not yet a usable external download. Build 0.1 (2), source b7bf563, passed signed archive/export and Apple validation at 23:06:21 UTC; upload succeeded at 23:08:00 UTC. At 23:10:33 UTC App Store Connect reported VALID and internal IN_BETA_TESTING after assignment to the existing Spottr Internal group. Both builds are internal. Build 2 remains READY_FOR_BETA_SUBMISSION and is not submitted externally; only build 1 is assigned to the external OxHack group. The configured discomfort fix and manual-set wording are after build 1 and are included in build 2, not the already available build 1. The unresolved MediaPipe upstream privacy/origin-signature gap is separate from successful Apple processing; no physical installation or public App Store approval is claimed. Sources: /Users/scsoc/dev/AI PT/docs/evidence/testflight-build-2-2026-10-24.md; /Users/scsoc/dev/AI PT/docs/testflight.md; /Users/scsoc/dev/AI PT/docs/app-guide.md; /Users/scsoc/dev/AI PT/docs/integration-readiness.md; /Users/scsoc/dev/AI PT/docs/release-readiness.md; /Users/scsoc/dev/AI PT/docs/testflight-provisioning.md.</a:t>
             </a:r>
           </a:p>
         </p:txBody>
@@ -591,7 +591,7 @@
           <a:lstStyle xmlns:a="http://schemas.openxmlformats.org/drawingml/2006/main"/>
           <a:p xmlns:a="http://schemas.openxmlformats.org/drawingml/2006/main">
             <a:r>
-              <a:t>Evidence snapshot 24 October 2026, 23:11 UTC (25 October locally). Implemented native flow, not a measured rep-accuracy claim. Manual/timed workouts work without cloud credentials. A real camera path exists for push-ups and squats; physical accuracy/error/abstention evaluation remains pending. Local speech is opt-in, fake-playback tested, with audible phone acceptance pending. Sources: /Users/scsoc/dev/AI PT/docs/app-guide.md; /Users/scsoc/dev/AI PT/docs/voice-feedback.md; /Users/scsoc/dev/AI PT/docs/integration-readiness.md.</a:t>
+              <a:t>Evidence snapshot 25 October 2026, 00:09 UTC. Implemented native flow, not a measured rep-accuracy claim. Manual/timed workouts work without cloud credentials. A real camera path exists for push-ups and squats; physical accuracy/error/abstention evaluation remains pending. Local speech is opt-in, fake-playback tested, with audible phone acceptance pending. Sources: /Users/scsoc/dev/AI PT/docs/app-guide.md; /Users/scsoc/dev/AI PT/docs/voice-feedback.md; /Users/scsoc/dev/AI PT/docs/integration-readiness.md.</a:t>
             </a:r>
           </a:p>
         </p:txBody>
@@ -661,7 +661,7 @@
           <a:lstStyle xmlns:a="http://schemas.openxmlformats.org/drawingml/2006/main"/>
           <a:p xmlns:a="http://schemas.openxmlformats.org/drawingml/2006/main">
             <a:r>
-              <a:t>Evidence snapshot 24 October 2026, 23:11 UTC (25 October locally). Editable architecture. Phone owns MediaPipe inference, session state and deterministic policy. Watch adapter forwards latest-value timestamped heart/motion signals, not raw lossless vectors. Simulator transport/visual evidence and unsigned device compilation are separate from physical Watch recording. Pi real HTTPS pairing/start/frame/stop tests succeeded, then USB disconnected after around two seconds. No Pi inference or sustained capture is claimed. Sources: /Users/scsoc/dev/AI PT/docs/watch-telemetry.md; /Users/scsoc/dev/AI PT/docs/watch-simulator-acceptance.md; /Users/scsoc/dev/AI PT/hardware/pi/EVIDENCE-2026-10-24.md; /Users/scsoc/dev/AI PT/hardware/pi/NATIVE-HANDOFF.md.</a:t>
+              <a:t>Evidence snapshot 25 October 2026, 00:09 UTC. Editable architecture. Phone owns MediaPipe inference, session state and deterministic policy. Watch adapter forwards latest-value timestamped heart/motion signals, not raw lossless vectors. Simulator transport/visual evidence and unsigned device compilation are separate from physical Watch recording. Pi real HTTPS pairing/start/frame/stop tests succeeded, then USB disconnected after around two seconds. No Pi inference or sustained capture is claimed. Sources: /Users/scsoc/dev/AI PT/docs/watch-telemetry.md; /Users/scsoc/dev/AI PT/docs/watch-simulator-acceptance.md; /Users/scsoc/dev/AI PT/hardware/pi/EVIDENCE-2026-10-24.md; /Users/scsoc/dev/AI PT/hardware/pi/NATIVE-HANDOFF.md.</a:t>
             </a:r>
           </a:p>
         </p:txBody>
@@ -731,7 +731,7 @@
           <a:lstStyle xmlns:a="http://schemas.openxmlformats.org/drawingml/2006/main"/>
           <a:p xmlns:a="http://schemas.openxmlformats.org/drawingml/2006/main">
             <a:r>
-              <a:t>Evidence snapshot 24 October 2026, 23:11 UTC (25 October locally). These are deterministic implementation rules, not calibrated physiological thresholds or a measurement of rep-count accuracy. RepCounter requires confidence&gt;=0.6 and a complete top-bottom-top cycle, resets on gaps&gt;0.75s or nonmonotonic time, uses0.15s zone stability and accepts0.6–15s cycle duration. CoachingPolicy compares a new valid rep with at least five prior valid durations using mean+max(sampleSD,0.25s). Reported discomfort has an exercise-independent stop decision, including manual reps and holds. PR #64 passed 23 native checks, 26 core checks and a Watch simulator build; fake playback does not establish audible acceptance. Stop identity persists across ticks; repeated stop does not cut itself off or replay after background return. Lifecycle invalidation prevents old cues/sensor callbacks entering a new state. Sources: /Users/scsoc/dev/AI PT/Shared/Core/RepCounter.swift; /Users/scsoc/dev/AI PT/Shared/Core/CoachingPolicy.swift; /Users/scsoc/dev/AI PT/docs/watch-telemetry.md; /Users/scsoc/dev/AI PT/docs/voice-feedback.md. Phase images are existing illustrations, not captured workout evidence.</a:t>
+              <a:t>Evidence snapshot 25 October 2026, 00:09 UTC. These are deterministic implementation rules, not calibrated physiological thresholds or a measurement of rep-count accuracy. RepCounter requires confidence&gt;=0.6 and a complete top-bottom-top cycle, resets on gaps&gt;0.75s or nonmonotonic time, uses0.15s zone stability and accepts0.6–15s cycle duration. CoachingPolicy compares a new valid rep with at least five prior valid durations using mean+max(sampleSD,0.25s). Reported discomfort has an exercise-independent stop decision, including manual reps and holds. PR #64 passed 23 native checks, 26 core checks and a Watch simulator build; fake playback does not establish audible acceptance. Stop identity persists across ticks; repeated stop does not cut itself off or replay after background return. Lifecycle invalidation prevents old cues/sensor callbacks entering a new state. Sources: /Users/scsoc/dev/AI PT/Shared/Core/RepCounter.swift; /Users/scsoc/dev/AI PT/Shared/Core/CoachingPolicy.swift; /Users/scsoc/dev/AI PT/docs/watch-telemetry.md; /Users/scsoc/dev/AI PT/docs/voice-feedback.md. Phase images are existing illustrations, not captured workout evidence.</a:t>
             </a:r>
           </a:p>
         </p:txBody>
@@ -801,7 +801,7 @@
           <a:lstStyle xmlns:a="http://schemas.openxmlformats.org/drawingml/2006/main"/>
           <a:p xmlns:a="http://schemas.openxmlformats.org/drawingml/2006/main">
             <a:r>
-              <a:t>Evidence snapshot 24 October 2026, 23:11 UTC (25 October locally). The current app has19 catalogue entries and connected tree/linear options. This diagram shows the exact immediate prerequisite example for pushup: kneePushup and plank. Earlier prerequisites of those nodes are omitted. Node completion needs three qualifying sets across two days after all immediate prerequisites complete. Manual/camera evidence can qualify; video replay and discomfort stops do not. Game points are not physical capacity. Sources: /Users/scsoc/dev/AI PT/Shared/Core/SkillProgress.swift; /Users/scsoc/dev/AI PT/Shared/Core/ExerciseCatalog.swift; /Users/scsoc/dev/AI PT/Native/iOS/SkillsViews.swift; /Users/scsoc/dev/AI PT/docs/app-guide.md. Exercise artwork is existing PNG content, with source hashes in assets.json.</a:t>
+              <a:t>Evidence snapshot 25 October 2026, 00:09 UTC. The current app has19 catalogue entries and connected tree/linear options. This diagram shows the exact immediate prerequisite example for pushup: kneePushup and plank. Earlier prerequisites of those nodes are omitted. Node completion needs three qualifying sets across two days after all immediate prerequisites complete. Manual/camera evidence can qualify; video replay and discomfort stops do not. Game points are not physical capacity. Sources: /Users/scsoc/dev/AI PT/Shared/Core/SkillProgress.swift; /Users/scsoc/dev/AI PT/Shared/Core/ExerciseCatalog.swift; /Users/scsoc/dev/AI PT/Native/iOS/SkillsViews.swift; /Users/scsoc/dev/AI PT/docs/app-guide.md. Exercise artwork is existing PNG content, with source hashes in assets.json.</a:t>
             </a:r>
           </a:p>
         </p:txBody>
@@ -871,7 +871,7 @@
           <a:lstStyle xmlns:a="http://schemas.openxmlformats.org/drawingml/2006/main"/>
           <a:p xmlns:a="http://schemas.openxmlformats.org/drawingml/2006/main">
             <a:r>
-              <a:t>Evidence snapshot 24 October 2026, 23:11 UTC (25 October locally). Local gateway returned actual200 responses for chat/session/weekly/proposal using synthetic inputs. Two signed-simulator native chats reached Google. The second accepted the server-owned capability context: base push-ups and squats support camera tracking; other rep exercises use manual logging and seconds exercises use an active hold timer. Native live proposals/reports, physical phone networking and personal factual review remain pending. Separate native fixture checks exercise structured-response display without a provider call. Automatic facts include selected goals and weekly target, omit optional name, and retain sources. Schema/evidence validation rejects missing/unknown fact IDs; generation identity rejects late context. Plans require explicit user selection/approval and proposed targets never count as completed work. No raw camera video or sensor stream is automatically supplied here. Sources: /Users/scsoc/dev/AI PT/docs/evidence/native-gemini-chat-2026-10-24.md; /Users/scsoc/dev/AI PT/docs/coach-goals.md; /Users/scsoc/dev/AI PT/Shared/Core/CoachContracts.swift; /Users/scsoc/dev/AI PT/Shared/Core/CoachGrounding.swift; /Users/scsoc/dev/AI PT/docs/integration-readiness.md.</a:t>
+              <a:t>Evidence snapshot 25 October 2026, 00:09 UTC. Local gateway returned actual200 responses for chat/session/weekly/proposal using synthetic inputs. Two signed-simulator native chats reached Google. The second accepted the server-owned capability context: base push-ups and squats support camera tracking; other rep exercises use manual logging and seconds exercises use an active hold timer. After a provider-only maxItems schema projection, three explicit native production actions accepted a proposal, weekly summary and session summary with isolated synthetic inputs. The full original output validator remains enforced. The proposal offered Squats, Knee push-ups and Forearm plank; only Squats was selected, with no approval or saved plan. The reports described one synthetic manual session/set with two Squats reps and no Watch data/profile. Physical phone networking and real-user coaching quality remain pending. Separate native fixture checks exercise structured-response display without a provider call. Automatic facts include selected goals and weekly target, omit optional name, and retain sources. Schema/evidence validation rejects missing/unknown fact IDs; generation identity rejects late context. Plans require explicit user selection/approval and proposed targets never count as completed work. No raw camera video or sensor stream is automatically supplied here. Sources: /Users/scsoc/dev/AI PT/docs/evidence/native-gemini-chat-2026-10-24.md; /Users/scsoc/dev/AI PT/docs/evidence/gemini-structured-compatibility-2026-10-25.md; /Users/scsoc/dev/AI PT/docs/coach-goals.md; /Users/scsoc/dev/AI PT/Shared/Core/CoachContracts.swift; /Users/scsoc/dev/AI PT/Shared/Core/CoachGrounding.swift; /Users/scsoc/dev/AI PT/docs/integration-readiness.md.</a:t>
             </a:r>
           </a:p>
         </p:txBody>
@@ -941,7 +941,7 @@
           <a:lstStyle xmlns:a="http://schemas.openxmlformats.org/drawingml/2006/main"/>
           <a:p xmlns:a="http://schemas.openxmlformats.org/drawingml/2006/main">
             <a:r>
-              <a:t>Evidence snapshot 24 October 2026, 23:11 UTC (25 October locally). These implemented adapters have offline acceptance, not live database usage. Operational Tiger storage and Snowflake retrospective public-data evaluation are separate. Tiger service exists but strict TLS fails SELF_SIGNED_CERT_IN_CHAIN with current private CA endpoint, so no live query/migration/persistence is accepted. Snowflake pinned public PAMAP2 import/reconciliation and bounded SQL transport are tested offline; dry-run is default and live public-data execution requires explicit opt-in. No actual warehouse statement/result is accepted. Local history and explicit optional sync remain distinct. Sources: /Users/scsoc/dev/AI PT/docs/integration-readiness.md; /Users/scsoc/dev/AI PT/docs/tiger-live-readiness.md; /Users/scsoc/dev/AI PT/docs/ISSUES.md; /Users/scsoc/dev/AI PT/docs/personal-learning.md.</a:t>
+              <a:t>Evidence snapshot 25 October 2026, 00:09 UTC. Operational Tiger storage and Snowflake retrospective public-data evaluation are separate. Authenticated Tiger Explorer accepted the exact gateway migration: two empty tables, 15 columns, seven validated PK/CHECK constraints, a one-day scalar hypertable and four usable indexes. No workout or sensor rows were inserted. The separate Node connection still fails strict TLS with SELF_SIGNED_CERT_IN_CHAIN; no gateway ingestion, replay/readback, rollup or standalone prototype database acceptance is claimed. Snowflake pinned public PAMAP2 import/reconciliation and bounded SQL transport are tested offline; dry-run is default and live public-data execution requires explicit opt-in. No actual warehouse statement/result is accepted. Local history and explicit optional sync remain distinct. Sources: /Users/scsoc/dev/AI PT/docs/integration-readiness.md; /Users/scsoc/dev/AI PT/docs/tiger-live-readiness.md; /Users/scsoc/dev/AI PT/docs/ISSUES.md; /Users/scsoc/dev/AI PT/docs/personal-learning.md; /Users/scsoc/dev/AI PT/docs/evidence/tiger-console-2026-10-24.md.</a:t>
             </a:r>
           </a:p>
         </p:txBody>
@@ -1011,7 +1011,7 @@
           <a:lstStyle xmlns:a="http://schemas.openxmlformats.org/drawingml/2006/main"/>
           <a:p xmlns:a="http://schemas.openxmlformats.org/drawingml/2006/main">
             <a:r>
-              <a:t>Evidence snapshot 24 October 2026, 23:11 UTC (25 October locally). Actual offline PAMAP2 run2026-10-24T20:43:51–20:43:59UTC. Source: Reiss,A.(2012), PAMAP2 Physical Activity Monitoring, UCI DOI10.24432/C5NW2H, CC BY4.0. Changes: causal features/ridge/figures/evaluation. Official source https://archive.ics.uci.edu/dataset/231/pamap2+physical+activity+monitoring. Train101–105,validation106–107,test108–109. Future target: mean of five observed1s HR-bin means ending10/30s after origin; input history60s. No interpolation, future covariates or test normalization. Validation selected HR-only ridge alpha0.1, not wrist candidates. Test108:80310s and79930s forecasts. Test109:only410s and030s forecasts from84.76s recording. Macro10s gives both participants equal weight despite tiny109 count. At30s only108 contributes. Fixed prequential bias adapter worsened full-run error. No calibrated intervals, Watch transfer, recovery, failure/RIR prediction, or app integration.13 contract tests pass. Sources: /Users/scsoc/dev/AI PT/research/hr_forecast/protocol.json; /Users/scsoc/dev/AI PT/research/hr_forecast/results/report.json; /Users/scsoc/dev/AI PT/research/hr_forecast/results/inventory.json; /Users/scsoc/dev/AI PT/docs/public-data-benchmark.md. Original plots copied unchanged into presentation/assets/ for supplementary evidence. Native chart values round the recorded metrics to three decimal places for editable workbook compatibility.</a:t>
+              <a:t>Evidence snapshot 25 October 2026, 00:09 UTC. Actual offline PAMAP2 run2026-10-24T20:43:51–20:43:59UTC. Source: Reiss,A.(2012), PAMAP2 Physical Activity Monitoring, UCI DOI10.24432/C5NW2H, CC BY4.0. Changes: causal features/ridge/figures/evaluation. Official source https://archive.ics.uci.edu/dataset/231/pamap2+physical+activity+monitoring. Train101–105,validation106–107,test108–109. Future target: mean of five observed1s HR-bin means ending10/30s after origin; input history60s. No interpolation, future covariates or test normalization. Validation selected HR-only ridge alpha0.1, not wrist candidates. Test108:80310s and79930s forecasts. Test109:only410s and030s forecasts from84.76s recording. Macro10s gives both participants equal weight despite tiny109 count. At30s only108 contributes. Fixed prequential bias adapter worsened full-run error. No calibrated intervals, Watch transfer, recovery, failure/RIR prediction, or app integration.13 contract tests pass. Sources: /Users/scsoc/dev/AI PT/research/hr_forecast/protocol.json; /Users/scsoc/dev/AI PT/research/hr_forecast/results/report.json; /Users/scsoc/dev/AI PT/research/hr_forecast/results/inventory.json; /Users/scsoc/dev/AI PT/docs/public-data-benchmark.md. Original plots copied unchanged into presentation/assets/ for supplementary evidence. Native chart values round the recorded metrics to three decimal places for editable workbook compatibility.</a:t>
             </a:r>
           </a:p>
         </p:txBody>
@@ -1081,7 +1081,7 @@
           <a:lstStyle xmlns:a="http://schemas.openxmlformats.org/drawingml/2006/main"/>
           <a:p xmlns:a="http://schemas.openxmlformats.org/drawingml/2006/main">
             <a:r>
-              <a:t>Evidence snapshot 24 October 2026, 23:11 UTC (25 October locally). This table summarizes implementation/fixture/live distinctions. Never claim all sponsors/providers were used. Gemini has four actual synthetic gateway response types and two signed-simulator native chat checks; physical networking and native structured-output acceptance remain pending. Voice local Apple synthesis is implemented with fake playback tests; no audible/ElevenLabs run. Tiger current endpoint/private CA chain unresolved, no trust bypass. Snowflake pinned batch workflow and local ARM64 gateway/Caddy runtime checks passed; no Snowflake live statement or Vultr VM/credit/spend scope; Presage automatic derived-vitals egress unresolved; Delta zero judge requests and missing installation/legal operator gate. Sources: /Users/scsoc/dev/AI PT/docs/evidence/pushup-prototype-integrity-2026-10-24.md; /Users/scsoc/dev/AI PT/docs/snowflake-analytics.md; /Users/scsoc/dev/AI PT/docs/vultr-deployment.md; /Users/scsoc/dev/AI PT/docs/integration-readiness.md; /Users/scsoc/dev/AI PT/docs/ISSUES.md; /Users/scsoc/dev/AI PT/docs/voice-feedback.md; /Users/scsoc/dev/AI PT/docs/presage-integration.md; /Users/scsoc/dev/AI PT/docs/delta-workflow.md; /Users/scsoc/dev/AI PT/docs/tiger-live-readiness.md.</a:t>
+              <a:t>Evidence snapshot 25 October 2026, 00:09 UTC. This table summarizes implementation/fixture/live distinctions. Never claim all sponsors/providers were used. Gemini has four actual synthetic gateway response types, two signed-simulator native chats, and three accepted native production structured actions (proposal/session/week) after the provider-only schema fix. All new inputs were isolated synthetic records. Physical phone networking and personal coaching quality remain pending. The investigation used seven new provider attempts total: initial normal native 502, two diagnostic native HTTP400, one controlled direct HTTP200 and three post-fix native responses accepted by native display validation. No automatic retry or provider fallback was introduced. Voice local Apple synthesis is implemented with fake playback tests; no audible/ElevenLabs run. Tiger authenticated console accepted the gateway schema with zero rows; strict Node TLS remains blocked without trust bypass. Ingestion, readback, rollups and the separate prototype path remain unverified. The revised local landing uses actual white simulator captures and passed four-width, keyboard and reduced-motion checks; no public deployment. Snowflake pinned batch workflow and local ARM64 gateway/Caddy runtime checks passed; no Snowflake live statement or Vultr VM/credit/spend scope; Presage automatic derived-vitals egress unresolved; Delta zero judge requests and missing installation/legal operator gate. Sources: /Users/scsoc/dev/AI PT/docs/evidence/pushup-prototype-integrity-2026-10-24.md; /Users/scsoc/dev/AI PT/docs/evidence/gemini-structured-compatibility-2026-10-25.md; /Users/scsoc/dev/AI PT/docs/snowflake-analytics.md; /Users/scsoc/dev/AI PT/docs/vultr-deployment.md; /Users/scsoc/dev/AI PT/docs/integration-readiness.md; /Users/scsoc/dev/AI PT/docs/ISSUES.md; /Users/scsoc/dev/AI PT/docs/voice-feedback.md; /Users/scsoc/dev/AI PT/docs/presage-integration.md; /Users/scsoc/dev/AI PT/docs/delta-workflow.md; /Users/scsoc/dev/AI PT/docs/tiger-live-readiness.md; /Users/scsoc/dev/AI PT/docs/evidence/tiger-console-2026-10-24.md; /Users/scsoc/dev/AI PT/docs/evidence/landing-browser-2026-10-24.md.</a:t>
             </a:r>
           </a:p>
         </p:txBody>
@@ -1128,7 +1128,7 @@
           <p:cNvPr id="3" name="Title">
             <a:extLst xmlns:a="http://schemas.openxmlformats.org/drawingml/2006/main">
               <a:ext uri="{FF2B5EF4-FFF2-40B4-BE49-F238E27FC236}">
-                <a16:creationId xmlns:a16="http://schemas.microsoft.com/office/drawing/2014/main" id="{0FD2E04B-C8D2-4B43-8CC0-DAC897275919}"/>
+                <a16:creationId xmlns:a16="http://schemas.microsoft.com/office/drawing/2014/main" id="{24AAEA46-41CC-40B3-9721-FE450B7A70E8}"/>
               </a:ext>
             </a:extLst>
           </p:cNvPr>
@@ -1357,7 +1357,7 @@
           <p:cNvPr id="2" name="Subtitle">
             <a:extLst xmlns:a="http://schemas.openxmlformats.org/drawingml/2006/main">
               <a:ext uri="{FF2B5EF4-FFF2-40B4-BE49-F238E27FC236}">
-                <a16:creationId xmlns:a16="http://schemas.microsoft.com/office/drawing/2014/main" id="{BF8D96D4-D090-4E5A-831C-C6A7FFDE04E0}"/>
+                <a16:creationId xmlns:a16="http://schemas.microsoft.com/office/drawing/2014/main" id="{B13D0701-D96A-41C8-BB66-8A94B2F234A6}"/>
               </a:ext>
             </a:extLst>
           </p:cNvPr>
@@ -1603,7 +1603,7 @@
           <p:cNvPr id="2" name="Section title">
             <a:extLst xmlns:a="http://schemas.openxmlformats.org/drawingml/2006/main">
               <a:ext uri="{FF2B5EF4-FFF2-40B4-BE49-F238E27FC236}">
-                <a16:creationId xmlns:a16="http://schemas.microsoft.com/office/drawing/2014/main" id="{36B99A51-D159-4176-ADBC-6EC3999A1FAA}"/>
+                <a16:creationId xmlns:a16="http://schemas.microsoft.com/office/drawing/2014/main" id="{33EDDB32-E291-482E-A1A1-B9A4610DB31A}"/>
               </a:ext>
             </a:extLst>
           </p:cNvPr>
@@ -1849,7 +1849,7 @@
           <p:cNvPr id="3" name="Title">
             <a:extLst xmlns:a="http://schemas.openxmlformats.org/drawingml/2006/main">
               <a:ext uri="{FF2B5EF4-FFF2-40B4-BE49-F238E27FC236}">
-                <a16:creationId xmlns:a16="http://schemas.microsoft.com/office/drawing/2014/main" id="{AD21DAFF-302A-44F4-A9D0-0D529E2ADDFE}"/>
+                <a16:creationId xmlns:a16="http://schemas.microsoft.com/office/drawing/2014/main" id="{529E123B-A32C-4DD2-884F-53A869899FA8}"/>
               </a:ext>
             </a:extLst>
           </p:cNvPr>
@@ -2078,7 +2078,7 @@
           <p:cNvPr id="2" name="Body">
             <a:extLst xmlns:a="http://schemas.openxmlformats.org/drawingml/2006/main">
               <a:ext uri="{FF2B5EF4-FFF2-40B4-BE49-F238E27FC236}">
-                <a16:creationId xmlns:a16="http://schemas.microsoft.com/office/drawing/2014/main" id="{01BDCFDC-E346-4EC8-B0CD-CF7E28458C97}"/>
+                <a16:creationId xmlns:a16="http://schemas.microsoft.com/office/drawing/2014/main" id="{E19C7931-9E2D-468B-8E4A-4DF5939ACA5E}"/>
               </a:ext>
             </a:extLst>
           </p:cNvPr>
@@ -2324,7 +2324,7 @@
           <p:cNvPr id="4" name="Title">
             <a:extLst xmlns:a="http://schemas.openxmlformats.org/drawingml/2006/main">
               <a:ext uri="{FF2B5EF4-FFF2-40B4-BE49-F238E27FC236}">
-                <a16:creationId xmlns:a16="http://schemas.microsoft.com/office/drawing/2014/main" id="{E2E1B8FD-2D8D-4F0E-A508-331AA63CC5C5}"/>
+                <a16:creationId xmlns:a16="http://schemas.microsoft.com/office/drawing/2014/main" id="{AE2E7595-E85D-4E39-A241-1A23697617A4}"/>
               </a:ext>
             </a:extLst>
           </p:cNvPr>
@@ -2553,7 +2553,7 @@
           <p:cNvPr id="2" name="Left column">
             <a:extLst xmlns:a="http://schemas.openxmlformats.org/drawingml/2006/main">
               <a:ext uri="{FF2B5EF4-FFF2-40B4-BE49-F238E27FC236}">
-                <a16:creationId xmlns:a16="http://schemas.microsoft.com/office/drawing/2014/main" id="{C3DFE2E4-7CFE-494C-B890-800B06F31738}"/>
+                <a16:creationId xmlns:a16="http://schemas.microsoft.com/office/drawing/2014/main" id="{F0B110AD-282E-43F3-BC84-D1CD57774F3B}"/>
               </a:ext>
             </a:extLst>
           </p:cNvPr>
@@ -2782,7 +2782,7 @@
           <p:cNvPr id="3" name="Right column">
             <a:extLst xmlns:a="http://schemas.openxmlformats.org/drawingml/2006/main">
               <a:ext uri="{FF2B5EF4-FFF2-40B4-BE49-F238E27FC236}">
-                <a16:creationId xmlns:a16="http://schemas.microsoft.com/office/drawing/2014/main" id="{1BF72B14-AEBC-4B92-B6A0-5A0F3304556D}"/>
+                <a16:creationId xmlns:a16="http://schemas.microsoft.com/office/drawing/2014/main" id="{CFE199FC-5242-4533-BD21-FD09BA233D5C}"/>
               </a:ext>
             </a:extLst>
           </p:cNvPr>
@@ -3028,7 +3028,7 @@
           <p:cNvPr id="3" name="Title">
             <a:extLst xmlns:a="http://schemas.openxmlformats.org/drawingml/2006/main">
               <a:ext uri="{FF2B5EF4-FFF2-40B4-BE49-F238E27FC236}">
-                <a16:creationId xmlns:a16="http://schemas.microsoft.com/office/drawing/2014/main" id="{8EC1E5D9-4C8B-49AB-848D-1455C626FC2B}"/>
+                <a16:creationId xmlns:a16="http://schemas.microsoft.com/office/drawing/2014/main" id="{6693EE4E-54CF-4AD7-BAB8-CC109545F2D9}"/>
               </a:ext>
             </a:extLst>
           </p:cNvPr>
@@ -3257,7 +3257,7 @@
           <p:cNvPr id="2" name="Left column">
             <a:extLst xmlns:a="http://schemas.openxmlformats.org/drawingml/2006/main">
               <a:ext uri="{FF2B5EF4-FFF2-40B4-BE49-F238E27FC236}">
-                <a16:creationId xmlns:a16="http://schemas.microsoft.com/office/drawing/2014/main" id="{8E2B016D-FB1A-4606-B420-F3D865D67C28}"/>
+                <a16:creationId xmlns:a16="http://schemas.microsoft.com/office/drawing/2014/main" id="{970CBD2A-B51A-4491-990E-D99924AFA39C}"/>
               </a:ext>
             </a:extLst>
           </p:cNvPr>
@@ -3524,12 +3524,12 @@
   </p:cSld>
   <p:clrMap bg1="lt1" tx1="dk1" bg2="lt2" tx2="dk2" accent1="accent1" accent2="accent2" accent3="accent3" accent4="accent4" accent5="accent5" accent6="accent6" hlink="hlink" folHlink="folHlink"/>
   <p:sldLayoutIdLst>
-    <p:sldLayoutId xmlns:r="http://schemas.openxmlformats.org/officeDocument/2006/relationships" id="2147483649" r:id="R8bc79d273e39421f"/>
-    <p:sldLayoutId xmlns:r="http://schemas.openxmlformats.org/officeDocument/2006/relationships" id="2147483650" r:id="R98d65baf0f2d46bb"/>
-    <p:sldLayoutId xmlns:r="http://schemas.openxmlformats.org/officeDocument/2006/relationships" id="2147483651" r:id="R781484734593441c"/>
-    <p:sldLayoutId xmlns:r="http://schemas.openxmlformats.org/officeDocument/2006/relationships" id="2147483652" r:id="R74be7b5a1de243ec"/>
-    <p:sldLayoutId xmlns:r="http://schemas.openxmlformats.org/officeDocument/2006/relationships" id="2147483653" r:id="R2bef9b5e8bb64076"/>
-    <p:sldLayoutId xmlns:r="http://schemas.openxmlformats.org/officeDocument/2006/relationships" id="2147483654" r:id="R8deca65135ef4244"/>
+    <p:sldLayoutId xmlns:r="http://schemas.openxmlformats.org/officeDocument/2006/relationships" id="2147483649" r:id="R684ffd94148244f7"/>
+    <p:sldLayoutId xmlns:r="http://schemas.openxmlformats.org/officeDocument/2006/relationships" id="2147483650" r:id="Re47c252e8c7247ee"/>
+    <p:sldLayoutId xmlns:r="http://schemas.openxmlformats.org/officeDocument/2006/relationships" id="2147483651" r:id="Rd526a94f684647e3"/>
+    <p:sldLayoutId xmlns:r="http://schemas.openxmlformats.org/officeDocument/2006/relationships" id="2147483652" r:id="R3cc7d7236e7b496d"/>
+    <p:sldLayoutId xmlns:r="http://schemas.openxmlformats.org/officeDocument/2006/relationships" id="2147483653" r:id="Rc52aa1eb10d1447d"/>
+    <p:sldLayoutId xmlns:r="http://schemas.openxmlformats.org/officeDocument/2006/relationships" id="2147483654" r:id="Rf52ac56a95f64c64"/>
   </p:sldLayoutIdLst>
   <p:txStyles>
     <p:titleStyle>
@@ -4403,7 +4403,7 @@
           <p:cNvPr id="7" name="text-1">
             <a:extLst xmlns:a="http://schemas.openxmlformats.org/drawingml/2006/main">
               <a:ext uri="{FF2B5EF4-FFF2-40B4-BE49-F238E27FC236}">
-                <a16:creationId xmlns:a16="http://schemas.microsoft.com/office/drawing/2014/main" id="{72700AA0-2983-4CBA-B5AF-0DA5C7286A34}"/>
+                <a16:creationId xmlns:a16="http://schemas.microsoft.com/office/drawing/2014/main" id="{5F626E21-7054-4618-BFFD-85AE6C371814}"/>
               </a:ext>
             </a:extLst>
           </p:cNvPr>
@@ -4561,7 +4561,7 @@
           <p:cNvPr id="2" name="text-2">
             <a:extLst xmlns:a="http://schemas.openxmlformats.org/drawingml/2006/main">
               <a:ext uri="{FF2B5EF4-FFF2-40B4-BE49-F238E27FC236}">
-                <a16:creationId xmlns:a16="http://schemas.microsoft.com/office/drawing/2014/main" id="{4B4B8753-4F2B-4EF3-B107-5696B9F4AE1F}"/>
+                <a16:creationId xmlns:a16="http://schemas.microsoft.com/office/drawing/2014/main" id="{D6C505A6-DE82-42F6-BCD6-CB964371DABF}"/>
               </a:ext>
             </a:extLst>
           </p:cNvPr>
@@ -4742,7 +4742,7 @@
           <p:cNvPr id="3" name="text-3">
             <a:extLst xmlns:a="http://schemas.openxmlformats.org/drawingml/2006/main">
               <a:ext uri="{FF2B5EF4-FFF2-40B4-BE49-F238E27FC236}">
-                <a16:creationId xmlns:a16="http://schemas.microsoft.com/office/drawing/2014/main" id="{7CCDEC46-F61B-4911-97B4-858479A9EFCA}"/>
+                <a16:creationId xmlns:a16="http://schemas.microsoft.com/office/drawing/2014/main" id="{92375CA3-F4C0-49A1-8511-9D7461EEBECB}"/>
               </a:ext>
             </a:extLst>
           </p:cNvPr>
@@ -4923,7 +4923,7 @@
           <p:cNvPr id="4" name="text-4">
             <a:extLst xmlns:a="http://schemas.openxmlformats.org/drawingml/2006/main">
               <a:ext uri="{FF2B5EF4-FFF2-40B4-BE49-F238E27FC236}">
-                <a16:creationId xmlns:a16="http://schemas.microsoft.com/office/drawing/2014/main" id="{1D57976C-6C9D-414C-B746-CA176A266525}"/>
+                <a16:creationId xmlns:a16="http://schemas.microsoft.com/office/drawing/2014/main" id="{685BEFE9-2D47-4904-917B-E7418E4DC73D}"/>
               </a:ext>
             </a:extLst>
           </p:cNvPr>
@@ -5081,7 +5081,7 @@
           <p:cNvPr id="5" name="">
             <a:extLst xmlns:a="http://schemas.openxmlformats.org/drawingml/2006/main">
               <a:ext uri="{FF2B5EF4-FFF2-40B4-BE49-F238E27FC236}">
-                <a16:creationId xmlns:a16="http://schemas.microsoft.com/office/drawing/2014/main" id="{E308BBC5-3233-405C-8701-8FAD13FF044F}"/>
+                <a16:creationId xmlns:a16="http://schemas.microsoft.com/office/drawing/2014/main" id="{C7EAB77F-5406-4C37-99E2-E0627053BE9C}"/>
               </a:ext>
             </a:extLst>
           </p:cNvPr>
@@ -5091,7 +5091,7 @@
           <p:nvPr/>
         </p:nvPicPr>
         <p:blipFill>
-          <a:blip xmlns:r="http://schemas.openxmlformats.org/officeDocument/2006/relationships" xmlns:a="http://schemas.openxmlformats.org/drawingml/2006/main" r:embed="R94acd0e96e7f48db"/>
+          <a:blip xmlns:r="http://schemas.openxmlformats.org/officeDocument/2006/relationships" xmlns:a="http://schemas.openxmlformats.org/drawingml/2006/main" r:embed="R0552ccd038dc4cca"/>
           <a:stretch xmlns:a="http://schemas.openxmlformats.org/drawingml/2006/main"/>
         </p:blipFill>
         <p:spPr>
@@ -5109,7 +5109,7 @@
           <p:cNvPr id="6" name="text-5">
             <a:extLst xmlns:a="http://schemas.openxmlformats.org/drawingml/2006/main">
               <a:ext uri="{FF2B5EF4-FFF2-40B4-BE49-F238E27FC236}">
-                <a16:creationId xmlns:a16="http://schemas.microsoft.com/office/drawing/2014/main" id="{843FCCE9-F014-4934-B818-64A921122D47}"/>
+                <a16:creationId xmlns:a16="http://schemas.microsoft.com/office/drawing/2014/main" id="{9EB3CE46-7EC3-4CEF-B865-A690C40F89B7}"/>
               </a:ext>
             </a:extLst>
           </p:cNvPr>
@@ -5265,7 +5265,7 @@
     </p:spTree>
     <p:extLst>
       <p:ext uri="{BB962C8B-B14F-4D97-AF65-F5344CB8AC3E}">
-        <p14:creationId xmlns:p14="http://schemas.microsoft.com/office/powerpoint/2010/main" val="1049942259"/>
+        <p14:creationId xmlns:p14="http://schemas.microsoft.com/office/powerpoint/2010/main" val="564967337"/>
       </p:ext>
     </p:extLst>
   </p:cSld>
@@ -5296,7 +5296,7 @@
           <p:cNvPr id="19" name="text-87">
             <a:extLst xmlns:a="http://schemas.openxmlformats.org/drawingml/2006/main">
               <a:ext uri="{FF2B5EF4-FFF2-40B4-BE49-F238E27FC236}">
-                <a16:creationId xmlns:a16="http://schemas.microsoft.com/office/drawing/2014/main" id="{BCFC194E-F60D-4064-9DA1-7E62B902C104}"/>
+                <a16:creationId xmlns:a16="http://schemas.microsoft.com/office/drawing/2014/main" id="{04C61408-6BD7-4B08-8664-B6FA3983F6CE}"/>
               </a:ext>
             </a:extLst>
           </p:cNvPr>
@@ -5454,7 +5454,7 @@
           <p:cNvPr id="2" name="text-88">
             <a:extLst xmlns:a="http://schemas.openxmlformats.org/drawingml/2006/main">
               <a:ext uri="{FF2B5EF4-FFF2-40B4-BE49-F238E27FC236}">
-                <a16:creationId xmlns:a16="http://schemas.microsoft.com/office/drawing/2014/main" id="{722C12CC-4E5D-4923-923C-6A2990D54A38}"/>
+                <a16:creationId xmlns:a16="http://schemas.microsoft.com/office/drawing/2014/main" id="{7B4A6B30-B2E1-4EDD-BCA7-EC885D7DF453}"/>
               </a:ext>
             </a:extLst>
           </p:cNvPr>
@@ -5612,7 +5612,7 @@
           <p:cNvPr id="3" name="text-89">
             <a:extLst xmlns:a="http://schemas.openxmlformats.org/drawingml/2006/main">
               <a:ext uri="{FF2B5EF4-FFF2-40B4-BE49-F238E27FC236}">
-                <a16:creationId xmlns:a16="http://schemas.microsoft.com/office/drawing/2014/main" id="{4CCEC1DA-375F-4BC2-91BA-790F53B14AAC}"/>
+                <a16:creationId xmlns:a16="http://schemas.microsoft.com/office/drawing/2014/main" id="{4A009826-3BC5-4117-9D0A-2E0E52A401B5}"/>
               </a:ext>
             </a:extLst>
           </p:cNvPr>
@@ -5770,7 +5770,7 @@
           <p:cNvPr id="4" name="text-90">
             <a:extLst xmlns:a="http://schemas.openxmlformats.org/drawingml/2006/main">
               <a:ext uri="{FF2B5EF4-FFF2-40B4-BE49-F238E27FC236}">
-                <a16:creationId xmlns:a16="http://schemas.microsoft.com/office/drawing/2014/main" id="{48B39156-976B-4CD5-A815-1B7423F63091}"/>
+                <a16:creationId xmlns:a16="http://schemas.microsoft.com/office/drawing/2014/main" id="{B8A6CA06-E5FE-4069-BA49-E065A02774F2}"/>
               </a:ext>
             </a:extLst>
           </p:cNvPr>
@@ -5928,7 +5928,7 @@
           <p:cNvPr id="5" name="text-91">
             <a:extLst xmlns:a="http://schemas.openxmlformats.org/drawingml/2006/main">
               <a:ext uri="{FF2B5EF4-FFF2-40B4-BE49-F238E27FC236}">
-                <a16:creationId xmlns:a16="http://schemas.microsoft.com/office/drawing/2014/main" id="{658A0912-AA03-4EA2-BE02-32947C7D503A}"/>
+                <a16:creationId xmlns:a16="http://schemas.microsoft.com/office/drawing/2014/main" id="{43E0B523-458B-46C4-808D-D0DA126359ED}"/>
               </a:ext>
             </a:extLst>
           </p:cNvPr>
@@ -6086,7 +6086,7 @@
           <p:cNvPr id="6" name="text-92">
             <a:extLst xmlns:a="http://schemas.openxmlformats.org/drawingml/2006/main">
               <a:ext uri="{FF2B5EF4-FFF2-40B4-BE49-F238E27FC236}">
-                <a16:creationId xmlns:a16="http://schemas.microsoft.com/office/drawing/2014/main" id="{5E6C3121-F008-4835-BB85-2572A743AE53}"/>
+                <a16:creationId xmlns:a16="http://schemas.microsoft.com/office/drawing/2014/main" id="{8FAA0BED-7930-4B48-8A9C-D52AE226A1F0}"/>
               </a:ext>
             </a:extLst>
           </p:cNvPr>
@@ -6244,7 +6244,7 @@
           <p:cNvPr id="7" name="text-93">
             <a:extLst xmlns:a="http://schemas.openxmlformats.org/drawingml/2006/main">
               <a:ext uri="{FF2B5EF4-FFF2-40B4-BE49-F238E27FC236}">
-                <a16:creationId xmlns:a16="http://schemas.microsoft.com/office/drawing/2014/main" id="{BACBED4B-F1DA-40ED-88C8-1AEFB6D4922A}"/>
+                <a16:creationId xmlns:a16="http://schemas.microsoft.com/office/drawing/2014/main" id="{D0C615C4-C22B-4375-B2DC-84BE9FB21385}"/>
               </a:ext>
             </a:extLst>
           </p:cNvPr>
@@ -6402,7 +6402,7 @@
           <p:cNvPr id="8" name="text-94">
             <a:extLst xmlns:a="http://schemas.openxmlformats.org/drawingml/2006/main">
               <a:ext uri="{FF2B5EF4-FFF2-40B4-BE49-F238E27FC236}">
-                <a16:creationId xmlns:a16="http://schemas.microsoft.com/office/drawing/2014/main" id="{BAB247B1-08EE-4B06-A002-3A859C43C8BC}"/>
+                <a16:creationId xmlns:a16="http://schemas.microsoft.com/office/drawing/2014/main" id="{8DE606A8-54FE-49E2-A290-88FBFFE70C6A}"/>
               </a:ext>
             </a:extLst>
           </p:cNvPr>
@@ -6560,7 +6560,7 @@
           <p:cNvPr id="9" name="text-95">
             <a:extLst xmlns:a="http://schemas.openxmlformats.org/drawingml/2006/main">
               <a:ext uri="{FF2B5EF4-FFF2-40B4-BE49-F238E27FC236}">
-                <a16:creationId xmlns:a16="http://schemas.microsoft.com/office/drawing/2014/main" id="{04A0BA92-DD24-4ECF-B0EE-14DC1CFF3A9D}"/>
+                <a16:creationId xmlns:a16="http://schemas.microsoft.com/office/drawing/2014/main" id="{48DB6B9E-7FFB-49AF-9867-6E12B3A12486}"/>
               </a:ext>
             </a:extLst>
           </p:cNvPr>
@@ -6718,7 +6718,7 @@
           <p:cNvPr id="10" name="text-96">
             <a:extLst xmlns:a="http://schemas.openxmlformats.org/drawingml/2006/main">
               <a:ext uri="{FF2B5EF4-FFF2-40B4-BE49-F238E27FC236}">
-                <a16:creationId xmlns:a16="http://schemas.microsoft.com/office/drawing/2014/main" id="{B04931F7-BE8A-4665-8142-371F10DE27E3}"/>
+                <a16:creationId xmlns:a16="http://schemas.microsoft.com/office/drawing/2014/main" id="{4F0FEFC6-A826-4B29-B09B-C83C7EBF94FF}"/>
               </a:ext>
             </a:extLst>
           </p:cNvPr>
@@ -6876,7 +6876,7 @@
           <p:cNvPr id="11" name="text-97">
             <a:extLst xmlns:a="http://schemas.openxmlformats.org/drawingml/2006/main">
               <a:ext uri="{FF2B5EF4-FFF2-40B4-BE49-F238E27FC236}">
-                <a16:creationId xmlns:a16="http://schemas.microsoft.com/office/drawing/2014/main" id="{FF4890F6-9CAB-45CD-B41C-276C5C088CE2}"/>
+                <a16:creationId xmlns:a16="http://schemas.microsoft.com/office/drawing/2014/main" id="{5979FC80-9C59-44CF-97B1-80C5C76E4576}"/>
               </a:ext>
             </a:extLst>
           </p:cNvPr>
@@ -7034,7 +7034,7 @@
           <p:cNvPr id="12" name="text-98">
             <a:extLst xmlns:a="http://schemas.openxmlformats.org/drawingml/2006/main">
               <a:ext uri="{FF2B5EF4-FFF2-40B4-BE49-F238E27FC236}">
-                <a16:creationId xmlns:a16="http://schemas.microsoft.com/office/drawing/2014/main" id="{8318A7C0-4A8D-45EB-B33D-AB92B347BCAF}"/>
+                <a16:creationId xmlns:a16="http://schemas.microsoft.com/office/drawing/2014/main" id="{D627F0B0-FD47-4E27-92AC-0DBDFC15F642}"/>
               </a:ext>
             </a:extLst>
           </p:cNvPr>
@@ -7192,7 +7192,7 @@
           <p:cNvPr id="13" name="text-99">
             <a:extLst xmlns:a="http://schemas.openxmlformats.org/drawingml/2006/main">
               <a:ext uri="{FF2B5EF4-FFF2-40B4-BE49-F238E27FC236}">
-                <a16:creationId xmlns:a16="http://schemas.microsoft.com/office/drawing/2014/main" id="{3721A6E5-228E-4268-AA71-CF7A40A145C1}"/>
+                <a16:creationId xmlns:a16="http://schemas.microsoft.com/office/drawing/2014/main" id="{CC4A260D-033A-4070-AAED-8BDAAA8763EF}"/>
               </a:ext>
             </a:extLst>
           </p:cNvPr>
@@ -7350,7 +7350,7 @@
           <p:cNvPr id="14" name="text-100">
             <a:extLst xmlns:a="http://schemas.openxmlformats.org/drawingml/2006/main">
               <a:ext uri="{FF2B5EF4-FFF2-40B4-BE49-F238E27FC236}">
-                <a16:creationId xmlns:a16="http://schemas.microsoft.com/office/drawing/2014/main" id="{DC134921-A5B4-4F5A-88C4-5E286DFDFFD1}"/>
+                <a16:creationId xmlns:a16="http://schemas.microsoft.com/office/drawing/2014/main" id="{607A45A0-2790-4A4E-A662-B31B6B486D46}"/>
               </a:ext>
             </a:extLst>
           </p:cNvPr>
@@ -7508,7 +7508,7 @@
           <p:cNvPr id="15" name="text-101">
             <a:extLst xmlns:a="http://schemas.openxmlformats.org/drawingml/2006/main">
               <a:ext uri="{FF2B5EF4-FFF2-40B4-BE49-F238E27FC236}">
-                <a16:creationId xmlns:a16="http://schemas.microsoft.com/office/drawing/2014/main" id="{A2FA879B-9702-42F3-B4B6-CEF3FAB8FDB4}"/>
+                <a16:creationId xmlns:a16="http://schemas.microsoft.com/office/drawing/2014/main" id="{D0F641B1-1CEF-4382-A17F-82B503B099B4}"/>
               </a:ext>
             </a:extLst>
           </p:cNvPr>
@@ -7666,7 +7666,7 @@
           <p:cNvPr id="16" name="text-102">
             <a:extLst xmlns:a="http://schemas.openxmlformats.org/drawingml/2006/main">
               <a:ext uri="{FF2B5EF4-FFF2-40B4-BE49-F238E27FC236}">
-                <a16:creationId xmlns:a16="http://schemas.microsoft.com/office/drawing/2014/main" id="{29744C9C-1578-4E8B-931E-2238781A2C47}"/>
+                <a16:creationId xmlns:a16="http://schemas.microsoft.com/office/drawing/2014/main" id="{B2B78698-1111-4666-ADE2-047AE0E509ED}"/>
               </a:ext>
             </a:extLst>
           </p:cNvPr>
@@ -7824,7 +7824,7 @@
           <p:cNvPr id="17" name="text-103">
             <a:extLst xmlns:a="http://schemas.openxmlformats.org/drawingml/2006/main">
               <a:ext uri="{FF2B5EF4-FFF2-40B4-BE49-F238E27FC236}">
-                <a16:creationId xmlns:a16="http://schemas.microsoft.com/office/drawing/2014/main" id="{3D44BB5B-FF0F-415A-936D-09843E0BA670}"/>
+                <a16:creationId xmlns:a16="http://schemas.microsoft.com/office/drawing/2014/main" id="{97CB358B-A091-48F9-90EF-8E666D925C0C}"/>
               </a:ext>
             </a:extLst>
           </p:cNvPr>
@@ -7982,7 +7982,7 @@
           <p:cNvPr id="18" name="text-104">
             <a:extLst xmlns:a="http://schemas.openxmlformats.org/drawingml/2006/main">
               <a:ext uri="{FF2B5EF4-FFF2-40B4-BE49-F238E27FC236}">
-                <a16:creationId xmlns:a16="http://schemas.microsoft.com/office/drawing/2014/main" id="{1ADD71DD-410B-4AAB-A6BB-C8FA9702ADDB}"/>
+                <a16:creationId xmlns:a16="http://schemas.microsoft.com/office/drawing/2014/main" id="{402C77B1-8DD1-4917-BAE9-7A756FE1DDF9}"/>
               </a:ext>
             </a:extLst>
           </p:cNvPr>
@@ -8161,7 +8161,7 @@
     </p:spTree>
     <p:extLst>
       <p:ext uri="{BB962C8B-B14F-4D97-AF65-F5344CB8AC3E}">
-        <p14:creationId xmlns:p14="http://schemas.microsoft.com/office/powerpoint/2010/main" val="956444445"/>
+        <p14:creationId xmlns:p14="http://schemas.microsoft.com/office/powerpoint/2010/main" val="1313706491"/>
       </p:ext>
     </p:extLst>
   </p:cSld>
@@ -8192,7 +8192,7 @@
           <p:cNvPr id="15" name="text-6">
             <a:extLst xmlns:a="http://schemas.openxmlformats.org/drawingml/2006/main">
               <a:ext uri="{FF2B5EF4-FFF2-40B4-BE49-F238E27FC236}">
-                <a16:creationId xmlns:a16="http://schemas.microsoft.com/office/drawing/2014/main" id="{DC80A6E8-86B1-46C0-9245-8C0EA2458982}"/>
+                <a16:creationId xmlns:a16="http://schemas.microsoft.com/office/drawing/2014/main" id="{1EE82BFE-E9BE-44AE-B68F-396F6DF86F42}"/>
               </a:ext>
             </a:extLst>
           </p:cNvPr>
@@ -8350,7 +8350,7 @@
           <p:cNvPr id="2" name="text-7">
             <a:extLst xmlns:a="http://schemas.openxmlformats.org/drawingml/2006/main">
               <a:ext uri="{FF2B5EF4-FFF2-40B4-BE49-F238E27FC236}">
-                <a16:creationId xmlns:a16="http://schemas.microsoft.com/office/drawing/2014/main" id="{C95168BE-C6A1-498C-BDA1-EB3C601F21EC}"/>
+                <a16:creationId xmlns:a16="http://schemas.microsoft.com/office/drawing/2014/main" id="{EB0C7333-FBC7-4ACB-8CB9-B810D246C047}"/>
               </a:ext>
             </a:extLst>
           </p:cNvPr>
@@ -8508,7 +8508,7 @@
           <p:cNvPr id="3" name="text-8">
             <a:extLst xmlns:a="http://schemas.openxmlformats.org/drawingml/2006/main">
               <a:ext uri="{FF2B5EF4-FFF2-40B4-BE49-F238E27FC236}">
-                <a16:creationId xmlns:a16="http://schemas.microsoft.com/office/drawing/2014/main" id="{453E64AD-9B72-4B2C-9866-6A238D1CC178}"/>
+                <a16:creationId xmlns:a16="http://schemas.microsoft.com/office/drawing/2014/main" id="{B0F28549-471C-4CF6-B00D-D33A087515CA}"/>
               </a:ext>
             </a:extLst>
           </p:cNvPr>
@@ -8666,7 +8666,7 @@
           <p:cNvPr id="4" name="text-9">
             <a:extLst xmlns:a="http://schemas.openxmlformats.org/drawingml/2006/main">
               <a:ext uri="{FF2B5EF4-FFF2-40B4-BE49-F238E27FC236}">
-                <a16:creationId xmlns:a16="http://schemas.microsoft.com/office/drawing/2014/main" id="{84CCF3AC-63B0-4A32-B663-4D458F8CBBEE}"/>
+                <a16:creationId xmlns:a16="http://schemas.microsoft.com/office/drawing/2014/main" id="{C743D614-9E23-423F-BC2A-8CAA395B4A10}"/>
               </a:ext>
             </a:extLst>
           </p:cNvPr>
@@ -8824,7 +8824,7 @@
           <p:cNvPr id="5" name="text-10">
             <a:extLst xmlns:a="http://schemas.openxmlformats.org/drawingml/2006/main">
               <a:ext uri="{FF2B5EF4-FFF2-40B4-BE49-F238E27FC236}">
-                <a16:creationId xmlns:a16="http://schemas.microsoft.com/office/drawing/2014/main" id="{808A1460-D680-4C7C-9A2D-E9FFC51A560E}"/>
+                <a16:creationId xmlns:a16="http://schemas.microsoft.com/office/drawing/2014/main" id="{DCEEF502-2770-45CB-95EB-B0341AF04BCF}"/>
               </a:ext>
             </a:extLst>
           </p:cNvPr>
@@ -8982,7 +8982,7 @@
           <p:cNvPr id="6" name="text-11">
             <a:extLst xmlns:a="http://schemas.openxmlformats.org/drawingml/2006/main">
               <a:ext uri="{FF2B5EF4-FFF2-40B4-BE49-F238E27FC236}">
-                <a16:creationId xmlns:a16="http://schemas.microsoft.com/office/drawing/2014/main" id="{A56C7DF6-47B2-491F-B698-FB1EF7ACE533}"/>
+                <a16:creationId xmlns:a16="http://schemas.microsoft.com/office/drawing/2014/main" id="{14BE3D9B-85C4-44CE-8ACE-E4850820488C}"/>
               </a:ext>
             </a:extLst>
           </p:cNvPr>
@@ -9140,7 +9140,7 @@
           <p:cNvPr id="7" name="text-12">
             <a:extLst xmlns:a="http://schemas.openxmlformats.org/drawingml/2006/main">
               <a:ext uri="{FF2B5EF4-FFF2-40B4-BE49-F238E27FC236}">
-                <a16:creationId xmlns:a16="http://schemas.microsoft.com/office/drawing/2014/main" id="{45E668D9-4C38-417C-B17A-BCD959C786A7}"/>
+                <a16:creationId xmlns:a16="http://schemas.microsoft.com/office/drawing/2014/main" id="{861A7C2C-3BBE-4332-B871-88ADC75092E7}"/>
               </a:ext>
             </a:extLst>
           </p:cNvPr>
@@ -9298,7 +9298,7 @@
           <p:cNvPr id="8" name="text-13">
             <a:extLst xmlns:a="http://schemas.openxmlformats.org/drawingml/2006/main">
               <a:ext uri="{FF2B5EF4-FFF2-40B4-BE49-F238E27FC236}">
-                <a16:creationId xmlns:a16="http://schemas.microsoft.com/office/drawing/2014/main" id="{6F358815-6D94-4462-9E75-8935DB12CDDB}"/>
+                <a16:creationId xmlns:a16="http://schemas.microsoft.com/office/drawing/2014/main" id="{74B42F22-ACA3-4097-AF6F-BD2AC60C7474}"/>
               </a:ext>
             </a:extLst>
           </p:cNvPr>
@@ -9456,7 +9456,7 @@
           <p:cNvPr id="9" name="text-14">
             <a:extLst xmlns:a="http://schemas.openxmlformats.org/drawingml/2006/main">
               <a:ext uri="{FF2B5EF4-FFF2-40B4-BE49-F238E27FC236}">
-                <a16:creationId xmlns:a16="http://schemas.microsoft.com/office/drawing/2014/main" id="{6E0CCA8D-BD53-4FF2-8A0B-070E08FA1DAA}"/>
+                <a16:creationId xmlns:a16="http://schemas.microsoft.com/office/drawing/2014/main" id="{264F3D14-9C4A-4592-AD9A-EF96BD29317E}"/>
               </a:ext>
             </a:extLst>
           </p:cNvPr>
@@ -9614,7 +9614,7 @@
           <p:cNvPr id="10" name="text-15">
             <a:extLst xmlns:a="http://schemas.openxmlformats.org/drawingml/2006/main">
               <a:ext uri="{FF2B5EF4-FFF2-40B4-BE49-F238E27FC236}">
-                <a16:creationId xmlns:a16="http://schemas.microsoft.com/office/drawing/2014/main" id="{29F37374-156B-47FB-BB08-85BDF3B84C0C}"/>
+                <a16:creationId xmlns:a16="http://schemas.microsoft.com/office/drawing/2014/main" id="{3B682AC4-147B-439F-AC2B-BFC166857723}"/>
               </a:ext>
             </a:extLst>
           </p:cNvPr>
@@ -9772,7 +9772,7 @@
           <p:cNvPr id="11" name="text-16">
             <a:extLst xmlns:a="http://schemas.openxmlformats.org/drawingml/2006/main">
               <a:ext uri="{FF2B5EF4-FFF2-40B4-BE49-F238E27FC236}">
-                <a16:creationId xmlns:a16="http://schemas.microsoft.com/office/drawing/2014/main" id="{782D0954-988B-40D4-BA28-6215FC67C505}"/>
+                <a16:creationId xmlns:a16="http://schemas.microsoft.com/office/drawing/2014/main" id="{67309391-00E6-4D26-A26D-C9AA94A8C767}"/>
               </a:ext>
             </a:extLst>
           </p:cNvPr>
@@ -9930,7 +9930,7 @@
           <p:cNvPr id="12" name="text-17">
             <a:extLst xmlns:a="http://schemas.openxmlformats.org/drawingml/2006/main">
               <a:ext uri="{FF2B5EF4-FFF2-40B4-BE49-F238E27FC236}">
-                <a16:creationId xmlns:a16="http://schemas.microsoft.com/office/drawing/2014/main" id="{9EFA180B-BAD4-4022-9DC9-D5CFC6AB2B10}"/>
+                <a16:creationId xmlns:a16="http://schemas.microsoft.com/office/drawing/2014/main" id="{3F33F3DF-80BF-4630-ACD4-48DB223D6316}"/>
               </a:ext>
             </a:extLst>
           </p:cNvPr>
@@ -10088,7 +10088,7 @@
           <p:cNvPr id="13" name="text-18">
             <a:extLst xmlns:a="http://schemas.openxmlformats.org/drawingml/2006/main">
               <a:ext uri="{FF2B5EF4-FFF2-40B4-BE49-F238E27FC236}">
-                <a16:creationId xmlns:a16="http://schemas.microsoft.com/office/drawing/2014/main" id="{D2960225-3C10-4C54-ACAB-FE7438F2CF50}"/>
+                <a16:creationId xmlns:a16="http://schemas.microsoft.com/office/drawing/2014/main" id="{6156AB4A-253D-4CF1-A5C6-152E23B05553}"/>
               </a:ext>
             </a:extLst>
           </p:cNvPr>
@@ -10246,7 +10246,7 @@
           <p:cNvPr id="14" name="text-19">
             <a:extLst xmlns:a="http://schemas.openxmlformats.org/drawingml/2006/main">
               <a:ext uri="{FF2B5EF4-FFF2-40B4-BE49-F238E27FC236}">
-                <a16:creationId xmlns:a16="http://schemas.microsoft.com/office/drawing/2014/main" id="{BC4BE32C-CF30-4053-A634-85664B7215C2}"/>
+                <a16:creationId xmlns:a16="http://schemas.microsoft.com/office/drawing/2014/main" id="{4F27AF85-A774-45BF-9C3A-569A315645E6}"/>
               </a:ext>
             </a:extLst>
           </p:cNvPr>
@@ -10402,7 +10402,7 @@
     </p:spTree>
     <p:extLst>
       <p:ext uri="{BB962C8B-B14F-4D97-AF65-F5344CB8AC3E}">
-        <p14:creationId xmlns:p14="http://schemas.microsoft.com/office/powerpoint/2010/main" val="1392655342"/>
+        <p14:creationId xmlns:p14="http://schemas.microsoft.com/office/powerpoint/2010/main" val="1020871894"/>
       </p:ext>
     </p:extLst>
   </p:cSld>
@@ -10433,7 +10433,7 @@
           <p:cNvPr id="7" name="">
             <a:extLst xmlns:a="http://schemas.openxmlformats.org/drawingml/2006/main">
               <a:ext uri="{FF2B5EF4-FFF2-40B4-BE49-F238E27FC236}">
-                <a16:creationId xmlns:a16="http://schemas.microsoft.com/office/drawing/2014/main" id="{8960A4D9-44AE-45C0-8FA8-2284B04DD1BA}"/>
+                <a16:creationId xmlns:a16="http://schemas.microsoft.com/office/drawing/2014/main" id="{2D131277-C80A-4E06-98E2-24774B78187C}"/>
               </a:ext>
             </a:extLst>
           </p:cNvPr>
@@ -10464,7 +10464,7 @@
           <p:cNvPr id="6" name="">
             <a:extLst xmlns:a="http://schemas.openxmlformats.org/drawingml/2006/main">
               <a:ext uri="{FF2B5EF4-FFF2-40B4-BE49-F238E27FC236}">
-                <a16:creationId xmlns:a16="http://schemas.microsoft.com/office/drawing/2014/main" id="{C1A15E6E-C573-425A-84E0-B640EE5E0EE9}"/>
+                <a16:creationId xmlns:a16="http://schemas.microsoft.com/office/drawing/2014/main" id="{F8E29534-F22C-46A2-9EDC-A123A789DAFD}"/>
               </a:ext>
             </a:extLst>
           </p:cNvPr>
@@ -10495,7 +10495,7 @@
           <p:cNvPr id="14" name="text-20">
             <a:extLst xmlns:a="http://schemas.openxmlformats.org/drawingml/2006/main">
               <a:ext uri="{FF2B5EF4-FFF2-40B4-BE49-F238E27FC236}">
-                <a16:creationId xmlns:a16="http://schemas.microsoft.com/office/drawing/2014/main" id="{113E5C02-453F-4A85-BE0C-D6474E3D4463}"/>
+                <a16:creationId xmlns:a16="http://schemas.microsoft.com/office/drawing/2014/main" id="{4DB7765F-F3F7-473E-A35E-1D3724724146}"/>
               </a:ext>
             </a:extLst>
           </p:cNvPr>
@@ -10653,7 +10653,7 @@
           <p:cNvPr id="2" name="text-21">
             <a:extLst xmlns:a="http://schemas.openxmlformats.org/drawingml/2006/main">
               <a:ext uri="{FF2B5EF4-FFF2-40B4-BE49-F238E27FC236}">
-                <a16:creationId xmlns:a16="http://schemas.microsoft.com/office/drawing/2014/main" id="{FD645D16-DEB5-41B4-B0A4-FF2756DA13FB}"/>
+                <a16:creationId xmlns:a16="http://schemas.microsoft.com/office/drawing/2014/main" id="{95CF288A-ADDE-493A-A670-DC5B2098493B}"/>
               </a:ext>
             </a:extLst>
           </p:cNvPr>
@@ -10811,7 +10811,7 @@
           <p:cNvPr id="3" name="diagram-22">
             <a:extLst xmlns:a="http://schemas.openxmlformats.org/drawingml/2006/main">
               <a:ext uri="{FF2B5EF4-FFF2-40B4-BE49-F238E27FC236}">
-                <a16:creationId xmlns:a16="http://schemas.microsoft.com/office/drawing/2014/main" id="{28C05971-AFDD-47B1-9805-C3FC603CC91E}"/>
+                <a16:creationId xmlns:a16="http://schemas.microsoft.com/office/drawing/2014/main" id="{CC1C36D5-383C-4889-A614-4538FF8CAD3C}"/>
               </a:ext>
             </a:extLst>
           </p:cNvPr>
@@ -10971,7 +10971,7 @@
           <p:cNvPr id="4" name="diagram-23">
             <a:extLst xmlns:a="http://schemas.openxmlformats.org/drawingml/2006/main">
               <a:ext uri="{FF2B5EF4-FFF2-40B4-BE49-F238E27FC236}">
-                <a16:creationId xmlns:a16="http://schemas.microsoft.com/office/drawing/2014/main" id="{A057E565-80BF-4431-AF3A-EDFC47861B35}"/>
+                <a16:creationId xmlns:a16="http://schemas.microsoft.com/office/drawing/2014/main" id="{20083A39-9DEF-48C3-8B28-036F06A03EEF}"/>
               </a:ext>
             </a:extLst>
           </p:cNvPr>
@@ -11131,7 +11131,7 @@
           <p:cNvPr id="5" name="diagram-24">
             <a:extLst xmlns:a="http://schemas.openxmlformats.org/drawingml/2006/main">
               <a:ext uri="{FF2B5EF4-FFF2-40B4-BE49-F238E27FC236}">
-                <a16:creationId xmlns:a16="http://schemas.microsoft.com/office/drawing/2014/main" id="{DF60A79A-EA13-4D3A-B370-844DCD9B5BA0}"/>
+                <a16:creationId xmlns:a16="http://schemas.microsoft.com/office/drawing/2014/main" id="{DAAA9B06-ECC9-4EF0-B137-2E4EDF2EA18C}"/>
               </a:ext>
             </a:extLst>
           </p:cNvPr>
@@ -11291,7 +11291,7 @@
           <p:cNvPr id="8" name="">
             <a:extLst xmlns:a="http://schemas.openxmlformats.org/drawingml/2006/main">
               <a:ext uri="{FF2B5EF4-FFF2-40B4-BE49-F238E27FC236}">
-                <a16:creationId xmlns:a16="http://schemas.microsoft.com/office/drawing/2014/main" id="{DF5A763E-D275-4A77-B97B-231DABEF2E70}"/>
+                <a16:creationId xmlns:a16="http://schemas.microsoft.com/office/drawing/2014/main" id="{070D4B50-A1F1-4832-9F99-E0F57BA50116}"/>
               </a:ext>
             </a:extLst>
           </p:cNvPr>
@@ -11301,7 +11301,7 @@
           <p:nvPr/>
         </p:nvPicPr>
         <p:blipFill>
-          <a:blip xmlns:r="http://schemas.openxmlformats.org/officeDocument/2006/relationships" xmlns:a="http://schemas.openxmlformats.org/drawingml/2006/main" r:embed="R1041a7c3814b4414"/>
+          <a:blip xmlns:r="http://schemas.openxmlformats.org/officeDocument/2006/relationships" xmlns:a="http://schemas.openxmlformats.org/drawingml/2006/main" r:embed="R8ed115096d654c24"/>
           <a:stretch xmlns:a="http://schemas.openxmlformats.org/drawingml/2006/main"/>
         </p:blipFill>
         <p:spPr>
@@ -11319,7 +11319,7 @@
           <p:cNvPr id="9" name="text-25">
             <a:extLst xmlns:a="http://schemas.openxmlformats.org/drawingml/2006/main">
               <a:ext uri="{FF2B5EF4-FFF2-40B4-BE49-F238E27FC236}">
-                <a16:creationId xmlns:a16="http://schemas.microsoft.com/office/drawing/2014/main" id="{C29171CF-053F-469B-AE4F-3B81F93C1C11}"/>
+                <a16:creationId xmlns:a16="http://schemas.microsoft.com/office/drawing/2014/main" id="{95A86C1D-8515-4744-ABA6-4FB9A560FB37}"/>
               </a:ext>
             </a:extLst>
           </p:cNvPr>
@@ -11500,7 +11500,7 @@
           <p:cNvPr id="10" name="text-26">
             <a:extLst xmlns:a="http://schemas.openxmlformats.org/drawingml/2006/main">
               <a:ext uri="{FF2B5EF4-FFF2-40B4-BE49-F238E27FC236}">
-                <a16:creationId xmlns:a16="http://schemas.microsoft.com/office/drawing/2014/main" id="{AA3473D6-EB46-4847-9286-6DF557801F21}"/>
+                <a16:creationId xmlns:a16="http://schemas.microsoft.com/office/drawing/2014/main" id="{077271D0-D6DD-4F73-A110-1C11B37AF430}"/>
               </a:ext>
             </a:extLst>
           </p:cNvPr>
@@ -11658,7 +11658,7 @@
           <p:cNvPr id="11" name="text-27">
             <a:extLst xmlns:a="http://schemas.openxmlformats.org/drawingml/2006/main">
               <a:ext uri="{FF2B5EF4-FFF2-40B4-BE49-F238E27FC236}">
-                <a16:creationId xmlns:a16="http://schemas.microsoft.com/office/drawing/2014/main" id="{1984E625-CDB2-475F-BEE7-FDAA88428F86}"/>
+                <a16:creationId xmlns:a16="http://schemas.microsoft.com/office/drawing/2014/main" id="{79116F62-E305-4516-BC67-1670B2F63256}"/>
               </a:ext>
             </a:extLst>
           </p:cNvPr>
@@ -11885,7 +11885,7 @@
           <p:cNvPr id="12" name="text-28">
             <a:extLst xmlns:a="http://schemas.openxmlformats.org/drawingml/2006/main">
               <a:ext uri="{FF2B5EF4-FFF2-40B4-BE49-F238E27FC236}">
-                <a16:creationId xmlns:a16="http://schemas.microsoft.com/office/drawing/2014/main" id="{E8C600DE-D6AB-4DCF-8C1A-C3A6A33E8C97}"/>
+                <a16:creationId xmlns:a16="http://schemas.microsoft.com/office/drawing/2014/main" id="{E6CA2C57-050E-4622-B93B-E77FB94D21AE}"/>
               </a:ext>
             </a:extLst>
           </p:cNvPr>
@@ -12043,7 +12043,7 @@
           <p:cNvPr id="13" name="text-29">
             <a:extLst xmlns:a="http://schemas.openxmlformats.org/drawingml/2006/main">
               <a:ext uri="{FF2B5EF4-FFF2-40B4-BE49-F238E27FC236}">
-                <a16:creationId xmlns:a16="http://schemas.microsoft.com/office/drawing/2014/main" id="{63026E24-5922-401D-A532-82BFA06984FC}"/>
+                <a16:creationId xmlns:a16="http://schemas.microsoft.com/office/drawing/2014/main" id="{BFB6EE57-87D4-4F4E-8F8F-7E6BBFD992B4}"/>
               </a:ext>
             </a:extLst>
           </p:cNvPr>
@@ -12268,7 +12268,7 @@
     </p:spTree>
     <p:extLst>
       <p:ext uri="{BB962C8B-B14F-4D97-AF65-F5344CB8AC3E}">
-        <p14:creationId xmlns:p14="http://schemas.microsoft.com/office/powerpoint/2010/main" val="413786090"/>
+        <p14:creationId xmlns:p14="http://schemas.microsoft.com/office/powerpoint/2010/main" val="1430140303"/>
       </p:ext>
     </p:extLst>
   </p:cSld>
@@ -12299,7 +12299,7 @@
           <p:cNvPr id="15" name="text-30">
             <a:extLst xmlns:a="http://schemas.openxmlformats.org/drawingml/2006/main">
               <a:ext uri="{FF2B5EF4-FFF2-40B4-BE49-F238E27FC236}">
-                <a16:creationId xmlns:a16="http://schemas.microsoft.com/office/drawing/2014/main" id="{3923CEDB-D6F1-4DC9-9038-3D51B6ADD081}"/>
+                <a16:creationId xmlns:a16="http://schemas.microsoft.com/office/drawing/2014/main" id="{66FE17D9-F983-417A-B91C-8F01EDFA74A7}"/>
               </a:ext>
             </a:extLst>
           </p:cNvPr>
@@ -12457,7 +12457,7 @@
           <p:cNvPr id="2" name="text-31">
             <a:extLst xmlns:a="http://schemas.openxmlformats.org/drawingml/2006/main">
               <a:ext uri="{FF2B5EF4-FFF2-40B4-BE49-F238E27FC236}">
-                <a16:creationId xmlns:a16="http://schemas.microsoft.com/office/drawing/2014/main" id="{0A505EC4-272F-489B-90C4-C22819A0BD93}"/>
+                <a16:creationId xmlns:a16="http://schemas.microsoft.com/office/drawing/2014/main" id="{813BA882-7FC5-44D6-B3D7-DD5A815690AD}"/>
               </a:ext>
             </a:extLst>
           </p:cNvPr>
@@ -12615,7 +12615,7 @@
           <p:cNvPr id="3" name="text-32">
             <a:extLst xmlns:a="http://schemas.openxmlformats.org/drawingml/2006/main">
               <a:ext uri="{FF2B5EF4-FFF2-40B4-BE49-F238E27FC236}">
-                <a16:creationId xmlns:a16="http://schemas.microsoft.com/office/drawing/2014/main" id="{932B375D-6E8A-4BFD-BB23-D38C169ABDC9}"/>
+                <a16:creationId xmlns:a16="http://schemas.microsoft.com/office/drawing/2014/main" id="{F6DDAEFD-B586-4838-8DC3-FBDA76F8C2B7}"/>
               </a:ext>
             </a:extLst>
           </p:cNvPr>
@@ -12773,7 +12773,7 @@
           <p:cNvPr id="4" name="text-33">
             <a:extLst xmlns:a="http://schemas.openxmlformats.org/drawingml/2006/main">
               <a:ext uri="{FF2B5EF4-FFF2-40B4-BE49-F238E27FC236}">
-                <a16:creationId xmlns:a16="http://schemas.microsoft.com/office/drawing/2014/main" id="{EAC4E178-633C-4004-BCEC-24C47E4A0705}"/>
+                <a16:creationId xmlns:a16="http://schemas.microsoft.com/office/drawing/2014/main" id="{C39E6971-9CE3-4A8A-AB35-9ADF56B038D0}"/>
               </a:ext>
             </a:extLst>
           </p:cNvPr>
@@ -12931,7 +12931,7 @@
           <p:cNvPr id="5" name="text-34">
             <a:extLst xmlns:a="http://schemas.openxmlformats.org/drawingml/2006/main">
               <a:ext uri="{FF2B5EF4-FFF2-40B4-BE49-F238E27FC236}">
-                <a16:creationId xmlns:a16="http://schemas.microsoft.com/office/drawing/2014/main" id="{4572090F-9D27-464E-B4F1-834931EB1496}"/>
+                <a16:creationId xmlns:a16="http://schemas.microsoft.com/office/drawing/2014/main" id="{F72AB9E1-E45D-42DA-8871-46BE4FBC793A}"/>
               </a:ext>
             </a:extLst>
           </p:cNvPr>
@@ -13089,7 +13089,7 @@
           <p:cNvPr id="6" name="text-35">
             <a:extLst xmlns:a="http://schemas.openxmlformats.org/drawingml/2006/main">
               <a:ext uri="{FF2B5EF4-FFF2-40B4-BE49-F238E27FC236}">
-                <a16:creationId xmlns:a16="http://schemas.microsoft.com/office/drawing/2014/main" id="{0F7DA814-AED6-4351-9EB5-D1C6FC3716F2}"/>
+                <a16:creationId xmlns:a16="http://schemas.microsoft.com/office/drawing/2014/main" id="{A2A3FCE5-E508-4F63-B8C9-B187387C28FE}"/>
               </a:ext>
             </a:extLst>
           </p:cNvPr>
@@ -13270,7 +13270,7 @@
           <p:cNvPr id="7" name="text-36">
             <a:extLst xmlns:a="http://schemas.openxmlformats.org/drawingml/2006/main">
               <a:ext uri="{FF2B5EF4-FFF2-40B4-BE49-F238E27FC236}">
-                <a16:creationId xmlns:a16="http://schemas.microsoft.com/office/drawing/2014/main" id="{BA8E233D-77ED-433F-8E3B-2FDC65CF58FA}"/>
+                <a16:creationId xmlns:a16="http://schemas.microsoft.com/office/drawing/2014/main" id="{C0BB8BF8-C7B9-44F2-A938-ADCB660B0D13}"/>
               </a:ext>
             </a:extLst>
           </p:cNvPr>
@@ -13428,7 +13428,7 @@
           <p:cNvPr id="8" name="text-37">
             <a:extLst xmlns:a="http://schemas.openxmlformats.org/drawingml/2006/main">
               <a:ext uri="{FF2B5EF4-FFF2-40B4-BE49-F238E27FC236}">
-                <a16:creationId xmlns:a16="http://schemas.microsoft.com/office/drawing/2014/main" id="{3C21CA51-BBD3-4E92-A127-57671F397638}"/>
+                <a16:creationId xmlns:a16="http://schemas.microsoft.com/office/drawing/2014/main" id="{5E0133B5-6A3F-4AC5-ADC7-4C819900BC63}"/>
               </a:ext>
             </a:extLst>
           </p:cNvPr>
@@ -13609,7 +13609,7 @@
           <p:cNvPr id="9" name="text-38">
             <a:extLst xmlns:a="http://schemas.openxmlformats.org/drawingml/2006/main">
               <a:ext uri="{FF2B5EF4-FFF2-40B4-BE49-F238E27FC236}">
-                <a16:creationId xmlns:a16="http://schemas.microsoft.com/office/drawing/2014/main" id="{04B4E6D5-9297-47E5-92CF-C75B9FEB80CE}"/>
+                <a16:creationId xmlns:a16="http://schemas.microsoft.com/office/drawing/2014/main" id="{4FD2820F-99D5-4AA2-9BD4-CE45C8E7513E}"/>
               </a:ext>
             </a:extLst>
           </p:cNvPr>
@@ -13767,7 +13767,7 @@
           <p:cNvPr id="10" name="text-39">
             <a:extLst xmlns:a="http://schemas.openxmlformats.org/drawingml/2006/main">
               <a:ext uri="{FF2B5EF4-FFF2-40B4-BE49-F238E27FC236}">
-                <a16:creationId xmlns:a16="http://schemas.microsoft.com/office/drawing/2014/main" id="{167E2A4F-1B11-436A-ADF6-1200FF8BDDA4}"/>
+                <a16:creationId xmlns:a16="http://schemas.microsoft.com/office/drawing/2014/main" id="{964632F6-79BE-4EEC-AA96-40F59865F94A}"/>
               </a:ext>
             </a:extLst>
           </p:cNvPr>
@@ -13925,7 +13925,7 @@
           <p:cNvPr id="11" name="">
             <a:extLst xmlns:a="http://schemas.openxmlformats.org/drawingml/2006/main">
               <a:ext uri="{FF2B5EF4-FFF2-40B4-BE49-F238E27FC236}">
-                <a16:creationId xmlns:a16="http://schemas.microsoft.com/office/drawing/2014/main" id="{79D105F0-ED84-458E-8D3C-5271EFE9A72B}"/>
+                <a16:creationId xmlns:a16="http://schemas.microsoft.com/office/drawing/2014/main" id="{A73B3B4C-D958-40FE-97A2-2140988AEF77}"/>
               </a:ext>
             </a:extLst>
           </p:cNvPr>
@@ -13935,7 +13935,7 @@
           <p:nvPr/>
         </p:nvPicPr>
         <p:blipFill>
-          <a:blip xmlns:r="http://schemas.openxmlformats.org/officeDocument/2006/relationships" xmlns:a="http://schemas.openxmlformats.org/drawingml/2006/main" r:embed="R1c2430076f014f01"/>
+          <a:blip xmlns:r="http://schemas.openxmlformats.org/officeDocument/2006/relationships" xmlns:a="http://schemas.openxmlformats.org/drawingml/2006/main" r:embed="R24a1bd2908874f4f"/>
           <a:stretch xmlns:a="http://schemas.openxmlformats.org/drawingml/2006/main"/>
         </p:blipFill>
         <p:spPr>
@@ -13953,7 +13953,7 @@
           <p:cNvPr id="12" name="">
             <a:extLst xmlns:a="http://schemas.openxmlformats.org/drawingml/2006/main">
               <a:ext uri="{FF2B5EF4-FFF2-40B4-BE49-F238E27FC236}">
-                <a16:creationId xmlns:a16="http://schemas.microsoft.com/office/drawing/2014/main" id="{A9224DF5-0D0A-4AA3-B531-5F239F8665D8}"/>
+                <a16:creationId xmlns:a16="http://schemas.microsoft.com/office/drawing/2014/main" id="{4FE725A1-43C2-4050-9898-9EB23EF0A3EC}"/>
               </a:ext>
             </a:extLst>
           </p:cNvPr>
@@ -13963,7 +13963,7 @@
           <p:nvPr/>
         </p:nvPicPr>
         <p:blipFill>
-          <a:blip xmlns:r="http://schemas.openxmlformats.org/officeDocument/2006/relationships" xmlns:a="http://schemas.openxmlformats.org/drawingml/2006/main" r:embed="R6e53aed85fd94a84"/>
+          <a:blip xmlns:r="http://schemas.openxmlformats.org/officeDocument/2006/relationships" xmlns:a="http://schemas.openxmlformats.org/drawingml/2006/main" r:embed="R811fce0f807449a7"/>
           <a:stretch xmlns:a="http://schemas.openxmlformats.org/drawingml/2006/main"/>
         </p:blipFill>
         <p:spPr>
@@ -13981,7 +13981,7 @@
           <p:cNvPr id="13" name="">
             <a:extLst xmlns:a="http://schemas.openxmlformats.org/drawingml/2006/main">
               <a:ext uri="{FF2B5EF4-FFF2-40B4-BE49-F238E27FC236}">
-                <a16:creationId xmlns:a16="http://schemas.microsoft.com/office/drawing/2014/main" id="{F27ECD71-0877-486E-B8C5-75192B85A15C}"/>
+                <a16:creationId xmlns:a16="http://schemas.microsoft.com/office/drawing/2014/main" id="{562C4AC7-D5EF-4C78-A18F-E148F7BC826F}"/>
               </a:ext>
             </a:extLst>
           </p:cNvPr>
@@ -13991,7 +13991,7 @@
           <p:nvPr/>
         </p:nvPicPr>
         <p:blipFill>
-          <a:blip xmlns:r="http://schemas.openxmlformats.org/officeDocument/2006/relationships" xmlns:a="http://schemas.openxmlformats.org/drawingml/2006/main" r:embed="Rae2d3b2b8cd74d23"/>
+          <a:blip xmlns:r="http://schemas.openxmlformats.org/officeDocument/2006/relationships" xmlns:a="http://schemas.openxmlformats.org/drawingml/2006/main" r:embed="Ra78c1bc349c744a1"/>
           <a:stretch xmlns:a="http://schemas.openxmlformats.org/drawingml/2006/main"/>
         </p:blipFill>
         <p:spPr>
@@ -14009,7 +14009,7 @@
           <p:cNvPr id="14" name="text-40">
             <a:extLst xmlns:a="http://schemas.openxmlformats.org/drawingml/2006/main">
               <a:ext uri="{FF2B5EF4-FFF2-40B4-BE49-F238E27FC236}">
-                <a16:creationId xmlns:a16="http://schemas.microsoft.com/office/drawing/2014/main" id="{DCF028F9-6D64-4F40-AF73-3D625A6D0E68}"/>
+                <a16:creationId xmlns:a16="http://schemas.microsoft.com/office/drawing/2014/main" id="{33EAFEB1-6B2C-46F8-8EE0-607E19863380}"/>
               </a:ext>
             </a:extLst>
           </p:cNvPr>
@@ -14165,7 +14165,7 @@
     </p:spTree>
     <p:extLst>
       <p:ext uri="{BB962C8B-B14F-4D97-AF65-F5344CB8AC3E}">
-        <p14:creationId xmlns:p14="http://schemas.microsoft.com/office/powerpoint/2010/main" val="113665178"/>
+        <p14:creationId xmlns:p14="http://schemas.microsoft.com/office/powerpoint/2010/main" val="506330863"/>
       </p:ext>
     </p:extLst>
   </p:cSld>
@@ -14196,7 +14196,7 @@
           <p:cNvPr id="8" name="">
             <a:extLst xmlns:a="http://schemas.openxmlformats.org/drawingml/2006/main">
               <a:ext uri="{FF2B5EF4-FFF2-40B4-BE49-F238E27FC236}">
-                <a16:creationId xmlns:a16="http://schemas.microsoft.com/office/drawing/2014/main" id="{E368BA08-271F-49FF-80F5-6AB6F3EC3A31}"/>
+                <a16:creationId xmlns:a16="http://schemas.microsoft.com/office/drawing/2014/main" id="{B724955E-2584-44B8-B22F-127F8B0D4F23}"/>
               </a:ext>
             </a:extLst>
           </p:cNvPr>
@@ -14229,7 +14229,7 @@
           <p:cNvPr id="7" name="">
             <a:extLst xmlns:a="http://schemas.openxmlformats.org/drawingml/2006/main">
               <a:ext uri="{FF2B5EF4-FFF2-40B4-BE49-F238E27FC236}">
-                <a16:creationId xmlns:a16="http://schemas.microsoft.com/office/drawing/2014/main" id="{27D3D5FD-7EFF-4620-8D83-231EA0E90993}"/>
+                <a16:creationId xmlns:a16="http://schemas.microsoft.com/office/drawing/2014/main" id="{DC62F8FB-2403-4A34-A1F5-889B5F8ACCFB}"/>
               </a:ext>
             </a:extLst>
           </p:cNvPr>
@@ -14262,7 +14262,7 @@
           <p:cNvPr id="13" name="text-41">
             <a:extLst xmlns:a="http://schemas.openxmlformats.org/drawingml/2006/main">
               <a:ext uri="{FF2B5EF4-FFF2-40B4-BE49-F238E27FC236}">
-                <a16:creationId xmlns:a16="http://schemas.microsoft.com/office/drawing/2014/main" id="{68F2D281-D60F-4D03-AE40-CF35BDEE5AB2}"/>
+                <a16:creationId xmlns:a16="http://schemas.microsoft.com/office/drawing/2014/main" id="{1D53137E-E14E-49F6-B9A1-99F1CC456E6C}"/>
               </a:ext>
             </a:extLst>
           </p:cNvPr>
@@ -14420,7 +14420,7 @@
           <p:cNvPr id="2" name="text-42">
             <a:extLst xmlns:a="http://schemas.openxmlformats.org/drawingml/2006/main">
               <a:ext uri="{FF2B5EF4-FFF2-40B4-BE49-F238E27FC236}">
-                <a16:creationId xmlns:a16="http://schemas.microsoft.com/office/drawing/2014/main" id="{A880CCBD-21AA-4759-BFA8-05DD8822966E}"/>
+                <a16:creationId xmlns:a16="http://schemas.microsoft.com/office/drawing/2014/main" id="{762FB8E4-40AF-4896-986E-46ECE8FB93E0}"/>
               </a:ext>
             </a:extLst>
           </p:cNvPr>
@@ -14578,7 +14578,7 @@
           <p:cNvPr id="3" name="text-43">
             <a:extLst xmlns:a="http://schemas.openxmlformats.org/drawingml/2006/main">
               <a:ext uri="{FF2B5EF4-FFF2-40B4-BE49-F238E27FC236}">
-                <a16:creationId xmlns:a16="http://schemas.microsoft.com/office/drawing/2014/main" id="{700CDD26-ACBE-4F5B-BD47-5CB3C6315600}"/>
+                <a16:creationId xmlns:a16="http://schemas.microsoft.com/office/drawing/2014/main" id="{70C16F48-6FB6-4E52-8677-D0CDDB67D1B9}"/>
               </a:ext>
             </a:extLst>
           </p:cNvPr>
@@ -14736,7 +14736,7 @@
           <p:cNvPr id="4" name="diagram-44">
             <a:extLst xmlns:a="http://schemas.openxmlformats.org/drawingml/2006/main">
               <a:ext uri="{FF2B5EF4-FFF2-40B4-BE49-F238E27FC236}">
-                <a16:creationId xmlns:a16="http://schemas.microsoft.com/office/drawing/2014/main" id="{D9DEC0CF-F9AD-4769-B7FF-E8273439A037}"/>
+                <a16:creationId xmlns:a16="http://schemas.microsoft.com/office/drawing/2014/main" id="{D0D2CD08-11EB-437B-B69C-20EBAC757B16}"/>
               </a:ext>
             </a:extLst>
           </p:cNvPr>
@@ -14896,7 +14896,7 @@
           <p:cNvPr id="5" name="diagram-45">
             <a:extLst xmlns:a="http://schemas.openxmlformats.org/drawingml/2006/main">
               <a:ext uri="{FF2B5EF4-FFF2-40B4-BE49-F238E27FC236}">
-                <a16:creationId xmlns:a16="http://schemas.microsoft.com/office/drawing/2014/main" id="{16A4DB2E-9AA7-413D-8ECB-F10CF1C7E4CC}"/>
+                <a16:creationId xmlns:a16="http://schemas.microsoft.com/office/drawing/2014/main" id="{97073719-FF8A-463F-8115-6DDD564AB865}"/>
               </a:ext>
             </a:extLst>
           </p:cNvPr>
@@ -15056,7 +15056,7 @@
           <p:cNvPr id="6" name="diagram-46">
             <a:extLst xmlns:a="http://schemas.openxmlformats.org/drawingml/2006/main">
               <a:ext uri="{FF2B5EF4-FFF2-40B4-BE49-F238E27FC236}">
-                <a16:creationId xmlns:a16="http://schemas.microsoft.com/office/drawing/2014/main" id="{CC735890-DA8C-4298-9926-14C6E9D5779F}"/>
+                <a16:creationId xmlns:a16="http://schemas.microsoft.com/office/drawing/2014/main" id="{D26779E9-4BCE-4D45-BD2C-7A7AC8ABDBD4}"/>
               </a:ext>
             </a:extLst>
           </p:cNvPr>
@@ -15216,7 +15216,7 @@
           <p:cNvPr id="9" name="text-47">
             <a:extLst xmlns:a="http://schemas.openxmlformats.org/drawingml/2006/main">
               <a:ext uri="{FF2B5EF4-FFF2-40B4-BE49-F238E27FC236}">
-                <a16:creationId xmlns:a16="http://schemas.microsoft.com/office/drawing/2014/main" id="{BFFC4EDE-566C-4349-B9ED-858393E010D6}"/>
+                <a16:creationId xmlns:a16="http://schemas.microsoft.com/office/drawing/2014/main" id="{5094F68A-2846-4E7A-96B6-200C33F64122}"/>
               </a:ext>
             </a:extLst>
           </p:cNvPr>
@@ -15374,7 +15374,7 @@
           <p:cNvPr id="10" name="text-48">
             <a:extLst xmlns:a="http://schemas.openxmlformats.org/drawingml/2006/main">
               <a:ext uri="{FF2B5EF4-FFF2-40B4-BE49-F238E27FC236}">
-                <a16:creationId xmlns:a16="http://schemas.microsoft.com/office/drawing/2014/main" id="{A43C8221-84C7-4C32-A768-63E84D08411F}"/>
+                <a16:creationId xmlns:a16="http://schemas.microsoft.com/office/drawing/2014/main" id="{8E061674-9C98-44B1-87F7-404DD85A3A05}"/>
               </a:ext>
             </a:extLst>
           </p:cNvPr>
@@ -15555,7 +15555,7 @@
           <p:cNvPr id="11" name="text-49">
             <a:extLst xmlns:a="http://schemas.openxmlformats.org/drawingml/2006/main">
               <a:ext uri="{FF2B5EF4-FFF2-40B4-BE49-F238E27FC236}">
-                <a16:creationId xmlns:a16="http://schemas.microsoft.com/office/drawing/2014/main" id="{9C0989D7-21D4-4B64-9504-FE1E1037FBC4}"/>
+                <a16:creationId xmlns:a16="http://schemas.microsoft.com/office/drawing/2014/main" id="{EA8168ED-815E-4391-8FCE-62076B257BFF}"/>
               </a:ext>
             </a:extLst>
           </p:cNvPr>
@@ -15759,7 +15759,7 @@
           <p:cNvPr id="12" name="text-50">
             <a:extLst xmlns:a="http://schemas.openxmlformats.org/drawingml/2006/main">
               <a:ext uri="{FF2B5EF4-FFF2-40B4-BE49-F238E27FC236}">
-                <a16:creationId xmlns:a16="http://schemas.microsoft.com/office/drawing/2014/main" id="{3092B195-321E-45D2-9755-4FDA896F35FB}"/>
+                <a16:creationId xmlns:a16="http://schemas.microsoft.com/office/drawing/2014/main" id="{5CB013A7-A99D-4BB2-88F5-E26EC7E5B99D}"/>
               </a:ext>
             </a:extLst>
           </p:cNvPr>
@@ -15938,7 +15938,7 @@
     </p:spTree>
     <p:extLst>
       <p:ext uri="{BB962C8B-B14F-4D97-AF65-F5344CB8AC3E}">
-        <p14:creationId xmlns:p14="http://schemas.microsoft.com/office/powerpoint/2010/main" val="532678147"/>
+        <p14:creationId xmlns:p14="http://schemas.microsoft.com/office/powerpoint/2010/main" val="2020540006"/>
       </p:ext>
     </p:extLst>
   </p:cSld>
@@ -15969,7 +15969,7 @@
           <p:cNvPr id="16" name="text-51">
             <a:extLst xmlns:a="http://schemas.openxmlformats.org/drawingml/2006/main">
               <a:ext uri="{FF2B5EF4-FFF2-40B4-BE49-F238E27FC236}">
-                <a16:creationId xmlns:a16="http://schemas.microsoft.com/office/drawing/2014/main" id="{4153F1DD-AE01-4C48-960E-33EAAAE33D52}"/>
+                <a16:creationId xmlns:a16="http://schemas.microsoft.com/office/drawing/2014/main" id="{A25DEED0-304F-44D0-885F-5E8B6B64171D}"/>
               </a:ext>
             </a:extLst>
           </p:cNvPr>
@@ -16127,7 +16127,7 @@
           <p:cNvPr id="2" name="text-52">
             <a:extLst xmlns:a="http://schemas.openxmlformats.org/drawingml/2006/main">
               <a:ext uri="{FF2B5EF4-FFF2-40B4-BE49-F238E27FC236}">
-                <a16:creationId xmlns:a16="http://schemas.microsoft.com/office/drawing/2014/main" id="{B7ECEFC8-E04E-4A18-939B-8334CD707A20}"/>
+                <a16:creationId xmlns:a16="http://schemas.microsoft.com/office/drawing/2014/main" id="{77A83F4C-C78F-45C3-8B20-C791645639C9}"/>
               </a:ext>
             </a:extLst>
           </p:cNvPr>
@@ -16285,7 +16285,7 @@
           <p:cNvPr id="3" name="text-53">
             <a:extLst xmlns:a="http://schemas.openxmlformats.org/drawingml/2006/main">
               <a:ext uri="{FF2B5EF4-FFF2-40B4-BE49-F238E27FC236}">
-                <a16:creationId xmlns:a16="http://schemas.microsoft.com/office/drawing/2014/main" id="{0F759620-ADE1-4828-A6CD-2A2D3445EB07}"/>
+                <a16:creationId xmlns:a16="http://schemas.microsoft.com/office/drawing/2014/main" id="{EAC194D6-C781-459F-9CBD-5485DF55EE23}"/>
               </a:ext>
             </a:extLst>
           </p:cNvPr>
@@ -16443,7 +16443,7 @@
           <p:cNvPr id="4" name="text-54">
             <a:extLst xmlns:a="http://schemas.openxmlformats.org/drawingml/2006/main">
               <a:ext uri="{FF2B5EF4-FFF2-40B4-BE49-F238E27FC236}">
-                <a16:creationId xmlns:a16="http://schemas.microsoft.com/office/drawing/2014/main" id="{C7BA7092-B4C8-47B0-A302-0F31EDD75BE3}"/>
+                <a16:creationId xmlns:a16="http://schemas.microsoft.com/office/drawing/2014/main" id="{EAC0DEC3-847F-4A18-B91B-453278EB183B}"/>
               </a:ext>
             </a:extLst>
           </p:cNvPr>
@@ -16601,7 +16601,7 @@
           <p:cNvPr id="5" name="text-55">
             <a:extLst xmlns:a="http://schemas.openxmlformats.org/drawingml/2006/main">
               <a:ext uri="{FF2B5EF4-FFF2-40B4-BE49-F238E27FC236}">
-                <a16:creationId xmlns:a16="http://schemas.microsoft.com/office/drawing/2014/main" id="{F3C38850-33FB-4DC6-9668-1A4AE851516C}"/>
+                <a16:creationId xmlns:a16="http://schemas.microsoft.com/office/drawing/2014/main" id="{E1C31875-9DCD-4082-A0C4-164F33DF87A0}"/>
               </a:ext>
             </a:extLst>
           </p:cNvPr>
@@ -16759,7 +16759,7 @@
           <p:cNvPr id="6" name="text-56">
             <a:extLst xmlns:a="http://schemas.openxmlformats.org/drawingml/2006/main">
               <a:ext uri="{FF2B5EF4-FFF2-40B4-BE49-F238E27FC236}">
-                <a16:creationId xmlns:a16="http://schemas.microsoft.com/office/drawing/2014/main" id="{7B80210D-F1E7-40B4-9A61-A0180B2CCB43}"/>
+                <a16:creationId xmlns:a16="http://schemas.microsoft.com/office/drawing/2014/main" id="{32724698-35E4-493E-B744-887903BD0ADB}"/>
               </a:ext>
             </a:extLst>
           </p:cNvPr>
@@ -16917,7 +16917,7 @@
           <p:cNvPr id="7" name="text-57">
             <a:extLst xmlns:a="http://schemas.openxmlformats.org/drawingml/2006/main">
               <a:ext uri="{FF2B5EF4-FFF2-40B4-BE49-F238E27FC236}">
-                <a16:creationId xmlns:a16="http://schemas.microsoft.com/office/drawing/2014/main" id="{2BA3692E-EC00-481D-8EFC-1DE28FB24DB6}"/>
+                <a16:creationId xmlns:a16="http://schemas.microsoft.com/office/drawing/2014/main" id="{B9D07D09-82B2-48FD-BFBF-64DDED92EE05}"/>
               </a:ext>
             </a:extLst>
           </p:cNvPr>
@@ -17075,7 +17075,7 @@
           <p:cNvPr id="8" name="text-58">
             <a:extLst xmlns:a="http://schemas.openxmlformats.org/drawingml/2006/main">
               <a:ext uri="{FF2B5EF4-FFF2-40B4-BE49-F238E27FC236}">
-                <a16:creationId xmlns:a16="http://schemas.microsoft.com/office/drawing/2014/main" id="{8ACAA3CC-F795-428C-BDB0-F1043E751ED4}"/>
+                <a16:creationId xmlns:a16="http://schemas.microsoft.com/office/drawing/2014/main" id="{9737CB54-85B7-47BA-856D-DD80D9322062}"/>
               </a:ext>
             </a:extLst>
           </p:cNvPr>
@@ -17233,7 +17233,7 @@
           <p:cNvPr id="9" name="text-59">
             <a:extLst xmlns:a="http://schemas.openxmlformats.org/drawingml/2006/main">
               <a:ext uri="{FF2B5EF4-FFF2-40B4-BE49-F238E27FC236}">
-                <a16:creationId xmlns:a16="http://schemas.microsoft.com/office/drawing/2014/main" id="{F95FE0EC-4547-481B-93E4-DEF05668795C}"/>
+                <a16:creationId xmlns:a16="http://schemas.microsoft.com/office/drawing/2014/main" id="{7AEBFAF1-F4F0-4991-B6EA-4A2EFB9D4970}"/>
               </a:ext>
             </a:extLst>
           </p:cNvPr>
@@ -17391,7 +17391,7 @@
           <p:cNvPr id="10" name="text-60">
             <a:extLst xmlns:a="http://schemas.openxmlformats.org/drawingml/2006/main">
               <a:ext uri="{FF2B5EF4-FFF2-40B4-BE49-F238E27FC236}">
-                <a16:creationId xmlns:a16="http://schemas.microsoft.com/office/drawing/2014/main" id="{989BB8B2-8AE7-42C6-96A2-47C7B05D5AE0}"/>
+                <a16:creationId xmlns:a16="http://schemas.microsoft.com/office/drawing/2014/main" id="{F06266E8-7E0E-4EC9-9CB3-D27849704B00}"/>
               </a:ext>
             </a:extLst>
           </p:cNvPr>
@@ -17549,7 +17549,7 @@
           <p:cNvPr id="11" name="text-61">
             <a:extLst xmlns:a="http://schemas.openxmlformats.org/drawingml/2006/main">
               <a:ext uri="{FF2B5EF4-FFF2-40B4-BE49-F238E27FC236}">
-                <a16:creationId xmlns:a16="http://schemas.microsoft.com/office/drawing/2014/main" id="{29CD5D5D-1C24-4D25-ACE8-4B04F7B4C895}"/>
+                <a16:creationId xmlns:a16="http://schemas.microsoft.com/office/drawing/2014/main" id="{6831F8D7-CC45-4610-8A05-C7ADC2DEDCB4}"/>
               </a:ext>
             </a:extLst>
           </p:cNvPr>
@@ -17707,7 +17707,7 @@
           <p:cNvPr id="12" name="text-62">
             <a:extLst xmlns:a="http://schemas.openxmlformats.org/drawingml/2006/main">
               <a:ext uri="{FF2B5EF4-FFF2-40B4-BE49-F238E27FC236}">
-                <a16:creationId xmlns:a16="http://schemas.microsoft.com/office/drawing/2014/main" id="{112EDD55-33A9-4999-A824-6F509DC45705}"/>
+                <a16:creationId xmlns:a16="http://schemas.microsoft.com/office/drawing/2014/main" id="{AC1835EC-E033-47BC-BCA0-2DEB8D641F3D}"/>
               </a:ext>
             </a:extLst>
           </p:cNvPr>
@@ -17911,7 +17911,7 @@
           <p:cNvPr id="13" name="text-63">
             <a:extLst xmlns:a="http://schemas.openxmlformats.org/drawingml/2006/main">
               <a:ext uri="{FF2B5EF4-FFF2-40B4-BE49-F238E27FC236}">
-                <a16:creationId xmlns:a16="http://schemas.microsoft.com/office/drawing/2014/main" id="{E92B20AE-B3C2-4194-B531-2C69D43FCCE0}"/>
+                <a16:creationId xmlns:a16="http://schemas.microsoft.com/office/drawing/2014/main" id="{D52C4F55-8D56-4854-A78C-0FAFF8072234}"/>
               </a:ext>
             </a:extLst>
           </p:cNvPr>
@@ -18069,7 +18069,7 @@
           <p:cNvPr id="14" name="text-64">
             <a:extLst xmlns:a="http://schemas.openxmlformats.org/drawingml/2006/main">
               <a:ext uri="{FF2B5EF4-FFF2-40B4-BE49-F238E27FC236}">
-                <a16:creationId xmlns:a16="http://schemas.microsoft.com/office/drawing/2014/main" id="{E266AEEC-5D74-4F05-B3B1-B3BF6DF6850F}"/>
+                <a16:creationId xmlns:a16="http://schemas.microsoft.com/office/drawing/2014/main" id="{C40F342C-4272-49B2-8248-0C1DE4E65416}"/>
               </a:ext>
             </a:extLst>
           </p:cNvPr>
@@ -18273,7 +18273,7 @@
           <p:cNvPr id="15" name="text-65">
             <a:extLst xmlns:a="http://schemas.openxmlformats.org/drawingml/2006/main">
               <a:ext uri="{FF2B5EF4-FFF2-40B4-BE49-F238E27FC236}">
-                <a16:creationId xmlns:a16="http://schemas.microsoft.com/office/drawing/2014/main" id="{35AF1440-D6BB-46B5-9065-04063F510963}"/>
+                <a16:creationId xmlns:a16="http://schemas.microsoft.com/office/drawing/2014/main" id="{6A093953-1694-4A5E-A6C9-FD5F40380E21}"/>
               </a:ext>
             </a:extLst>
           </p:cNvPr>
@@ -18284,8 +18284,8 @@
         </p:nvSpPr>
         <p:spPr>
           <a:xfrm xmlns:a="http://schemas.openxmlformats.org/drawingml/2006/main">
-            <a:off x="762000" y="6124575"/>
-            <a:ext cx="10477500" cy="466725"/>
+            <a:off x="762000" y="6019800"/>
+            <a:ext cx="10477500" cy="628650"/>
           </a:xfrm>
           <a:prstGeom xmlns:a="http://schemas.openxmlformats.org/drawingml/2006/main" prst="rect">
             <a:avLst/>
@@ -18421,7 +18421,30 @@
                 <a:ea typeface="Helvetica Neue"/>
                 <a:cs typeface="Helvetica Neue"/>
               </a:rPr>
-              <a:t>4 gateway types; 2 native chats. Live native plans/reports and physical phone checks pending.</a:t>
+              <a:t>All four types accepted in the signed simulator with synthetic inputs.</a:t>
+            </a:r>
+          </a:p>
+          <a:p xmlns:a="http://schemas.openxmlformats.org/drawingml/2006/main">
+            <a:pPr>
+              <a:defRPr sz="1725" b="0">
+                <a:solidFill>
+                  <a:srgbClr val="5D6560"/>
+                </a:solidFill>
+                <a:latin typeface="Helvetica Neue"/>
+                <a:ea typeface="Helvetica Neue"/>
+                <a:cs typeface="Helvetica Neue"/>
+              </a:defRPr>
+            </a:pPr>
+            <a:r>
+              <a:rPr sz="1725" b="0">
+                <a:solidFill>
+                  <a:srgbClr val="5D6560"/>
+                </a:solidFill>
+                <a:latin typeface="Helvetica Neue"/>
+                <a:ea typeface="Helvetica Neue"/>
+                <a:cs typeface="Helvetica Neue"/>
+              </a:rPr>
+              <a:t>Physical phone networking and real-user coaching remain unverified.</a:t>
             </a:r>
           </a:p>
         </p:txBody>
@@ -18429,7 +18452,7 @@
     </p:spTree>
     <p:extLst>
       <p:ext uri="{BB962C8B-B14F-4D97-AF65-F5344CB8AC3E}">
-        <p14:creationId xmlns:p14="http://schemas.microsoft.com/office/powerpoint/2010/main" val="1530314371"/>
+        <p14:creationId xmlns:p14="http://schemas.microsoft.com/office/powerpoint/2010/main" val="1787701784"/>
       </p:ext>
     </p:extLst>
   </p:cSld>
@@ -18460,7 +18483,7 @@
           <p:cNvPr id="11" name="text-66">
             <a:extLst xmlns:a="http://schemas.openxmlformats.org/drawingml/2006/main">
               <a:ext uri="{FF2B5EF4-FFF2-40B4-BE49-F238E27FC236}">
-                <a16:creationId xmlns:a16="http://schemas.microsoft.com/office/drawing/2014/main" id="{36D6C4C2-CE75-4674-9880-04EE6795897A}"/>
+                <a16:creationId xmlns:a16="http://schemas.microsoft.com/office/drawing/2014/main" id="{B3DEAB8C-1209-424D-A5B6-A780D7A72127}"/>
               </a:ext>
             </a:extLst>
           </p:cNvPr>
@@ -18618,7 +18641,7 @@
           <p:cNvPr id="2" name="text-67">
             <a:extLst xmlns:a="http://schemas.openxmlformats.org/drawingml/2006/main">
               <a:ext uri="{FF2B5EF4-FFF2-40B4-BE49-F238E27FC236}">
-                <a16:creationId xmlns:a16="http://schemas.microsoft.com/office/drawing/2014/main" id="{F3A4DB76-CE33-4EF0-83E1-117D66FC9F7C}"/>
+                <a16:creationId xmlns:a16="http://schemas.microsoft.com/office/drawing/2014/main" id="{AC8155EB-983C-4F8C-BA50-5B7E37557F3A}"/>
               </a:ext>
             </a:extLst>
           </p:cNvPr>
@@ -18776,7 +18799,7 @@
           <p:cNvPr id="3" name="text-68">
             <a:extLst xmlns:a="http://schemas.openxmlformats.org/drawingml/2006/main">
               <a:ext uri="{FF2B5EF4-FFF2-40B4-BE49-F238E27FC236}">
-                <a16:creationId xmlns:a16="http://schemas.microsoft.com/office/drawing/2014/main" id="{E1C6494E-61D0-4F58-9C2B-132388465C40}"/>
+                <a16:creationId xmlns:a16="http://schemas.microsoft.com/office/drawing/2014/main" id="{21264FBA-0C9B-4E28-A902-A877199937AE}"/>
               </a:ext>
             </a:extLst>
           </p:cNvPr>
@@ -18934,7 +18957,7 @@
           <p:cNvPr id="4" name="text-69">
             <a:extLst xmlns:a="http://schemas.openxmlformats.org/drawingml/2006/main">
               <a:ext uri="{FF2B5EF4-FFF2-40B4-BE49-F238E27FC236}">
-                <a16:creationId xmlns:a16="http://schemas.microsoft.com/office/drawing/2014/main" id="{7E71E3C1-7D16-43E1-A2D8-9AAD7AEE175A}"/>
+                <a16:creationId xmlns:a16="http://schemas.microsoft.com/office/drawing/2014/main" id="{DAC21C45-806D-4A65-B132-6D0411E871C0}"/>
               </a:ext>
             </a:extLst>
           </p:cNvPr>
@@ -19092,7 +19115,7 @@
           <p:cNvPr id="5" name="text-70">
             <a:extLst xmlns:a="http://schemas.openxmlformats.org/drawingml/2006/main">
               <a:ext uri="{FF2B5EF4-FFF2-40B4-BE49-F238E27FC236}">
-                <a16:creationId xmlns:a16="http://schemas.microsoft.com/office/drawing/2014/main" id="{6E09ADC8-A45D-488F-99E3-236240E33CF5}"/>
+                <a16:creationId xmlns:a16="http://schemas.microsoft.com/office/drawing/2014/main" id="{D6815232-67B4-422C-A1F7-B5651661E4FB}"/>
               </a:ext>
             </a:extLst>
           </p:cNvPr>
@@ -19240,7 +19263,7 @@
                 <a:ea typeface="Helvetica Neue"/>
                 <a:cs typeface="Helvetica Neue"/>
               </a:rPr>
-              <a:t>Implemented adapters</a:t>
+              <a:t>Implemented snapshot adapter</a:t>
             </a:r>
           </a:p>
           <a:p xmlns:a="http://schemas.openxmlformats.org/drawingml/2006/main">
@@ -19263,7 +19286,7 @@
                 <a:ea typeface="Helvetica Neue"/>
                 <a:cs typeface="Helvetica Neue"/>
               </a:rPr>
-              <a:t>Timestamped workout events</a:t>
+              <a:t>Timestamped Watch scalars</a:t>
             </a:r>
           </a:p>
           <a:p xmlns:a="http://schemas.openxmlformats.org/drawingml/2006/main">
@@ -19286,7 +19309,7 @@
                 <a:ea typeface="Helvetica Neue"/>
                 <a:cs typeface="Helvetica Neue"/>
               </a:rPr>
-              <a:t>and rolling aggregates</a:t>
+              <a:t>Explicit optional upload</a:t>
             </a:r>
           </a:p>
         </p:txBody>
@@ -19296,7 +19319,7 @@
           <p:cNvPr id="6" name="text-71">
             <a:extLst xmlns:a="http://schemas.openxmlformats.org/drawingml/2006/main">
               <a:ext uri="{FF2B5EF4-FFF2-40B4-BE49-F238E27FC236}">
-                <a16:creationId xmlns:a16="http://schemas.microsoft.com/office/drawing/2014/main" id="{200C39A6-A151-459F-9C25-4958BDF59279}"/>
+                <a16:creationId xmlns:a16="http://schemas.microsoft.com/office/drawing/2014/main" id="{6B8E988C-5106-4FE9-9977-88FC0C8EA362}"/>
               </a:ext>
             </a:extLst>
           </p:cNvPr>
@@ -19444,7 +19467,7 @@
                 <a:ea typeface="Helvetica Neue"/>
                 <a:cs typeface="Helvetica Neue"/>
               </a:rPr>
-              <a:t>Adapter and migration tests pass.</a:t>
+              <a:t>Console schema accepted; zero rows.</a:t>
             </a:r>
           </a:p>
           <a:p xmlns:a="http://schemas.openxmlformats.org/drawingml/2006/main">
@@ -19467,7 +19490,7 @@
                 <a:ea typeface="Helvetica Neue"/>
                 <a:cs typeface="Helvetica Neue"/>
               </a:rPr>
-              <a:t>Strict TLS blocks live SQL.</a:t>
+              <a:t>Node TLS and ingestion pending.</a:t>
             </a:r>
           </a:p>
         </p:txBody>
@@ -19477,7 +19500,7 @@
           <p:cNvPr id="7" name="text-72">
             <a:extLst xmlns:a="http://schemas.openxmlformats.org/drawingml/2006/main">
               <a:ext uri="{FF2B5EF4-FFF2-40B4-BE49-F238E27FC236}">
-                <a16:creationId xmlns:a16="http://schemas.microsoft.com/office/drawing/2014/main" id="{8024F765-581B-4057-BAFA-40B5E1FF0347}"/>
+                <a16:creationId xmlns:a16="http://schemas.microsoft.com/office/drawing/2014/main" id="{CC2B6BC7-2CF8-4C52-9A24-6E4B2B97C4D0}"/>
               </a:ext>
             </a:extLst>
           </p:cNvPr>
@@ -19635,7 +19658,7 @@
           <p:cNvPr id="8" name="text-73">
             <a:extLst xmlns:a="http://schemas.openxmlformats.org/drawingml/2006/main">
               <a:ext uri="{FF2B5EF4-FFF2-40B4-BE49-F238E27FC236}">
-                <a16:creationId xmlns:a16="http://schemas.microsoft.com/office/drawing/2014/main" id="{8C4FC370-F69E-4737-BDE8-5C16BDA46F52}"/>
+                <a16:creationId xmlns:a16="http://schemas.microsoft.com/office/drawing/2014/main" id="{5C471571-6B80-45BD-A73F-A70555D01C7E}"/>
               </a:ext>
             </a:extLst>
           </p:cNvPr>
@@ -19793,7 +19816,7 @@
           <p:cNvPr id="9" name="text-74">
             <a:extLst xmlns:a="http://schemas.openxmlformats.org/drawingml/2006/main">
               <a:ext uri="{FF2B5EF4-FFF2-40B4-BE49-F238E27FC236}">
-                <a16:creationId xmlns:a16="http://schemas.microsoft.com/office/drawing/2014/main" id="{AF6402EF-AD3D-40A6-889B-E8975CFA8FA0}"/>
+                <a16:creationId xmlns:a16="http://schemas.microsoft.com/office/drawing/2014/main" id="{C8DB153E-4A94-477E-9EB8-041C501105F8}"/>
               </a:ext>
             </a:extLst>
           </p:cNvPr>
@@ -19997,7 +20020,7 @@
           <p:cNvPr id="10" name="text-75">
             <a:extLst xmlns:a="http://schemas.openxmlformats.org/drawingml/2006/main">
               <a:ext uri="{FF2B5EF4-FFF2-40B4-BE49-F238E27FC236}">
-                <a16:creationId xmlns:a16="http://schemas.microsoft.com/office/drawing/2014/main" id="{44A9CD28-74E6-44FF-90E5-105FD1ACCC2D}"/>
+                <a16:creationId xmlns:a16="http://schemas.microsoft.com/office/drawing/2014/main" id="{432F1D7B-476B-4E57-9DFA-EFD6D85A7316}"/>
               </a:ext>
             </a:extLst>
           </p:cNvPr>
@@ -20176,7 +20199,7 @@
     </p:spTree>
     <p:extLst>
       <p:ext uri="{BB962C8B-B14F-4D97-AF65-F5344CB8AC3E}">
-        <p14:creationId xmlns:p14="http://schemas.microsoft.com/office/powerpoint/2010/main" val="1618343240"/>
+        <p14:creationId xmlns:p14="http://schemas.microsoft.com/office/powerpoint/2010/main" val="276059141"/>
       </p:ext>
     </p:extLst>
   </p:cSld>
@@ -20207,7 +20230,7 @@
           <p:cNvPr id="10" name="text-76">
             <a:extLst xmlns:a="http://schemas.openxmlformats.org/drawingml/2006/main">
               <a:ext uri="{FF2B5EF4-FFF2-40B4-BE49-F238E27FC236}">
-                <a16:creationId xmlns:a16="http://schemas.microsoft.com/office/drawing/2014/main" id="{918CAB0C-67AE-44EE-9502-2CDA4139A2CD}"/>
+                <a16:creationId xmlns:a16="http://schemas.microsoft.com/office/drawing/2014/main" id="{7AF05816-CE1A-49B6-86B1-68BA4F6FBFA4}"/>
               </a:ext>
             </a:extLst>
           </p:cNvPr>
@@ -20365,7 +20388,7 @@
           <p:cNvPr id="2" name="text-77">
             <a:extLst xmlns:a="http://schemas.openxmlformats.org/drawingml/2006/main">
               <a:ext uri="{FF2B5EF4-FFF2-40B4-BE49-F238E27FC236}">
-                <a16:creationId xmlns:a16="http://schemas.microsoft.com/office/drawing/2014/main" id="{487A4F16-9E3C-4340-857D-002376C2EDAC}"/>
+                <a16:creationId xmlns:a16="http://schemas.microsoft.com/office/drawing/2014/main" id="{F503D48C-1826-4C41-86D9-86DA832EB5A9}"/>
               </a:ext>
             </a:extLst>
           </p:cNvPr>
@@ -20523,7 +20546,7 @@
           <p:cNvPr id="3" name="text-78">
             <a:extLst xmlns:a="http://schemas.openxmlformats.org/drawingml/2006/main">
               <a:ext uri="{FF2B5EF4-FFF2-40B4-BE49-F238E27FC236}">
-                <a16:creationId xmlns:a16="http://schemas.microsoft.com/office/drawing/2014/main" id="{82F58ABE-4287-4200-B140-B199E2F74109}"/>
+                <a16:creationId xmlns:a16="http://schemas.microsoft.com/office/drawing/2014/main" id="{4C590AD0-B742-43BC-8A22-9240165A720A}"/>
               </a:ext>
             </a:extLst>
           </p:cNvPr>
@@ -20681,7 +20704,7 @@
           <p:cNvPr id="4" name="Chart">
             <a:extLst xmlns:a="http://schemas.openxmlformats.org/drawingml/2006/main">
               <a:ext uri="{FF2B5EF4-FFF2-40B4-BE49-F238E27FC236}">
-                <a16:creationId xmlns:a16="http://schemas.microsoft.com/office/drawing/2014/main" id="{C5DEB631-9D6A-4874-8896-C79650FA988A}"/>
+                <a16:creationId xmlns:a16="http://schemas.microsoft.com/office/drawing/2014/main" id="{E8176BD8-25FC-4EFA-9DBD-D1B927ECC190}"/>
               </a:ext>
             </a:extLst>
           </p:cNvPr>
@@ -20694,7 +20717,7 @@
         </p:xfrm>
         <a:graphic xmlns:a="http://schemas.openxmlformats.org/drawingml/2006/main">
           <a:graphicData uri="http://schemas.openxmlformats.org/drawingml/2006/chart">
-            <c:chart xmlns:r="http://schemas.openxmlformats.org/officeDocument/2006/relationships" xmlns:c="http://schemas.openxmlformats.org/drawingml/2006/chart" r:id="R1175eb1d9bd84a1e"/>
+            <c:chart xmlns:r="http://schemas.openxmlformats.org/officeDocument/2006/relationships" xmlns:c="http://schemas.openxmlformats.org/drawingml/2006/chart" r:id="Ra5a7bb54c6254f98"/>
           </a:graphicData>
         </a:graphic>
       </p:graphicFrame>
@@ -20703,7 +20726,7 @@
           <p:cNvPr id="5" name="text-79">
             <a:extLst xmlns:a="http://schemas.openxmlformats.org/drawingml/2006/main">
               <a:ext uri="{FF2B5EF4-FFF2-40B4-BE49-F238E27FC236}">
-                <a16:creationId xmlns:a16="http://schemas.microsoft.com/office/drawing/2014/main" id="{59EE30D4-E356-4A73-88A5-9074C82C5DF6}"/>
+                <a16:creationId xmlns:a16="http://schemas.microsoft.com/office/drawing/2014/main" id="{BD8A0CA3-56C3-4979-8A12-C6A1BE654B33}"/>
               </a:ext>
             </a:extLst>
           </p:cNvPr>
@@ -20861,7 +20884,7 @@
           <p:cNvPr id="6" name="text-80">
             <a:extLst xmlns:a="http://schemas.openxmlformats.org/drawingml/2006/main">
               <a:ext uri="{FF2B5EF4-FFF2-40B4-BE49-F238E27FC236}">
-                <a16:creationId xmlns:a16="http://schemas.microsoft.com/office/drawing/2014/main" id="{CB8C1937-91CA-41BB-AB95-AED8D62509FC}"/>
+                <a16:creationId xmlns:a16="http://schemas.microsoft.com/office/drawing/2014/main" id="{C7B3B192-1C96-4643-92BD-C227D06D6F2E}"/>
               </a:ext>
             </a:extLst>
           </p:cNvPr>
@@ -21019,7 +21042,7 @@
           <p:cNvPr id="7" name="text-81">
             <a:extLst xmlns:a="http://schemas.openxmlformats.org/drawingml/2006/main">
               <a:ext uri="{FF2B5EF4-FFF2-40B4-BE49-F238E27FC236}">
-                <a16:creationId xmlns:a16="http://schemas.microsoft.com/office/drawing/2014/main" id="{8D4F131B-3847-4778-871F-E24DFB49FDFF}"/>
+                <a16:creationId xmlns:a16="http://schemas.microsoft.com/office/drawing/2014/main" id="{5978F7CD-0442-4DB1-9704-5E1FEC259557}"/>
               </a:ext>
             </a:extLst>
           </p:cNvPr>
@@ -21200,7 +21223,7 @@
           <p:cNvPr id="8" name="text-82">
             <a:extLst xmlns:a="http://schemas.openxmlformats.org/drawingml/2006/main">
               <a:ext uri="{FF2B5EF4-FFF2-40B4-BE49-F238E27FC236}">
-                <a16:creationId xmlns:a16="http://schemas.microsoft.com/office/drawing/2014/main" id="{287419B9-1F08-481F-931A-2EA639930623}"/>
+                <a16:creationId xmlns:a16="http://schemas.microsoft.com/office/drawing/2014/main" id="{973AB192-1FB5-47F5-9141-F552F4093FC5}"/>
               </a:ext>
             </a:extLst>
           </p:cNvPr>
@@ -21381,7 +21404,7 @@
           <p:cNvPr id="9" name="text-83">
             <a:extLst xmlns:a="http://schemas.openxmlformats.org/drawingml/2006/main">
               <a:ext uri="{FF2B5EF4-FFF2-40B4-BE49-F238E27FC236}">
-                <a16:creationId xmlns:a16="http://schemas.microsoft.com/office/drawing/2014/main" id="{41A621C9-5D2D-415D-AFF4-C6064FF3C1B6}"/>
+                <a16:creationId xmlns:a16="http://schemas.microsoft.com/office/drawing/2014/main" id="{973FA991-6482-4D5C-A460-67057DC1AC79}"/>
               </a:ext>
             </a:extLst>
           </p:cNvPr>
@@ -21537,7 +21560,7 @@
     </p:spTree>
     <p:extLst>
       <p:ext uri="{BB962C8B-B14F-4D97-AF65-F5344CB8AC3E}">
-        <p14:creationId xmlns:p14="http://schemas.microsoft.com/office/powerpoint/2010/main" val="1389472466"/>
+        <p14:creationId xmlns:p14="http://schemas.microsoft.com/office/powerpoint/2010/main" val="1717977144"/>
       </p:ext>
     </p:extLst>
   </p:cSld>
@@ -21568,7 +21591,7 @@
           <p:cNvPr id="5" name="text-84">
             <a:extLst xmlns:a="http://schemas.openxmlformats.org/drawingml/2006/main">
               <a:ext uri="{FF2B5EF4-FFF2-40B4-BE49-F238E27FC236}">
-                <a16:creationId xmlns:a16="http://schemas.microsoft.com/office/drawing/2014/main" id="{6EEFD6F9-A67D-43A2-BAAA-50074EA31323}"/>
+                <a16:creationId xmlns:a16="http://schemas.microsoft.com/office/drawing/2014/main" id="{429ABD2A-F9A7-4C70-BEC3-40B51C0E2325}"/>
               </a:ext>
             </a:extLst>
           </p:cNvPr>
@@ -21726,7 +21749,7 @@
           <p:cNvPr id="2" name="text-85">
             <a:extLst xmlns:a="http://schemas.openxmlformats.org/drawingml/2006/main">
               <a:ext uri="{FF2B5EF4-FFF2-40B4-BE49-F238E27FC236}">
-                <a16:creationId xmlns:a16="http://schemas.microsoft.com/office/drawing/2014/main" id="{8B54B533-43F2-4EF2-8F0B-B27E0F5A1FA0}"/>
+                <a16:creationId xmlns:a16="http://schemas.microsoft.com/office/drawing/2014/main" id="{07535582-48E1-43C8-82C6-3A0074C196A0}"/>
               </a:ext>
             </a:extLst>
           </p:cNvPr>
@@ -21884,7 +21907,7 @@
           <p:cNvPr id="3" name="">
             <a:extLst xmlns:a="http://schemas.openxmlformats.org/drawingml/2006/main">
               <a:ext uri="{FF2B5EF4-FFF2-40B4-BE49-F238E27FC236}">
-                <a16:creationId xmlns:a16="http://schemas.microsoft.com/office/drawing/2014/main" id="{3915D413-0934-4A1B-93D5-9648B3C6A4E8}"/>
+                <a16:creationId xmlns:a16="http://schemas.microsoft.com/office/drawing/2014/main" id="{4FC6A918-7D57-4F1F-8FB5-DFCDE55035A3}"/>
               </a:ext>
             </a:extLst>
           </p:cNvPr>
@@ -22095,7 +22118,7 @@
                           <a:ea typeface="Helvetica Neue"/>
                           <a:cs typeface="Helvetica Neue"/>
                         </a:rPr>
-                        <a:t>Gateway + 2 native chats</a:t>
+                        <a:t>4 native types; synthetic</a:t>
                       </a:r>
                     </a:p>
                   </a:txBody>
@@ -22131,7 +22154,7 @@
                           <a:ea typeface="Helvetica Neue"/>
                           <a:cs typeface="Helvetica Neue"/>
                         </a:rPr>
-                        <a:t>Native plans/reports; physical networking</a:t>
+                        <a:t>Physical network; real-user review</a:t>
                       </a:r>
                     </a:p>
                   </a:txBody>
@@ -22211,7 +22234,7 @@
                           <a:ea typeface="Helvetica Neue"/>
                           <a:cs typeface="Helvetica Neue"/>
                         </a:rPr>
-                        <a:t>Service provisioned</a:t>
+                        <a:t>Console schema; zero rows</a:t>
                       </a:r>
                     </a:p>
                   </a:txBody>
@@ -22247,7 +22270,7 @@
                           <a:ea typeface="Helvetica Neue"/>
                           <a:cs typeface="Helvetica Neue"/>
                         </a:rPr>
-                        <a:t>Strict TLS private-CA chain</a:t>
+                        <a:t>Strict Node TLS; ingest/readback</a:t>
                       </a:r>
                     </a:p>
                   </a:txBody>
@@ -22859,7 +22882,7 @@
           <p:cNvPr id="4" name="text-86">
             <a:extLst xmlns:a="http://schemas.openxmlformats.org/drawingml/2006/main">
               <a:ext uri="{FF2B5EF4-FFF2-40B4-BE49-F238E27FC236}">
-                <a16:creationId xmlns:a16="http://schemas.microsoft.com/office/drawing/2014/main" id="{FF31FBA8-94D1-4748-86A8-67072320C59B}"/>
+                <a16:creationId xmlns:a16="http://schemas.microsoft.com/office/drawing/2014/main" id="{5E0220DD-AAC1-4EDF-AA9C-98144638E150}"/>
               </a:ext>
             </a:extLst>
           </p:cNvPr>
@@ -23007,7 +23030,30 @@
                 <a:ea typeface="Helvetica Neue"/>
                 <a:cs typeface="Helvetica Neue"/>
               </a:rPr>
-              <a:t>Standalone web prototype: 92 offline checks and mock-profile browser acceptance. Real cloud upload pending.</a:t>
+              <a:t>Web prototype: 92 offline checks; real cloud upload pending.</a:t>
+            </a:r>
+          </a:p>
+          <a:p xmlns:a="http://schemas.openxmlformats.org/drawingml/2006/main">
+            <a:pPr>
+              <a:defRPr sz="1725" b="0">
+                <a:solidFill>
+                  <a:srgbClr val="5D6560"/>
+                </a:solidFill>
+                <a:latin typeface="Helvetica Neue"/>
+                <a:ea typeface="Helvetica Neue"/>
+                <a:cs typeface="Helvetica Neue"/>
+              </a:defRPr>
+            </a:pPr>
+            <a:r>
+              <a:rPr sz="1725" b="0">
+                <a:solidFill>
+                  <a:srgbClr val="5D6560"/>
+                </a:solidFill>
+                <a:latin typeface="Helvetica Neue"/>
+                <a:ea typeface="Helvetica Neue"/>
+                <a:cs typeface="Helvetica Neue"/>
+              </a:rPr>
+              <a:t>Landing: local browser accepted; public deployment pending.</a:t>
             </a:r>
           </a:p>
         </p:txBody>
@@ -23015,7 +23061,7 @@
     </p:spTree>
     <p:extLst>
       <p:ext uri="{BB962C8B-B14F-4D97-AF65-F5344CB8AC3E}">
-        <p14:creationId xmlns:p14="http://schemas.microsoft.com/office/powerpoint/2010/main" val="1701730222"/>
+        <p14:creationId xmlns:p14="http://schemas.microsoft.com/office/powerpoint/2010/main" val="1446356543"/>
       </p:ext>
     </p:extLst>
   </p:cSld>

</xml_diff>

<commit_message>
Refresh judges deck for approved external build 3
</commit_message>
<xml_diff>
--- a/presentation/output/spottr-judges.pptx
+++ b/presentation/output/spottr-judges.pptx
@@ -2,22 +2,22 @@
 <file path=ppt/presentation.xml><?xml version="1.0" encoding="utf-8"?>
 <p:presentation xmlns:p="http://schemas.openxmlformats.org/presentationml/2006/main">
   <p:sldMasterIdLst>
-    <p:sldMasterId xmlns:r="http://schemas.openxmlformats.org/officeDocument/2006/relationships" id="2147483648" r:id="R401fdfa0c3a941ce"/>
+    <p:sldMasterId xmlns:r="http://schemas.openxmlformats.org/officeDocument/2006/relationships" id="2147483648" r:id="R8c238501e6224f15"/>
   </p:sldMasterIdLst>
   <p:notesMasterIdLst>
-    <p:notesMasterId xmlns:r="http://schemas.openxmlformats.org/officeDocument/2006/relationships" r:id="R5990c4beba4b4a8b"/>
+    <p:notesMasterId xmlns:r="http://schemas.openxmlformats.org/officeDocument/2006/relationships" r:id="Rd346478e06844cf9"/>
   </p:notesMasterIdLst>
   <p:sldIdLst>
-    <p:sldId xmlns:r="http://schemas.openxmlformats.org/officeDocument/2006/relationships" id="256" r:id="R802c8f7c07c74c09"/>
-    <p:sldId xmlns:r="http://schemas.openxmlformats.org/officeDocument/2006/relationships" id="257" r:id="Rbdb04ac153c44c86"/>
-    <p:sldId xmlns:r="http://schemas.openxmlformats.org/officeDocument/2006/relationships" id="258" r:id="R10cab054fbd0443b"/>
-    <p:sldId xmlns:r="http://schemas.openxmlformats.org/officeDocument/2006/relationships" id="259" r:id="R8d00568116e84d03"/>
-    <p:sldId xmlns:r="http://schemas.openxmlformats.org/officeDocument/2006/relationships" id="260" r:id="R23e93013f5284f4a"/>
-    <p:sldId xmlns:r="http://schemas.openxmlformats.org/officeDocument/2006/relationships" id="261" r:id="Rd5b8bfab77d548e4"/>
-    <p:sldId xmlns:r="http://schemas.openxmlformats.org/officeDocument/2006/relationships" id="262" r:id="Re284a0b4f4264fe3"/>
-    <p:sldId xmlns:r="http://schemas.openxmlformats.org/officeDocument/2006/relationships" id="263" r:id="Rba689a70b59f4b6f"/>
-    <p:sldId xmlns:r="http://schemas.openxmlformats.org/officeDocument/2006/relationships" id="264" r:id="Ra6cd5b914ae54cd5"/>
-    <p:sldId xmlns:r="http://schemas.openxmlformats.org/officeDocument/2006/relationships" id="265" r:id="Re3defebe5d50421c"/>
+    <p:sldId xmlns:r="http://schemas.openxmlformats.org/officeDocument/2006/relationships" id="256" r:id="Rf8ea162f68f84a08"/>
+    <p:sldId xmlns:r="http://schemas.openxmlformats.org/officeDocument/2006/relationships" id="257" r:id="R094a04d0245f42a3"/>
+    <p:sldId xmlns:r="http://schemas.openxmlformats.org/officeDocument/2006/relationships" id="258" r:id="Ra3aab8388f5d4453"/>
+    <p:sldId xmlns:r="http://schemas.openxmlformats.org/officeDocument/2006/relationships" id="259" r:id="Rbf4482fa68384bd9"/>
+    <p:sldId xmlns:r="http://schemas.openxmlformats.org/officeDocument/2006/relationships" id="260" r:id="R93a20c845f584577"/>
+    <p:sldId xmlns:r="http://schemas.openxmlformats.org/officeDocument/2006/relationships" id="261" r:id="R7e6ddc3166a34a1e"/>
+    <p:sldId xmlns:r="http://schemas.openxmlformats.org/officeDocument/2006/relationships" id="262" r:id="R91a034eef7d54ce5"/>
+    <p:sldId xmlns:r="http://schemas.openxmlformats.org/officeDocument/2006/relationships" id="263" r:id="R7e9da2584a774037"/>
+    <p:sldId xmlns:r="http://schemas.openxmlformats.org/officeDocument/2006/relationships" id="264" r:id="R08d4c6cd31024e95"/>
+    <p:sldId xmlns:r="http://schemas.openxmlformats.org/officeDocument/2006/relationships" id="265" r:id="Re302c357960f40f0"/>
   </p:sldIdLst>
   <p:sldSz cx="12192000" cy="6858000"/>
   <p:notesSz cx="6858000" cy="9144000"/>
@@ -451,7 +451,7 @@
           <a:lstStyle xmlns:a="http://schemas.openxmlformats.org/drawingml/2006/main"/>
           <a:p xmlns:a="http://schemas.openxmlformats.org/drawingml/2006/main">
             <a:r>
-              <a:t>Opening: Spottr is an implemented native bodyweight workout prototype. The motivation is short, timely feedback with an explicit evidence boundary, not a clinical or physical-capacity claim. The image is an actual iPhone simulator screenshot approved by the owner, with missing/unearned progress shown honestly. Evidence snapshot 25 October 2026, 00:09 UTC. Sources: /Users/scsoc/dev/AI PT/docs/app-guide.md; /Users/scsoc/dev/AI PT/docs/integration-readiness.md. Asset source and SHA256 are in presentation/source/assets.json.</a:t>
+              <a:t>Opening: Spottr is an implemented native bodyweight workout prototype. The motivation is short, timely feedback with an explicit evidence boundary, not a clinical or physical-capacity claim. The image is an actual iPhone simulator screenshot approved by the owner, with missing/unearned progress shown honestly. Evidence snapshot 25 October 2026, 00:36 UTC. Sources: /Users/scsoc/dev/AI PT/docs/app-guide.md; /Users/scsoc/dev/AI PT/docs/integration-readiness.md. Asset source and SHA256 are in presentation/source/assets.json.</a:t>
             </a:r>
           </a:p>
         </p:txBody>
@@ -521,7 +521,7 @@
           <a:lstStyle xmlns:a="http://schemas.openxmlformats.org/drawingml/2006/main"/>
           <a:p xmlns:a="http://schemas.openxmlformats.org/drawingml/2006/main">
             <a:r>
-              <a:t>Evidence snapshot 25 October 2026, 00:09 UTC. This is a suggested rehearsal sequence, not an assertion that a rehearsal occurred. Use normal history safely. Open current Today/profile, then tracked workout, pause/end and source-aware record, Skills and explicit Coach controls. If fixtures or a simulator supply values, label them and do not call them live physiological data. Do not spend provider credits as part of rehearsal without the existing approved scope. Show the saved public-data benchmark as offline. Build 0.1 (1) passed Apple validation/upload, is VALID and internally IN_BETA_TESTING. External build 1 remains WAITING_FOR_BETA_REVIEW and its 25-person invitation is not yet a usable external download. Build 0.1 (2), source b7bf563, passed signed archive/export and Apple validation at 23:06:21 UTC; upload succeeded at 23:08:00 UTC. At 23:10:33 UTC App Store Connect reported VALID and internal IN_BETA_TESTING after assignment to the existing Spottr Internal group. Both builds are internal. Build 2 remains READY_FOR_BETA_SUBMISSION and is not submitted externally; only build 1 is assigned to the external OxHack group. The configured discomfort fix and manual-set wording are after build 1 and are included in build 2, not the already available build 1. The unresolved MediaPipe upstream privacy/origin-signature gap is separate from successful Apple processing; no physical installation or public App Store approval is claimed. Sources: /Users/scsoc/dev/AI PT/docs/evidence/testflight-build-2-2026-10-24.md; /Users/scsoc/dev/AI PT/docs/testflight.md; /Users/scsoc/dev/AI PT/docs/app-guide.md; /Users/scsoc/dev/AI PT/docs/integration-readiness.md; /Users/scsoc/dev/AI PT/docs/release-readiness.md; /Users/scsoc/dev/AI PT/docs/testflight-provisioning.md.</a:t>
+              <a:t>Evidence snapshot 25 October 2026, 00:36 UTC. This is a suggested rehearsal sequence, not an assertion that a rehearsal occurred. Use normal history safely. Open current Today/profile, then tracked workout, pause/end and source-aware record, Skills and explicit Coach controls. If fixtures or a simulator supply values, label them and do not call them live physiological data. Do not spend provider credits as part of rehearsal without the existing approved scope. Show the saved public-data benchmark as offline. Source inventory is current main 0006472; native TestFlight build 3 is frozen at ebbe560737d16ec3c6a72da7436ba25730587e19. Build 0.1 (3) passed signed archive/export and Apple validation at 00:22:55 UTC on 25 October; upload succeeded at 00:27:06 UTC. App Store Connect reports build 3 VALID, internal IN_BETA_TESTING and external IN_BETA_TESTING, with beta submission APPROVED at the 00:36 UTC read-back. Builds 1, 2 and 3 remain internal; the external OxHack group contains builds 3 and 1. Build 2 is not externally submitted. The existing public invitation https://testflight.apple.com/join/f3MhePbf remains enabled for 25 testers. Its public Apple page and both landing HTTPS links were verified; no itms-beta deep link, invitation acceptance or installation was performed. Build 3 includes the rendering/history refactor; the Gemini compatibility correction runs separately on the gateway. All four native Gemini request types accepted real responses with synthetic inputs; physical networking and real-user guidance remain unverified. The unresolved MediaPipe upstream privacy/origin-signature gap is separate from Apple processing. No physical installation or public App Store approval is claimed. Sources: /Users/scsoc/dev/AI PT/docs/evidence/testflight-build-3-2026-10-25.md; /Users/scsoc/dev/AI PT/docs/evidence/testflight-availability-2026-10-25.md; /Users/scsoc/dev/AI PT/docs/testflight.md; /Users/scsoc/dev/AI PT/docs/app-guide.md; /Users/scsoc/dev/AI PT/docs/integration-readiness.md; /Users/scsoc/dev/AI PT/docs/release-readiness.md; /Users/scsoc/dev/AI PT/docs/testflight-provisioning.md.</a:t>
             </a:r>
           </a:p>
         </p:txBody>
@@ -591,7 +591,7 @@
           <a:lstStyle xmlns:a="http://schemas.openxmlformats.org/drawingml/2006/main"/>
           <a:p xmlns:a="http://schemas.openxmlformats.org/drawingml/2006/main">
             <a:r>
-              <a:t>Evidence snapshot 25 October 2026, 00:09 UTC. Implemented native flow, not a measured rep-accuracy claim. Manual/timed workouts work without cloud credentials. A real camera path exists for push-ups and squats; physical accuracy/error/abstention evaluation remains pending. Local speech is opt-in, fake-playback tested, with audible phone acceptance pending. Sources: /Users/scsoc/dev/AI PT/docs/app-guide.md; /Users/scsoc/dev/AI PT/docs/voice-feedback.md; /Users/scsoc/dev/AI PT/docs/integration-readiness.md.</a:t>
+              <a:t>Evidence snapshot 25 October 2026, 00:36 UTC. Implemented native flow, not a measured rep-accuracy claim. Manual/timed workouts work without cloud credentials. A real camera path exists for push-ups and squats; physical accuracy/error/abstention evaluation remains pending. Local speech is opt-in, fake-playback tested, with audible phone acceptance pending. Sources: /Users/scsoc/dev/AI PT/docs/app-guide.md; /Users/scsoc/dev/AI PT/docs/voice-feedback.md; /Users/scsoc/dev/AI PT/docs/integration-readiness.md.</a:t>
             </a:r>
           </a:p>
         </p:txBody>
@@ -661,7 +661,7 @@
           <a:lstStyle xmlns:a="http://schemas.openxmlformats.org/drawingml/2006/main"/>
           <a:p xmlns:a="http://schemas.openxmlformats.org/drawingml/2006/main">
             <a:r>
-              <a:t>Evidence snapshot 25 October 2026, 00:09 UTC. Editable architecture. Phone owns MediaPipe inference, session state and deterministic policy. Watch adapter forwards latest-value timestamped heart/motion signals, not raw lossless vectors. Simulator transport/visual evidence and unsigned device compilation are separate from physical Watch recording. Pi real HTTPS pairing/start/frame/stop tests succeeded, then USB disconnected after around two seconds. No Pi inference or sustained capture is claimed. Sources: /Users/scsoc/dev/AI PT/docs/watch-telemetry.md; /Users/scsoc/dev/AI PT/docs/watch-simulator-acceptance.md; /Users/scsoc/dev/AI PT/hardware/pi/EVIDENCE-2026-10-24.md; /Users/scsoc/dev/AI PT/hardware/pi/NATIVE-HANDOFF.md.</a:t>
+              <a:t>Evidence snapshot 25 October 2026, 00:36 UTC. Editable architecture. Phone owns MediaPipe inference, session state and deterministic policy. Watch adapter forwards latest-value timestamped heart/motion signals, not raw lossless vectors. Simulator transport/visual evidence and unsigned device compilation are separate from physical Watch recording. Pi real HTTPS pairing/start/frame/stop tests succeeded, then USB disconnected after around two seconds. No Pi inference or sustained capture is claimed. Sources: /Users/scsoc/dev/AI PT/docs/watch-telemetry.md; /Users/scsoc/dev/AI PT/docs/watch-simulator-acceptance.md; /Users/scsoc/dev/AI PT/hardware/pi/EVIDENCE-2026-10-24.md; /Users/scsoc/dev/AI PT/hardware/pi/NATIVE-HANDOFF.md.</a:t>
             </a:r>
           </a:p>
         </p:txBody>
@@ -731,7 +731,7 @@
           <a:lstStyle xmlns:a="http://schemas.openxmlformats.org/drawingml/2006/main"/>
           <a:p xmlns:a="http://schemas.openxmlformats.org/drawingml/2006/main">
             <a:r>
-              <a:t>Evidence snapshot 25 October 2026, 00:09 UTC. These are deterministic implementation rules, not calibrated physiological thresholds or a measurement of rep-count accuracy. RepCounter requires confidence&gt;=0.6 and a complete top-bottom-top cycle, resets on gaps&gt;0.75s or nonmonotonic time, uses0.15s zone stability and accepts0.6–15s cycle duration. CoachingPolicy compares a new valid rep with at least five prior valid durations using mean+max(sampleSD,0.25s). Reported discomfort has an exercise-independent stop decision, including manual reps and holds. PR #64 passed 23 native checks, 26 core checks and a Watch simulator build; fake playback does not establish audible acceptance. Stop identity persists across ticks; repeated stop does not cut itself off or replay after background return. Lifecycle invalidation prevents old cues/sensor callbacks entering a new state. Sources: /Users/scsoc/dev/AI PT/Shared/Core/RepCounter.swift; /Users/scsoc/dev/AI PT/Shared/Core/CoachingPolicy.swift; /Users/scsoc/dev/AI PT/docs/watch-telemetry.md; /Users/scsoc/dev/AI PT/docs/voice-feedback.md. Phase images are existing illustrations, not captured workout evidence.</a:t>
+              <a:t>Evidence snapshot 25 October 2026, 00:36 UTC. These are deterministic implementation rules, not calibrated physiological thresholds or a measurement of rep-count accuracy. RepCounter requires confidence&gt;=0.6 and a complete top-bottom-top cycle, resets on gaps&gt;0.75s or nonmonotonic time, uses0.15s zone stability and accepts0.6–15s cycle duration. CoachingPolicy compares a new valid rep with at least five prior valid durations using mean+max(sampleSD,0.25s). Reported discomfort has an exercise-independent stop decision, including manual reps and holds. PR #64 passed 23 native checks, 26 core checks and a Watch simulator build; fake playback does not establish audible acceptance. Stop identity persists across ticks; repeated stop does not cut itself off or replay after background return. Lifecycle invalidation prevents old cues/sensor callbacks entering a new state. Sources: /Users/scsoc/dev/AI PT/Shared/Core/RepCounter.swift; /Users/scsoc/dev/AI PT/Shared/Core/CoachingPolicy.swift; /Users/scsoc/dev/AI PT/docs/watch-telemetry.md; /Users/scsoc/dev/AI PT/docs/voice-feedback.md. Phase images are existing illustrations, not captured workout evidence.</a:t>
             </a:r>
           </a:p>
         </p:txBody>
@@ -801,7 +801,7 @@
           <a:lstStyle xmlns:a="http://schemas.openxmlformats.org/drawingml/2006/main"/>
           <a:p xmlns:a="http://schemas.openxmlformats.org/drawingml/2006/main">
             <a:r>
-              <a:t>Evidence snapshot 25 October 2026, 00:09 UTC. The current app has19 catalogue entries and connected tree/linear options. This diagram shows the exact immediate prerequisite example for pushup: kneePushup and plank. Earlier prerequisites of those nodes are omitted. Node completion needs three qualifying sets across two days after all immediate prerequisites complete. Manual/camera evidence can qualify; video replay and discomfort stops do not. Game points are not physical capacity. Sources: /Users/scsoc/dev/AI PT/Shared/Core/SkillProgress.swift; /Users/scsoc/dev/AI PT/Shared/Core/ExerciseCatalog.swift; /Users/scsoc/dev/AI PT/Native/iOS/SkillsViews.swift; /Users/scsoc/dev/AI PT/docs/app-guide.md. Exercise artwork is existing PNG content, with source hashes in assets.json.</a:t>
+              <a:t>Evidence snapshot 25 October 2026, 00:36 UTC. The current app has19 catalogue entries and connected tree/linear options. This diagram shows the exact immediate prerequisite example for pushup: kneePushup and plank. Earlier prerequisites of those nodes are omitted. Node completion needs three qualifying sets across two days after all immediate prerequisites complete. Manual/camera evidence can qualify; video replay and discomfort stops do not. Game points are not physical capacity. Sources: /Users/scsoc/dev/AI PT/Shared/Core/SkillProgress.swift; /Users/scsoc/dev/AI PT/Shared/Core/ExerciseCatalog.swift; /Users/scsoc/dev/AI PT/Native/iOS/SkillsViews.swift; /Users/scsoc/dev/AI PT/docs/app-guide.md. Exercise artwork is existing PNG content, with source hashes in assets.json.</a:t>
             </a:r>
           </a:p>
         </p:txBody>
@@ -871,7 +871,7 @@
           <a:lstStyle xmlns:a="http://schemas.openxmlformats.org/drawingml/2006/main"/>
           <a:p xmlns:a="http://schemas.openxmlformats.org/drawingml/2006/main">
             <a:r>
-              <a:t>Evidence snapshot 25 October 2026, 00:09 UTC. Local gateway returned actual200 responses for chat/session/weekly/proposal using synthetic inputs. Two signed-simulator native chats reached Google. The second accepted the server-owned capability context: base push-ups and squats support camera tracking; other rep exercises use manual logging and seconds exercises use an active hold timer. After a provider-only maxItems schema projection, three explicit native production actions accepted a proposal, weekly summary and session summary with isolated synthetic inputs. The full original output validator remains enforced. The proposal offered Squats, Knee push-ups and Forearm plank; only Squats was selected, with no approval or saved plan. The reports described one synthetic manual session/set with two Squats reps and no Watch data/profile. Physical phone networking and real-user coaching quality remain pending. Separate native fixture checks exercise structured-response display without a provider call. Automatic facts include selected goals and weekly target, omit optional name, and retain sources. Schema/evidence validation rejects missing/unknown fact IDs; generation identity rejects late context. Plans require explicit user selection/approval and proposed targets never count as completed work. No raw camera video or sensor stream is automatically supplied here. Sources: /Users/scsoc/dev/AI PT/docs/evidence/native-gemini-chat-2026-10-24.md; /Users/scsoc/dev/AI PT/docs/evidence/gemini-structured-compatibility-2026-10-25.md; /Users/scsoc/dev/AI PT/docs/coach-goals.md; /Users/scsoc/dev/AI PT/Shared/Core/CoachContracts.swift; /Users/scsoc/dev/AI PT/Shared/Core/CoachGrounding.swift; /Users/scsoc/dev/AI PT/docs/integration-readiness.md.</a:t>
+              <a:t>Evidence snapshot 25 October 2026, 00:36 UTC. Local gateway returned actual200 responses for chat/session/weekly/proposal using synthetic inputs. Two signed-simulator native chats reached Google. The second accepted the server-owned capability context: base push-ups and squats support camera tracking; other rep exercises use manual logging and seconds exercises use an active hold timer. After a provider-only maxItems schema projection, three explicit native production actions accepted a proposal, weekly summary and session summary with isolated synthetic inputs. The full original output validator remains enforced. The proposal offered Squats, Knee push-ups and Forearm plank; only Squats was selected, with no approval or saved plan. The reports described one synthetic manual session/set with two Squats reps and no Watch data/profile. Physical phone networking and real-user coaching quality remain pending. Separate native fixture checks exercise structured-response display without a provider call. Automatic facts include selected goals and weekly target, omit optional name, and retain sources. Schema/evidence validation rejects missing/unknown fact IDs; generation identity rejects late context. Plans require explicit user selection/approval and proposed targets never count as completed work. No raw camera video or sensor stream is automatically supplied here. Sources: /Users/scsoc/dev/AI PT/docs/evidence/native-gemini-chat-2026-10-24.md; /Users/scsoc/dev/AI PT/docs/evidence/gemini-structured-compatibility-2026-10-25.md; /Users/scsoc/dev/AI PT/docs/coach-goals.md; /Users/scsoc/dev/AI PT/Shared/Core/CoachContracts.swift; /Users/scsoc/dev/AI PT/Shared/Core/CoachGrounding.swift; /Users/scsoc/dev/AI PT/docs/integration-readiness.md.</a:t>
             </a:r>
           </a:p>
         </p:txBody>
@@ -941,7 +941,7 @@
           <a:lstStyle xmlns:a="http://schemas.openxmlformats.org/drawingml/2006/main"/>
           <a:p xmlns:a="http://schemas.openxmlformats.org/drawingml/2006/main">
             <a:r>
-              <a:t>Evidence snapshot 25 October 2026, 00:09 UTC. Operational Tiger storage and Snowflake retrospective public-data evaluation are separate. Authenticated Tiger Explorer accepted the exact gateway migration: two empty tables, 15 columns, seven validated PK/CHECK constraints, a one-day scalar hypertable and four usable indexes. No workout or sensor rows were inserted. The separate Node connection still fails strict TLS with SELF_SIGNED_CERT_IN_CHAIN; no gateway ingestion, replay/readback, rollup or standalone prototype database acceptance is claimed. Snowflake pinned public PAMAP2 import/reconciliation and bounded SQL transport are tested offline; dry-run is default and live public-data execution requires explicit opt-in. No actual warehouse statement/result is accepted. Local history and explicit optional sync remain distinct. Sources: /Users/scsoc/dev/AI PT/docs/integration-readiness.md; /Users/scsoc/dev/AI PT/docs/tiger-live-readiness.md; /Users/scsoc/dev/AI PT/docs/ISSUES.md; /Users/scsoc/dev/AI PT/docs/personal-learning.md; /Users/scsoc/dev/AI PT/docs/evidence/tiger-console-2026-10-24.md.</a:t>
+              <a:t>Evidence snapshot 25 October 2026, 00:36 UTC. Operational Tiger storage and Snowflake retrospective public-data evaluation are separate. Authenticated Tiger Explorer accepted the exact gateway migration: two empty tables, 15 columns, seven validated PK/CHECK constraints, a one-day scalar hypertable and four usable indexes. No workout or sensor rows were inserted. The separate Node connection still fails strict TLS with SELF_SIGNED_CERT_IN_CHAIN; no gateway ingestion, replay/readback, rollup or standalone prototype database acceptance is claimed. Snowflake pinned public PAMAP2 import/reconciliation and bounded SQL transport are tested offline; dry-run is default and live public-data execution requires explicit opt-in. No actual warehouse statement/result is accepted. Local history and explicit optional sync remain distinct. Sources: /Users/scsoc/dev/AI PT/docs/integration-readiness.md; /Users/scsoc/dev/AI PT/docs/tiger-live-readiness.md; /Users/scsoc/dev/AI PT/docs/ISSUES.md; /Users/scsoc/dev/AI PT/docs/personal-learning.md; /Users/scsoc/dev/AI PT/docs/evidence/tiger-console-2026-10-24.md.</a:t>
             </a:r>
           </a:p>
         </p:txBody>
@@ -1011,7 +1011,7 @@
           <a:lstStyle xmlns:a="http://schemas.openxmlformats.org/drawingml/2006/main"/>
           <a:p xmlns:a="http://schemas.openxmlformats.org/drawingml/2006/main">
             <a:r>
-              <a:t>Evidence snapshot 25 October 2026, 00:09 UTC. Actual offline PAMAP2 run2026-10-24T20:43:51–20:43:59UTC. Source: Reiss,A.(2012), PAMAP2 Physical Activity Monitoring, UCI DOI10.24432/C5NW2H, CC BY4.0. Changes: causal features/ridge/figures/evaluation. Official source https://archive.ics.uci.edu/dataset/231/pamap2+physical+activity+monitoring. Train101–105,validation106–107,test108–109. Future target: mean of five observed1s HR-bin means ending10/30s after origin; input history60s. No interpolation, future covariates or test normalization. Validation selected HR-only ridge alpha0.1, not wrist candidates. Test108:80310s and79930s forecasts. Test109:only410s and030s forecasts from84.76s recording. Macro10s gives both participants equal weight despite tiny109 count. At30s only108 contributes. Fixed prequential bias adapter worsened full-run error. No calibrated intervals, Watch transfer, recovery, failure/RIR prediction, or app integration.13 contract tests pass. Sources: /Users/scsoc/dev/AI PT/research/hr_forecast/protocol.json; /Users/scsoc/dev/AI PT/research/hr_forecast/results/report.json; /Users/scsoc/dev/AI PT/research/hr_forecast/results/inventory.json; /Users/scsoc/dev/AI PT/docs/public-data-benchmark.md. Original plots copied unchanged into presentation/assets/ for supplementary evidence. Native chart values round the recorded metrics to three decimal places for editable workbook compatibility.</a:t>
+              <a:t>Evidence snapshot 25 October 2026, 00:36 UTC. Actual offline PAMAP2 run2026-10-24T20:43:51–20:43:59UTC. Source: Reiss,A.(2012), PAMAP2 Physical Activity Monitoring, UCI DOI10.24432/C5NW2H, CC BY4.0. Changes: causal features/ridge/figures/evaluation. Official source https://archive.ics.uci.edu/dataset/231/pamap2+physical+activity+monitoring. Train101–105,validation106–107,test108–109. Future target: mean of five observed1s HR-bin means ending10/30s after origin; input history60s. No interpolation, future covariates or test normalization. Validation selected HR-only ridge alpha0.1, not wrist candidates. Test108:80310s and79930s forecasts. Test109:only410s and030s forecasts from84.76s recording. Macro10s gives both participants equal weight despite tiny109 count. At30s only108 contributes. Fixed prequential bias adapter worsened full-run error. No calibrated intervals, Watch transfer, recovery, failure/RIR prediction, or app integration.13 contract tests pass. Sources: /Users/scsoc/dev/AI PT/research/hr_forecast/protocol.json; /Users/scsoc/dev/AI PT/research/hr_forecast/results/report.json; /Users/scsoc/dev/AI PT/research/hr_forecast/results/inventory.json; /Users/scsoc/dev/AI PT/docs/public-data-benchmark.md. Original plots copied unchanged into presentation/assets/ for supplementary evidence. Native chart values round the recorded metrics to three decimal places for editable workbook compatibility.</a:t>
             </a:r>
           </a:p>
         </p:txBody>
@@ -1081,7 +1081,7 @@
           <a:lstStyle xmlns:a="http://schemas.openxmlformats.org/drawingml/2006/main"/>
           <a:p xmlns:a="http://schemas.openxmlformats.org/drawingml/2006/main">
             <a:r>
-              <a:t>Evidence snapshot 25 October 2026, 00:09 UTC. This table summarizes implementation/fixture/live distinctions. Never claim all sponsors/providers were used. Gemini has four actual synthetic gateway response types, two signed-simulator native chats, and three accepted native production structured actions (proposal/session/week) after the provider-only schema fix. All new inputs were isolated synthetic records. Physical phone networking and personal coaching quality remain pending. The investigation used seven new provider attempts total: initial normal native 502, two diagnostic native HTTP400, one controlled direct HTTP200 and three post-fix native responses accepted by native display validation. No automatic retry or provider fallback was introduced. Voice local Apple synthesis is implemented with fake playback tests; no audible/ElevenLabs run. Tiger authenticated console accepted the gateway schema with zero rows; strict Node TLS remains blocked without trust bypass. Ingestion, readback, rollups and the separate prototype path remain unverified. The revised local landing uses actual white simulator captures and passed four-width, keyboard and reduced-motion checks; no public deployment. Snowflake pinned batch workflow and local ARM64 gateway/Caddy runtime checks passed; no Snowflake live statement or Vultr VM/credit/spend scope; Presage automatic derived-vitals egress unresolved; Delta zero judge requests and missing installation/legal operator gate. Sources: /Users/scsoc/dev/AI PT/docs/evidence/pushup-prototype-integrity-2026-10-24.md; /Users/scsoc/dev/AI PT/docs/evidence/gemini-structured-compatibility-2026-10-25.md; /Users/scsoc/dev/AI PT/docs/snowflake-analytics.md; /Users/scsoc/dev/AI PT/docs/vultr-deployment.md; /Users/scsoc/dev/AI PT/docs/integration-readiness.md; /Users/scsoc/dev/AI PT/docs/ISSUES.md; /Users/scsoc/dev/AI PT/docs/voice-feedback.md; /Users/scsoc/dev/AI PT/docs/presage-integration.md; /Users/scsoc/dev/AI PT/docs/delta-workflow.md; /Users/scsoc/dev/AI PT/docs/tiger-live-readiness.md; /Users/scsoc/dev/AI PT/docs/evidence/tiger-console-2026-10-24.md; /Users/scsoc/dev/AI PT/docs/evidence/landing-browser-2026-10-24.md.</a:t>
+              <a:t>Evidence snapshot 25 October 2026, 00:36 UTC. This table summarizes implementation/fixture/live distinctions. Never claim all sponsors/providers were used. Gemini has four actual synthetic gateway response types, two signed-simulator native chats, and three accepted native production structured actions (proposal/session/week) after the provider-only schema fix. All new inputs were isolated synthetic records. Physical phone networking and personal coaching quality remain pending. The investigation used seven new provider attempts total: initial normal native 502, two diagnostic native HTTP400, one controlled direct HTTP200 and three post-fix native responses accepted by native display validation. No automatic retry or provider fallback was introduced. Voice local Apple synthesis is implemented with fake playback tests; no audible/ElevenLabs run. Tiger authenticated console accepted the gateway schema with zero rows; strict Node TLS remains blocked without trust bypass. Ingestion, readback, rollups and the separate prototype path remain unverified. The revised local landing uses actual white simulator captures and passed four-width, keyboard and reduced-motion checks; no public deployment. Snowflake pinned batch workflow and local ARM64 gateway/Caddy runtime checks passed; no Snowflake live statement or Vultr VM/credit/spend scope; Presage automatic derived-vitals egress unresolved; Delta zero judge requests and missing installation/legal operator gate. Sources: /Users/scsoc/dev/AI PT/docs/evidence/pushup-prototype-integrity-2026-10-24.md; /Users/scsoc/dev/AI PT/docs/evidence/gemini-structured-compatibility-2026-10-25.md; /Users/scsoc/dev/AI PT/docs/snowflake-analytics.md; /Users/scsoc/dev/AI PT/docs/vultr-deployment.md; /Users/scsoc/dev/AI PT/docs/integration-readiness.md; /Users/scsoc/dev/AI PT/docs/ISSUES.md; /Users/scsoc/dev/AI PT/docs/voice-feedback.md; /Users/scsoc/dev/AI PT/docs/presage-integration.md; /Users/scsoc/dev/AI PT/docs/delta-workflow.md; /Users/scsoc/dev/AI PT/docs/tiger-live-readiness.md; /Users/scsoc/dev/AI PT/docs/evidence/tiger-console-2026-10-24.md; /Users/scsoc/dev/AI PT/docs/evidence/landing-browser-2026-10-24.md.</a:t>
             </a:r>
           </a:p>
         </p:txBody>
@@ -1128,7 +1128,7 @@
           <p:cNvPr id="3" name="Title">
             <a:extLst xmlns:a="http://schemas.openxmlformats.org/drawingml/2006/main">
               <a:ext uri="{FF2B5EF4-FFF2-40B4-BE49-F238E27FC236}">
-                <a16:creationId xmlns:a16="http://schemas.microsoft.com/office/drawing/2014/main" id="{24AAEA46-41CC-40B3-9721-FE450B7A70E8}"/>
+                <a16:creationId xmlns:a16="http://schemas.microsoft.com/office/drawing/2014/main" id="{B10DD7F0-BF45-47AB-9335-C164C25CF9BB}"/>
               </a:ext>
             </a:extLst>
           </p:cNvPr>
@@ -1357,7 +1357,7 @@
           <p:cNvPr id="2" name="Subtitle">
             <a:extLst xmlns:a="http://schemas.openxmlformats.org/drawingml/2006/main">
               <a:ext uri="{FF2B5EF4-FFF2-40B4-BE49-F238E27FC236}">
-                <a16:creationId xmlns:a16="http://schemas.microsoft.com/office/drawing/2014/main" id="{B13D0701-D96A-41C8-BB66-8A94B2F234A6}"/>
+                <a16:creationId xmlns:a16="http://schemas.microsoft.com/office/drawing/2014/main" id="{65FB6FCD-3BD3-49A3-A6B5-D4FF0528A3CE}"/>
               </a:ext>
             </a:extLst>
           </p:cNvPr>
@@ -1603,7 +1603,7 @@
           <p:cNvPr id="2" name="Section title">
             <a:extLst xmlns:a="http://schemas.openxmlformats.org/drawingml/2006/main">
               <a:ext uri="{FF2B5EF4-FFF2-40B4-BE49-F238E27FC236}">
-                <a16:creationId xmlns:a16="http://schemas.microsoft.com/office/drawing/2014/main" id="{33EDDB32-E291-482E-A1A1-B9A4610DB31A}"/>
+                <a16:creationId xmlns:a16="http://schemas.microsoft.com/office/drawing/2014/main" id="{20E38167-1FC7-43F8-9621-1F74E65BF65F}"/>
               </a:ext>
             </a:extLst>
           </p:cNvPr>
@@ -1849,7 +1849,7 @@
           <p:cNvPr id="3" name="Title">
             <a:extLst xmlns:a="http://schemas.openxmlformats.org/drawingml/2006/main">
               <a:ext uri="{FF2B5EF4-FFF2-40B4-BE49-F238E27FC236}">
-                <a16:creationId xmlns:a16="http://schemas.microsoft.com/office/drawing/2014/main" id="{529E123B-A32C-4DD2-884F-53A869899FA8}"/>
+                <a16:creationId xmlns:a16="http://schemas.microsoft.com/office/drawing/2014/main" id="{EFFC6995-A90F-4121-961C-AF4005B0A3AC}"/>
               </a:ext>
             </a:extLst>
           </p:cNvPr>
@@ -2078,7 +2078,7 @@
           <p:cNvPr id="2" name="Body">
             <a:extLst xmlns:a="http://schemas.openxmlformats.org/drawingml/2006/main">
               <a:ext uri="{FF2B5EF4-FFF2-40B4-BE49-F238E27FC236}">
-                <a16:creationId xmlns:a16="http://schemas.microsoft.com/office/drawing/2014/main" id="{E19C7931-9E2D-468B-8E4A-4DF5939ACA5E}"/>
+                <a16:creationId xmlns:a16="http://schemas.microsoft.com/office/drawing/2014/main" id="{E8D1C770-77FC-4D19-8680-2B142FA356CD}"/>
               </a:ext>
             </a:extLst>
           </p:cNvPr>
@@ -2324,7 +2324,7 @@
           <p:cNvPr id="4" name="Title">
             <a:extLst xmlns:a="http://schemas.openxmlformats.org/drawingml/2006/main">
               <a:ext uri="{FF2B5EF4-FFF2-40B4-BE49-F238E27FC236}">
-                <a16:creationId xmlns:a16="http://schemas.microsoft.com/office/drawing/2014/main" id="{AE2E7595-E85D-4E39-A241-1A23697617A4}"/>
+                <a16:creationId xmlns:a16="http://schemas.microsoft.com/office/drawing/2014/main" id="{92F050EF-147D-4B53-8FDB-9C7E7F74D6F2}"/>
               </a:ext>
             </a:extLst>
           </p:cNvPr>
@@ -2553,7 +2553,7 @@
           <p:cNvPr id="2" name="Left column">
             <a:extLst xmlns:a="http://schemas.openxmlformats.org/drawingml/2006/main">
               <a:ext uri="{FF2B5EF4-FFF2-40B4-BE49-F238E27FC236}">
-                <a16:creationId xmlns:a16="http://schemas.microsoft.com/office/drawing/2014/main" id="{F0B110AD-282E-43F3-BC84-D1CD57774F3B}"/>
+                <a16:creationId xmlns:a16="http://schemas.microsoft.com/office/drawing/2014/main" id="{A5F4DEFA-DAA1-4A6A-94DB-C579A5ECAAAF}"/>
               </a:ext>
             </a:extLst>
           </p:cNvPr>
@@ -2782,7 +2782,7 @@
           <p:cNvPr id="3" name="Right column">
             <a:extLst xmlns:a="http://schemas.openxmlformats.org/drawingml/2006/main">
               <a:ext uri="{FF2B5EF4-FFF2-40B4-BE49-F238E27FC236}">
-                <a16:creationId xmlns:a16="http://schemas.microsoft.com/office/drawing/2014/main" id="{CFE199FC-5242-4533-BD21-FD09BA233D5C}"/>
+                <a16:creationId xmlns:a16="http://schemas.microsoft.com/office/drawing/2014/main" id="{A14175CC-5F7C-4031-84AF-D96830663D56}"/>
               </a:ext>
             </a:extLst>
           </p:cNvPr>
@@ -3028,7 +3028,7 @@
           <p:cNvPr id="3" name="Title">
             <a:extLst xmlns:a="http://schemas.openxmlformats.org/drawingml/2006/main">
               <a:ext uri="{FF2B5EF4-FFF2-40B4-BE49-F238E27FC236}">
-                <a16:creationId xmlns:a16="http://schemas.microsoft.com/office/drawing/2014/main" id="{6693EE4E-54CF-4AD7-BAB8-CC109545F2D9}"/>
+                <a16:creationId xmlns:a16="http://schemas.microsoft.com/office/drawing/2014/main" id="{0F844D77-4FB1-4F36-8622-5BD8399F5C2A}"/>
               </a:ext>
             </a:extLst>
           </p:cNvPr>
@@ -3257,7 +3257,7 @@
           <p:cNvPr id="2" name="Left column">
             <a:extLst xmlns:a="http://schemas.openxmlformats.org/drawingml/2006/main">
               <a:ext uri="{FF2B5EF4-FFF2-40B4-BE49-F238E27FC236}">
-                <a16:creationId xmlns:a16="http://schemas.microsoft.com/office/drawing/2014/main" id="{970CBD2A-B51A-4491-990E-D99924AFA39C}"/>
+                <a16:creationId xmlns:a16="http://schemas.microsoft.com/office/drawing/2014/main" id="{3D671F23-3E64-4799-9C74-574575D5D243}"/>
               </a:ext>
             </a:extLst>
           </p:cNvPr>
@@ -3524,12 +3524,12 @@
   </p:cSld>
   <p:clrMap bg1="lt1" tx1="dk1" bg2="lt2" tx2="dk2" accent1="accent1" accent2="accent2" accent3="accent3" accent4="accent4" accent5="accent5" accent6="accent6" hlink="hlink" folHlink="folHlink"/>
   <p:sldLayoutIdLst>
-    <p:sldLayoutId xmlns:r="http://schemas.openxmlformats.org/officeDocument/2006/relationships" id="2147483649" r:id="R684ffd94148244f7"/>
-    <p:sldLayoutId xmlns:r="http://schemas.openxmlformats.org/officeDocument/2006/relationships" id="2147483650" r:id="Re47c252e8c7247ee"/>
-    <p:sldLayoutId xmlns:r="http://schemas.openxmlformats.org/officeDocument/2006/relationships" id="2147483651" r:id="Rd526a94f684647e3"/>
-    <p:sldLayoutId xmlns:r="http://schemas.openxmlformats.org/officeDocument/2006/relationships" id="2147483652" r:id="R3cc7d7236e7b496d"/>
-    <p:sldLayoutId xmlns:r="http://schemas.openxmlformats.org/officeDocument/2006/relationships" id="2147483653" r:id="Rc52aa1eb10d1447d"/>
-    <p:sldLayoutId xmlns:r="http://schemas.openxmlformats.org/officeDocument/2006/relationships" id="2147483654" r:id="Rf52ac56a95f64c64"/>
+    <p:sldLayoutId xmlns:r="http://schemas.openxmlformats.org/officeDocument/2006/relationships" id="2147483649" r:id="Ree968ad2099041bc"/>
+    <p:sldLayoutId xmlns:r="http://schemas.openxmlformats.org/officeDocument/2006/relationships" id="2147483650" r:id="R3892290af4a9456b"/>
+    <p:sldLayoutId xmlns:r="http://schemas.openxmlformats.org/officeDocument/2006/relationships" id="2147483651" r:id="R3ac5b942e6684ca1"/>
+    <p:sldLayoutId xmlns:r="http://schemas.openxmlformats.org/officeDocument/2006/relationships" id="2147483652" r:id="Rff27ede1ced9428e"/>
+    <p:sldLayoutId xmlns:r="http://schemas.openxmlformats.org/officeDocument/2006/relationships" id="2147483653" r:id="R7dabb936f3074519"/>
+    <p:sldLayoutId xmlns:r="http://schemas.openxmlformats.org/officeDocument/2006/relationships" id="2147483654" r:id="R8fc3de5275674636"/>
   </p:sldLayoutIdLst>
   <p:txStyles>
     <p:titleStyle>
@@ -4403,7 +4403,7 @@
           <p:cNvPr id="7" name="text-1">
             <a:extLst xmlns:a="http://schemas.openxmlformats.org/drawingml/2006/main">
               <a:ext uri="{FF2B5EF4-FFF2-40B4-BE49-F238E27FC236}">
-                <a16:creationId xmlns:a16="http://schemas.microsoft.com/office/drawing/2014/main" id="{5F626E21-7054-4618-BFFD-85AE6C371814}"/>
+                <a16:creationId xmlns:a16="http://schemas.microsoft.com/office/drawing/2014/main" id="{CF94B9FF-DF3C-4B98-83D0-235C364F364E}"/>
               </a:ext>
             </a:extLst>
           </p:cNvPr>
@@ -4561,7 +4561,7 @@
           <p:cNvPr id="2" name="text-2">
             <a:extLst xmlns:a="http://schemas.openxmlformats.org/drawingml/2006/main">
               <a:ext uri="{FF2B5EF4-FFF2-40B4-BE49-F238E27FC236}">
-                <a16:creationId xmlns:a16="http://schemas.microsoft.com/office/drawing/2014/main" id="{D6C505A6-DE82-42F6-BCD6-CB964371DABF}"/>
+                <a16:creationId xmlns:a16="http://schemas.microsoft.com/office/drawing/2014/main" id="{1AF84CFC-AB65-4310-9AB5-ADD576FE044A}"/>
               </a:ext>
             </a:extLst>
           </p:cNvPr>
@@ -4742,7 +4742,7 @@
           <p:cNvPr id="3" name="text-3">
             <a:extLst xmlns:a="http://schemas.openxmlformats.org/drawingml/2006/main">
               <a:ext uri="{FF2B5EF4-FFF2-40B4-BE49-F238E27FC236}">
-                <a16:creationId xmlns:a16="http://schemas.microsoft.com/office/drawing/2014/main" id="{92375CA3-F4C0-49A1-8511-9D7461EEBECB}"/>
+                <a16:creationId xmlns:a16="http://schemas.microsoft.com/office/drawing/2014/main" id="{F436AB6B-506B-4CE6-A952-4BDE6F7FBD69}"/>
               </a:ext>
             </a:extLst>
           </p:cNvPr>
@@ -4923,7 +4923,7 @@
           <p:cNvPr id="4" name="text-4">
             <a:extLst xmlns:a="http://schemas.openxmlformats.org/drawingml/2006/main">
               <a:ext uri="{FF2B5EF4-FFF2-40B4-BE49-F238E27FC236}">
-                <a16:creationId xmlns:a16="http://schemas.microsoft.com/office/drawing/2014/main" id="{685BEFE9-2D47-4904-917B-E7418E4DC73D}"/>
+                <a16:creationId xmlns:a16="http://schemas.microsoft.com/office/drawing/2014/main" id="{602BB8F7-DBEA-4A05-AF5D-36B6B1C7B70F}"/>
               </a:ext>
             </a:extLst>
           </p:cNvPr>
@@ -5081,7 +5081,7 @@
           <p:cNvPr id="5" name="">
             <a:extLst xmlns:a="http://schemas.openxmlformats.org/drawingml/2006/main">
               <a:ext uri="{FF2B5EF4-FFF2-40B4-BE49-F238E27FC236}">
-                <a16:creationId xmlns:a16="http://schemas.microsoft.com/office/drawing/2014/main" id="{C7EAB77F-5406-4C37-99E2-E0627053BE9C}"/>
+                <a16:creationId xmlns:a16="http://schemas.microsoft.com/office/drawing/2014/main" id="{B29377BD-8FCC-4A47-B8FE-56CCE9E0928D}"/>
               </a:ext>
             </a:extLst>
           </p:cNvPr>
@@ -5091,7 +5091,7 @@
           <p:nvPr/>
         </p:nvPicPr>
         <p:blipFill>
-          <a:blip xmlns:r="http://schemas.openxmlformats.org/officeDocument/2006/relationships" xmlns:a="http://schemas.openxmlformats.org/drawingml/2006/main" r:embed="R0552ccd038dc4cca"/>
+          <a:blip xmlns:r="http://schemas.openxmlformats.org/officeDocument/2006/relationships" xmlns:a="http://schemas.openxmlformats.org/drawingml/2006/main" r:embed="R0d2f49d24c3244a7"/>
           <a:stretch xmlns:a="http://schemas.openxmlformats.org/drawingml/2006/main"/>
         </p:blipFill>
         <p:spPr>
@@ -5109,7 +5109,7 @@
           <p:cNvPr id="6" name="text-5">
             <a:extLst xmlns:a="http://schemas.openxmlformats.org/drawingml/2006/main">
               <a:ext uri="{FF2B5EF4-FFF2-40B4-BE49-F238E27FC236}">
-                <a16:creationId xmlns:a16="http://schemas.microsoft.com/office/drawing/2014/main" id="{9EB3CE46-7EC3-4CEF-B865-A690C40F89B7}"/>
+                <a16:creationId xmlns:a16="http://schemas.microsoft.com/office/drawing/2014/main" id="{2E559C11-7FEA-4FD6-8D4F-313A2F1F7989}"/>
               </a:ext>
             </a:extLst>
           </p:cNvPr>
@@ -5265,7 +5265,7 @@
     </p:spTree>
     <p:extLst>
       <p:ext uri="{BB962C8B-B14F-4D97-AF65-F5344CB8AC3E}">
-        <p14:creationId xmlns:p14="http://schemas.microsoft.com/office/powerpoint/2010/main" val="564967337"/>
+        <p14:creationId xmlns:p14="http://schemas.microsoft.com/office/powerpoint/2010/main" val="1545136940"/>
       </p:ext>
     </p:extLst>
   </p:cSld>
@@ -5296,7 +5296,7 @@
           <p:cNvPr id="19" name="text-87">
             <a:extLst xmlns:a="http://schemas.openxmlformats.org/drawingml/2006/main">
               <a:ext uri="{FF2B5EF4-FFF2-40B4-BE49-F238E27FC236}">
-                <a16:creationId xmlns:a16="http://schemas.microsoft.com/office/drawing/2014/main" id="{04C61408-6BD7-4B08-8664-B6FA3983F6CE}"/>
+                <a16:creationId xmlns:a16="http://schemas.microsoft.com/office/drawing/2014/main" id="{CDAA6975-F33B-4FD9-B93C-D27289BB6CC0}"/>
               </a:ext>
             </a:extLst>
           </p:cNvPr>
@@ -5454,7 +5454,7 @@
           <p:cNvPr id="2" name="text-88">
             <a:extLst xmlns:a="http://schemas.openxmlformats.org/drawingml/2006/main">
               <a:ext uri="{FF2B5EF4-FFF2-40B4-BE49-F238E27FC236}">
-                <a16:creationId xmlns:a16="http://schemas.microsoft.com/office/drawing/2014/main" id="{7B4A6B30-B2E1-4EDD-BCA7-EC885D7DF453}"/>
+                <a16:creationId xmlns:a16="http://schemas.microsoft.com/office/drawing/2014/main" id="{417DC9A3-FE40-45E9-ADA5-867888692262}"/>
               </a:ext>
             </a:extLst>
           </p:cNvPr>
@@ -5612,7 +5612,7 @@
           <p:cNvPr id="3" name="text-89">
             <a:extLst xmlns:a="http://schemas.openxmlformats.org/drawingml/2006/main">
               <a:ext uri="{FF2B5EF4-FFF2-40B4-BE49-F238E27FC236}">
-                <a16:creationId xmlns:a16="http://schemas.microsoft.com/office/drawing/2014/main" id="{4A009826-3BC5-4117-9D0A-2E0E52A401B5}"/>
+                <a16:creationId xmlns:a16="http://schemas.microsoft.com/office/drawing/2014/main" id="{356B7066-9E77-442D-9173-8452B78F0C9E}"/>
               </a:ext>
             </a:extLst>
           </p:cNvPr>
@@ -5770,7 +5770,7 @@
           <p:cNvPr id="4" name="text-90">
             <a:extLst xmlns:a="http://schemas.openxmlformats.org/drawingml/2006/main">
               <a:ext uri="{FF2B5EF4-FFF2-40B4-BE49-F238E27FC236}">
-                <a16:creationId xmlns:a16="http://schemas.microsoft.com/office/drawing/2014/main" id="{B8A6CA06-E5FE-4069-BA49-E065A02774F2}"/>
+                <a16:creationId xmlns:a16="http://schemas.microsoft.com/office/drawing/2014/main" id="{5D54935D-9D34-4572-A7BE-E67C6AE330E3}"/>
               </a:ext>
             </a:extLst>
           </p:cNvPr>
@@ -5928,7 +5928,7 @@
           <p:cNvPr id="5" name="text-91">
             <a:extLst xmlns:a="http://schemas.openxmlformats.org/drawingml/2006/main">
               <a:ext uri="{FF2B5EF4-FFF2-40B4-BE49-F238E27FC236}">
-                <a16:creationId xmlns:a16="http://schemas.microsoft.com/office/drawing/2014/main" id="{43E0B523-458B-46C4-808D-D0DA126359ED}"/>
+                <a16:creationId xmlns:a16="http://schemas.microsoft.com/office/drawing/2014/main" id="{E040DB97-5F53-4A6A-85CE-32870FDE5943}"/>
               </a:ext>
             </a:extLst>
           </p:cNvPr>
@@ -6086,7 +6086,7 @@
           <p:cNvPr id="6" name="text-92">
             <a:extLst xmlns:a="http://schemas.openxmlformats.org/drawingml/2006/main">
               <a:ext uri="{FF2B5EF4-FFF2-40B4-BE49-F238E27FC236}">
-                <a16:creationId xmlns:a16="http://schemas.microsoft.com/office/drawing/2014/main" id="{8FAA0BED-7930-4B48-8A9C-D52AE226A1F0}"/>
+                <a16:creationId xmlns:a16="http://schemas.microsoft.com/office/drawing/2014/main" id="{13F6D127-8F9A-41D9-AFB8-59AFB204DFFA}"/>
               </a:ext>
             </a:extLst>
           </p:cNvPr>
@@ -6244,7 +6244,7 @@
           <p:cNvPr id="7" name="text-93">
             <a:extLst xmlns:a="http://schemas.openxmlformats.org/drawingml/2006/main">
               <a:ext uri="{FF2B5EF4-FFF2-40B4-BE49-F238E27FC236}">
-                <a16:creationId xmlns:a16="http://schemas.microsoft.com/office/drawing/2014/main" id="{D0C615C4-C22B-4375-B2DC-84BE9FB21385}"/>
+                <a16:creationId xmlns:a16="http://schemas.microsoft.com/office/drawing/2014/main" id="{BAC7FCB9-6AC3-4F6B-BCF4-112008F2BF8A}"/>
               </a:ext>
             </a:extLst>
           </p:cNvPr>
@@ -6402,7 +6402,7 @@
           <p:cNvPr id="8" name="text-94">
             <a:extLst xmlns:a="http://schemas.openxmlformats.org/drawingml/2006/main">
               <a:ext uri="{FF2B5EF4-FFF2-40B4-BE49-F238E27FC236}">
-                <a16:creationId xmlns:a16="http://schemas.microsoft.com/office/drawing/2014/main" id="{8DE606A8-54FE-49E2-A290-88FBFFE70C6A}"/>
+                <a16:creationId xmlns:a16="http://schemas.microsoft.com/office/drawing/2014/main" id="{6DF2B053-2FC2-4F23-A0F2-611C8AB0058D}"/>
               </a:ext>
             </a:extLst>
           </p:cNvPr>
@@ -6560,7 +6560,7 @@
           <p:cNvPr id="9" name="text-95">
             <a:extLst xmlns:a="http://schemas.openxmlformats.org/drawingml/2006/main">
               <a:ext uri="{FF2B5EF4-FFF2-40B4-BE49-F238E27FC236}">
-                <a16:creationId xmlns:a16="http://schemas.microsoft.com/office/drawing/2014/main" id="{48DB6B9E-7FFB-49AF-9867-6E12B3A12486}"/>
+                <a16:creationId xmlns:a16="http://schemas.microsoft.com/office/drawing/2014/main" id="{971525A5-E2EE-4720-8780-1D53EB81A876}"/>
               </a:ext>
             </a:extLst>
           </p:cNvPr>
@@ -6718,7 +6718,7 @@
           <p:cNvPr id="10" name="text-96">
             <a:extLst xmlns:a="http://schemas.openxmlformats.org/drawingml/2006/main">
               <a:ext uri="{FF2B5EF4-FFF2-40B4-BE49-F238E27FC236}">
-                <a16:creationId xmlns:a16="http://schemas.microsoft.com/office/drawing/2014/main" id="{4F0FEFC6-A826-4B29-B09B-C83C7EBF94FF}"/>
+                <a16:creationId xmlns:a16="http://schemas.microsoft.com/office/drawing/2014/main" id="{8B603871-B07E-4031-A33D-C6302F572594}"/>
               </a:ext>
             </a:extLst>
           </p:cNvPr>
@@ -6876,7 +6876,7 @@
           <p:cNvPr id="11" name="text-97">
             <a:extLst xmlns:a="http://schemas.openxmlformats.org/drawingml/2006/main">
               <a:ext uri="{FF2B5EF4-FFF2-40B4-BE49-F238E27FC236}">
-                <a16:creationId xmlns:a16="http://schemas.microsoft.com/office/drawing/2014/main" id="{5979FC80-9C59-44CF-97B1-80C5C76E4576}"/>
+                <a16:creationId xmlns:a16="http://schemas.microsoft.com/office/drawing/2014/main" id="{27490423-BFB5-4EF4-8D8D-A75C6D06D95B}"/>
               </a:ext>
             </a:extLst>
           </p:cNvPr>
@@ -7034,7 +7034,7 @@
           <p:cNvPr id="12" name="text-98">
             <a:extLst xmlns:a="http://schemas.openxmlformats.org/drawingml/2006/main">
               <a:ext uri="{FF2B5EF4-FFF2-40B4-BE49-F238E27FC236}">
-                <a16:creationId xmlns:a16="http://schemas.microsoft.com/office/drawing/2014/main" id="{D627F0B0-FD47-4E27-92AC-0DBDFC15F642}"/>
+                <a16:creationId xmlns:a16="http://schemas.microsoft.com/office/drawing/2014/main" id="{7F504845-4F07-4A1C-8173-D0EC5A385006}"/>
               </a:ext>
             </a:extLst>
           </p:cNvPr>
@@ -7192,7 +7192,7 @@
           <p:cNvPr id="13" name="text-99">
             <a:extLst xmlns:a="http://schemas.openxmlformats.org/drawingml/2006/main">
               <a:ext uri="{FF2B5EF4-FFF2-40B4-BE49-F238E27FC236}">
-                <a16:creationId xmlns:a16="http://schemas.microsoft.com/office/drawing/2014/main" id="{CC4A260D-033A-4070-AAED-8BDAAA8763EF}"/>
+                <a16:creationId xmlns:a16="http://schemas.microsoft.com/office/drawing/2014/main" id="{C59CC5FD-D02B-44D6-BEBC-AEB0C44B6675}"/>
               </a:ext>
             </a:extLst>
           </p:cNvPr>
@@ -7350,7 +7350,7 @@
           <p:cNvPr id="14" name="text-100">
             <a:extLst xmlns:a="http://schemas.openxmlformats.org/drawingml/2006/main">
               <a:ext uri="{FF2B5EF4-FFF2-40B4-BE49-F238E27FC236}">
-                <a16:creationId xmlns:a16="http://schemas.microsoft.com/office/drawing/2014/main" id="{607A45A0-2790-4A4E-A662-B31B6B486D46}"/>
+                <a16:creationId xmlns:a16="http://schemas.microsoft.com/office/drawing/2014/main" id="{4FDC87A8-8898-4AFE-B05D-776AF0B67433}"/>
               </a:ext>
             </a:extLst>
           </p:cNvPr>
@@ -7508,7 +7508,7 @@
           <p:cNvPr id="15" name="text-101">
             <a:extLst xmlns:a="http://schemas.openxmlformats.org/drawingml/2006/main">
               <a:ext uri="{FF2B5EF4-FFF2-40B4-BE49-F238E27FC236}">
-                <a16:creationId xmlns:a16="http://schemas.microsoft.com/office/drawing/2014/main" id="{D0F641B1-1CEF-4382-A17F-82B503B099B4}"/>
+                <a16:creationId xmlns:a16="http://schemas.microsoft.com/office/drawing/2014/main" id="{63C7D949-2BE7-4620-859F-0E3C8ED98AE1}"/>
               </a:ext>
             </a:extLst>
           </p:cNvPr>
@@ -7666,7 +7666,7 @@
           <p:cNvPr id="16" name="text-102">
             <a:extLst xmlns:a="http://schemas.openxmlformats.org/drawingml/2006/main">
               <a:ext uri="{FF2B5EF4-FFF2-40B4-BE49-F238E27FC236}">
-                <a16:creationId xmlns:a16="http://schemas.microsoft.com/office/drawing/2014/main" id="{B2B78698-1111-4666-ADE2-047AE0E509ED}"/>
+                <a16:creationId xmlns:a16="http://schemas.microsoft.com/office/drawing/2014/main" id="{B636AC58-D030-471F-B04C-D4A2B46F09FE}"/>
               </a:ext>
             </a:extLst>
           </p:cNvPr>
@@ -7824,7 +7824,7 @@
           <p:cNvPr id="17" name="text-103">
             <a:extLst xmlns:a="http://schemas.openxmlformats.org/drawingml/2006/main">
               <a:ext uri="{FF2B5EF4-FFF2-40B4-BE49-F238E27FC236}">
-                <a16:creationId xmlns:a16="http://schemas.microsoft.com/office/drawing/2014/main" id="{97CB358B-A091-48F9-90EF-8E666D925C0C}"/>
+                <a16:creationId xmlns:a16="http://schemas.microsoft.com/office/drawing/2014/main" id="{EDBCD675-5554-40F1-987B-0D23CF88C7E2}"/>
               </a:ext>
             </a:extLst>
           </p:cNvPr>
@@ -7982,7 +7982,7 @@
           <p:cNvPr id="18" name="text-104">
             <a:extLst xmlns:a="http://schemas.openxmlformats.org/drawingml/2006/main">
               <a:ext uri="{FF2B5EF4-FFF2-40B4-BE49-F238E27FC236}">
-                <a16:creationId xmlns:a16="http://schemas.microsoft.com/office/drawing/2014/main" id="{402C77B1-8DD1-4917-BAE9-7A756FE1DDF9}"/>
+                <a16:creationId xmlns:a16="http://schemas.microsoft.com/office/drawing/2014/main" id="{A19C3B2B-EF38-439E-A3A3-8CA93E5AF5DB}"/>
               </a:ext>
             </a:extLst>
           </p:cNvPr>
@@ -8130,7 +8130,7 @@
                 <a:ea typeface="Helvetica Neue"/>
                 <a:cs typeface="Helvetica Neue"/>
               </a:rPr>
-              <a:t>Builds 1 + 2: available internally in TestFlight.</a:t>
+              <a:t>TestFlight: builds 1 + 2 + 3 internal; builds 1 + 3 external.</a:t>
             </a:r>
           </a:p>
           <a:p xmlns:a="http://schemas.openxmlformats.org/drawingml/2006/main">
@@ -8153,7 +8153,7 @@
                 <a:ea typeface="Helvetica Neue"/>
                 <a:cs typeface="Helvetica Neue"/>
               </a:rPr>
-              <a:t>External build 1: beta review pending; physical installs unverified.</a:t>
+              <a:t>Build 3 beta review approved. Physical installs unverified.</a:t>
             </a:r>
           </a:p>
         </p:txBody>
@@ -8161,7 +8161,7 @@
     </p:spTree>
     <p:extLst>
       <p:ext uri="{BB962C8B-B14F-4D97-AF65-F5344CB8AC3E}">
-        <p14:creationId xmlns:p14="http://schemas.microsoft.com/office/powerpoint/2010/main" val="1313706491"/>
+        <p14:creationId xmlns:p14="http://schemas.microsoft.com/office/powerpoint/2010/main" val="1146926917"/>
       </p:ext>
     </p:extLst>
   </p:cSld>
@@ -8192,7 +8192,7 @@
           <p:cNvPr id="15" name="text-6">
             <a:extLst xmlns:a="http://schemas.openxmlformats.org/drawingml/2006/main">
               <a:ext uri="{FF2B5EF4-FFF2-40B4-BE49-F238E27FC236}">
-                <a16:creationId xmlns:a16="http://schemas.microsoft.com/office/drawing/2014/main" id="{1EE82BFE-E9BE-44AE-B68F-396F6DF86F42}"/>
+                <a16:creationId xmlns:a16="http://schemas.microsoft.com/office/drawing/2014/main" id="{9970BB2E-D055-436F-95CF-03EF37820BF6}"/>
               </a:ext>
             </a:extLst>
           </p:cNvPr>
@@ -8350,7 +8350,7 @@
           <p:cNvPr id="2" name="text-7">
             <a:extLst xmlns:a="http://schemas.openxmlformats.org/drawingml/2006/main">
               <a:ext uri="{FF2B5EF4-FFF2-40B4-BE49-F238E27FC236}">
-                <a16:creationId xmlns:a16="http://schemas.microsoft.com/office/drawing/2014/main" id="{EB0C7333-FBC7-4ACB-8CB9-B810D246C047}"/>
+                <a16:creationId xmlns:a16="http://schemas.microsoft.com/office/drawing/2014/main" id="{1DA80092-2D67-436D-BD74-D21ABBDB6921}"/>
               </a:ext>
             </a:extLst>
           </p:cNvPr>
@@ -8508,7 +8508,7 @@
           <p:cNvPr id="3" name="text-8">
             <a:extLst xmlns:a="http://schemas.openxmlformats.org/drawingml/2006/main">
               <a:ext uri="{FF2B5EF4-FFF2-40B4-BE49-F238E27FC236}">
-                <a16:creationId xmlns:a16="http://schemas.microsoft.com/office/drawing/2014/main" id="{B0F28549-471C-4CF6-B00D-D33A087515CA}"/>
+                <a16:creationId xmlns:a16="http://schemas.microsoft.com/office/drawing/2014/main" id="{71450F83-64B1-4A52-A2C8-BAEEE9CBB17C}"/>
               </a:ext>
             </a:extLst>
           </p:cNvPr>
@@ -8666,7 +8666,7 @@
           <p:cNvPr id="4" name="text-9">
             <a:extLst xmlns:a="http://schemas.openxmlformats.org/drawingml/2006/main">
               <a:ext uri="{FF2B5EF4-FFF2-40B4-BE49-F238E27FC236}">
-                <a16:creationId xmlns:a16="http://schemas.microsoft.com/office/drawing/2014/main" id="{C743D614-9E23-423F-BC2A-8CAA395B4A10}"/>
+                <a16:creationId xmlns:a16="http://schemas.microsoft.com/office/drawing/2014/main" id="{03C62035-17C0-48B3-A453-2AD7DA6ADBC3}"/>
               </a:ext>
             </a:extLst>
           </p:cNvPr>
@@ -8824,7 +8824,7 @@
           <p:cNvPr id="5" name="text-10">
             <a:extLst xmlns:a="http://schemas.openxmlformats.org/drawingml/2006/main">
               <a:ext uri="{FF2B5EF4-FFF2-40B4-BE49-F238E27FC236}">
-                <a16:creationId xmlns:a16="http://schemas.microsoft.com/office/drawing/2014/main" id="{DCEEF502-2770-45CB-95EB-B0341AF04BCF}"/>
+                <a16:creationId xmlns:a16="http://schemas.microsoft.com/office/drawing/2014/main" id="{A0B75417-414E-49C5-9D0B-3838EF31D32F}"/>
               </a:ext>
             </a:extLst>
           </p:cNvPr>
@@ -8982,7 +8982,7 @@
           <p:cNvPr id="6" name="text-11">
             <a:extLst xmlns:a="http://schemas.openxmlformats.org/drawingml/2006/main">
               <a:ext uri="{FF2B5EF4-FFF2-40B4-BE49-F238E27FC236}">
-                <a16:creationId xmlns:a16="http://schemas.microsoft.com/office/drawing/2014/main" id="{14BE3D9B-85C4-44CE-8ACE-E4850820488C}"/>
+                <a16:creationId xmlns:a16="http://schemas.microsoft.com/office/drawing/2014/main" id="{B4BD4E20-1766-480F-818E-8063C1DEA03E}"/>
               </a:ext>
             </a:extLst>
           </p:cNvPr>
@@ -9140,7 +9140,7 @@
           <p:cNvPr id="7" name="text-12">
             <a:extLst xmlns:a="http://schemas.openxmlformats.org/drawingml/2006/main">
               <a:ext uri="{FF2B5EF4-FFF2-40B4-BE49-F238E27FC236}">
-                <a16:creationId xmlns:a16="http://schemas.microsoft.com/office/drawing/2014/main" id="{861A7C2C-3BBE-4332-B871-88ADC75092E7}"/>
+                <a16:creationId xmlns:a16="http://schemas.microsoft.com/office/drawing/2014/main" id="{5A419473-1077-43CC-80A5-72291F5F9FE5}"/>
               </a:ext>
             </a:extLst>
           </p:cNvPr>
@@ -9298,7 +9298,7 @@
           <p:cNvPr id="8" name="text-13">
             <a:extLst xmlns:a="http://schemas.openxmlformats.org/drawingml/2006/main">
               <a:ext uri="{FF2B5EF4-FFF2-40B4-BE49-F238E27FC236}">
-                <a16:creationId xmlns:a16="http://schemas.microsoft.com/office/drawing/2014/main" id="{74B42F22-ACA3-4097-AF6F-BD2AC60C7474}"/>
+                <a16:creationId xmlns:a16="http://schemas.microsoft.com/office/drawing/2014/main" id="{2752C846-EC6F-4D2C-8B52-BC0F46675A1E}"/>
               </a:ext>
             </a:extLst>
           </p:cNvPr>
@@ -9456,7 +9456,7 @@
           <p:cNvPr id="9" name="text-14">
             <a:extLst xmlns:a="http://schemas.openxmlformats.org/drawingml/2006/main">
               <a:ext uri="{FF2B5EF4-FFF2-40B4-BE49-F238E27FC236}">
-                <a16:creationId xmlns:a16="http://schemas.microsoft.com/office/drawing/2014/main" id="{264F3D14-9C4A-4592-AD9A-EF96BD29317E}"/>
+                <a16:creationId xmlns:a16="http://schemas.microsoft.com/office/drawing/2014/main" id="{15A7F86C-6875-4A06-B849-E4B2933AB7E7}"/>
               </a:ext>
             </a:extLst>
           </p:cNvPr>
@@ -9614,7 +9614,7 @@
           <p:cNvPr id="10" name="text-15">
             <a:extLst xmlns:a="http://schemas.openxmlformats.org/drawingml/2006/main">
               <a:ext uri="{FF2B5EF4-FFF2-40B4-BE49-F238E27FC236}">
-                <a16:creationId xmlns:a16="http://schemas.microsoft.com/office/drawing/2014/main" id="{3B682AC4-147B-439F-AC2B-BFC166857723}"/>
+                <a16:creationId xmlns:a16="http://schemas.microsoft.com/office/drawing/2014/main" id="{C5E80153-E22F-4E22-8A5C-E65985886295}"/>
               </a:ext>
             </a:extLst>
           </p:cNvPr>
@@ -9772,7 +9772,7 @@
           <p:cNvPr id="11" name="text-16">
             <a:extLst xmlns:a="http://schemas.openxmlformats.org/drawingml/2006/main">
               <a:ext uri="{FF2B5EF4-FFF2-40B4-BE49-F238E27FC236}">
-                <a16:creationId xmlns:a16="http://schemas.microsoft.com/office/drawing/2014/main" id="{67309391-00E6-4D26-A26D-C9AA94A8C767}"/>
+                <a16:creationId xmlns:a16="http://schemas.microsoft.com/office/drawing/2014/main" id="{75F02EEE-503A-4359-AA02-3FF5F40612CC}"/>
               </a:ext>
             </a:extLst>
           </p:cNvPr>
@@ -9930,7 +9930,7 @@
           <p:cNvPr id="12" name="text-17">
             <a:extLst xmlns:a="http://schemas.openxmlformats.org/drawingml/2006/main">
               <a:ext uri="{FF2B5EF4-FFF2-40B4-BE49-F238E27FC236}">
-                <a16:creationId xmlns:a16="http://schemas.microsoft.com/office/drawing/2014/main" id="{3F33F3DF-80BF-4630-ACD4-48DB223D6316}"/>
+                <a16:creationId xmlns:a16="http://schemas.microsoft.com/office/drawing/2014/main" id="{EB112305-7E23-46B4-8AB9-1E2D4F1C5C86}"/>
               </a:ext>
             </a:extLst>
           </p:cNvPr>
@@ -10088,7 +10088,7 @@
           <p:cNvPr id="13" name="text-18">
             <a:extLst xmlns:a="http://schemas.openxmlformats.org/drawingml/2006/main">
               <a:ext uri="{FF2B5EF4-FFF2-40B4-BE49-F238E27FC236}">
-                <a16:creationId xmlns:a16="http://schemas.microsoft.com/office/drawing/2014/main" id="{6156AB4A-253D-4CF1-A5C6-152E23B05553}"/>
+                <a16:creationId xmlns:a16="http://schemas.microsoft.com/office/drawing/2014/main" id="{1A0BAD9B-4BAF-4511-8A49-E348F285E20E}"/>
               </a:ext>
             </a:extLst>
           </p:cNvPr>
@@ -10246,7 +10246,7 @@
           <p:cNvPr id="14" name="text-19">
             <a:extLst xmlns:a="http://schemas.openxmlformats.org/drawingml/2006/main">
               <a:ext uri="{FF2B5EF4-FFF2-40B4-BE49-F238E27FC236}">
-                <a16:creationId xmlns:a16="http://schemas.microsoft.com/office/drawing/2014/main" id="{4F27AF85-A774-45BF-9C3A-569A315645E6}"/>
+                <a16:creationId xmlns:a16="http://schemas.microsoft.com/office/drawing/2014/main" id="{3C62D96E-C67B-4D02-8E2D-AF48269F0C04}"/>
               </a:ext>
             </a:extLst>
           </p:cNvPr>
@@ -10402,7 +10402,7 @@
     </p:spTree>
     <p:extLst>
       <p:ext uri="{BB962C8B-B14F-4D97-AF65-F5344CB8AC3E}">
-        <p14:creationId xmlns:p14="http://schemas.microsoft.com/office/powerpoint/2010/main" val="1020871894"/>
+        <p14:creationId xmlns:p14="http://schemas.microsoft.com/office/powerpoint/2010/main" val="45778675"/>
       </p:ext>
     </p:extLst>
   </p:cSld>
@@ -10433,7 +10433,7 @@
           <p:cNvPr id="7" name="">
             <a:extLst xmlns:a="http://schemas.openxmlformats.org/drawingml/2006/main">
               <a:ext uri="{FF2B5EF4-FFF2-40B4-BE49-F238E27FC236}">
-                <a16:creationId xmlns:a16="http://schemas.microsoft.com/office/drawing/2014/main" id="{2D131277-C80A-4E06-98E2-24774B78187C}"/>
+                <a16:creationId xmlns:a16="http://schemas.microsoft.com/office/drawing/2014/main" id="{1A9D7693-8D59-496D-B763-89AA69BEA7DD}"/>
               </a:ext>
             </a:extLst>
           </p:cNvPr>
@@ -10464,7 +10464,7 @@
           <p:cNvPr id="6" name="">
             <a:extLst xmlns:a="http://schemas.openxmlformats.org/drawingml/2006/main">
               <a:ext uri="{FF2B5EF4-FFF2-40B4-BE49-F238E27FC236}">
-                <a16:creationId xmlns:a16="http://schemas.microsoft.com/office/drawing/2014/main" id="{F8E29534-F22C-46A2-9EDC-A123A789DAFD}"/>
+                <a16:creationId xmlns:a16="http://schemas.microsoft.com/office/drawing/2014/main" id="{C2D2F827-E410-42D1-886B-9771A6C207A1}"/>
               </a:ext>
             </a:extLst>
           </p:cNvPr>
@@ -10495,7 +10495,7 @@
           <p:cNvPr id="14" name="text-20">
             <a:extLst xmlns:a="http://schemas.openxmlformats.org/drawingml/2006/main">
               <a:ext uri="{FF2B5EF4-FFF2-40B4-BE49-F238E27FC236}">
-                <a16:creationId xmlns:a16="http://schemas.microsoft.com/office/drawing/2014/main" id="{4DB7765F-F3F7-473E-A35E-1D3724724146}"/>
+                <a16:creationId xmlns:a16="http://schemas.microsoft.com/office/drawing/2014/main" id="{0623840E-F91D-49BC-9BA9-6AA5092220D8}"/>
               </a:ext>
             </a:extLst>
           </p:cNvPr>
@@ -10653,7 +10653,7 @@
           <p:cNvPr id="2" name="text-21">
             <a:extLst xmlns:a="http://schemas.openxmlformats.org/drawingml/2006/main">
               <a:ext uri="{FF2B5EF4-FFF2-40B4-BE49-F238E27FC236}">
-                <a16:creationId xmlns:a16="http://schemas.microsoft.com/office/drawing/2014/main" id="{95CF288A-ADDE-493A-A670-DC5B2098493B}"/>
+                <a16:creationId xmlns:a16="http://schemas.microsoft.com/office/drawing/2014/main" id="{F71E0349-AB87-4AC2-96C9-4DCF1A789341}"/>
               </a:ext>
             </a:extLst>
           </p:cNvPr>
@@ -10811,7 +10811,7 @@
           <p:cNvPr id="3" name="diagram-22">
             <a:extLst xmlns:a="http://schemas.openxmlformats.org/drawingml/2006/main">
               <a:ext uri="{FF2B5EF4-FFF2-40B4-BE49-F238E27FC236}">
-                <a16:creationId xmlns:a16="http://schemas.microsoft.com/office/drawing/2014/main" id="{CC1C36D5-383C-4889-A614-4538FF8CAD3C}"/>
+                <a16:creationId xmlns:a16="http://schemas.microsoft.com/office/drawing/2014/main" id="{42FA7AAB-E7DD-4694-856E-1164470DDD67}"/>
               </a:ext>
             </a:extLst>
           </p:cNvPr>
@@ -10971,7 +10971,7 @@
           <p:cNvPr id="4" name="diagram-23">
             <a:extLst xmlns:a="http://schemas.openxmlformats.org/drawingml/2006/main">
               <a:ext uri="{FF2B5EF4-FFF2-40B4-BE49-F238E27FC236}">
-                <a16:creationId xmlns:a16="http://schemas.microsoft.com/office/drawing/2014/main" id="{20083A39-9DEF-48C3-8B28-036F06A03EEF}"/>
+                <a16:creationId xmlns:a16="http://schemas.microsoft.com/office/drawing/2014/main" id="{08DD5AA7-3D26-4B9D-91C9-2F32511348BC}"/>
               </a:ext>
             </a:extLst>
           </p:cNvPr>
@@ -11131,7 +11131,7 @@
           <p:cNvPr id="5" name="diagram-24">
             <a:extLst xmlns:a="http://schemas.openxmlformats.org/drawingml/2006/main">
               <a:ext uri="{FF2B5EF4-FFF2-40B4-BE49-F238E27FC236}">
-                <a16:creationId xmlns:a16="http://schemas.microsoft.com/office/drawing/2014/main" id="{DAAA9B06-ECC9-4EF0-B137-2E4EDF2EA18C}"/>
+                <a16:creationId xmlns:a16="http://schemas.microsoft.com/office/drawing/2014/main" id="{CB94A18C-0FC4-48A4-8204-AE35D0254C47}"/>
               </a:ext>
             </a:extLst>
           </p:cNvPr>
@@ -11291,7 +11291,7 @@
           <p:cNvPr id="8" name="">
             <a:extLst xmlns:a="http://schemas.openxmlformats.org/drawingml/2006/main">
               <a:ext uri="{FF2B5EF4-FFF2-40B4-BE49-F238E27FC236}">
-                <a16:creationId xmlns:a16="http://schemas.microsoft.com/office/drawing/2014/main" id="{070D4B50-A1F1-4832-9F99-E0F57BA50116}"/>
+                <a16:creationId xmlns:a16="http://schemas.microsoft.com/office/drawing/2014/main" id="{1218F474-0981-4B6F-AE2F-371406899645}"/>
               </a:ext>
             </a:extLst>
           </p:cNvPr>
@@ -11301,7 +11301,7 @@
           <p:nvPr/>
         </p:nvPicPr>
         <p:blipFill>
-          <a:blip xmlns:r="http://schemas.openxmlformats.org/officeDocument/2006/relationships" xmlns:a="http://schemas.openxmlformats.org/drawingml/2006/main" r:embed="R8ed115096d654c24"/>
+          <a:blip xmlns:r="http://schemas.openxmlformats.org/officeDocument/2006/relationships" xmlns:a="http://schemas.openxmlformats.org/drawingml/2006/main" r:embed="Rbdd170485ef14e71"/>
           <a:stretch xmlns:a="http://schemas.openxmlformats.org/drawingml/2006/main"/>
         </p:blipFill>
         <p:spPr>
@@ -11319,7 +11319,7 @@
           <p:cNvPr id="9" name="text-25">
             <a:extLst xmlns:a="http://schemas.openxmlformats.org/drawingml/2006/main">
               <a:ext uri="{FF2B5EF4-FFF2-40B4-BE49-F238E27FC236}">
-                <a16:creationId xmlns:a16="http://schemas.microsoft.com/office/drawing/2014/main" id="{95A86C1D-8515-4744-ABA6-4FB9A560FB37}"/>
+                <a16:creationId xmlns:a16="http://schemas.microsoft.com/office/drawing/2014/main" id="{6F9CCEED-A766-436F-A60D-AB0D3265A475}"/>
               </a:ext>
             </a:extLst>
           </p:cNvPr>
@@ -11500,7 +11500,7 @@
           <p:cNvPr id="10" name="text-26">
             <a:extLst xmlns:a="http://schemas.openxmlformats.org/drawingml/2006/main">
               <a:ext uri="{FF2B5EF4-FFF2-40B4-BE49-F238E27FC236}">
-                <a16:creationId xmlns:a16="http://schemas.microsoft.com/office/drawing/2014/main" id="{077271D0-D6DD-4F73-A110-1C11B37AF430}"/>
+                <a16:creationId xmlns:a16="http://schemas.microsoft.com/office/drawing/2014/main" id="{F8412CC9-6C4B-491F-BB8B-BD475EEA873C}"/>
               </a:ext>
             </a:extLst>
           </p:cNvPr>
@@ -11658,7 +11658,7 @@
           <p:cNvPr id="11" name="text-27">
             <a:extLst xmlns:a="http://schemas.openxmlformats.org/drawingml/2006/main">
               <a:ext uri="{FF2B5EF4-FFF2-40B4-BE49-F238E27FC236}">
-                <a16:creationId xmlns:a16="http://schemas.microsoft.com/office/drawing/2014/main" id="{79116F62-E305-4516-BC67-1670B2F63256}"/>
+                <a16:creationId xmlns:a16="http://schemas.microsoft.com/office/drawing/2014/main" id="{3442C844-3134-40D1-8DC2-68BA520392E7}"/>
               </a:ext>
             </a:extLst>
           </p:cNvPr>
@@ -11885,7 +11885,7 @@
           <p:cNvPr id="12" name="text-28">
             <a:extLst xmlns:a="http://schemas.openxmlformats.org/drawingml/2006/main">
               <a:ext uri="{FF2B5EF4-FFF2-40B4-BE49-F238E27FC236}">
-                <a16:creationId xmlns:a16="http://schemas.microsoft.com/office/drawing/2014/main" id="{E6CA2C57-050E-4622-B93B-E77FB94D21AE}"/>
+                <a16:creationId xmlns:a16="http://schemas.microsoft.com/office/drawing/2014/main" id="{4A9438BE-8EB4-429C-BBD7-5321F410DC60}"/>
               </a:ext>
             </a:extLst>
           </p:cNvPr>
@@ -12043,7 +12043,7 @@
           <p:cNvPr id="13" name="text-29">
             <a:extLst xmlns:a="http://schemas.openxmlformats.org/drawingml/2006/main">
               <a:ext uri="{FF2B5EF4-FFF2-40B4-BE49-F238E27FC236}">
-                <a16:creationId xmlns:a16="http://schemas.microsoft.com/office/drawing/2014/main" id="{BFB6EE57-87D4-4F4E-8F8F-7E6BBFD992B4}"/>
+                <a16:creationId xmlns:a16="http://schemas.microsoft.com/office/drawing/2014/main" id="{A82EF41D-A8CE-4820-9C1D-12D588C0360F}"/>
               </a:ext>
             </a:extLst>
           </p:cNvPr>
@@ -12268,7 +12268,7 @@
     </p:spTree>
     <p:extLst>
       <p:ext uri="{BB962C8B-B14F-4D97-AF65-F5344CB8AC3E}">
-        <p14:creationId xmlns:p14="http://schemas.microsoft.com/office/powerpoint/2010/main" val="1430140303"/>
+        <p14:creationId xmlns:p14="http://schemas.microsoft.com/office/powerpoint/2010/main" val="1393545754"/>
       </p:ext>
     </p:extLst>
   </p:cSld>
@@ -12299,7 +12299,7 @@
           <p:cNvPr id="15" name="text-30">
             <a:extLst xmlns:a="http://schemas.openxmlformats.org/drawingml/2006/main">
               <a:ext uri="{FF2B5EF4-FFF2-40B4-BE49-F238E27FC236}">
-                <a16:creationId xmlns:a16="http://schemas.microsoft.com/office/drawing/2014/main" id="{66FE17D9-F983-417A-B91C-8F01EDFA74A7}"/>
+                <a16:creationId xmlns:a16="http://schemas.microsoft.com/office/drawing/2014/main" id="{BE68550D-ED57-49A3-8114-828C228CD6DA}"/>
               </a:ext>
             </a:extLst>
           </p:cNvPr>
@@ -12457,7 +12457,7 @@
           <p:cNvPr id="2" name="text-31">
             <a:extLst xmlns:a="http://schemas.openxmlformats.org/drawingml/2006/main">
               <a:ext uri="{FF2B5EF4-FFF2-40B4-BE49-F238E27FC236}">
-                <a16:creationId xmlns:a16="http://schemas.microsoft.com/office/drawing/2014/main" id="{813BA882-7FC5-44D6-B3D7-DD5A815690AD}"/>
+                <a16:creationId xmlns:a16="http://schemas.microsoft.com/office/drawing/2014/main" id="{636588D8-86C2-4591-878A-4EB0712189D1}"/>
               </a:ext>
             </a:extLst>
           </p:cNvPr>
@@ -12615,7 +12615,7 @@
           <p:cNvPr id="3" name="text-32">
             <a:extLst xmlns:a="http://schemas.openxmlformats.org/drawingml/2006/main">
               <a:ext uri="{FF2B5EF4-FFF2-40B4-BE49-F238E27FC236}">
-                <a16:creationId xmlns:a16="http://schemas.microsoft.com/office/drawing/2014/main" id="{F6DDAEFD-B586-4838-8DC3-FBDA76F8C2B7}"/>
+                <a16:creationId xmlns:a16="http://schemas.microsoft.com/office/drawing/2014/main" id="{40BF0D1C-9B0E-4E55-808A-DAF0EB1B9199}"/>
               </a:ext>
             </a:extLst>
           </p:cNvPr>
@@ -12773,7 +12773,7 @@
           <p:cNvPr id="4" name="text-33">
             <a:extLst xmlns:a="http://schemas.openxmlformats.org/drawingml/2006/main">
               <a:ext uri="{FF2B5EF4-FFF2-40B4-BE49-F238E27FC236}">
-                <a16:creationId xmlns:a16="http://schemas.microsoft.com/office/drawing/2014/main" id="{C39E6971-9CE3-4A8A-AB35-9ADF56B038D0}"/>
+                <a16:creationId xmlns:a16="http://schemas.microsoft.com/office/drawing/2014/main" id="{4DF71CC4-3DAD-40FE-84A2-1CF86F2C1363}"/>
               </a:ext>
             </a:extLst>
           </p:cNvPr>
@@ -12931,7 +12931,7 @@
           <p:cNvPr id="5" name="text-34">
             <a:extLst xmlns:a="http://schemas.openxmlformats.org/drawingml/2006/main">
               <a:ext uri="{FF2B5EF4-FFF2-40B4-BE49-F238E27FC236}">
-                <a16:creationId xmlns:a16="http://schemas.microsoft.com/office/drawing/2014/main" id="{F72AB9E1-E45D-42DA-8871-46BE4FBC793A}"/>
+                <a16:creationId xmlns:a16="http://schemas.microsoft.com/office/drawing/2014/main" id="{DCFB640B-B985-474A-8A98-5565A572E6C7}"/>
               </a:ext>
             </a:extLst>
           </p:cNvPr>
@@ -13089,7 +13089,7 @@
           <p:cNvPr id="6" name="text-35">
             <a:extLst xmlns:a="http://schemas.openxmlformats.org/drawingml/2006/main">
               <a:ext uri="{FF2B5EF4-FFF2-40B4-BE49-F238E27FC236}">
-                <a16:creationId xmlns:a16="http://schemas.microsoft.com/office/drawing/2014/main" id="{A2A3FCE5-E508-4F63-B8C9-B187387C28FE}"/>
+                <a16:creationId xmlns:a16="http://schemas.microsoft.com/office/drawing/2014/main" id="{84BAA558-F4BB-4C57-BEEE-B3439D5C7AA3}"/>
               </a:ext>
             </a:extLst>
           </p:cNvPr>
@@ -13270,7 +13270,7 @@
           <p:cNvPr id="7" name="text-36">
             <a:extLst xmlns:a="http://schemas.openxmlformats.org/drawingml/2006/main">
               <a:ext uri="{FF2B5EF4-FFF2-40B4-BE49-F238E27FC236}">
-                <a16:creationId xmlns:a16="http://schemas.microsoft.com/office/drawing/2014/main" id="{C0BB8BF8-C7B9-44F2-A938-ADCB660B0D13}"/>
+                <a16:creationId xmlns:a16="http://schemas.microsoft.com/office/drawing/2014/main" id="{35D91104-8FB1-4B5B-B6CF-605479AC6DED}"/>
               </a:ext>
             </a:extLst>
           </p:cNvPr>
@@ -13428,7 +13428,7 @@
           <p:cNvPr id="8" name="text-37">
             <a:extLst xmlns:a="http://schemas.openxmlformats.org/drawingml/2006/main">
               <a:ext uri="{FF2B5EF4-FFF2-40B4-BE49-F238E27FC236}">
-                <a16:creationId xmlns:a16="http://schemas.microsoft.com/office/drawing/2014/main" id="{5E0133B5-6A3F-4AC5-ADC7-4C819900BC63}"/>
+                <a16:creationId xmlns:a16="http://schemas.microsoft.com/office/drawing/2014/main" id="{E24D654F-CAED-424B-A812-EDDCCC54E9EE}"/>
               </a:ext>
             </a:extLst>
           </p:cNvPr>
@@ -13609,7 +13609,7 @@
           <p:cNvPr id="9" name="text-38">
             <a:extLst xmlns:a="http://schemas.openxmlformats.org/drawingml/2006/main">
               <a:ext uri="{FF2B5EF4-FFF2-40B4-BE49-F238E27FC236}">
-                <a16:creationId xmlns:a16="http://schemas.microsoft.com/office/drawing/2014/main" id="{4FD2820F-99D5-4AA2-9BD4-CE45C8E7513E}"/>
+                <a16:creationId xmlns:a16="http://schemas.microsoft.com/office/drawing/2014/main" id="{DE776F29-5D2C-4DB6-82A5-4E86FF41D9F4}"/>
               </a:ext>
             </a:extLst>
           </p:cNvPr>
@@ -13767,7 +13767,7 @@
           <p:cNvPr id="10" name="text-39">
             <a:extLst xmlns:a="http://schemas.openxmlformats.org/drawingml/2006/main">
               <a:ext uri="{FF2B5EF4-FFF2-40B4-BE49-F238E27FC236}">
-                <a16:creationId xmlns:a16="http://schemas.microsoft.com/office/drawing/2014/main" id="{964632F6-79BE-4EEC-AA96-40F59865F94A}"/>
+                <a16:creationId xmlns:a16="http://schemas.microsoft.com/office/drawing/2014/main" id="{6C74F5BE-1554-4B9F-B159-38B2FAF5F860}"/>
               </a:ext>
             </a:extLst>
           </p:cNvPr>
@@ -13925,7 +13925,7 @@
           <p:cNvPr id="11" name="">
             <a:extLst xmlns:a="http://schemas.openxmlformats.org/drawingml/2006/main">
               <a:ext uri="{FF2B5EF4-FFF2-40B4-BE49-F238E27FC236}">
-                <a16:creationId xmlns:a16="http://schemas.microsoft.com/office/drawing/2014/main" id="{A73B3B4C-D958-40FE-97A2-2140988AEF77}"/>
+                <a16:creationId xmlns:a16="http://schemas.microsoft.com/office/drawing/2014/main" id="{A9E20F9C-DCEC-4735-93EC-7AA12EE0ED44}"/>
               </a:ext>
             </a:extLst>
           </p:cNvPr>
@@ -13935,7 +13935,7 @@
           <p:nvPr/>
         </p:nvPicPr>
         <p:blipFill>
-          <a:blip xmlns:r="http://schemas.openxmlformats.org/officeDocument/2006/relationships" xmlns:a="http://schemas.openxmlformats.org/drawingml/2006/main" r:embed="R24a1bd2908874f4f"/>
+          <a:blip xmlns:r="http://schemas.openxmlformats.org/officeDocument/2006/relationships" xmlns:a="http://schemas.openxmlformats.org/drawingml/2006/main" r:embed="Rb3e5f2fbe1e549c6"/>
           <a:stretch xmlns:a="http://schemas.openxmlformats.org/drawingml/2006/main"/>
         </p:blipFill>
         <p:spPr>
@@ -13953,7 +13953,7 @@
           <p:cNvPr id="12" name="">
             <a:extLst xmlns:a="http://schemas.openxmlformats.org/drawingml/2006/main">
               <a:ext uri="{FF2B5EF4-FFF2-40B4-BE49-F238E27FC236}">
-                <a16:creationId xmlns:a16="http://schemas.microsoft.com/office/drawing/2014/main" id="{4FE725A1-43C2-4050-9898-9EB23EF0A3EC}"/>
+                <a16:creationId xmlns:a16="http://schemas.microsoft.com/office/drawing/2014/main" id="{052358C0-67FB-498B-AA76-C1AF94C0A006}"/>
               </a:ext>
             </a:extLst>
           </p:cNvPr>
@@ -13963,7 +13963,7 @@
           <p:nvPr/>
         </p:nvPicPr>
         <p:blipFill>
-          <a:blip xmlns:r="http://schemas.openxmlformats.org/officeDocument/2006/relationships" xmlns:a="http://schemas.openxmlformats.org/drawingml/2006/main" r:embed="R811fce0f807449a7"/>
+          <a:blip xmlns:r="http://schemas.openxmlformats.org/officeDocument/2006/relationships" xmlns:a="http://schemas.openxmlformats.org/drawingml/2006/main" r:embed="Rf92022089082473e"/>
           <a:stretch xmlns:a="http://schemas.openxmlformats.org/drawingml/2006/main"/>
         </p:blipFill>
         <p:spPr>
@@ -13981,7 +13981,7 @@
           <p:cNvPr id="13" name="">
             <a:extLst xmlns:a="http://schemas.openxmlformats.org/drawingml/2006/main">
               <a:ext uri="{FF2B5EF4-FFF2-40B4-BE49-F238E27FC236}">
-                <a16:creationId xmlns:a16="http://schemas.microsoft.com/office/drawing/2014/main" id="{562C4AC7-D5EF-4C78-A18F-E148F7BC826F}"/>
+                <a16:creationId xmlns:a16="http://schemas.microsoft.com/office/drawing/2014/main" id="{349B90A1-9F29-464D-8A22-3D13CE38F2D6}"/>
               </a:ext>
             </a:extLst>
           </p:cNvPr>
@@ -13991,7 +13991,7 @@
           <p:nvPr/>
         </p:nvPicPr>
         <p:blipFill>
-          <a:blip xmlns:r="http://schemas.openxmlformats.org/officeDocument/2006/relationships" xmlns:a="http://schemas.openxmlformats.org/drawingml/2006/main" r:embed="Ra78c1bc349c744a1"/>
+          <a:blip xmlns:r="http://schemas.openxmlformats.org/officeDocument/2006/relationships" xmlns:a="http://schemas.openxmlformats.org/drawingml/2006/main" r:embed="R5c04e0dcd2914ead"/>
           <a:stretch xmlns:a="http://schemas.openxmlformats.org/drawingml/2006/main"/>
         </p:blipFill>
         <p:spPr>
@@ -14009,7 +14009,7 @@
           <p:cNvPr id="14" name="text-40">
             <a:extLst xmlns:a="http://schemas.openxmlformats.org/drawingml/2006/main">
               <a:ext uri="{FF2B5EF4-FFF2-40B4-BE49-F238E27FC236}">
-                <a16:creationId xmlns:a16="http://schemas.microsoft.com/office/drawing/2014/main" id="{33EAFEB1-6B2C-46F8-8EE0-607E19863380}"/>
+                <a16:creationId xmlns:a16="http://schemas.microsoft.com/office/drawing/2014/main" id="{EE277142-0F0E-4D55-9A44-D0BB0ED5C66F}"/>
               </a:ext>
             </a:extLst>
           </p:cNvPr>
@@ -14165,7 +14165,7 @@
     </p:spTree>
     <p:extLst>
       <p:ext uri="{BB962C8B-B14F-4D97-AF65-F5344CB8AC3E}">
-        <p14:creationId xmlns:p14="http://schemas.microsoft.com/office/powerpoint/2010/main" val="506330863"/>
+        <p14:creationId xmlns:p14="http://schemas.microsoft.com/office/powerpoint/2010/main" val="899343303"/>
       </p:ext>
     </p:extLst>
   </p:cSld>
@@ -14196,7 +14196,7 @@
           <p:cNvPr id="8" name="">
             <a:extLst xmlns:a="http://schemas.openxmlformats.org/drawingml/2006/main">
               <a:ext uri="{FF2B5EF4-FFF2-40B4-BE49-F238E27FC236}">
-                <a16:creationId xmlns:a16="http://schemas.microsoft.com/office/drawing/2014/main" id="{B724955E-2584-44B8-B22F-127F8B0D4F23}"/>
+                <a16:creationId xmlns:a16="http://schemas.microsoft.com/office/drawing/2014/main" id="{137B24FF-8CAB-46E0-A252-270B43C42D80}"/>
               </a:ext>
             </a:extLst>
           </p:cNvPr>
@@ -14229,7 +14229,7 @@
           <p:cNvPr id="7" name="">
             <a:extLst xmlns:a="http://schemas.openxmlformats.org/drawingml/2006/main">
               <a:ext uri="{FF2B5EF4-FFF2-40B4-BE49-F238E27FC236}">
-                <a16:creationId xmlns:a16="http://schemas.microsoft.com/office/drawing/2014/main" id="{DC62F8FB-2403-4A34-A1F5-889B5F8ACCFB}"/>
+                <a16:creationId xmlns:a16="http://schemas.microsoft.com/office/drawing/2014/main" id="{E97B5D5E-B6D6-4BAD-94D8-1CC23BEE9783}"/>
               </a:ext>
             </a:extLst>
           </p:cNvPr>
@@ -14262,7 +14262,7 @@
           <p:cNvPr id="13" name="text-41">
             <a:extLst xmlns:a="http://schemas.openxmlformats.org/drawingml/2006/main">
               <a:ext uri="{FF2B5EF4-FFF2-40B4-BE49-F238E27FC236}">
-                <a16:creationId xmlns:a16="http://schemas.microsoft.com/office/drawing/2014/main" id="{1D53137E-E14E-49F6-B9A1-99F1CC456E6C}"/>
+                <a16:creationId xmlns:a16="http://schemas.microsoft.com/office/drawing/2014/main" id="{3E6B2DCA-5D6D-48CB-B4D3-8481D1B92D03}"/>
               </a:ext>
             </a:extLst>
           </p:cNvPr>
@@ -14420,7 +14420,7 @@
           <p:cNvPr id="2" name="text-42">
             <a:extLst xmlns:a="http://schemas.openxmlformats.org/drawingml/2006/main">
               <a:ext uri="{FF2B5EF4-FFF2-40B4-BE49-F238E27FC236}">
-                <a16:creationId xmlns:a16="http://schemas.microsoft.com/office/drawing/2014/main" id="{762FB8E4-40AF-4896-986E-46ECE8FB93E0}"/>
+                <a16:creationId xmlns:a16="http://schemas.microsoft.com/office/drawing/2014/main" id="{1689B586-A6CA-40FE-8ABA-47C2271BBC6C}"/>
               </a:ext>
             </a:extLst>
           </p:cNvPr>
@@ -14578,7 +14578,7 @@
           <p:cNvPr id="3" name="text-43">
             <a:extLst xmlns:a="http://schemas.openxmlformats.org/drawingml/2006/main">
               <a:ext uri="{FF2B5EF4-FFF2-40B4-BE49-F238E27FC236}">
-                <a16:creationId xmlns:a16="http://schemas.microsoft.com/office/drawing/2014/main" id="{70C16F48-6FB6-4E52-8677-D0CDDB67D1B9}"/>
+                <a16:creationId xmlns:a16="http://schemas.microsoft.com/office/drawing/2014/main" id="{7663AB4B-DA4F-4A95-B44F-ED2B08CC2794}"/>
               </a:ext>
             </a:extLst>
           </p:cNvPr>
@@ -14736,7 +14736,7 @@
           <p:cNvPr id="4" name="diagram-44">
             <a:extLst xmlns:a="http://schemas.openxmlformats.org/drawingml/2006/main">
               <a:ext uri="{FF2B5EF4-FFF2-40B4-BE49-F238E27FC236}">
-                <a16:creationId xmlns:a16="http://schemas.microsoft.com/office/drawing/2014/main" id="{D0D2CD08-11EB-437B-B69C-20EBAC757B16}"/>
+                <a16:creationId xmlns:a16="http://schemas.microsoft.com/office/drawing/2014/main" id="{1928419B-8DE9-49CA-A23F-E3C101BBF299}"/>
               </a:ext>
             </a:extLst>
           </p:cNvPr>
@@ -14896,7 +14896,7 @@
           <p:cNvPr id="5" name="diagram-45">
             <a:extLst xmlns:a="http://schemas.openxmlformats.org/drawingml/2006/main">
               <a:ext uri="{FF2B5EF4-FFF2-40B4-BE49-F238E27FC236}">
-                <a16:creationId xmlns:a16="http://schemas.microsoft.com/office/drawing/2014/main" id="{97073719-FF8A-463F-8115-6DDD564AB865}"/>
+                <a16:creationId xmlns:a16="http://schemas.microsoft.com/office/drawing/2014/main" id="{215DB424-58F5-439D-BFFB-46DAC1FD0780}"/>
               </a:ext>
             </a:extLst>
           </p:cNvPr>
@@ -15056,7 +15056,7 @@
           <p:cNvPr id="6" name="diagram-46">
             <a:extLst xmlns:a="http://schemas.openxmlformats.org/drawingml/2006/main">
               <a:ext uri="{FF2B5EF4-FFF2-40B4-BE49-F238E27FC236}">
-                <a16:creationId xmlns:a16="http://schemas.microsoft.com/office/drawing/2014/main" id="{D26779E9-4BCE-4D45-BD2C-7A7AC8ABDBD4}"/>
+                <a16:creationId xmlns:a16="http://schemas.microsoft.com/office/drawing/2014/main" id="{5EEFC38F-52A4-4B66-A90E-21D595C0CB1F}"/>
               </a:ext>
             </a:extLst>
           </p:cNvPr>
@@ -15216,7 +15216,7 @@
           <p:cNvPr id="9" name="text-47">
             <a:extLst xmlns:a="http://schemas.openxmlformats.org/drawingml/2006/main">
               <a:ext uri="{FF2B5EF4-FFF2-40B4-BE49-F238E27FC236}">
-                <a16:creationId xmlns:a16="http://schemas.microsoft.com/office/drawing/2014/main" id="{5094F68A-2846-4E7A-96B6-200C33F64122}"/>
+                <a16:creationId xmlns:a16="http://schemas.microsoft.com/office/drawing/2014/main" id="{89AE67C6-CAE3-44EC-82C3-6412692E25A0}"/>
               </a:ext>
             </a:extLst>
           </p:cNvPr>
@@ -15374,7 +15374,7 @@
           <p:cNvPr id="10" name="text-48">
             <a:extLst xmlns:a="http://schemas.openxmlformats.org/drawingml/2006/main">
               <a:ext uri="{FF2B5EF4-FFF2-40B4-BE49-F238E27FC236}">
-                <a16:creationId xmlns:a16="http://schemas.microsoft.com/office/drawing/2014/main" id="{8E061674-9C98-44B1-87F7-404DD85A3A05}"/>
+                <a16:creationId xmlns:a16="http://schemas.microsoft.com/office/drawing/2014/main" id="{9DB8B8BD-EBBA-40AF-B9C3-ACF8E72A4D3F}"/>
               </a:ext>
             </a:extLst>
           </p:cNvPr>
@@ -15555,7 +15555,7 @@
           <p:cNvPr id="11" name="text-49">
             <a:extLst xmlns:a="http://schemas.openxmlformats.org/drawingml/2006/main">
               <a:ext uri="{FF2B5EF4-FFF2-40B4-BE49-F238E27FC236}">
-                <a16:creationId xmlns:a16="http://schemas.microsoft.com/office/drawing/2014/main" id="{EA8168ED-815E-4391-8FCE-62076B257BFF}"/>
+                <a16:creationId xmlns:a16="http://schemas.microsoft.com/office/drawing/2014/main" id="{95AF7DE4-B17F-4AC4-B836-868455D5ED85}"/>
               </a:ext>
             </a:extLst>
           </p:cNvPr>
@@ -15759,7 +15759,7 @@
           <p:cNvPr id="12" name="text-50">
             <a:extLst xmlns:a="http://schemas.openxmlformats.org/drawingml/2006/main">
               <a:ext uri="{FF2B5EF4-FFF2-40B4-BE49-F238E27FC236}">
-                <a16:creationId xmlns:a16="http://schemas.microsoft.com/office/drawing/2014/main" id="{5CB013A7-A99D-4BB2-88F5-E26EC7E5B99D}"/>
+                <a16:creationId xmlns:a16="http://schemas.microsoft.com/office/drawing/2014/main" id="{B929AE7A-9C47-4BF2-A7E4-0D2A7D00AE50}"/>
               </a:ext>
             </a:extLst>
           </p:cNvPr>
@@ -15938,7 +15938,7 @@
     </p:spTree>
     <p:extLst>
       <p:ext uri="{BB962C8B-B14F-4D97-AF65-F5344CB8AC3E}">
-        <p14:creationId xmlns:p14="http://schemas.microsoft.com/office/powerpoint/2010/main" val="2020540006"/>
+        <p14:creationId xmlns:p14="http://schemas.microsoft.com/office/powerpoint/2010/main" val="827888815"/>
       </p:ext>
     </p:extLst>
   </p:cSld>
@@ -15969,7 +15969,7 @@
           <p:cNvPr id="16" name="text-51">
             <a:extLst xmlns:a="http://schemas.openxmlformats.org/drawingml/2006/main">
               <a:ext uri="{FF2B5EF4-FFF2-40B4-BE49-F238E27FC236}">
-                <a16:creationId xmlns:a16="http://schemas.microsoft.com/office/drawing/2014/main" id="{A25DEED0-304F-44D0-885F-5E8B6B64171D}"/>
+                <a16:creationId xmlns:a16="http://schemas.microsoft.com/office/drawing/2014/main" id="{AE2E6828-BE1D-4C5D-A987-9A30E04FD894}"/>
               </a:ext>
             </a:extLst>
           </p:cNvPr>
@@ -16127,7 +16127,7 @@
           <p:cNvPr id="2" name="text-52">
             <a:extLst xmlns:a="http://schemas.openxmlformats.org/drawingml/2006/main">
               <a:ext uri="{FF2B5EF4-FFF2-40B4-BE49-F238E27FC236}">
-                <a16:creationId xmlns:a16="http://schemas.microsoft.com/office/drawing/2014/main" id="{77A83F4C-C78F-45C3-8B20-C791645639C9}"/>
+                <a16:creationId xmlns:a16="http://schemas.microsoft.com/office/drawing/2014/main" id="{9F9BDA60-6421-4569-B7CD-436327F44A36}"/>
               </a:ext>
             </a:extLst>
           </p:cNvPr>
@@ -16285,7 +16285,7 @@
           <p:cNvPr id="3" name="text-53">
             <a:extLst xmlns:a="http://schemas.openxmlformats.org/drawingml/2006/main">
               <a:ext uri="{FF2B5EF4-FFF2-40B4-BE49-F238E27FC236}">
-                <a16:creationId xmlns:a16="http://schemas.microsoft.com/office/drawing/2014/main" id="{EAC194D6-C781-459F-9CBD-5485DF55EE23}"/>
+                <a16:creationId xmlns:a16="http://schemas.microsoft.com/office/drawing/2014/main" id="{1A9DFF59-9E42-4ADE-B01E-7786BC74C059}"/>
               </a:ext>
             </a:extLst>
           </p:cNvPr>
@@ -16443,7 +16443,7 @@
           <p:cNvPr id="4" name="text-54">
             <a:extLst xmlns:a="http://schemas.openxmlformats.org/drawingml/2006/main">
               <a:ext uri="{FF2B5EF4-FFF2-40B4-BE49-F238E27FC236}">
-                <a16:creationId xmlns:a16="http://schemas.microsoft.com/office/drawing/2014/main" id="{EAC0DEC3-847F-4A18-B91B-453278EB183B}"/>
+                <a16:creationId xmlns:a16="http://schemas.microsoft.com/office/drawing/2014/main" id="{78A4DC51-83D5-408E-A21A-1614268741DE}"/>
               </a:ext>
             </a:extLst>
           </p:cNvPr>
@@ -16601,7 +16601,7 @@
           <p:cNvPr id="5" name="text-55">
             <a:extLst xmlns:a="http://schemas.openxmlformats.org/drawingml/2006/main">
               <a:ext uri="{FF2B5EF4-FFF2-40B4-BE49-F238E27FC236}">
-                <a16:creationId xmlns:a16="http://schemas.microsoft.com/office/drawing/2014/main" id="{E1C31875-9DCD-4082-A0C4-164F33DF87A0}"/>
+                <a16:creationId xmlns:a16="http://schemas.microsoft.com/office/drawing/2014/main" id="{D7BB496D-30D3-447D-8934-1BE1DAD78029}"/>
               </a:ext>
             </a:extLst>
           </p:cNvPr>
@@ -16759,7 +16759,7 @@
           <p:cNvPr id="6" name="text-56">
             <a:extLst xmlns:a="http://schemas.openxmlformats.org/drawingml/2006/main">
               <a:ext uri="{FF2B5EF4-FFF2-40B4-BE49-F238E27FC236}">
-                <a16:creationId xmlns:a16="http://schemas.microsoft.com/office/drawing/2014/main" id="{32724698-35E4-493E-B744-887903BD0ADB}"/>
+                <a16:creationId xmlns:a16="http://schemas.microsoft.com/office/drawing/2014/main" id="{F346A603-73C5-408E-880B-EA44703FD64D}"/>
               </a:ext>
             </a:extLst>
           </p:cNvPr>
@@ -16917,7 +16917,7 @@
           <p:cNvPr id="7" name="text-57">
             <a:extLst xmlns:a="http://schemas.openxmlformats.org/drawingml/2006/main">
               <a:ext uri="{FF2B5EF4-FFF2-40B4-BE49-F238E27FC236}">
-                <a16:creationId xmlns:a16="http://schemas.microsoft.com/office/drawing/2014/main" id="{B9D07D09-82B2-48FD-BFBF-64DDED92EE05}"/>
+                <a16:creationId xmlns:a16="http://schemas.microsoft.com/office/drawing/2014/main" id="{371E3DB3-08D6-45F8-9581-7E9AFE479213}"/>
               </a:ext>
             </a:extLst>
           </p:cNvPr>
@@ -17075,7 +17075,7 @@
           <p:cNvPr id="8" name="text-58">
             <a:extLst xmlns:a="http://schemas.openxmlformats.org/drawingml/2006/main">
               <a:ext uri="{FF2B5EF4-FFF2-40B4-BE49-F238E27FC236}">
-                <a16:creationId xmlns:a16="http://schemas.microsoft.com/office/drawing/2014/main" id="{9737CB54-85B7-47BA-856D-DD80D9322062}"/>
+                <a16:creationId xmlns:a16="http://schemas.microsoft.com/office/drawing/2014/main" id="{A468B022-C80E-451A-BE78-BEE6E9FD2C26}"/>
               </a:ext>
             </a:extLst>
           </p:cNvPr>
@@ -17233,7 +17233,7 @@
           <p:cNvPr id="9" name="text-59">
             <a:extLst xmlns:a="http://schemas.openxmlformats.org/drawingml/2006/main">
               <a:ext uri="{FF2B5EF4-FFF2-40B4-BE49-F238E27FC236}">
-                <a16:creationId xmlns:a16="http://schemas.microsoft.com/office/drawing/2014/main" id="{7AEBFAF1-F4F0-4991-B6EA-4A2EFB9D4970}"/>
+                <a16:creationId xmlns:a16="http://schemas.microsoft.com/office/drawing/2014/main" id="{03583D03-B5F6-4594-9E59-CA5285AD9308}"/>
               </a:ext>
             </a:extLst>
           </p:cNvPr>
@@ -17391,7 +17391,7 @@
           <p:cNvPr id="10" name="text-60">
             <a:extLst xmlns:a="http://schemas.openxmlformats.org/drawingml/2006/main">
               <a:ext uri="{FF2B5EF4-FFF2-40B4-BE49-F238E27FC236}">
-                <a16:creationId xmlns:a16="http://schemas.microsoft.com/office/drawing/2014/main" id="{F06266E8-7E0E-4EC9-9CB3-D27849704B00}"/>
+                <a16:creationId xmlns:a16="http://schemas.microsoft.com/office/drawing/2014/main" id="{1B4BC487-0AAB-4BA0-AB50-B9D6FADF7A4E}"/>
               </a:ext>
             </a:extLst>
           </p:cNvPr>
@@ -17549,7 +17549,7 @@
           <p:cNvPr id="11" name="text-61">
             <a:extLst xmlns:a="http://schemas.openxmlformats.org/drawingml/2006/main">
               <a:ext uri="{FF2B5EF4-FFF2-40B4-BE49-F238E27FC236}">
-                <a16:creationId xmlns:a16="http://schemas.microsoft.com/office/drawing/2014/main" id="{6831F8D7-CC45-4610-8A05-C7ADC2DEDCB4}"/>
+                <a16:creationId xmlns:a16="http://schemas.microsoft.com/office/drawing/2014/main" id="{712291B4-D5A0-4A9C-8989-6395F24EDA55}"/>
               </a:ext>
             </a:extLst>
           </p:cNvPr>
@@ -17707,7 +17707,7 @@
           <p:cNvPr id="12" name="text-62">
             <a:extLst xmlns:a="http://schemas.openxmlformats.org/drawingml/2006/main">
               <a:ext uri="{FF2B5EF4-FFF2-40B4-BE49-F238E27FC236}">
-                <a16:creationId xmlns:a16="http://schemas.microsoft.com/office/drawing/2014/main" id="{AC1835EC-E033-47BC-BCA0-2DEB8D641F3D}"/>
+                <a16:creationId xmlns:a16="http://schemas.microsoft.com/office/drawing/2014/main" id="{72136932-3C8A-4C70-8018-17F4CB5F61B9}"/>
               </a:ext>
             </a:extLst>
           </p:cNvPr>
@@ -17911,7 +17911,7 @@
           <p:cNvPr id="13" name="text-63">
             <a:extLst xmlns:a="http://schemas.openxmlformats.org/drawingml/2006/main">
               <a:ext uri="{FF2B5EF4-FFF2-40B4-BE49-F238E27FC236}">
-                <a16:creationId xmlns:a16="http://schemas.microsoft.com/office/drawing/2014/main" id="{D52C4F55-8D56-4854-A78C-0FAFF8072234}"/>
+                <a16:creationId xmlns:a16="http://schemas.microsoft.com/office/drawing/2014/main" id="{1B5B8731-CD55-41B2-B9E3-3DC8C93D05EC}"/>
               </a:ext>
             </a:extLst>
           </p:cNvPr>
@@ -18069,7 +18069,7 @@
           <p:cNvPr id="14" name="text-64">
             <a:extLst xmlns:a="http://schemas.openxmlformats.org/drawingml/2006/main">
               <a:ext uri="{FF2B5EF4-FFF2-40B4-BE49-F238E27FC236}">
-                <a16:creationId xmlns:a16="http://schemas.microsoft.com/office/drawing/2014/main" id="{C40F342C-4272-49B2-8248-0C1DE4E65416}"/>
+                <a16:creationId xmlns:a16="http://schemas.microsoft.com/office/drawing/2014/main" id="{834B06EA-1C07-489D-9444-903069AEC00D}"/>
               </a:ext>
             </a:extLst>
           </p:cNvPr>
@@ -18273,7 +18273,7 @@
           <p:cNvPr id="15" name="text-65">
             <a:extLst xmlns:a="http://schemas.openxmlformats.org/drawingml/2006/main">
               <a:ext uri="{FF2B5EF4-FFF2-40B4-BE49-F238E27FC236}">
-                <a16:creationId xmlns:a16="http://schemas.microsoft.com/office/drawing/2014/main" id="{6A093953-1694-4A5E-A6C9-FD5F40380E21}"/>
+                <a16:creationId xmlns:a16="http://schemas.microsoft.com/office/drawing/2014/main" id="{74EF9F9B-E919-40D4-8F6A-7154BA92E0D3}"/>
               </a:ext>
             </a:extLst>
           </p:cNvPr>
@@ -18452,7 +18452,7 @@
     </p:spTree>
     <p:extLst>
       <p:ext uri="{BB962C8B-B14F-4D97-AF65-F5344CB8AC3E}">
-        <p14:creationId xmlns:p14="http://schemas.microsoft.com/office/powerpoint/2010/main" val="1787701784"/>
+        <p14:creationId xmlns:p14="http://schemas.microsoft.com/office/powerpoint/2010/main" val="1960144095"/>
       </p:ext>
     </p:extLst>
   </p:cSld>
@@ -18483,7 +18483,7 @@
           <p:cNvPr id="11" name="text-66">
             <a:extLst xmlns:a="http://schemas.openxmlformats.org/drawingml/2006/main">
               <a:ext uri="{FF2B5EF4-FFF2-40B4-BE49-F238E27FC236}">
-                <a16:creationId xmlns:a16="http://schemas.microsoft.com/office/drawing/2014/main" id="{B3DEAB8C-1209-424D-A5B6-A780D7A72127}"/>
+                <a16:creationId xmlns:a16="http://schemas.microsoft.com/office/drawing/2014/main" id="{82D71774-FCC5-4844-A8BC-D71F44624966}"/>
               </a:ext>
             </a:extLst>
           </p:cNvPr>
@@ -18641,7 +18641,7 @@
           <p:cNvPr id="2" name="text-67">
             <a:extLst xmlns:a="http://schemas.openxmlformats.org/drawingml/2006/main">
               <a:ext uri="{FF2B5EF4-FFF2-40B4-BE49-F238E27FC236}">
-                <a16:creationId xmlns:a16="http://schemas.microsoft.com/office/drawing/2014/main" id="{AC8155EB-983C-4F8C-BA50-5B7E37557F3A}"/>
+                <a16:creationId xmlns:a16="http://schemas.microsoft.com/office/drawing/2014/main" id="{AD8F60F0-3FC7-4824-93DF-E4CFA963C639}"/>
               </a:ext>
             </a:extLst>
           </p:cNvPr>
@@ -18799,7 +18799,7 @@
           <p:cNvPr id="3" name="text-68">
             <a:extLst xmlns:a="http://schemas.openxmlformats.org/drawingml/2006/main">
               <a:ext uri="{FF2B5EF4-FFF2-40B4-BE49-F238E27FC236}">
-                <a16:creationId xmlns:a16="http://schemas.microsoft.com/office/drawing/2014/main" id="{21264FBA-0C9B-4E28-A902-A877199937AE}"/>
+                <a16:creationId xmlns:a16="http://schemas.microsoft.com/office/drawing/2014/main" id="{2449533B-2B83-4077-8202-426C0D09C04B}"/>
               </a:ext>
             </a:extLst>
           </p:cNvPr>
@@ -18957,7 +18957,7 @@
           <p:cNvPr id="4" name="text-69">
             <a:extLst xmlns:a="http://schemas.openxmlformats.org/drawingml/2006/main">
               <a:ext uri="{FF2B5EF4-FFF2-40B4-BE49-F238E27FC236}">
-                <a16:creationId xmlns:a16="http://schemas.microsoft.com/office/drawing/2014/main" id="{DAC21C45-806D-4A65-B132-6D0411E871C0}"/>
+                <a16:creationId xmlns:a16="http://schemas.microsoft.com/office/drawing/2014/main" id="{AE848AF7-E33E-433F-A80E-9569B7E4B0AC}"/>
               </a:ext>
             </a:extLst>
           </p:cNvPr>
@@ -19115,7 +19115,7 @@
           <p:cNvPr id="5" name="text-70">
             <a:extLst xmlns:a="http://schemas.openxmlformats.org/drawingml/2006/main">
               <a:ext uri="{FF2B5EF4-FFF2-40B4-BE49-F238E27FC236}">
-                <a16:creationId xmlns:a16="http://schemas.microsoft.com/office/drawing/2014/main" id="{D6815232-67B4-422C-A1F7-B5651661E4FB}"/>
+                <a16:creationId xmlns:a16="http://schemas.microsoft.com/office/drawing/2014/main" id="{0DD13DDA-E630-4E30-BD69-E391F2940668}"/>
               </a:ext>
             </a:extLst>
           </p:cNvPr>
@@ -19319,7 +19319,7 @@
           <p:cNvPr id="6" name="text-71">
             <a:extLst xmlns:a="http://schemas.openxmlformats.org/drawingml/2006/main">
               <a:ext uri="{FF2B5EF4-FFF2-40B4-BE49-F238E27FC236}">
-                <a16:creationId xmlns:a16="http://schemas.microsoft.com/office/drawing/2014/main" id="{6B8E988C-5106-4FE9-9977-88FC0C8EA362}"/>
+                <a16:creationId xmlns:a16="http://schemas.microsoft.com/office/drawing/2014/main" id="{3F7B54CC-5DA0-4100-8CE3-7F367D38BC1F}"/>
               </a:ext>
             </a:extLst>
           </p:cNvPr>
@@ -19500,7 +19500,7 @@
           <p:cNvPr id="7" name="text-72">
             <a:extLst xmlns:a="http://schemas.openxmlformats.org/drawingml/2006/main">
               <a:ext uri="{FF2B5EF4-FFF2-40B4-BE49-F238E27FC236}">
-                <a16:creationId xmlns:a16="http://schemas.microsoft.com/office/drawing/2014/main" id="{CC2B6BC7-2CF8-4C52-9A24-6E4B2B97C4D0}"/>
+                <a16:creationId xmlns:a16="http://schemas.microsoft.com/office/drawing/2014/main" id="{793155FC-7CA0-421F-9A44-D58E72F324D9}"/>
               </a:ext>
             </a:extLst>
           </p:cNvPr>
@@ -19658,7 +19658,7 @@
           <p:cNvPr id="8" name="text-73">
             <a:extLst xmlns:a="http://schemas.openxmlformats.org/drawingml/2006/main">
               <a:ext uri="{FF2B5EF4-FFF2-40B4-BE49-F238E27FC236}">
-                <a16:creationId xmlns:a16="http://schemas.microsoft.com/office/drawing/2014/main" id="{5C471571-6B80-45BD-A73F-A70555D01C7E}"/>
+                <a16:creationId xmlns:a16="http://schemas.microsoft.com/office/drawing/2014/main" id="{8727B440-81B7-4AB6-94CB-47289755A4D6}"/>
               </a:ext>
             </a:extLst>
           </p:cNvPr>
@@ -19816,7 +19816,7 @@
           <p:cNvPr id="9" name="text-74">
             <a:extLst xmlns:a="http://schemas.openxmlformats.org/drawingml/2006/main">
               <a:ext uri="{FF2B5EF4-FFF2-40B4-BE49-F238E27FC236}">
-                <a16:creationId xmlns:a16="http://schemas.microsoft.com/office/drawing/2014/main" id="{C8DB153E-4A94-477E-9EB8-041C501105F8}"/>
+                <a16:creationId xmlns:a16="http://schemas.microsoft.com/office/drawing/2014/main" id="{BE159378-D834-4447-A112-232CD2ACD3BA}"/>
               </a:ext>
             </a:extLst>
           </p:cNvPr>
@@ -20020,7 +20020,7 @@
           <p:cNvPr id="10" name="text-75">
             <a:extLst xmlns:a="http://schemas.openxmlformats.org/drawingml/2006/main">
               <a:ext uri="{FF2B5EF4-FFF2-40B4-BE49-F238E27FC236}">
-                <a16:creationId xmlns:a16="http://schemas.microsoft.com/office/drawing/2014/main" id="{432F1D7B-476B-4E57-9DFA-EFD6D85A7316}"/>
+                <a16:creationId xmlns:a16="http://schemas.microsoft.com/office/drawing/2014/main" id="{B25119D5-C29D-429F-AD9D-EAD231909751}"/>
               </a:ext>
             </a:extLst>
           </p:cNvPr>
@@ -20199,7 +20199,7 @@
     </p:spTree>
     <p:extLst>
       <p:ext uri="{BB962C8B-B14F-4D97-AF65-F5344CB8AC3E}">
-        <p14:creationId xmlns:p14="http://schemas.microsoft.com/office/powerpoint/2010/main" val="276059141"/>
+        <p14:creationId xmlns:p14="http://schemas.microsoft.com/office/powerpoint/2010/main" val="619142594"/>
       </p:ext>
     </p:extLst>
   </p:cSld>
@@ -20230,7 +20230,7 @@
           <p:cNvPr id="10" name="text-76">
             <a:extLst xmlns:a="http://schemas.openxmlformats.org/drawingml/2006/main">
               <a:ext uri="{FF2B5EF4-FFF2-40B4-BE49-F238E27FC236}">
-                <a16:creationId xmlns:a16="http://schemas.microsoft.com/office/drawing/2014/main" id="{7AF05816-CE1A-49B6-86B1-68BA4F6FBFA4}"/>
+                <a16:creationId xmlns:a16="http://schemas.microsoft.com/office/drawing/2014/main" id="{5A4C2F91-2BC6-4FB6-BFC4-25FD22870D75}"/>
               </a:ext>
             </a:extLst>
           </p:cNvPr>
@@ -20388,7 +20388,7 @@
           <p:cNvPr id="2" name="text-77">
             <a:extLst xmlns:a="http://schemas.openxmlformats.org/drawingml/2006/main">
               <a:ext uri="{FF2B5EF4-FFF2-40B4-BE49-F238E27FC236}">
-                <a16:creationId xmlns:a16="http://schemas.microsoft.com/office/drawing/2014/main" id="{F503D48C-1826-4C41-86D9-86DA832EB5A9}"/>
+                <a16:creationId xmlns:a16="http://schemas.microsoft.com/office/drawing/2014/main" id="{A0012381-6351-4605-B8A8-1CCCB63BBF23}"/>
               </a:ext>
             </a:extLst>
           </p:cNvPr>
@@ -20546,7 +20546,7 @@
           <p:cNvPr id="3" name="text-78">
             <a:extLst xmlns:a="http://schemas.openxmlformats.org/drawingml/2006/main">
               <a:ext uri="{FF2B5EF4-FFF2-40B4-BE49-F238E27FC236}">
-                <a16:creationId xmlns:a16="http://schemas.microsoft.com/office/drawing/2014/main" id="{4C590AD0-B742-43BC-8A22-9240165A720A}"/>
+                <a16:creationId xmlns:a16="http://schemas.microsoft.com/office/drawing/2014/main" id="{21832A2F-3ECD-4476-8D80-CE88D6DEB9E8}"/>
               </a:ext>
             </a:extLst>
           </p:cNvPr>
@@ -20704,7 +20704,7 @@
           <p:cNvPr id="4" name="Chart">
             <a:extLst xmlns:a="http://schemas.openxmlformats.org/drawingml/2006/main">
               <a:ext uri="{FF2B5EF4-FFF2-40B4-BE49-F238E27FC236}">
-                <a16:creationId xmlns:a16="http://schemas.microsoft.com/office/drawing/2014/main" id="{E8176BD8-25FC-4EFA-9DBD-D1B927ECC190}"/>
+                <a16:creationId xmlns:a16="http://schemas.microsoft.com/office/drawing/2014/main" id="{2A450C1B-3DE5-4439-9D0C-3D733C452124}"/>
               </a:ext>
             </a:extLst>
           </p:cNvPr>
@@ -20717,7 +20717,7 @@
         </p:xfrm>
         <a:graphic xmlns:a="http://schemas.openxmlformats.org/drawingml/2006/main">
           <a:graphicData uri="http://schemas.openxmlformats.org/drawingml/2006/chart">
-            <c:chart xmlns:r="http://schemas.openxmlformats.org/officeDocument/2006/relationships" xmlns:c="http://schemas.openxmlformats.org/drawingml/2006/chart" r:id="Ra5a7bb54c6254f98"/>
+            <c:chart xmlns:r="http://schemas.openxmlformats.org/officeDocument/2006/relationships" xmlns:c="http://schemas.openxmlformats.org/drawingml/2006/chart" r:id="R70caaa97602747fb"/>
           </a:graphicData>
         </a:graphic>
       </p:graphicFrame>
@@ -20726,7 +20726,7 @@
           <p:cNvPr id="5" name="text-79">
             <a:extLst xmlns:a="http://schemas.openxmlformats.org/drawingml/2006/main">
               <a:ext uri="{FF2B5EF4-FFF2-40B4-BE49-F238E27FC236}">
-                <a16:creationId xmlns:a16="http://schemas.microsoft.com/office/drawing/2014/main" id="{BD8A0CA3-56C3-4979-8A12-C6A1BE654B33}"/>
+                <a16:creationId xmlns:a16="http://schemas.microsoft.com/office/drawing/2014/main" id="{6B45517C-B0B6-46B0-8A21-8A1C4CF32A4C}"/>
               </a:ext>
             </a:extLst>
           </p:cNvPr>
@@ -20884,7 +20884,7 @@
           <p:cNvPr id="6" name="text-80">
             <a:extLst xmlns:a="http://schemas.openxmlformats.org/drawingml/2006/main">
               <a:ext uri="{FF2B5EF4-FFF2-40B4-BE49-F238E27FC236}">
-                <a16:creationId xmlns:a16="http://schemas.microsoft.com/office/drawing/2014/main" id="{C7B3B192-1C96-4643-92BD-C227D06D6F2E}"/>
+                <a16:creationId xmlns:a16="http://schemas.microsoft.com/office/drawing/2014/main" id="{62E3CB05-CB25-4CCA-BA66-854C8F8D4761}"/>
               </a:ext>
             </a:extLst>
           </p:cNvPr>
@@ -21042,7 +21042,7 @@
           <p:cNvPr id="7" name="text-81">
             <a:extLst xmlns:a="http://schemas.openxmlformats.org/drawingml/2006/main">
               <a:ext uri="{FF2B5EF4-FFF2-40B4-BE49-F238E27FC236}">
-                <a16:creationId xmlns:a16="http://schemas.microsoft.com/office/drawing/2014/main" id="{5978F7CD-0442-4DB1-9704-5E1FEC259557}"/>
+                <a16:creationId xmlns:a16="http://schemas.microsoft.com/office/drawing/2014/main" id="{888467A9-D81E-447F-8BB9-68418A8BE2BB}"/>
               </a:ext>
             </a:extLst>
           </p:cNvPr>
@@ -21223,7 +21223,7 @@
           <p:cNvPr id="8" name="text-82">
             <a:extLst xmlns:a="http://schemas.openxmlformats.org/drawingml/2006/main">
               <a:ext uri="{FF2B5EF4-FFF2-40B4-BE49-F238E27FC236}">
-                <a16:creationId xmlns:a16="http://schemas.microsoft.com/office/drawing/2014/main" id="{973AB192-1FB5-47F5-9141-F552F4093FC5}"/>
+                <a16:creationId xmlns:a16="http://schemas.microsoft.com/office/drawing/2014/main" id="{94593023-CAC4-4A92-81B1-7BACD55C3700}"/>
               </a:ext>
             </a:extLst>
           </p:cNvPr>
@@ -21404,7 +21404,7 @@
           <p:cNvPr id="9" name="text-83">
             <a:extLst xmlns:a="http://schemas.openxmlformats.org/drawingml/2006/main">
               <a:ext uri="{FF2B5EF4-FFF2-40B4-BE49-F238E27FC236}">
-                <a16:creationId xmlns:a16="http://schemas.microsoft.com/office/drawing/2014/main" id="{973FA991-6482-4D5C-A460-67057DC1AC79}"/>
+                <a16:creationId xmlns:a16="http://schemas.microsoft.com/office/drawing/2014/main" id="{CDF3E0F4-4D17-4A17-ACEC-D7DC361C6CC9}"/>
               </a:ext>
             </a:extLst>
           </p:cNvPr>
@@ -21560,7 +21560,7 @@
     </p:spTree>
     <p:extLst>
       <p:ext uri="{BB962C8B-B14F-4D97-AF65-F5344CB8AC3E}">
-        <p14:creationId xmlns:p14="http://schemas.microsoft.com/office/powerpoint/2010/main" val="1717977144"/>
+        <p14:creationId xmlns:p14="http://schemas.microsoft.com/office/powerpoint/2010/main" val="313081989"/>
       </p:ext>
     </p:extLst>
   </p:cSld>
@@ -21591,7 +21591,7 @@
           <p:cNvPr id="5" name="text-84">
             <a:extLst xmlns:a="http://schemas.openxmlformats.org/drawingml/2006/main">
               <a:ext uri="{FF2B5EF4-FFF2-40B4-BE49-F238E27FC236}">
-                <a16:creationId xmlns:a16="http://schemas.microsoft.com/office/drawing/2014/main" id="{429ABD2A-F9A7-4C70-BEC3-40B51C0E2325}"/>
+                <a16:creationId xmlns:a16="http://schemas.microsoft.com/office/drawing/2014/main" id="{FC35F6BC-DD73-4EE2-97CB-76C0CD5DAE06}"/>
               </a:ext>
             </a:extLst>
           </p:cNvPr>
@@ -21749,7 +21749,7 @@
           <p:cNvPr id="2" name="text-85">
             <a:extLst xmlns:a="http://schemas.openxmlformats.org/drawingml/2006/main">
               <a:ext uri="{FF2B5EF4-FFF2-40B4-BE49-F238E27FC236}">
-                <a16:creationId xmlns:a16="http://schemas.microsoft.com/office/drawing/2014/main" id="{07535582-48E1-43C8-82C6-3A0074C196A0}"/>
+                <a16:creationId xmlns:a16="http://schemas.microsoft.com/office/drawing/2014/main" id="{CB3C11A6-70D3-421F-958C-BE3A7E863F7F}"/>
               </a:ext>
             </a:extLst>
           </p:cNvPr>
@@ -21907,7 +21907,7 @@
           <p:cNvPr id="3" name="">
             <a:extLst xmlns:a="http://schemas.openxmlformats.org/drawingml/2006/main">
               <a:ext uri="{FF2B5EF4-FFF2-40B4-BE49-F238E27FC236}">
-                <a16:creationId xmlns:a16="http://schemas.microsoft.com/office/drawing/2014/main" id="{4FC6A918-7D57-4F1F-8FB5-DFCDE55035A3}"/>
+                <a16:creationId xmlns:a16="http://schemas.microsoft.com/office/drawing/2014/main" id="{88398C82-73AC-4104-A985-FD8D3F7FE526}"/>
               </a:ext>
             </a:extLst>
           </p:cNvPr>
@@ -22882,7 +22882,7 @@
           <p:cNvPr id="4" name="text-86">
             <a:extLst xmlns:a="http://schemas.openxmlformats.org/drawingml/2006/main">
               <a:ext uri="{FF2B5EF4-FFF2-40B4-BE49-F238E27FC236}">
-                <a16:creationId xmlns:a16="http://schemas.microsoft.com/office/drawing/2014/main" id="{5E0220DD-AAC1-4EDF-AA9C-98144638E150}"/>
+                <a16:creationId xmlns:a16="http://schemas.microsoft.com/office/drawing/2014/main" id="{F08533D8-2B2B-4E0C-BF0F-5F8AB6E3B158}"/>
               </a:ext>
             </a:extLst>
           </p:cNvPr>
@@ -23061,7 +23061,7 @@
     </p:spTree>
     <p:extLst>
       <p:ext uri="{BB962C8B-B14F-4D97-AF65-F5344CB8AC3E}">
-        <p14:creationId xmlns:p14="http://schemas.microsoft.com/office/powerpoint/2010/main" val="1446356543"/>
+        <p14:creationId xmlns:p14="http://schemas.microsoft.com/office/powerpoint/2010/main" val="1975748998"/>
       </p:ext>
     </p:extLst>
   </p:cSld>

</xml_diff>